<commit_message>
Misión/visión/valores aprobados, viernes y 40 % confirmados; Gantt por días (05–11/10) y prompt para Gantt editable
Co-Authored-By: Claude Opus 5.5 <noreply@anthropic.com>
Claude-Session: https://claude.ai/code/session_01TgHUE7MvKMHN7LYxdL7oKE
</commit_message>
<xml_diff>
--- a/docs/presentacion/DanyPizzas_Presentacion.pptx
+++ b/docs/presentacion/DanyPizzas_Presentacion.pptx
@@ -126,25 +126,25 @@
   <p:extLst>
     <p:ext uri="{521415D9-36F7-43E2-AB2F-B90AF26B5E84}">
       <p14:sectionLst xmlns:p14="http://schemas.microsoft.com/office/powerpoint/2010/main">
-        <p14:section name="Introducción" id="{6e700f2d-935d-e648-b967-c5e9bb01fdba}">
+        <p14:section name="Introducción" id="{ce98ef85-d3a2-192c-ad2e-937b166d682f}">
           <p14:sldIdLst>
             <p14:sldId id="256"/>
             <p14:sldId id="257"/>
           </p14:sldIdLst>
         </p14:section>
-        <p14:section name="I. Curriculum vitae" id="{5f91c308-5a0e-17b4-adcd-9835cd00dcc6}">
+        <p14:section name="I. Curriculum vitae" id="{67386510-cf01-fc37-4855-f3567a422c75}">
           <p14:sldIdLst>
             <p14:sldId id="258"/>
           </p14:sldIdLst>
         </p14:section>
-        <p14:section name="II. Memoria descriptiva" id="{54fa70bf-d2c0-a6e8-394c-24d3fef67435}">
+        <p14:section name="II. Memoria descriptiva" id="{9d30f5c9-130e-6457-fa43-abe9f807edab}">
           <p14:sldIdLst>
             <p14:sldId id="259"/>
             <p14:sldId id="260"/>
             <p14:sldId id="261"/>
           </p14:sldIdLst>
         </p14:section>
-        <p14:section name="III. Trabajo principal" id="{51dd74d1-9aa2-040d-082f-0262b02aba4f}">
+        <p14:section name="III. Trabajo principal" id="{fb64ec64-eaab-b2f7-2d1d-bb662dc9a08f}">
           <p14:sldIdLst>
             <p14:sldId id="262"/>
             <p14:sldId id="263"/>
@@ -927,7 +927,7 @@
             <a:r>
               <a:rPr lang="en-US" dirty="0"/>
               <a:t>⏱ 0:40 (acumulado 6:40)
-El alcance es deliberadamente chico: lo mínimo que resuelve el problema. El pago en línea o una app quedan para una versión 2. Trabajé en cuatro incrementos semanales con un tablero Kanban, mostrando cada avance a la familia. El sitio se publicó el 6 de octubre.</a:t>
+El alcance es deliberadamente chico: lo mínimo que resuelve el problema. El pago en línea o una app quedan para una versión 2. El plan entra en una semana: el lunes 5 y el martes 6 hice el análisis y los cuatro incrementos cortos, con un tablero Kanban y mostrando cada avance a la familia; el sitio se publicó el martes 6. El miércoles validé el análisis con el negocio, y hasta el domingo 11 quedan la evaluación, el pedido real con la medición de uso y el ensayo. Todo termina antes de la exposición del 13.</a:t>
             </a:r>
             <a:endParaRPr lang="en-US" dirty="0"/>
           </a:p>
@@ -1728,7 +1728,7 @@
             <a:r>
               <a:rPr lang="en-US" dirty="0"/>
               <a:t>⏱ 0:25 (acumulado 13:00)
-Y tres recomendaciones: al dueño, aprobar la misión y mantener los precios; a quien atiende, anotar los pedidos perdidos durante un mes para medir; y como desarrollador, recalcular la evaluación con esos datos reales y avanzar a una versión 2.</a:t>
+Y tres recomendaciones: al dueño, difundir la misión y los valores, y mantener los precios; a quien atiende, anotar los pedidos perdidos durante un mes para medir; y como desarrollador, recalcular la evaluación con esos datos reales y avanzar a una versión 2.</a:t>
             </a:r>
             <a:endParaRPr lang="en-US" dirty="0"/>
           </a:p>
@@ -2084,7 +2084,7 @@
             <a:r>
               <a:rPr lang="en-US" dirty="0"/>
               <a:t>⏱ 0:40 (acumulado 1:50)
-Dany Pizzas es un emprendimiento familiar e informal de Chilecito, que empezó en 2024. Trabaja solo con envío, de noche, y vende unos 50 pedidos por semana. Todo entra por WhatsApp. Como no tenían misión ni visión, propuse estas dos.</a:t>
+Dany Pizzas es un emprendimiento familiar e informal de Chilecito, que empezó en 2024. Trabaja solo con envío, de noche, y vende unos 50 pedidos por semana. Todo entra por WhatsApp. Como no tenían misión ni visión, las redacté con ellos y el dueño las aprobó el 7 de octubre, junto con cuatro valores: calidad casera, precio justo, trato cercano y cumplir con el horario de entrega.</a:t>
             </a:r>
             <a:endParaRPr lang="en-US" dirty="0"/>
           </a:p>
@@ -4151,24 +4151,24 @@
         </p:nvSpPr>
         <p:spPr>
           <a:xfrm>
-            <a:off x="6720840" y="1463040"/>
-            <a:ext cx="978408" cy="320040"/>
-          </a:xfrm>
-          <a:prstGeom prst="rect">
-            <a:avLst/>
-          </a:prstGeom>
-          <a:noFill/>
-          <a:ln/>
-        </p:spPr>
-        <p:txBody>
-          <a:bodyPr wrap="square" lIns="0" tIns="0" rIns="0" bIns="0" rtlCol="0" anchor="t"/>
+            <a:off x="6903720" y="1417320"/>
+            <a:ext cx="585216" cy="457200"/>
+          </a:xfrm>
+          <a:prstGeom prst="rect">
+            <a:avLst/>
+          </a:prstGeom>
+          <a:noFill/>
+          <a:ln/>
+        </p:spPr>
+        <p:txBody>
+          <a:bodyPr wrap="square" lIns="0" tIns="0" rIns="0" bIns="0" rtlCol="0" anchor="ctr"/>
           <a:lstStyle/>
           <a:p>
             <a:pPr algn="ctr" indent="0" marL="0">
               <a:buNone/>
             </a:pPr>
             <a:r>
-              <a:rPr lang="en-US" sz="1200" b="1" dirty="0">
+              <a:rPr lang="en-US" sz="1100" b="1" dirty="0">
                 <a:solidFill>
                   <a:schemeClr val="accent4"/>
                 </a:solidFill>
@@ -4176,9 +4176,26 @@
                 <a:ea typeface="Calibri" pitchFamily="34" charset="-122"/>
                 <a:cs typeface="Calibri" pitchFamily="34" charset="-120"/>
               </a:rPr>
-              <a:t>Sem 1</a:t>
-            </a:r>
-            <a:endParaRPr lang="en-US" sz="1200" dirty="0"/>
+              <a:t>Lun</a:t>
+            </a:r>
+            <a:endParaRPr lang="en-US" sz="1100" dirty="0"/>
+          </a:p>
+          <a:p>
+            <a:pPr algn="ctr" indent="0" marL="0">
+              <a:buNone/>
+            </a:pPr>
+            <a:r>
+              <a:rPr lang="en-US" sz="1100" b="1" dirty="0">
+                <a:solidFill>
+                  <a:schemeClr val="accent4"/>
+                </a:solidFill>
+                <a:latin typeface="Calibri" pitchFamily="34" charset="0"/>
+                <a:ea typeface="Calibri" pitchFamily="34" charset="-122"/>
+                <a:cs typeface="Calibri" pitchFamily="34" charset="-120"/>
+              </a:rPr>
+              <a:t>05</a:t>
+            </a:r>
+            <a:endParaRPr lang="en-US" sz="1100" dirty="0"/>
           </a:p>
         </p:txBody>
       </p:sp>
@@ -4190,24 +4207,24 @@
         </p:nvSpPr>
         <p:spPr>
           <a:xfrm>
-            <a:off x="7699248" y="1463040"/>
-            <a:ext cx="978408" cy="320040"/>
-          </a:xfrm>
-          <a:prstGeom prst="rect">
-            <a:avLst/>
-          </a:prstGeom>
-          <a:noFill/>
-          <a:ln/>
-        </p:spPr>
-        <p:txBody>
-          <a:bodyPr wrap="square" lIns="0" tIns="0" rIns="0" bIns="0" rtlCol="0" anchor="t"/>
+            <a:off x="7488936" y="1417320"/>
+            <a:ext cx="585216" cy="457200"/>
+          </a:xfrm>
+          <a:prstGeom prst="rect">
+            <a:avLst/>
+          </a:prstGeom>
+          <a:noFill/>
+          <a:ln/>
+        </p:spPr>
+        <p:txBody>
+          <a:bodyPr wrap="square" lIns="0" tIns="0" rIns="0" bIns="0" rtlCol="0" anchor="ctr"/>
           <a:lstStyle/>
           <a:p>
             <a:pPr algn="ctr" indent="0" marL="0">
               <a:buNone/>
             </a:pPr>
             <a:r>
-              <a:rPr lang="en-US" sz="1200" b="1" dirty="0">
+              <a:rPr lang="en-US" sz="1100" b="1" dirty="0">
                 <a:solidFill>
                   <a:schemeClr val="accent4"/>
                 </a:solidFill>
@@ -4215,9 +4232,26 @@
                 <a:ea typeface="Calibri" pitchFamily="34" charset="-122"/>
                 <a:cs typeface="Calibri" pitchFamily="34" charset="-120"/>
               </a:rPr>
-              <a:t>Sem 2</a:t>
-            </a:r>
-            <a:endParaRPr lang="en-US" sz="1200" dirty="0"/>
+              <a:t>Mar</a:t>
+            </a:r>
+            <a:endParaRPr lang="en-US" sz="1100" dirty="0"/>
+          </a:p>
+          <a:p>
+            <a:pPr algn="ctr" indent="0" marL="0">
+              <a:buNone/>
+            </a:pPr>
+            <a:r>
+              <a:rPr lang="en-US" sz="1100" b="1" dirty="0">
+                <a:solidFill>
+                  <a:schemeClr val="accent4"/>
+                </a:solidFill>
+                <a:latin typeface="Calibri" pitchFamily="34" charset="0"/>
+                <a:ea typeface="Calibri" pitchFamily="34" charset="-122"/>
+                <a:cs typeface="Calibri" pitchFamily="34" charset="-120"/>
+              </a:rPr>
+              <a:t>06</a:t>
+            </a:r>
+            <a:endParaRPr lang="en-US" sz="1100" dirty="0"/>
           </a:p>
         </p:txBody>
       </p:sp>
@@ -4229,24 +4263,24 @@
         </p:nvSpPr>
         <p:spPr>
           <a:xfrm>
-            <a:off x="8677656" y="1463040"/>
-            <a:ext cx="978408" cy="320040"/>
-          </a:xfrm>
-          <a:prstGeom prst="rect">
-            <a:avLst/>
-          </a:prstGeom>
-          <a:noFill/>
-          <a:ln/>
-        </p:spPr>
-        <p:txBody>
-          <a:bodyPr wrap="square" lIns="0" tIns="0" rIns="0" bIns="0" rtlCol="0" anchor="t"/>
+            <a:off x="8074152" y="1417320"/>
+            <a:ext cx="585216" cy="457200"/>
+          </a:xfrm>
+          <a:prstGeom prst="rect">
+            <a:avLst/>
+          </a:prstGeom>
+          <a:noFill/>
+          <a:ln/>
+        </p:spPr>
+        <p:txBody>
+          <a:bodyPr wrap="square" lIns="0" tIns="0" rIns="0" bIns="0" rtlCol="0" anchor="ctr"/>
           <a:lstStyle/>
           <a:p>
             <a:pPr algn="ctr" indent="0" marL="0">
               <a:buNone/>
             </a:pPr>
             <a:r>
-              <a:rPr lang="en-US" sz="1200" b="1" dirty="0">
+              <a:rPr lang="en-US" sz="1100" b="1" dirty="0">
                 <a:solidFill>
                   <a:schemeClr val="accent4"/>
                 </a:solidFill>
@@ -4254,9 +4288,26 @@
                 <a:ea typeface="Calibri" pitchFamily="34" charset="-122"/>
                 <a:cs typeface="Calibri" pitchFamily="34" charset="-120"/>
               </a:rPr>
-              <a:t>Sem 3</a:t>
-            </a:r>
-            <a:endParaRPr lang="en-US" sz="1200" dirty="0"/>
+              <a:t>Mié</a:t>
+            </a:r>
+            <a:endParaRPr lang="en-US" sz="1100" dirty="0"/>
+          </a:p>
+          <a:p>
+            <a:pPr algn="ctr" indent="0" marL="0">
+              <a:buNone/>
+            </a:pPr>
+            <a:r>
+              <a:rPr lang="en-US" sz="1100" b="1" dirty="0">
+                <a:solidFill>
+                  <a:schemeClr val="accent4"/>
+                </a:solidFill>
+                <a:latin typeface="Calibri" pitchFamily="34" charset="0"/>
+                <a:ea typeface="Calibri" pitchFamily="34" charset="-122"/>
+                <a:cs typeface="Calibri" pitchFamily="34" charset="-120"/>
+              </a:rPr>
+              <a:t>07</a:t>
+            </a:r>
+            <a:endParaRPr lang="en-US" sz="1100" dirty="0"/>
           </a:p>
         </p:txBody>
       </p:sp>
@@ -4268,24 +4319,24 @@
         </p:nvSpPr>
         <p:spPr>
           <a:xfrm>
-            <a:off x="9656064" y="1463040"/>
-            <a:ext cx="978408" cy="320040"/>
-          </a:xfrm>
-          <a:prstGeom prst="rect">
-            <a:avLst/>
-          </a:prstGeom>
-          <a:noFill/>
-          <a:ln/>
-        </p:spPr>
-        <p:txBody>
-          <a:bodyPr wrap="square" lIns="0" tIns="0" rIns="0" bIns="0" rtlCol="0" anchor="t"/>
+            <a:off x="8659368" y="1417320"/>
+            <a:ext cx="585216" cy="457200"/>
+          </a:xfrm>
+          <a:prstGeom prst="rect">
+            <a:avLst/>
+          </a:prstGeom>
+          <a:noFill/>
+          <a:ln/>
+        </p:spPr>
+        <p:txBody>
+          <a:bodyPr wrap="square" lIns="0" tIns="0" rIns="0" bIns="0" rtlCol="0" anchor="ctr"/>
           <a:lstStyle/>
           <a:p>
             <a:pPr algn="ctr" indent="0" marL="0">
               <a:buNone/>
             </a:pPr>
             <a:r>
-              <a:rPr lang="en-US" sz="1200" b="1" dirty="0">
+              <a:rPr lang="en-US" sz="1100" b="1" dirty="0">
                 <a:solidFill>
                   <a:schemeClr val="accent4"/>
                 </a:solidFill>
@@ -4293,9 +4344,26 @@
                 <a:ea typeface="Calibri" pitchFamily="34" charset="-122"/>
                 <a:cs typeface="Calibri" pitchFamily="34" charset="-120"/>
               </a:rPr>
-              <a:t>Sem 4</a:t>
-            </a:r>
-            <a:endParaRPr lang="en-US" sz="1200" dirty="0"/>
+              <a:t>Jue</a:t>
+            </a:r>
+            <a:endParaRPr lang="en-US" sz="1100" dirty="0"/>
+          </a:p>
+          <a:p>
+            <a:pPr algn="ctr" indent="0" marL="0">
+              <a:buNone/>
+            </a:pPr>
+            <a:r>
+              <a:rPr lang="en-US" sz="1100" b="1" dirty="0">
+                <a:solidFill>
+                  <a:schemeClr val="accent4"/>
+                </a:solidFill>
+                <a:latin typeface="Calibri" pitchFamily="34" charset="0"/>
+                <a:ea typeface="Calibri" pitchFamily="34" charset="-122"/>
+                <a:cs typeface="Calibri" pitchFamily="34" charset="-120"/>
+              </a:rPr>
+              <a:t>08</a:t>
+            </a:r>
+            <a:endParaRPr lang="en-US" sz="1100" dirty="0"/>
           </a:p>
         </p:txBody>
       </p:sp>
@@ -4307,24 +4375,24 @@
         </p:nvSpPr>
         <p:spPr>
           <a:xfrm>
-            <a:off x="10634472" y="1463040"/>
-            <a:ext cx="978408" cy="320040"/>
-          </a:xfrm>
-          <a:prstGeom prst="rect">
-            <a:avLst/>
-          </a:prstGeom>
-          <a:noFill/>
-          <a:ln/>
-        </p:spPr>
-        <p:txBody>
-          <a:bodyPr wrap="square" lIns="0" tIns="0" rIns="0" bIns="0" rtlCol="0" anchor="t"/>
+            <a:off x="9244584" y="1417320"/>
+            <a:ext cx="585216" cy="457200"/>
+          </a:xfrm>
+          <a:prstGeom prst="rect">
+            <a:avLst/>
+          </a:prstGeom>
+          <a:noFill/>
+          <a:ln/>
+        </p:spPr>
+        <p:txBody>
+          <a:bodyPr wrap="square" lIns="0" tIns="0" rIns="0" bIns="0" rtlCol="0" anchor="ctr"/>
           <a:lstStyle/>
           <a:p>
             <a:pPr algn="ctr" indent="0" marL="0">
               <a:buNone/>
             </a:pPr>
             <a:r>
-              <a:rPr lang="en-US" sz="1200" b="1" dirty="0">
+              <a:rPr lang="en-US" sz="1100" b="1" dirty="0">
                 <a:solidFill>
                   <a:schemeClr val="accent4"/>
                 </a:solidFill>
@@ -4332,22 +4400,207 @@
                 <a:ea typeface="Calibri" pitchFamily="34" charset="-122"/>
                 <a:cs typeface="Calibri" pitchFamily="34" charset="-120"/>
               </a:rPr>
-              <a:t>06–13/10</a:t>
-            </a:r>
-            <a:endParaRPr lang="en-US" sz="1200" dirty="0"/>
-          </a:p>
-        </p:txBody>
-      </p:sp>
-      <p:sp>
-        <p:nvSpPr>
-          <p:cNvPr id="15" name="fila-87"/>
+              <a:t>Vie</a:t>
+            </a:r>
+            <a:endParaRPr lang="en-US" sz="1100" dirty="0"/>
+          </a:p>
+          <a:p>
+            <a:pPr algn="ctr" indent="0" marL="0">
+              <a:buNone/>
+            </a:pPr>
+            <a:r>
+              <a:rPr lang="en-US" sz="1100" b="1" dirty="0">
+                <a:solidFill>
+                  <a:schemeClr val="accent4"/>
+                </a:solidFill>
+                <a:latin typeface="Calibri" pitchFamily="34" charset="0"/>
+                <a:ea typeface="Calibri" pitchFamily="34" charset="-122"/>
+                <a:cs typeface="Calibri" pitchFamily="34" charset="-120"/>
+              </a:rPr>
+              <a:t>09</a:t>
+            </a:r>
+            <a:endParaRPr lang="en-US" sz="1100" dirty="0"/>
+          </a:p>
+        </p:txBody>
+      </p:sp>
+      <p:sp>
+        <p:nvSpPr>
+          <p:cNvPr id="15" name="Text 13"/>
+          <p:cNvSpPr txBox="1"/>
+          <p:nvPr/>
+        </p:nvSpPr>
+        <p:spPr>
+          <a:xfrm>
+            <a:off x="9829800" y="1417320"/>
+            <a:ext cx="585216" cy="457200"/>
+          </a:xfrm>
+          <a:prstGeom prst="rect">
+            <a:avLst/>
+          </a:prstGeom>
+          <a:noFill/>
+          <a:ln/>
+        </p:spPr>
+        <p:txBody>
+          <a:bodyPr wrap="square" lIns="0" tIns="0" rIns="0" bIns="0" rtlCol="0" anchor="ctr"/>
+          <a:lstStyle/>
+          <a:p>
+            <a:pPr algn="ctr" indent="0" marL="0">
+              <a:buNone/>
+            </a:pPr>
+            <a:r>
+              <a:rPr lang="en-US" sz="1100" b="1" dirty="0">
+                <a:solidFill>
+                  <a:schemeClr val="accent4"/>
+                </a:solidFill>
+                <a:latin typeface="Calibri" pitchFamily="34" charset="0"/>
+                <a:ea typeface="Calibri" pitchFamily="34" charset="-122"/>
+                <a:cs typeface="Calibri" pitchFamily="34" charset="-120"/>
+              </a:rPr>
+              <a:t>Sáb</a:t>
+            </a:r>
+            <a:endParaRPr lang="en-US" sz="1100" dirty="0"/>
+          </a:p>
+          <a:p>
+            <a:pPr algn="ctr" indent="0" marL="0">
+              <a:buNone/>
+            </a:pPr>
+            <a:r>
+              <a:rPr lang="en-US" sz="1100" b="1" dirty="0">
+                <a:solidFill>
+                  <a:schemeClr val="accent4"/>
+                </a:solidFill>
+                <a:latin typeface="Calibri" pitchFamily="34" charset="0"/>
+                <a:ea typeface="Calibri" pitchFamily="34" charset="-122"/>
+                <a:cs typeface="Calibri" pitchFamily="34" charset="-120"/>
+              </a:rPr>
+              <a:t>10</a:t>
+            </a:r>
+            <a:endParaRPr lang="en-US" sz="1100" dirty="0"/>
+          </a:p>
+        </p:txBody>
+      </p:sp>
+      <p:sp>
+        <p:nvSpPr>
+          <p:cNvPr id="16" name="Text 14"/>
+          <p:cNvSpPr txBox="1"/>
+          <p:nvPr/>
+        </p:nvSpPr>
+        <p:spPr>
+          <a:xfrm>
+            <a:off x="10415016" y="1417320"/>
+            <a:ext cx="585216" cy="457200"/>
+          </a:xfrm>
+          <a:prstGeom prst="rect">
+            <a:avLst/>
+          </a:prstGeom>
+          <a:noFill/>
+          <a:ln/>
+        </p:spPr>
+        <p:txBody>
+          <a:bodyPr wrap="square" lIns="0" tIns="0" rIns="0" bIns="0" rtlCol="0" anchor="ctr"/>
+          <a:lstStyle/>
+          <a:p>
+            <a:pPr algn="ctr" indent="0" marL="0">
+              <a:buNone/>
+            </a:pPr>
+            <a:r>
+              <a:rPr lang="en-US" sz="1100" b="1" dirty="0">
+                <a:solidFill>
+                  <a:schemeClr val="accent4"/>
+                </a:solidFill>
+                <a:latin typeface="Calibri" pitchFamily="34" charset="0"/>
+                <a:ea typeface="Calibri" pitchFamily="34" charset="-122"/>
+                <a:cs typeface="Calibri" pitchFamily="34" charset="-120"/>
+              </a:rPr>
+              <a:t>Dom</a:t>
+            </a:r>
+            <a:endParaRPr lang="en-US" sz="1100" dirty="0"/>
+          </a:p>
+          <a:p>
+            <a:pPr algn="ctr" indent="0" marL="0">
+              <a:buNone/>
+            </a:pPr>
+            <a:r>
+              <a:rPr lang="en-US" sz="1100" b="1" dirty="0">
+                <a:solidFill>
+                  <a:schemeClr val="accent4"/>
+                </a:solidFill>
+                <a:latin typeface="Calibri" pitchFamily="34" charset="0"/>
+                <a:ea typeface="Calibri" pitchFamily="34" charset="-122"/>
+                <a:cs typeface="Calibri" pitchFamily="34" charset="-120"/>
+              </a:rPr>
+              <a:t>11</a:t>
+            </a:r>
+            <a:endParaRPr lang="en-US" sz="1100" dirty="0"/>
+          </a:p>
+        </p:txBody>
+      </p:sp>
+      <p:sp>
+        <p:nvSpPr>
+          <p:cNvPr id="17" name="Text 15"/>
+          <p:cNvSpPr txBox="1"/>
+          <p:nvPr/>
+        </p:nvSpPr>
+        <p:spPr>
+          <a:xfrm>
+            <a:off x="11000232" y="1417320"/>
+            <a:ext cx="585216" cy="457200"/>
+          </a:xfrm>
+          <a:prstGeom prst="rect">
+            <a:avLst/>
+          </a:prstGeom>
+          <a:noFill/>
+          <a:ln/>
+        </p:spPr>
+        <p:txBody>
+          <a:bodyPr wrap="square" lIns="0" tIns="0" rIns="0" bIns="0" rtlCol="0" anchor="ctr"/>
+          <a:lstStyle/>
+          <a:p>
+            <a:pPr algn="ctr" indent="0" marL="0">
+              <a:buNone/>
+            </a:pPr>
+            <a:r>
+              <a:rPr lang="en-US" sz="1100" b="1" dirty="0">
+                <a:solidFill>
+                  <a:schemeClr val="accent3"/>
+                </a:solidFill>
+                <a:latin typeface="Calibri" pitchFamily="34" charset="0"/>
+                <a:ea typeface="Calibri" pitchFamily="34" charset="-122"/>
+                <a:cs typeface="Calibri" pitchFamily="34" charset="-120"/>
+              </a:rPr>
+              <a:t>Mar</a:t>
+            </a:r>
+            <a:endParaRPr lang="en-US" sz="1100" dirty="0"/>
+          </a:p>
+          <a:p>
+            <a:pPr algn="ctr" indent="0" marL="0">
+              <a:buNone/>
+            </a:pPr>
+            <a:r>
+              <a:rPr lang="en-US" sz="1100" b="1" dirty="0">
+                <a:solidFill>
+                  <a:schemeClr val="accent3"/>
+                </a:solidFill>
+                <a:latin typeface="Calibri" pitchFamily="34" charset="0"/>
+                <a:ea typeface="Calibri" pitchFamily="34" charset="-122"/>
+                <a:cs typeface="Calibri" pitchFamily="34" charset="-120"/>
+              </a:rPr>
+              <a:t>13</a:t>
+            </a:r>
+            <a:endParaRPr lang="en-US" sz="1100" dirty="0"/>
+          </a:p>
+        </p:txBody>
+      </p:sp>
+      <p:sp>
+        <p:nvSpPr>
+          <p:cNvPr id="18" name="fila-87"/>
           <p:cNvSpPr/>
           <p:nvPr/>
         </p:nvSpPr>
         <p:spPr>
           <a:xfrm>
-            <a:off x="4389120" y="1874520"/>
-            <a:ext cx="7223760" cy="502920"/>
+            <a:off x="4343400" y="1920240"/>
+            <a:ext cx="7242048" cy="429768"/>
           </a:xfrm>
           <a:prstGeom prst="rect">
             <a:avLst/>
@@ -4360,14 +4613,14 @@
       </p:sp>
       <p:sp>
         <p:nvSpPr>
-          <p:cNvPr id="16" name="Text 14"/>
+          <p:cNvPr id="19" name="Text 17"/>
           <p:cNvSpPr txBox="1"/>
           <p:nvPr/>
         </p:nvSpPr>
         <p:spPr>
           <a:xfrm>
-            <a:off x="4480560" y="1874520"/>
-            <a:ext cx="2240280" cy="502920"/>
+            <a:off x="4416552" y="1920240"/>
+            <a:ext cx="2514600" cy="429768"/>
           </a:xfrm>
           <a:prstGeom prst="rect">
             <a:avLst/>
@@ -4383,7 +4636,7 @@
               <a:buNone/>
             </a:pPr>
             <a:r>
-              <a:rPr lang="en-US" sz="1400" dirty="0">
+              <a:rPr lang="en-US" sz="1300" dirty="0">
                 <a:solidFill>
                   <a:schemeClr val="tx1"/>
                 </a:solidFill>
@@ -4391,26 +4644,26 @@
                 <a:ea typeface="Calibri" pitchFamily="34" charset="-122"/>
                 <a:cs typeface="Calibri" pitchFamily="34" charset="-120"/>
               </a:rPr>
-              <a:t>Análisis y diseño</a:t>
-            </a:r>
-            <a:endParaRPr lang="en-US" sz="1400" dirty="0"/>
-          </a:p>
-        </p:txBody>
-      </p:sp>
-      <p:sp>
-        <p:nvSpPr>
-          <p:cNvPr id="17" name="barra-88"/>
+              <a:t>Análisis y requisitos</a:t>
+            </a:r>
+            <a:endParaRPr lang="en-US" sz="1300" dirty="0"/>
+          </a:p>
+        </p:txBody>
+      </p:sp>
+      <p:sp>
+        <p:nvSpPr>
+          <p:cNvPr id="20" name="barra-88"/>
           <p:cNvSpPr/>
           <p:nvPr/>
         </p:nvSpPr>
         <p:spPr>
           <a:xfrm>
-            <a:off x="6748272" y="1993392"/>
-            <a:ext cx="1217066" cy="265176"/>
+            <a:off x="6940296" y="2029968"/>
+            <a:ext cx="1097280" cy="210312"/>
           </a:xfrm>
           <a:prstGeom prst="roundRect">
             <a:avLst>
-              <a:gd name="adj" fmla="val 24138"/>
+              <a:gd name="adj" fmla="val 26087"/>
             </a:avLst>
           </a:prstGeom>
           <a:solidFill>
@@ -4421,14 +4674,14 @@
       </p:sp>
       <p:sp>
         <p:nvSpPr>
-          <p:cNvPr id="18" name="Text 16"/>
+          <p:cNvPr id="21" name="Text 19"/>
           <p:cNvSpPr txBox="1"/>
           <p:nvPr/>
         </p:nvSpPr>
         <p:spPr>
           <a:xfrm>
-            <a:off x="4480560" y="2377440"/>
-            <a:ext cx="2240280" cy="502920"/>
+            <a:off x="4416552" y="2350008"/>
+            <a:ext cx="2514600" cy="429768"/>
           </a:xfrm>
           <a:prstGeom prst="rect">
             <a:avLst/>
@@ -4444,7 +4697,7 @@
               <a:buNone/>
             </a:pPr>
             <a:r>
-              <a:rPr lang="en-US" sz="1400" dirty="0">
+              <a:rPr lang="en-US" sz="1300" dirty="0">
                 <a:solidFill>
                   <a:schemeClr val="tx1"/>
                 </a:solidFill>
@@ -4452,26 +4705,107 @@
                 <a:ea typeface="Calibri" pitchFamily="34" charset="-122"/>
                 <a:cs typeface="Calibri" pitchFamily="34" charset="-120"/>
               </a:rPr>
-              <a:t>Inc. 1: carta</a:t>
-            </a:r>
-            <a:endParaRPr lang="en-US" sz="1400" dirty="0"/>
-          </a:p>
-        </p:txBody>
-      </p:sp>
-      <p:sp>
-        <p:nvSpPr>
-          <p:cNvPr id="19" name="barra-89"/>
+              <a:t>Diseño y arquitectura</a:t>
+            </a:r>
+            <a:endParaRPr lang="en-US" sz="1300" dirty="0"/>
+          </a:p>
+        </p:txBody>
+      </p:sp>
+      <p:sp>
+        <p:nvSpPr>
+          <p:cNvPr id="22" name="barra-89"/>
           <p:cNvSpPr/>
           <p:nvPr/>
         </p:nvSpPr>
         <p:spPr>
           <a:xfrm>
-            <a:off x="7726680" y="2496312"/>
-            <a:ext cx="727862" cy="265176"/>
+            <a:off x="6940296" y="2459736"/>
+            <a:ext cx="512064" cy="210312"/>
           </a:xfrm>
           <a:prstGeom prst="roundRect">
             <a:avLst>
-              <a:gd name="adj" fmla="val 24138"/>
+              <a:gd name="adj" fmla="val 26087"/>
+            </a:avLst>
+          </a:prstGeom>
+          <a:solidFill>
+            <a:schemeClr val="accent4"/>
+          </a:solidFill>
+          <a:ln/>
+        </p:spPr>
+      </p:sp>
+      <p:sp>
+        <p:nvSpPr>
+          <p:cNvPr id="23" name="fila-90"/>
+          <p:cNvSpPr/>
+          <p:nvPr/>
+        </p:nvSpPr>
+        <p:spPr>
+          <a:xfrm>
+            <a:off x="4343400" y="2779776"/>
+            <a:ext cx="7242048" cy="429768"/>
+          </a:xfrm>
+          <a:prstGeom prst="rect">
+            <a:avLst/>
+          </a:prstGeom>
+          <a:solidFill>
+            <a:schemeClr val="accent6"/>
+          </a:solidFill>
+          <a:ln/>
+        </p:spPr>
+      </p:sp>
+      <p:sp>
+        <p:nvSpPr>
+          <p:cNvPr id="24" name="Text 22"/>
+          <p:cNvSpPr txBox="1"/>
+          <p:nvPr/>
+        </p:nvSpPr>
+        <p:spPr>
+          <a:xfrm>
+            <a:off x="4416552" y="2779776"/>
+            <a:ext cx="2514600" cy="429768"/>
+          </a:xfrm>
+          <a:prstGeom prst="rect">
+            <a:avLst/>
+          </a:prstGeom>
+          <a:noFill/>
+          <a:ln/>
+        </p:spPr>
+        <p:txBody>
+          <a:bodyPr wrap="square" lIns="0" tIns="0" rIns="0" bIns="0" rtlCol="0" anchor="ctr"/>
+          <a:lstStyle/>
+          <a:p>
+            <a:pPr indent="0" marL="0">
+              <a:buNone/>
+            </a:pPr>
+            <a:r>
+              <a:rPr lang="en-US" sz="1300" dirty="0">
+                <a:solidFill>
+                  <a:schemeClr val="tx1"/>
+                </a:solidFill>
+                <a:latin typeface="Calibri" pitchFamily="34" charset="0"/>
+                <a:ea typeface="Calibri" pitchFamily="34" charset="-122"/>
+                <a:cs typeface="Calibri" pitchFamily="34" charset="-120"/>
+              </a:rPr>
+              <a:t>Inc. 1–2: carta y carrito</a:t>
+            </a:r>
+            <a:endParaRPr lang="en-US" sz="1300" dirty="0"/>
+          </a:p>
+        </p:txBody>
+      </p:sp>
+      <p:sp>
+        <p:nvSpPr>
+          <p:cNvPr id="25" name="barra-91"/>
+          <p:cNvSpPr/>
+          <p:nvPr/>
+        </p:nvSpPr>
+        <p:spPr>
+          <a:xfrm>
+            <a:off x="6940296" y="2889504"/>
+            <a:ext cx="1097280" cy="210312"/>
+          </a:xfrm>
+          <a:prstGeom prst="roundRect">
+            <a:avLst>
+              <a:gd name="adj" fmla="val 26087"/>
             </a:avLst>
           </a:prstGeom>
           <a:solidFill>
@@ -4482,14 +4816,75 @@
       </p:sp>
       <p:sp>
         <p:nvSpPr>
-          <p:cNvPr id="20" name="fila-90"/>
+          <p:cNvPr id="26" name="Text 24"/>
+          <p:cNvSpPr txBox="1"/>
+          <p:nvPr/>
+        </p:nvSpPr>
+        <p:spPr>
+          <a:xfrm>
+            <a:off x="4416552" y="3209544"/>
+            <a:ext cx="2514600" cy="429768"/>
+          </a:xfrm>
+          <a:prstGeom prst="rect">
+            <a:avLst/>
+          </a:prstGeom>
+          <a:noFill/>
+          <a:ln/>
+        </p:spPr>
+        <p:txBody>
+          <a:bodyPr wrap="square" lIns="0" tIns="0" rIns="0" bIns="0" rtlCol="0" anchor="ctr"/>
+          <a:lstStyle/>
+          <a:p>
+            <a:pPr indent="0" marL="0">
+              <a:buNone/>
+            </a:pPr>
+            <a:r>
+              <a:rPr lang="en-US" sz="1300" dirty="0">
+                <a:solidFill>
+                  <a:schemeClr val="tx1"/>
+                </a:solidFill>
+                <a:latin typeface="Calibri" pitchFamily="34" charset="0"/>
+                <a:ea typeface="Calibri" pitchFamily="34" charset="-122"/>
+                <a:cs typeface="Calibri" pitchFamily="34" charset="-120"/>
+              </a:rPr>
+              <a:t>Inc. 3–4: recibo y backend</a:t>
+            </a:r>
+            <a:endParaRPr lang="en-US" sz="1300" dirty="0"/>
+          </a:p>
+        </p:txBody>
+      </p:sp>
+      <p:sp>
+        <p:nvSpPr>
+          <p:cNvPr id="27" name="barra-92"/>
           <p:cNvSpPr/>
           <p:nvPr/>
         </p:nvSpPr>
         <p:spPr>
           <a:xfrm>
-            <a:off x="4389120" y="2880360"/>
-            <a:ext cx="7223760" cy="502920"/>
+            <a:off x="7525512" y="3319272"/>
+            <a:ext cx="512064" cy="210312"/>
+          </a:xfrm>
+          <a:prstGeom prst="roundRect">
+            <a:avLst>
+              <a:gd name="adj" fmla="val 26087"/>
+            </a:avLst>
+          </a:prstGeom>
+          <a:solidFill>
+            <a:schemeClr val="accent1"/>
+          </a:solidFill>
+          <a:ln/>
+        </p:spPr>
+      </p:sp>
+      <p:sp>
+        <p:nvSpPr>
+          <p:cNvPr id="28" name="fila-93"/>
+          <p:cNvSpPr/>
+          <p:nvPr/>
+        </p:nvSpPr>
+        <p:spPr>
+          <a:xfrm>
+            <a:off x="4343400" y="3639312"/>
+            <a:ext cx="7242048" cy="429768"/>
           </a:xfrm>
           <a:prstGeom prst="rect">
             <a:avLst/>
@@ -4502,14 +4897,14 @@
       </p:sp>
       <p:sp>
         <p:nvSpPr>
-          <p:cNvPr id="21" name="Text 19"/>
+          <p:cNvPr id="29" name="Text 27"/>
           <p:cNvSpPr txBox="1"/>
           <p:nvPr/>
         </p:nvSpPr>
         <p:spPr>
           <a:xfrm>
-            <a:off x="4480560" y="2880360"/>
-            <a:ext cx="2240280" cy="502920"/>
+            <a:off x="4416552" y="3639312"/>
+            <a:ext cx="2514600" cy="429768"/>
           </a:xfrm>
           <a:prstGeom prst="rect">
             <a:avLst/>
@@ -4525,7 +4920,7 @@
               <a:buNone/>
             </a:pPr>
             <a:r>
-              <a:rPr lang="en-US" sz="1400" dirty="0">
+              <a:rPr lang="en-US" sz="1300" dirty="0">
                 <a:solidFill>
                   <a:schemeClr val="tx1"/>
                 </a:solidFill>
@@ -4533,44 +4928,44 @@
                 <a:ea typeface="Calibri" pitchFamily="34" charset="-122"/>
                 <a:cs typeface="Calibri" pitchFamily="34" charset="-120"/>
               </a:rPr>
-              <a:t>Inc. 2: carrito</a:t>
-            </a:r>
-            <a:endParaRPr lang="en-US" sz="1400" dirty="0"/>
-          </a:p>
-        </p:txBody>
-      </p:sp>
-      <p:sp>
-        <p:nvSpPr>
-          <p:cNvPr id="22" name="barra-91"/>
+              <a:t>Pruebas y publicación</a:t>
+            </a:r>
+            <a:endParaRPr lang="en-US" sz="1300" dirty="0"/>
+          </a:p>
+        </p:txBody>
+      </p:sp>
+      <p:sp>
+        <p:nvSpPr>
+          <p:cNvPr id="30" name="barra-94"/>
           <p:cNvSpPr/>
           <p:nvPr/>
         </p:nvSpPr>
         <p:spPr>
           <a:xfrm>
-            <a:off x="8411566" y="2999232"/>
-            <a:ext cx="727862" cy="265176"/>
+            <a:off x="7525512" y="3749040"/>
+            <a:ext cx="512064" cy="210312"/>
           </a:xfrm>
           <a:prstGeom prst="roundRect">
             <a:avLst>
-              <a:gd name="adj" fmla="val 24138"/>
+              <a:gd name="adj" fmla="val 26087"/>
             </a:avLst>
           </a:prstGeom>
           <a:solidFill>
-            <a:schemeClr val="accent1"/>
+            <a:schemeClr val="accent2"/>
           </a:solidFill>
           <a:ln/>
         </p:spPr>
       </p:sp>
       <p:sp>
         <p:nvSpPr>
-          <p:cNvPr id="23" name="Text 21"/>
+          <p:cNvPr id="31" name="Text 29"/>
           <p:cNvSpPr txBox="1"/>
           <p:nvPr/>
         </p:nvSpPr>
         <p:spPr>
           <a:xfrm>
-            <a:off x="4480560" y="3383280"/>
-            <a:ext cx="2240280" cy="502920"/>
+            <a:off x="4416552" y="4069080"/>
+            <a:ext cx="2514600" cy="429768"/>
           </a:xfrm>
           <a:prstGeom prst="rect">
             <a:avLst/>
@@ -4586,7 +4981,7 @@
               <a:buNone/>
             </a:pPr>
             <a:r>
-              <a:rPr lang="en-US" sz="1400" dirty="0">
+              <a:rPr lang="en-US" sz="1300" dirty="0">
                 <a:solidFill>
                   <a:schemeClr val="tx1"/>
                 </a:solidFill>
@@ -4594,44 +4989,44 @@
                 <a:ea typeface="Calibri" pitchFamily="34" charset="-122"/>
                 <a:cs typeface="Calibri" pitchFamily="34" charset="-120"/>
               </a:rPr>
-              <a:t>Inc. 3: recibo y WhatsApp</a:t>
-            </a:r>
-            <a:endParaRPr lang="en-US" sz="1400" dirty="0"/>
-          </a:p>
-        </p:txBody>
-      </p:sp>
-      <p:sp>
-        <p:nvSpPr>
-          <p:cNvPr id="24" name="barra-92"/>
+              <a:t>Validación con el negocio</a:t>
+            </a:r>
+            <a:endParaRPr lang="en-US" sz="1300" dirty="0"/>
+          </a:p>
+        </p:txBody>
+      </p:sp>
+      <p:sp>
+        <p:nvSpPr>
+          <p:cNvPr id="32" name="barra-95"/>
           <p:cNvSpPr/>
           <p:nvPr/>
         </p:nvSpPr>
         <p:spPr>
           <a:xfrm>
-            <a:off x="9096451" y="3502152"/>
-            <a:ext cx="727862" cy="265176"/>
+            <a:off x="8110728" y="4178808"/>
+            <a:ext cx="512064" cy="210312"/>
           </a:xfrm>
           <a:prstGeom prst="roundRect">
             <a:avLst>
-              <a:gd name="adj" fmla="val 24138"/>
+              <a:gd name="adj" fmla="val 26087"/>
             </a:avLst>
           </a:prstGeom>
           <a:solidFill>
-            <a:schemeClr val="accent1"/>
+            <a:schemeClr val="tx2"/>
           </a:solidFill>
           <a:ln/>
         </p:spPr>
       </p:sp>
       <p:sp>
         <p:nvSpPr>
-          <p:cNvPr id="25" name="fila-93"/>
+          <p:cNvPr id="33" name="fila-96"/>
           <p:cNvSpPr/>
           <p:nvPr/>
         </p:nvSpPr>
         <p:spPr>
           <a:xfrm>
-            <a:off x="4389120" y="3886200"/>
-            <a:ext cx="7223760" cy="502920"/>
+            <a:off x="4343400" y="4498848"/>
+            <a:ext cx="7242048" cy="429768"/>
           </a:xfrm>
           <a:prstGeom prst="rect">
             <a:avLst/>
@@ -4644,14 +5039,14 @@
       </p:sp>
       <p:sp>
         <p:nvSpPr>
-          <p:cNvPr id="26" name="Text 24"/>
+          <p:cNvPr id="34" name="Text 32"/>
           <p:cNvSpPr txBox="1"/>
           <p:nvPr/>
         </p:nvSpPr>
         <p:spPr>
           <a:xfrm>
-            <a:off x="4480560" y="3886200"/>
-            <a:ext cx="2240280" cy="502920"/>
+            <a:off x="4416552" y="4498848"/>
+            <a:ext cx="2514600" cy="429768"/>
           </a:xfrm>
           <a:prstGeom prst="rect">
             <a:avLst/>
@@ -4667,7 +5062,7 @@
               <a:buNone/>
             </a:pPr>
             <a:r>
-              <a:rPr lang="en-US" sz="1400" dirty="0">
+              <a:rPr lang="en-US" sz="1300" dirty="0">
                 <a:solidFill>
                   <a:schemeClr val="tx1"/>
                 </a:solidFill>
@@ -4675,44 +5070,44 @@
                 <a:ea typeface="Calibri" pitchFamily="34" charset="-122"/>
                 <a:cs typeface="Calibri" pitchFamily="34" charset="-120"/>
               </a:rPr>
-              <a:t>Inc. 4: backend y planilla</a:t>
-            </a:r>
-            <a:endParaRPr lang="en-US" sz="1400" dirty="0"/>
-          </a:p>
-        </p:txBody>
-      </p:sp>
-      <p:sp>
-        <p:nvSpPr>
-          <p:cNvPr id="27" name="barra-94"/>
+              <a:t>Evaluación y documentos</a:t>
+            </a:r>
+            <a:endParaRPr lang="en-US" sz="1300" dirty="0"/>
+          </a:p>
+        </p:txBody>
+      </p:sp>
+      <p:sp>
+        <p:nvSpPr>
+          <p:cNvPr id="35" name="barra-97"/>
           <p:cNvSpPr/>
           <p:nvPr/>
         </p:nvSpPr>
         <p:spPr>
           <a:xfrm>
-            <a:off x="9683496" y="4005072"/>
-            <a:ext cx="874624" cy="265176"/>
+            <a:off x="8110728" y="4608576"/>
+            <a:ext cx="1097280" cy="210312"/>
           </a:xfrm>
           <a:prstGeom prst="roundRect">
             <a:avLst>
-              <a:gd name="adj" fmla="val 24138"/>
+              <a:gd name="adj" fmla="val 26087"/>
             </a:avLst>
           </a:prstGeom>
           <a:solidFill>
-            <a:schemeClr val="accent1"/>
+            <a:schemeClr val="tx2"/>
           </a:solidFill>
           <a:ln/>
         </p:spPr>
       </p:sp>
       <p:sp>
         <p:nvSpPr>
-          <p:cNvPr id="28" name="Text 26"/>
+          <p:cNvPr id="36" name="Text 34"/>
           <p:cNvSpPr txBox="1"/>
           <p:nvPr/>
         </p:nvSpPr>
         <p:spPr>
           <a:xfrm>
-            <a:off x="4480560" y="4389120"/>
-            <a:ext cx="2240280" cy="502920"/>
+            <a:off x="4416552" y="4928616"/>
+            <a:ext cx="2514600" cy="429768"/>
           </a:xfrm>
           <a:prstGeom prst="rect">
             <a:avLst/>
@@ -4728,7 +5123,7 @@
               <a:buNone/>
             </a:pPr>
             <a:r>
-              <a:rPr lang="en-US" sz="1400" dirty="0">
+              <a:rPr lang="en-US" sz="1300" dirty="0">
                 <a:solidFill>
                   <a:schemeClr val="tx1"/>
                 </a:solidFill>
@@ -4736,26 +5131,26 @@
                 <a:ea typeface="Calibri" pitchFamily="34" charset="-122"/>
                 <a:cs typeface="Calibri" pitchFamily="34" charset="-120"/>
               </a:rPr>
-              <a:t>Pruebas y publicación</a:t>
-            </a:r>
-            <a:endParaRPr lang="en-US" sz="1400" dirty="0"/>
-          </a:p>
-        </p:txBody>
-      </p:sp>
-      <p:sp>
-        <p:nvSpPr>
-          <p:cNvPr id="29" name="barra-95"/>
+              <a:t>Pedido real y medición</a:t>
+            </a:r>
+            <a:endParaRPr lang="en-US" sz="1300" dirty="0"/>
+          </a:p>
+        </p:txBody>
+      </p:sp>
+      <p:sp>
+        <p:nvSpPr>
+          <p:cNvPr id="37" name="barra-98"/>
           <p:cNvSpPr/>
           <p:nvPr/>
         </p:nvSpPr>
         <p:spPr>
           <a:xfrm>
-            <a:off x="10172700" y="4507992"/>
-            <a:ext cx="1021385" cy="265176"/>
+            <a:off x="8695944" y="5038344"/>
+            <a:ext cx="2267712" cy="210312"/>
           </a:xfrm>
           <a:prstGeom prst="roundRect">
             <a:avLst>
-              <a:gd name="adj" fmla="val 24138"/>
+              <a:gd name="adj" fmla="val 26087"/>
             </a:avLst>
           </a:prstGeom>
           <a:solidFill>
@@ -4766,14 +5161,14 @@
       </p:sp>
       <p:sp>
         <p:nvSpPr>
-          <p:cNvPr id="30" name="fila-96"/>
+          <p:cNvPr id="38" name="fila-99"/>
           <p:cNvSpPr/>
           <p:nvPr/>
         </p:nvSpPr>
         <p:spPr>
           <a:xfrm>
-            <a:off x="4389120" y="4892040"/>
-            <a:ext cx="7223760" cy="502920"/>
+            <a:off x="4343400" y="5358384"/>
+            <a:ext cx="7242048" cy="429768"/>
           </a:xfrm>
           <a:prstGeom prst="rect">
             <a:avLst/>
@@ -4786,14 +5181,14 @@
       </p:sp>
       <p:sp>
         <p:nvSpPr>
-          <p:cNvPr id="31" name="Text 29"/>
+          <p:cNvPr id="39" name="Text 37"/>
           <p:cNvSpPr txBox="1"/>
           <p:nvPr/>
         </p:nvSpPr>
         <p:spPr>
           <a:xfrm>
-            <a:off x="4480560" y="4892040"/>
-            <a:ext cx="2240280" cy="502920"/>
+            <a:off x="4416552" y="5358384"/>
+            <a:ext cx="2514600" cy="429768"/>
           </a:xfrm>
           <a:prstGeom prst="rect">
             <a:avLst/>
@@ -4809,7 +5204,7 @@
               <a:buNone/>
             </a:pPr>
             <a:r>
-              <a:rPr lang="en-US" sz="1400" dirty="0">
+              <a:rPr lang="en-US" sz="1300" dirty="0">
                 <a:solidFill>
                   <a:schemeClr val="tx1"/>
                 </a:solidFill>
@@ -4817,44 +5212,44 @@
                 <a:ea typeface="Calibri" pitchFamily="34" charset="-122"/>
                 <a:cs typeface="Calibri" pitchFamily="34" charset="-120"/>
               </a:rPr>
-              <a:t>Evaluación y exposición</a:t>
-            </a:r>
-            <a:endParaRPr lang="en-US" sz="1400" dirty="0"/>
-          </a:p>
-        </p:txBody>
-      </p:sp>
-      <p:sp>
-        <p:nvSpPr>
-          <p:cNvPr id="32" name="barra-97"/>
+              <a:t>Presentación y ensayo</a:t>
+            </a:r>
+            <a:endParaRPr lang="en-US" sz="1300" dirty="0"/>
+          </a:p>
+        </p:txBody>
+      </p:sp>
+      <p:sp>
+        <p:nvSpPr>
+          <p:cNvPr id="40" name="barra-100"/>
           <p:cNvSpPr/>
           <p:nvPr/>
         </p:nvSpPr>
         <p:spPr>
           <a:xfrm>
-            <a:off x="10759745" y="5010912"/>
-            <a:ext cx="825703" cy="265176"/>
+            <a:off x="8110728" y="5468112"/>
+            <a:ext cx="2852928" cy="210312"/>
           </a:xfrm>
           <a:prstGeom prst="roundRect">
             <a:avLst>
-              <a:gd name="adj" fmla="val 24138"/>
+              <a:gd name="adj" fmla="val 26087"/>
             </a:avLst>
           </a:prstGeom>
           <a:solidFill>
-            <a:schemeClr val="tx2"/>
+            <a:schemeClr val="tx1"/>
           </a:solidFill>
           <a:ln/>
         </p:spPr>
       </p:sp>
       <p:sp>
         <p:nvSpPr>
-          <p:cNvPr id="33" name="hito-98"/>
+          <p:cNvPr id="41" name="hito-101"/>
           <p:cNvSpPr/>
           <p:nvPr/>
         </p:nvSpPr>
         <p:spPr>
           <a:xfrm>
-            <a:off x="10634472" y="1828800"/>
-            <a:ext cx="0" cy="3611880"/>
+            <a:off x="8074152" y="1874520"/>
+            <a:ext cx="0" cy="3959352"/>
           </a:xfrm>
           <a:prstGeom prst="line">
             <a:avLst/>
@@ -4870,22 +5265,22 @@
       </p:sp>
       <p:sp>
         <p:nvSpPr>
-          <p:cNvPr id="34" name="hito-99"/>
+          <p:cNvPr id="42" name="hito-102"/>
           <p:cNvSpPr/>
           <p:nvPr/>
         </p:nvSpPr>
         <p:spPr>
           <a:xfrm>
-            <a:off x="11612880" y="1828800"/>
-            <a:ext cx="0" cy="3611880"/>
+            <a:off x="11292840" y="1874520"/>
+            <a:ext cx="0" cy="3959352"/>
           </a:xfrm>
           <a:prstGeom prst="line">
             <a:avLst/>
           </a:prstGeom>
           <a:noFill/>
-          <a:ln w="15875">
+          <a:ln w="19050">
             <a:solidFill>
-              <a:srgbClr val="2B2420"/>
+              <a:schemeClr val="accent3"/>
             </a:solidFill>
             <a:prstDash val="dash"/>
           </a:ln>
@@ -4893,14 +5288,14 @@
       </p:sp>
       <p:sp>
         <p:nvSpPr>
-          <p:cNvPr id="35" name="Text 33"/>
+          <p:cNvPr id="43" name="Text 41"/>
           <p:cNvSpPr txBox="1"/>
           <p:nvPr/>
         </p:nvSpPr>
         <p:spPr>
           <a:xfrm>
-            <a:off x="8897112" y="5486400"/>
-            <a:ext cx="1691640" cy="274320"/>
+            <a:off x="8028432" y="5897880"/>
+            <a:ext cx="1737360" cy="274320"/>
           </a:xfrm>
           <a:prstGeom prst="rect">
             <a:avLst/>
@@ -4912,19 +5307,58 @@
           <a:bodyPr wrap="square" lIns="0" tIns="0" rIns="0" bIns="0" rtlCol="0" anchor="t"/>
           <a:lstStyle/>
           <a:p>
+            <a:pPr indent="0" marL="0">
+              <a:buNone/>
+            </a:pPr>
+            <a:r>
+              <a:rPr lang="en-US" sz="1200" b="1" dirty="0">
+                <a:solidFill>
+                  <a:schemeClr val="tx1"/>
+                </a:solidFill>
+                <a:latin typeface="Calibri" pitchFamily="34" charset="0"/>
+                <a:ea typeface="Calibri" pitchFamily="34" charset="-122"/>
+                <a:cs typeface="Calibri" pitchFamily="34" charset="-120"/>
+              </a:rPr>
+              <a:t>▲ Publicado 06/10</a:t>
+            </a:r>
+            <a:endParaRPr lang="en-US" sz="1200" dirty="0"/>
+          </a:p>
+        </p:txBody>
+      </p:sp>
+      <p:sp>
+        <p:nvSpPr>
+          <p:cNvPr id="44" name="Text 42"/>
+          <p:cNvSpPr txBox="1"/>
+          <p:nvPr/>
+        </p:nvSpPr>
+        <p:spPr>
+          <a:xfrm>
+            <a:off x="9966960" y="5897880"/>
+            <a:ext cx="1280160" cy="274320"/>
+          </a:xfrm>
+          <a:prstGeom prst="rect">
+            <a:avLst/>
+          </a:prstGeom>
+          <a:noFill/>
+          <a:ln/>
+        </p:spPr>
+        <p:txBody>
+          <a:bodyPr wrap="square" lIns="0" tIns="0" rIns="0" bIns="0" rtlCol="0" anchor="t"/>
+          <a:lstStyle/>
+          <a:p>
             <a:pPr algn="r" indent="0" marL="0">
               <a:buNone/>
             </a:pPr>
             <a:r>
               <a:rPr lang="en-US" sz="1200" b="1" dirty="0">
                 <a:solidFill>
-                  <a:schemeClr val="tx1"/>
-                </a:solidFill>
-                <a:latin typeface="Calibri" pitchFamily="34" charset="0"/>
-                <a:ea typeface="Calibri" pitchFamily="34" charset="-122"/>
-                <a:cs typeface="Calibri" pitchFamily="34" charset="-120"/>
-              </a:rPr>
-              <a:t>Publicado 06/10 ▲</a:t>
+                  <a:schemeClr val="accent3"/>
+                </a:solidFill>
+                <a:latin typeface="Calibri" pitchFamily="34" charset="0"/>
+                <a:ea typeface="Calibri" pitchFamily="34" charset="-122"/>
+                <a:cs typeface="Calibri" pitchFamily="34" charset="-120"/>
+              </a:rPr>
+              <a:t>Expo 13/10 ▲</a:t>
             </a:r>
             <a:endParaRPr lang="en-US" sz="1200" dirty="0"/>
           </a:p>
@@ -4932,14 +5366,14 @@
       </p:sp>
       <p:sp>
         <p:nvSpPr>
-          <p:cNvPr id="36" name="Text 34"/>
+          <p:cNvPr id="45" name="Text 43"/>
           <p:cNvSpPr txBox="1"/>
           <p:nvPr/>
         </p:nvSpPr>
         <p:spPr>
           <a:xfrm>
-            <a:off x="10424160" y="5486400"/>
-            <a:ext cx="1143000" cy="274320"/>
+            <a:off x="4343400" y="6199632"/>
+            <a:ext cx="7223760" cy="274320"/>
           </a:xfrm>
           <a:prstGeom prst="rect">
             <a:avLst/>
@@ -4951,101 +5385,21 @@
           <a:bodyPr wrap="square" lIns="0" tIns="0" rIns="0" bIns="0" rtlCol="0" anchor="t"/>
           <a:lstStyle/>
           <a:p>
-            <a:pPr algn="r" indent="0" marL="0">
-              <a:buNone/>
-            </a:pPr>
-            <a:r>
-              <a:rPr lang="en-US" sz="1200" b="1" dirty="0">
-                <a:solidFill>
-                  <a:schemeClr val="tx1"/>
-                </a:solidFill>
-                <a:latin typeface="Calibri" pitchFamily="34" charset="0"/>
-                <a:ea typeface="Calibri" pitchFamily="34" charset="-122"/>
-                <a:cs typeface="Calibri" pitchFamily="34" charset="-120"/>
-              </a:rPr>
-              <a:t>Expo 13/10 ▲</a:t>
+            <a:pPr indent="0" marL="0">
+              <a:buNone/>
+            </a:pPr>
+            <a:r>
+              <a:rPr lang="en-US" sz="1200" i="1" dirty="0">
+                <a:solidFill>
+                  <a:schemeClr val="accent4"/>
+                </a:solidFill>
+                <a:latin typeface="Calibri" pitchFamily="34" charset="0"/>
+                <a:ea typeface="Calibri" pitchFamily="34" charset="-122"/>
+                <a:cs typeface="Calibri" pitchFamily="34" charset="-120"/>
+              </a:rPr>
+              <a:t>Todas las tareas terminan el domingo 11/10.</a:t>
             </a:r>
             <a:endParaRPr lang="en-US" sz="1200" dirty="0"/>
-          </a:p>
-        </p:txBody>
-      </p:sp>
-      <p:sp>
-        <p:nvSpPr>
-          <p:cNvPr id="37" name="pendiente-100"/>
-          <p:cNvSpPr/>
-          <p:nvPr/>
-        </p:nvSpPr>
-        <p:spPr>
-          <a:xfrm>
-            <a:off x="4389120" y="5760720"/>
-            <a:ext cx="7223760" cy="411480"/>
-          </a:xfrm>
-          <a:prstGeom prst="roundRect">
-            <a:avLst>
-              <a:gd name="adj" fmla="val 22222"/>
-            </a:avLst>
-          </a:prstGeom>
-          <a:solidFill>
-            <a:srgbClr val="FFF4F2"/>
-          </a:solidFill>
-          <a:ln w="19050">
-            <a:solidFill>
-              <a:srgbClr val="E83030"/>
-            </a:solidFill>
-            <a:prstDash val="dash"/>
-          </a:ln>
-        </p:spPr>
-      </p:sp>
-      <p:sp>
-        <p:nvSpPr>
-          <p:cNvPr id="38" name="Text 36"/>
-          <p:cNvSpPr txBox="1"/>
-          <p:nvPr/>
-        </p:nvSpPr>
-        <p:spPr>
-          <a:xfrm>
-            <a:off x="4572000" y="5870448"/>
-            <a:ext cx="6858000" cy="192024"/>
-          </a:xfrm>
-          <a:prstGeom prst="rect">
-            <a:avLst/>
-          </a:prstGeom>
-          <a:noFill/>
-          <a:ln/>
-        </p:spPr>
-        <p:txBody>
-          <a:bodyPr wrap="square" lIns="0" tIns="0" rIns="0" bIns="0" rtlCol="0" anchor="ctr"/>
-          <a:lstStyle/>
-          <a:p>
-            <a:pPr indent="0" marL="0">
-              <a:buNone/>
-            </a:pPr>
-            <a:r>
-              <a:rPr lang="en-US" sz="1000" b="1" dirty="0">
-                <a:solidFill>
-                  <a:schemeClr val="accent3"/>
-                </a:solidFill>
-                <a:latin typeface="Calibri" pitchFamily="34" charset="0"/>
-                <a:ea typeface="Calibri" pitchFamily="34" charset="-122"/>
-                <a:cs typeface="Calibri" pitchFamily="34" charset="-120"/>
-              </a:rPr>
-              <a:t>PENDIENTE  </a:t>
-            </a:r>
-            <a:pPr indent="0" marL="0">
-              <a:buNone/>
-            </a:pPr>
-            <a:r>
-              <a:rPr lang="en-US" sz="1200" dirty="0">
-                <a:solidFill>
-                  <a:schemeClr val="accent3"/>
-                </a:solidFill>
-                <a:latin typeface="Calibri" pitchFamily="34" charset="0"/>
-                <a:ea typeface="Calibri" pitchFamily="34" charset="-122"/>
-                <a:cs typeface="Calibri" pitchFamily="34" charset="-120"/>
-              </a:rPr>
-              <a:t>Fechas reales de las semanas 1 a 4.</a:t>
-            </a:r>
-            <a:endParaRPr lang="en-US" sz="1400" dirty="0"/>
           </a:p>
         </p:txBody>
       </p:sp>
@@ -5219,7 +5573,7 @@
       </p:graphicFrame>
       <p:sp>
         <p:nvSpPr>
-          <p:cNvPr id="5" name="card-101"/>
+          <p:cNvPr id="5" name="card-103"/>
           <p:cNvSpPr/>
           <p:nvPr/>
         </p:nvSpPr>
@@ -5358,7 +5712,7 @@
       </p:sp>
       <p:sp>
         <p:nvSpPr>
-          <p:cNvPr id="9" name="card-102"/>
+          <p:cNvPr id="9" name="card-104"/>
           <p:cNvSpPr/>
           <p:nvPr/>
         </p:nvSpPr>
@@ -5695,7 +6049,7 @@
       </p:sp>
       <p:sp>
         <p:nvSpPr>
-          <p:cNvPr id="5" name="icono-fondo-103"/>
+          <p:cNvPr id="5" name="icono-fondo-105"/>
           <p:cNvSpPr/>
           <p:nvPr/>
         </p:nvSpPr>
@@ -5715,7 +6069,7 @@
       </p:sp>
       <p:pic>
         <p:nvPicPr>
-          <p:cNvPr id="6" name="icono-104" descr="preencoded.png">    </p:cNvPr>
+          <p:cNvPr id="6" name="icono-106" descr="preencoded.png">    </p:cNvPr>
           <p:cNvPicPr>
             <a:picLocks noChangeAspect="1"/>
           </p:cNvPicPr>
@@ -5817,7 +6171,7 @@
       </p:sp>
       <p:sp>
         <p:nvSpPr>
-          <p:cNvPr id="9" name="icono-fondo-105"/>
+          <p:cNvPr id="9" name="icono-fondo-107"/>
           <p:cNvSpPr/>
           <p:nvPr/>
         </p:nvSpPr>
@@ -5837,7 +6191,7 @@
       </p:sp>
       <p:pic>
         <p:nvPicPr>
-          <p:cNvPr id="10" name="icono-106" descr="preencoded.png">    </p:cNvPr>
+          <p:cNvPr id="10" name="icono-108" descr="preencoded.png">    </p:cNvPr>
           <p:cNvPicPr>
             <a:picLocks noChangeAspect="1"/>
           </p:cNvPicPr>
@@ -5939,7 +6293,7 @@
       </p:sp>
       <p:sp>
         <p:nvSpPr>
-          <p:cNvPr id="13" name="icono-fondo-107"/>
+          <p:cNvPr id="13" name="icono-fondo-109"/>
           <p:cNvSpPr/>
           <p:nvPr/>
         </p:nvSpPr>
@@ -5959,7 +6313,7 @@
       </p:sp>
       <p:pic>
         <p:nvPicPr>
-          <p:cNvPr id="14" name="icono-108" descr="preencoded.png">    </p:cNvPr>
+          <p:cNvPr id="14" name="icono-110" descr="preencoded.png">    </p:cNvPr>
           <p:cNvPicPr>
             <a:picLocks noChangeAspect="1"/>
           </p:cNvPicPr>
@@ -6061,7 +6415,7 @@
       </p:sp>
       <p:sp>
         <p:nvSpPr>
-          <p:cNvPr id="17" name="card-109"/>
+          <p:cNvPr id="17" name="card-111"/>
           <p:cNvSpPr/>
           <p:nvPr/>
         </p:nvSpPr>
@@ -8289,7 +8643,7 @@
       </p:sp>
       <p:sp>
         <p:nvSpPr>
-          <p:cNvPr id="6" name="card-110"/>
+          <p:cNvPr id="6" name="card-112"/>
           <p:cNvSpPr/>
           <p:nvPr/>
         </p:nvSpPr>
@@ -8389,7 +8743,7 @@
       </p:sp>
       <p:sp>
         <p:nvSpPr>
-          <p:cNvPr id="9" name="card-111"/>
+          <p:cNvPr id="9" name="card-113"/>
           <p:cNvSpPr/>
           <p:nvPr/>
         </p:nvSpPr>
@@ -8489,7 +8843,7 @@
       </p:sp>
       <p:sp>
         <p:nvSpPr>
-          <p:cNvPr id="12" name="card-112"/>
+          <p:cNvPr id="12" name="card-114"/>
           <p:cNvSpPr/>
           <p:nvPr/>
         </p:nvSpPr>
@@ -8719,7 +9073,7 @@
       </p:sp>
       <p:sp>
         <p:nvSpPr>
-          <p:cNvPr id="4" name="nodo-113"/>
+          <p:cNvPr id="4" name="nodo-115"/>
           <p:cNvSpPr/>
           <p:nvPr/>
         </p:nvSpPr>
@@ -8826,7 +9180,7 @@
       </p:sp>
       <p:sp>
         <p:nvSpPr>
-          <p:cNvPr id="7" name="nodo-114"/>
+          <p:cNvPr id="7" name="nodo-116"/>
           <p:cNvSpPr/>
           <p:nvPr/>
         </p:nvSpPr>
@@ -8894,7 +9248,7 @@
       </p:sp>
       <p:sp>
         <p:nvSpPr>
-          <p:cNvPr id="9" name="capa-115"/>
+          <p:cNvPr id="9" name="capa-117"/>
           <p:cNvSpPr/>
           <p:nvPr/>
         </p:nvSpPr>
@@ -8972,7 +9326,7 @@
       </p:sp>
       <p:sp>
         <p:nvSpPr>
-          <p:cNvPr id="11" name="capa-116"/>
+          <p:cNvPr id="11" name="capa-118"/>
           <p:cNvSpPr/>
           <p:nvPr/>
         </p:nvSpPr>
@@ -9050,7 +9404,7 @@
       </p:sp>
       <p:sp>
         <p:nvSpPr>
-          <p:cNvPr id="13" name="capa-117"/>
+          <p:cNvPr id="13" name="capa-119"/>
           <p:cNvSpPr/>
           <p:nvPr/>
         </p:nvSpPr>
@@ -9128,7 +9482,7 @@
       </p:sp>
       <p:sp>
         <p:nvSpPr>
-          <p:cNvPr id="15" name="nodo-118"/>
+          <p:cNvPr id="15" name="nodo-120"/>
           <p:cNvSpPr/>
           <p:nvPr/>
         </p:nvSpPr>
@@ -9235,7 +9589,7 @@
       </p:sp>
       <p:sp>
         <p:nvSpPr>
-          <p:cNvPr id="18" name="nodo-119"/>
+          <p:cNvPr id="18" name="nodo-121"/>
           <p:cNvSpPr/>
           <p:nvPr/>
         </p:nvSpPr>
@@ -9342,7 +9696,7 @@
       </p:sp>
       <p:sp>
         <p:nvSpPr>
-          <p:cNvPr id="21" name="nodo-120"/>
+          <p:cNvPr id="21" name="nodo-122"/>
           <p:cNvSpPr/>
           <p:nvPr/>
         </p:nvSpPr>
@@ -9410,7 +9764,7 @@
       </p:sp>
       <p:sp>
         <p:nvSpPr>
-          <p:cNvPr id="23" name="nodo-121"/>
+          <p:cNvPr id="23" name="nodo-123"/>
           <p:cNvSpPr/>
           <p:nvPr/>
         </p:nvSpPr>
@@ -9478,7 +9832,7 @@
       </p:sp>
       <p:sp>
         <p:nvSpPr>
-          <p:cNvPr id="25" name="flecha-122"/>
+          <p:cNvPr id="25" name="flecha-124"/>
           <p:cNvSpPr/>
           <p:nvPr/>
         </p:nvSpPr>
@@ -9541,7 +9895,7 @@
       </p:sp>
       <p:sp>
         <p:nvSpPr>
-          <p:cNvPr id="27" name="flecha-123"/>
+          <p:cNvPr id="27" name="flecha-125"/>
           <p:cNvSpPr/>
           <p:nvPr/>
         </p:nvSpPr>
@@ -9604,7 +9958,7 @@
       </p:sp>
       <p:sp>
         <p:nvSpPr>
-          <p:cNvPr id="29" name="flecha-124"/>
+          <p:cNvPr id="29" name="flecha-126"/>
           <p:cNvSpPr/>
           <p:nvPr/>
         </p:nvSpPr>
@@ -9628,7 +9982,7 @@
       </p:sp>
       <p:sp>
         <p:nvSpPr>
-          <p:cNvPr id="30" name="flecha-125"/>
+          <p:cNvPr id="30" name="flecha-127"/>
           <p:cNvSpPr/>
           <p:nvPr/>
         </p:nvSpPr>
@@ -9691,7 +10045,7 @@
       </p:sp>
       <p:sp>
         <p:nvSpPr>
-          <p:cNvPr id="32" name="flecha-126"/>
+          <p:cNvPr id="32" name="flecha-128"/>
           <p:cNvSpPr/>
           <p:nvPr/>
         </p:nvSpPr>
@@ -9754,7 +10108,7 @@
       </p:sp>
       <p:sp>
         <p:nvSpPr>
-          <p:cNvPr id="34" name="card-127"/>
+          <p:cNvPr id="34" name="card-129"/>
           <p:cNvSpPr/>
           <p:nvPr/>
         </p:nvSpPr>
@@ -10006,7 +10360,7 @@
       </p:sp>
       <p:sp>
         <p:nvSpPr>
-          <p:cNvPr id="5" name="card-128"/>
+          <p:cNvPr id="5" name="card-130"/>
           <p:cNvSpPr/>
           <p:nvPr/>
         </p:nvSpPr>
@@ -10084,7 +10438,7 @@
       </p:sp>
       <p:sp>
         <p:nvSpPr>
-          <p:cNvPr id="7" name="card-129"/>
+          <p:cNvPr id="7" name="card-131"/>
           <p:cNvSpPr/>
           <p:nvPr/>
         </p:nvSpPr>
@@ -10162,7 +10516,7 @@
       </p:sp>
       <p:sp>
         <p:nvSpPr>
-          <p:cNvPr id="9" name="card-130"/>
+          <p:cNvPr id="9" name="card-132"/>
           <p:cNvSpPr/>
           <p:nvPr/>
         </p:nvSpPr>
@@ -10240,7 +10594,7 @@
       </p:sp>
       <p:sp>
         <p:nvSpPr>
-          <p:cNvPr id="11" name="card-131"/>
+          <p:cNvPr id="11" name="card-133"/>
           <p:cNvSpPr/>
           <p:nvPr/>
         </p:nvSpPr>
@@ -10318,7 +10672,7 @@
       </p:sp>
       <p:sp>
         <p:nvSpPr>
-          <p:cNvPr id="13" name="card-132"/>
+          <p:cNvPr id="13" name="card-134"/>
           <p:cNvSpPr/>
           <p:nvPr/>
         </p:nvSpPr>
@@ -10396,7 +10750,7 @@
       </p:sp>
       <p:sp>
         <p:nvSpPr>
-          <p:cNvPr id="15" name="card-133"/>
+          <p:cNvPr id="15" name="card-135"/>
           <p:cNvSpPr/>
           <p:nvPr/>
         </p:nvSpPr>
@@ -10552,7 +10906,7 @@
       </p:sp>
       <p:sp>
         <p:nvSpPr>
-          <p:cNvPr id="19" name="etiqueta-134"/>
+          <p:cNvPr id="19" name="etiqueta-136"/>
           <p:cNvSpPr/>
           <p:nvPr/>
         </p:nvSpPr>
@@ -10613,7 +10967,7 @@
       </p:sp>
       <p:sp>
         <p:nvSpPr>
-          <p:cNvPr id="21" name="etiqueta-135"/>
+          <p:cNvPr id="21" name="etiqueta-137"/>
           <p:cNvSpPr/>
           <p:nvPr/>
         </p:nvSpPr>
@@ -10674,7 +11028,7 @@
       </p:sp>
       <p:sp>
         <p:nvSpPr>
-          <p:cNvPr id="23" name="etiqueta-136"/>
+          <p:cNvPr id="23" name="etiqueta-138"/>
           <p:cNvSpPr/>
           <p:nvPr/>
         </p:nvSpPr>
@@ -10735,7 +11089,7 @@
       </p:sp>
       <p:sp>
         <p:nvSpPr>
-          <p:cNvPr id="25" name="etiqueta-137"/>
+          <p:cNvPr id="25" name="etiqueta-139"/>
           <p:cNvSpPr/>
           <p:nvPr/>
         </p:nvSpPr>
@@ -10796,7 +11150,7 @@
       </p:sp>
       <p:sp>
         <p:nvSpPr>
-          <p:cNvPr id="27" name="etiqueta-138"/>
+          <p:cNvPr id="27" name="etiqueta-140"/>
           <p:cNvSpPr/>
           <p:nvPr/>
         </p:nvSpPr>
@@ -10857,7 +11211,7 @@
       </p:sp>
       <p:sp>
         <p:nvSpPr>
-          <p:cNvPr id="29" name="etiqueta-139"/>
+          <p:cNvPr id="29" name="etiqueta-141"/>
           <p:cNvSpPr/>
           <p:nvPr/>
         </p:nvSpPr>
@@ -10918,7 +11272,7 @@
       </p:sp>
       <p:sp>
         <p:nvSpPr>
-          <p:cNvPr id="31" name="etiqueta-140"/>
+          <p:cNvPr id="31" name="etiqueta-142"/>
           <p:cNvSpPr/>
           <p:nvPr/>
         </p:nvSpPr>
@@ -10979,7 +11333,7 @@
       </p:sp>
       <p:sp>
         <p:nvSpPr>
-          <p:cNvPr id="33" name="etiqueta-141"/>
+          <p:cNvPr id="33" name="etiqueta-143"/>
           <p:cNvSpPr/>
           <p:nvPr/>
         </p:nvSpPr>
@@ -11040,7 +11394,7 @@
       </p:sp>
       <p:sp>
         <p:nvSpPr>
-          <p:cNvPr id="35" name="card-142"/>
+          <p:cNvPr id="35" name="card-144"/>
           <p:cNvSpPr/>
           <p:nvPr/>
         </p:nvSpPr>
@@ -11292,7 +11646,7 @@
       </p:sp>
       <p:sp>
         <p:nvSpPr>
-          <p:cNvPr id="4" name="icono-fondo-143"/>
+          <p:cNvPr id="4" name="icono-fondo-145"/>
           <p:cNvSpPr/>
           <p:nvPr/>
         </p:nvSpPr>
@@ -11312,7 +11666,7 @@
       </p:sp>
       <p:pic>
         <p:nvPicPr>
-          <p:cNvPr id="5" name="icono-144" descr="preencoded.png">    </p:cNvPr>
+          <p:cNvPr id="5" name="icono-146" descr="preencoded.png">    </p:cNvPr>
           <p:cNvPicPr>
             <a:picLocks noChangeAspect="1"/>
           </p:cNvPicPr>
@@ -11414,7 +11768,7 @@
       </p:sp>
       <p:pic>
         <p:nvPicPr>
-          <p:cNvPr id="8" name="flecha-145" descr="preencoded.png">    </p:cNvPr>
+          <p:cNvPr id="8" name="flecha-147" descr="preencoded.png">    </p:cNvPr>
           <p:cNvPicPr>
             <a:picLocks noChangeAspect="1"/>
           </p:cNvPicPr>
@@ -11438,7 +11792,7 @@
       </p:pic>
       <p:sp>
         <p:nvSpPr>
-          <p:cNvPr id="9" name="icono-fondo-146"/>
+          <p:cNvPr id="9" name="icono-fondo-148"/>
           <p:cNvSpPr/>
           <p:nvPr/>
         </p:nvSpPr>
@@ -11458,7 +11812,7 @@
       </p:sp>
       <p:pic>
         <p:nvPicPr>
-          <p:cNvPr id="10" name="icono-147" descr="preencoded.png">    </p:cNvPr>
+          <p:cNvPr id="10" name="icono-149" descr="preencoded.png">    </p:cNvPr>
           <p:cNvPicPr>
             <a:picLocks noChangeAspect="1"/>
           </p:cNvPicPr>
@@ -11560,7 +11914,7 @@
       </p:sp>
       <p:pic>
         <p:nvPicPr>
-          <p:cNvPr id="13" name="flecha-148" descr="preencoded.png">    </p:cNvPr>
+          <p:cNvPr id="13" name="flecha-150" descr="preencoded.png">    </p:cNvPr>
           <p:cNvPicPr>
             <a:picLocks noChangeAspect="1"/>
           </p:cNvPicPr>
@@ -11584,7 +11938,7 @@
       </p:pic>
       <p:sp>
         <p:nvSpPr>
-          <p:cNvPr id="14" name="icono-fondo-149"/>
+          <p:cNvPr id="14" name="icono-fondo-151"/>
           <p:cNvSpPr/>
           <p:nvPr/>
         </p:nvSpPr>
@@ -11604,7 +11958,7 @@
       </p:sp>
       <p:pic>
         <p:nvPicPr>
-          <p:cNvPr id="15" name="icono-150" descr="preencoded.png">    </p:cNvPr>
+          <p:cNvPr id="15" name="icono-152" descr="preencoded.png">    </p:cNvPr>
           <p:cNvPicPr>
             <a:picLocks noChangeAspect="1"/>
           </p:cNvPicPr>
@@ -11706,7 +12060,7 @@
       </p:sp>
       <p:pic>
         <p:nvPicPr>
-          <p:cNvPr id="18" name="flecha-151" descr="preencoded.png">    </p:cNvPr>
+          <p:cNvPr id="18" name="flecha-153" descr="preencoded.png">    </p:cNvPr>
           <p:cNvPicPr>
             <a:picLocks noChangeAspect="1"/>
           </p:cNvPicPr>
@@ -11730,7 +12084,7 @@
       </p:pic>
       <p:sp>
         <p:nvSpPr>
-          <p:cNvPr id="19" name="icono-fondo-152"/>
+          <p:cNvPr id="19" name="icono-fondo-154"/>
           <p:cNvSpPr/>
           <p:nvPr/>
         </p:nvSpPr>
@@ -11750,7 +12104,7 @@
       </p:sp>
       <p:pic>
         <p:nvPicPr>
-          <p:cNvPr id="20" name="icono-153" descr="preencoded.png">    </p:cNvPr>
+          <p:cNvPr id="20" name="icono-155" descr="preencoded.png">    </p:cNvPr>
           <p:cNvPicPr>
             <a:picLocks noChangeAspect="1"/>
           </p:cNvPicPr>
@@ -11852,7 +12206,7 @@
       </p:sp>
       <p:sp>
         <p:nvSpPr>
-          <p:cNvPr id="23" name="card-154"/>
+          <p:cNvPr id="23" name="card-156"/>
           <p:cNvSpPr/>
           <p:nvPr/>
         </p:nvSpPr>
@@ -11913,7 +12267,7 @@
       </p:sp>
       <p:sp>
         <p:nvSpPr>
-          <p:cNvPr id="25" name="card-155"/>
+          <p:cNvPr id="25" name="card-157"/>
           <p:cNvSpPr/>
           <p:nvPr/>
         </p:nvSpPr>
@@ -12013,7 +12367,7 @@
       </p:sp>
       <p:sp>
         <p:nvSpPr>
-          <p:cNvPr id="28" name="card-156"/>
+          <p:cNvPr id="28" name="card-158"/>
           <p:cNvSpPr/>
           <p:nvPr/>
         </p:nvSpPr>
@@ -12113,7 +12467,7 @@
       </p:sp>
       <p:sp>
         <p:nvSpPr>
-          <p:cNvPr id="31" name="card-157"/>
+          <p:cNvPr id="31" name="card-159"/>
           <p:cNvSpPr/>
           <p:nvPr/>
         </p:nvSpPr>
@@ -12213,7 +12567,7 @@
       </p:sp>
       <p:sp>
         <p:nvSpPr>
-          <p:cNvPr id="34" name="marco-celular-158"/>
+          <p:cNvPr id="34" name="marco-celular-160"/>
           <p:cNvSpPr/>
           <p:nvPr/>
         </p:nvSpPr>
@@ -12235,7 +12589,7 @@
       </p:sp>
       <p:pic>
         <p:nvPicPr>
-          <p:cNvPr id="35" name="captura-159" descr="/home/claude/danypizzas/docs/capturas/01-movil-inicio.png">    </p:cNvPr>
+          <p:cNvPr id="35" name="captura-161" descr="/home/claude/danypizzas/docs/capturas/01-movil-inicio.png">    </p:cNvPr>
           <p:cNvPicPr>
             <a:picLocks noChangeAspect="1"/>
           </p:cNvPicPr>
@@ -12258,7 +12612,7 @@
       </p:pic>
       <p:sp>
         <p:nvSpPr>
-          <p:cNvPr id="36" name="marco-celular-160"/>
+          <p:cNvPr id="36" name="marco-celular-162"/>
           <p:cNvSpPr/>
           <p:nvPr/>
         </p:nvSpPr>
@@ -12280,7 +12634,7 @@
       </p:sp>
       <p:pic>
         <p:nvPicPr>
-          <p:cNvPr id="37" name="captura-161" descr="/home/claude/danypizzas/docs/capturas/03-movil-confirmacion.png">    </p:cNvPr>
+          <p:cNvPr id="37" name="captura-163" descr="/home/claude/danypizzas/docs/capturas/03-movil-confirmacion.png">    </p:cNvPr>
           <p:cNvPicPr>
             <a:picLocks noChangeAspect="1"/>
           </p:cNvPicPr>
@@ -14153,7 +14507,7 @@
       </p:sp>
       <p:sp>
         <p:nvSpPr>
-          <p:cNvPr id="6" name="pendiente-162"/>
+          <p:cNvPr id="6" name="pendiente-164"/>
           <p:cNvSpPr/>
           <p:nvPr/>
         </p:nvSpPr>
@@ -14233,7 +14587,7 @@
       </p:sp>
       <p:sp>
         <p:nvSpPr>
-          <p:cNvPr id="8" name="pendiente-163"/>
+          <p:cNvPr id="8" name="pendiente-165"/>
           <p:cNvSpPr/>
           <p:nvPr/>
         </p:nvSpPr>
@@ -14313,7 +14667,7 @@
       </p:sp>
       <p:sp>
         <p:nvSpPr>
-          <p:cNvPr id="10" name="pendiente-164"/>
+          <p:cNvPr id="10" name="pendiente-166"/>
           <p:cNvSpPr/>
           <p:nvPr/>
         </p:nvSpPr>
@@ -14393,7 +14747,7 @@
       </p:sp>
       <p:sp>
         <p:nvSpPr>
-          <p:cNvPr id="12" name="pendiente-165"/>
+          <p:cNvPr id="12" name="pendiente-167"/>
           <p:cNvSpPr/>
           <p:nvPr/>
         </p:nvSpPr>
@@ -15715,7 +16069,7 @@
       </p:graphicFrame>
       <p:sp>
         <p:nvSpPr>
-          <p:cNvPr id="5" name="card-166"/>
+          <p:cNvPr id="5" name="card-168"/>
           <p:cNvSpPr/>
           <p:nvPr/>
         </p:nvSpPr>
@@ -15942,7 +16296,7 @@
       </p:sp>
       <p:sp>
         <p:nvSpPr>
-          <p:cNvPr id="4" name="card-167"/>
+          <p:cNvPr id="4" name="card-169"/>
           <p:cNvSpPr/>
           <p:nvPr/>
         </p:nvSpPr>
@@ -15964,7 +16318,7 @@
       </p:sp>
       <p:sp>
         <p:nvSpPr>
-          <p:cNvPr id="5" name="icono-fondo-168"/>
+          <p:cNvPr id="5" name="icono-fondo-170"/>
           <p:cNvSpPr/>
           <p:nvPr/>
         </p:nvSpPr>
@@ -15984,7 +16338,7 @@
       </p:sp>
       <p:pic>
         <p:nvPicPr>
-          <p:cNvPr id="6" name="icono-169" descr="preencoded.png">    </p:cNvPr>
+          <p:cNvPr id="6" name="icono-171" descr="preencoded.png">    </p:cNvPr>
           <p:cNvPicPr>
             <a:picLocks noChangeAspect="1"/>
           </p:cNvPicPr>
@@ -16082,7 +16436,7 @@
                 <a:ea typeface="Calibri" pitchFamily="34" charset="-122"/>
                 <a:cs typeface="Calibri" pitchFamily="34" charset="-120"/>
               </a:rPr>
-              <a:t>Aprobar misión y visión</a:t>
+              <a:t>Difundir misión y valores</a:t>
             </a:r>
             <a:endParaRPr lang="en-US" sz="1800" dirty="0"/>
           </a:p>
@@ -16132,7 +16486,7 @@
       </p:sp>
       <p:sp>
         <p:nvSpPr>
-          <p:cNvPr id="9" name="card-170"/>
+          <p:cNvPr id="9" name="card-172"/>
           <p:cNvSpPr/>
           <p:nvPr/>
         </p:nvSpPr>
@@ -16154,7 +16508,7 @@
       </p:sp>
       <p:sp>
         <p:nvSpPr>
-          <p:cNvPr id="10" name="icono-fondo-171"/>
+          <p:cNvPr id="10" name="icono-fondo-173"/>
           <p:cNvSpPr/>
           <p:nvPr/>
         </p:nvSpPr>
@@ -16174,7 +16528,7 @@
       </p:sp>
       <p:pic>
         <p:nvPicPr>
-          <p:cNvPr id="11" name="icono-172" descr="preencoded.png">    </p:cNvPr>
+          <p:cNvPr id="11" name="icono-174" descr="preencoded.png">    </p:cNvPr>
           <p:cNvPicPr>
             <a:picLocks noChangeAspect="1"/>
           </p:cNvPicPr>
@@ -16322,7 +16676,7 @@
       </p:sp>
       <p:sp>
         <p:nvSpPr>
-          <p:cNvPr id="14" name="card-173"/>
+          <p:cNvPr id="14" name="card-175"/>
           <p:cNvSpPr/>
           <p:nvPr/>
         </p:nvSpPr>
@@ -16344,7 +16698,7 @@
       </p:sp>
       <p:sp>
         <p:nvSpPr>
-          <p:cNvPr id="15" name="icono-fondo-174"/>
+          <p:cNvPr id="15" name="icono-fondo-176"/>
           <p:cNvSpPr/>
           <p:nvPr/>
         </p:nvSpPr>
@@ -16364,7 +16718,7 @@
       </p:sp>
       <p:pic>
         <p:nvPicPr>
-          <p:cNvPr id="16" name="icono-175" descr="preencoded.png">    </p:cNvPr>
+          <p:cNvPr id="16" name="icono-177" descr="preencoded.png">    </p:cNvPr>
           <p:cNvPicPr>
             <a:picLocks noChangeAspect="1"/>
           </p:cNvPicPr>
@@ -19162,8 +19516,8 @@
         </p:nvSpPr>
         <p:spPr>
           <a:xfrm>
-            <a:off x="8549640" y="3840480"/>
-            <a:ext cx="2926080" cy="310896"/>
+            <a:off x="8686800" y="3840480"/>
+            <a:ext cx="2788920" cy="310896"/>
           </a:xfrm>
           <a:prstGeom prst="roundRect">
             <a:avLst>
@@ -19171,7 +19525,7 @@
             </a:avLst>
           </a:prstGeom>
           <a:solidFill>
-            <a:schemeClr val="bg1"/>
+            <a:schemeClr val="tx2"/>
           </a:solidFill>
           <a:ln/>
         </p:spPr>
@@ -19184,8 +19538,8 @@
         </p:nvSpPr>
         <p:spPr>
           <a:xfrm>
-            <a:off x="8549640" y="3840480"/>
-            <a:ext cx="2926080" cy="310896"/>
+            <a:off x="8686800" y="3840480"/>
+            <a:ext cx="2788920" cy="310896"/>
           </a:xfrm>
           <a:prstGeom prst="rect">
             <a:avLst/>
@@ -19203,13 +19557,13 @@
             <a:r>
               <a:rPr lang="en-US" sz="1100" b="1" dirty="0">
                 <a:solidFill>
-                  <a:schemeClr val="accent3"/>
-                </a:solidFill>
-                <a:latin typeface="Calibri" pitchFamily="34" charset="0"/>
-                <a:ea typeface="Calibri" pitchFamily="34" charset="-122"/>
-                <a:cs typeface="Calibri" pitchFamily="34" charset="-120"/>
-              </a:rPr>
-              <a:t>PROPUESTA · A APROBAR POR EL DUEÑO</a:t>
+                  <a:schemeClr val="bg1"/>
+                </a:solidFill>
+                <a:latin typeface="Calibri" pitchFamily="34" charset="0"/>
+                <a:ea typeface="Calibri" pitchFamily="34" charset="-122"/>
+                <a:cs typeface="Calibri" pitchFamily="34" charset="-120"/>
+              </a:rPr>
+              <a:t>APROBADAS POR EL DUEÑO · 07/10</a:t>
             </a:r>
             <a:endParaRPr lang="en-US" sz="1100" dirty="0"/>
           </a:p>
@@ -19223,8 +19577,8 @@
         </p:nvSpPr>
         <p:spPr>
           <a:xfrm>
-            <a:off x="5577840" y="4251960"/>
-            <a:ext cx="5806440" cy="1828800"/>
+            <a:off x="5577840" y="4206240"/>
+            <a:ext cx="5806440" cy="1920240"/>
           </a:xfrm>
           <a:prstGeom prst="rect">
             <a:avLst/>
@@ -19240,7 +19594,7 @@
               <a:buNone/>
             </a:pPr>
             <a:r>
-              <a:rPr lang="en-US" sz="1700" b="1" dirty="0">
+              <a:rPr lang="en-US" sz="1500" b="1" dirty="0">
                 <a:solidFill>
                   <a:schemeClr val="accent3"/>
                 </a:solidFill>
@@ -19254,7 +19608,7 @@
               <a:buNone/>
             </a:pPr>
             <a:r>
-              <a:rPr lang="en-US" sz="1700" dirty="0">
+              <a:rPr lang="en-US" sz="1500" dirty="0">
                 <a:solidFill>
                   <a:schemeClr val="tx1"/>
                 </a:solidFill>
@@ -19264,7 +19618,7 @@
               </a:rPr>
               <a:t>Llevar a las casas de Chilecito pizzas caseras y a buen precio, con un pedido simple y una atención cercana.</a:t>
             </a:r>
-            <a:endParaRPr lang="en-US" sz="1700" dirty="0"/>
+            <a:endParaRPr lang="en-US" sz="1500" dirty="0"/>
           </a:p>
           <a:p>
             <a:pPr indent="0" marL="0">
@@ -19281,14 +19635,14 @@
               </a:rPr>
               <a:t> </a:t>
             </a:r>
-            <a:endParaRPr lang="en-US" sz="1700" dirty="0"/>
+            <a:endParaRPr lang="en-US" sz="1500" dirty="0"/>
           </a:p>
           <a:p>
             <a:pPr indent="0" marL="0">
               <a:buNone/>
             </a:pPr>
             <a:r>
-              <a:rPr lang="en-US" sz="1700" b="1" dirty="0">
+              <a:rPr lang="en-US" sz="1500" b="1" dirty="0">
                 <a:solidFill>
                   <a:schemeClr val="tx2"/>
                 </a:solidFill>
@@ -19302,7 +19656,7 @@
               <a:buNone/>
             </a:pPr>
             <a:r>
-              <a:rPr lang="en-US" sz="1700" dirty="0">
+              <a:rPr lang="en-US" sz="1500" dirty="0">
                 <a:solidFill>
                   <a:schemeClr val="tx1"/>
                 </a:solidFill>
@@ -19312,7 +19666,55 @@
               </a:rPr>
               <a:t>Ser para 2028 la pizzería de envío de referencia en Chilecito, creciendo de forma ordenada y formalizándose.</a:t>
             </a:r>
-            <a:endParaRPr lang="en-US" sz="1700" dirty="0"/>
+            <a:endParaRPr lang="en-US" sz="1500" dirty="0"/>
+          </a:p>
+          <a:p>
+            <a:pPr indent="0" marL="0">
+              <a:buNone/>
+            </a:pPr>
+            <a:r>
+              <a:rPr lang="en-US" sz="600" dirty="0">
+                <a:solidFill>
+                  <a:schemeClr val="tx1"/>
+                </a:solidFill>
+                <a:latin typeface="Calibri" pitchFamily="34" charset="0"/>
+                <a:ea typeface="Calibri" pitchFamily="34" charset="-122"/>
+                <a:cs typeface="Calibri" pitchFamily="34" charset="-120"/>
+              </a:rPr>
+              <a:t> </a:t>
+            </a:r>
+            <a:endParaRPr lang="en-US" sz="1500" dirty="0"/>
+          </a:p>
+          <a:p>
+            <a:pPr indent="0" marL="0">
+              <a:buNone/>
+            </a:pPr>
+            <a:r>
+              <a:rPr lang="en-US" sz="1500" b="1" dirty="0">
+                <a:solidFill>
+                  <a:schemeClr val="tx1"/>
+                </a:solidFill>
+                <a:latin typeface="Calibri" pitchFamily="34" charset="0"/>
+                <a:ea typeface="Calibri" pitchFamily="34" charset="-122"/>
+                <a:cs typeface="Calibri" pitchFamily="34" charset="-120"/>
+              </a:rPr>
+              <a:t>Valores. </a:t>
+            </a:r>
+            <a:pPr indent="0" marL="0">
+              <a:buNone/>
+            </a:pPr>
+            <a:r>
+              <a:rPr lang="en-US" sz="1500" dirty="0">
+                <a:solidFill>
+                  <a:schemeClr val="tx1"/>
+                </a:solidFill>
+                <a:latin typeface="Calibri" pitchFamily="34" charset="0"/>
+                <a:ea typeface="Calibri" pitchFamily="34" charset="-122"/>
+                <a:cs typeface="Calibri" pitchFamily="34" charset="-120"/>
+              </a:rPr>
+              <a:t>Calidad casera · Precio justo · Trato cercano · Cumplimiento del horario.</a:t>
+            </a:r>
+            <a:endParaRPr lang="en-US" sz="1500" dirty="0"/>
           </a:p>
         </p:txBody>
       </p:sp>

</xml_diff>

<commit_message>
Gantt de dos semanas (28/09–11/10) con las 48 h del presupuesto repartidas; prompt del Gantt editable, guion, pendientes y HANDOFF actualizados
Co-Authored-By: Claude Opus 5.5 <noreply@anthropic.com>
Claude-Session: https://claude.ai/code/session_01TgHUE7MvKMHN7LYxdL7oKE
</commit_message>
<xml_diff>
--- a/docs/presentacion/DanyPizzas_Presentacion.pptx
+++ b/docs/presentacion/DanyPizzas_Presentacion.pptx
@@ -126,25 +126,25 @@
   <p:extLst>
     <p:ext uri="{521415D9-36F7-43E2-AB2F-B90AF26B5E84}">
       <p14:sectionLst xmlns:p14="http://schemas.microsoft.com/office/powerpoint/2010/main">
-        <p14:section name="Introducción" id="{ce98ef85-d3a2-192c-ad2e-937b166d682f}">
+        <p14:section name="Introducción" id="{b78d934f-615c-f4c5-96c2-df7f1a88393f}">
           <p14:sldIdLst>
             <p14:sldId id="256"/>
             <p14:sldId id="257"/>
           </p14:sldIdLst>
         </p14:section>
-        <p14:section name="I. Curriculum vitae" id="{67386510-cf01-fc37-4855-f3567a422c75}">
+        <p14:section name="I. Curriculum vitae" id="{e4a94dcd-0360-7152-87eb-b3bcd670174b}">
           <p14:sldIdLst>
             <p14:sldId id="258"/>
           </p14:sldIdLst>
         </p14:section>
-        <p14:section name="II. Memoria descriptiva" id="{9d30f5c9-130e-6457-fa43-abe9f807edab}">
+        <p14:section name="II. Memoria descriptiva" id="{3ba987fd-7d85-6ea0-b948-9c5252e1be6a}">
           <p14:sldIdLst>
             <p14:sldId id="259"/>
             <p14:sldId id="260"/>
             <p14:sldId id="261"/>
           </p14:sldIdLst>
         </p14:section>
-        <p14:section name="III. Trabajo principal" id="{fb64ec64-eaab-b2f7-2d1d-bb662dc9a08f}">
+        <p14:section name="III. Trabajo principal" id="{e6046d1e-052e-237b-3840-e02a2737e42e}">
           <p14:sldIdLst>
             <p14:sldId id="262"/>
             <p14:sldId id="263"/>
@@ -927,7 +927,7 @@
             <a:r>
               <a:rPr lang="en-US" dirty="0"/>
               <a:t>⏱ 0:40 (acumulado 6:40)
-El alcance es deliberadamente chico: lo mínimo que resuelve el problema. El pago en línea o una app quedan para una versión 2. El plan entra en una semana: el lunes 5 y el martes 6 hice el análisis y los cuatro incrementos cortos, con un tablero Kanban y mostrando cada avance a la familia; el sitio se publicó el martes 6. El miércoles validé el análisis con el negocio, y hasta el domingo 11 quedan la evaluación, el pedido real con la medición de uso y el ensayo. Todo termina antes de la exposición del 13.</a:t>
+El alcance es deliberadamente chico: lo mínimo que resuelve el problema. El pago en línea o una app quedan para una versión 2. El proyecto llevó dos semanas y 48 horas de trabajo. La primera semana fue de planificación: el Beat Chart con el enfoque y el método, el cuestionario al negocio, el diseño y un prototipo de la carta. La segunda fue de construcción, en incrementos cortos con un tablero Kanban y mostrando cada avance a la familia: el sitio se publicó el martes 6, el 7 validé el análisis con el negocio, y hasta el domingo 11 quedan el pedido real con la medición de uso y el ensayo. Todo termina antes de la exposición del 13.</a:t>
             </a:r>
             <a:endParaRPr lang="en-US" dirty="0"/>
           </a:p>
@@ -4151,8 +4151,8 @@
         </p:nvSpPr>
         <p:spPr>
           <a:xfrm>
-            <a:off x="6903720" y="1417320"/>
-            <a:ext cx="585216" cy="457200"/>
+            <a:off x="6830568" y="1417320"/>
+            <a:ext cx="2176272" cy="228600"/>
           </a:xfrm>
           <a:prstGeom prst="rect">
             <a:avLst/>
@@ -4168,7 +4168,7 @@
               <a:buNone/>
             </a:pPr>
             <a:r>
-              <a:rPr lang="en-US" sz="1100" b="1" dirty="0">
+              <a:rPr lang="en-US" sz="1000" b="1" dirty="0">
                 <a:solidFill>
                   <a:schemeClr val="accent4"/>
                 </a:solidFill>
@@ -4176,26 +4176,9 @@
                 <a:ea typeface="Calibri" pitchFamily="34" charset="-122"/>
                 <a:cs typeface="Calibri" pitchFamily="34" charset="-120"/>
               </a:rPr>
-              <a:t>Lun</a:t>
-            </a:r>
-            <a:endParaRPr lang="en-US" sz="1100" dirty="0"/>
-          </a:p>
-          <a:p>
-            <a:pPr algn="ctr" indent="0" marL="0">
-              <a:buNone/>
-            </a:pPr>
-            <a:r>
-              <a:rPr lang="en-US" sz="1100" b="1" dirty="0">
-                <a:solidFill>
-                  <a:schemeClr val="accent4"/>
-                </a:solidFill>
-                <a:latin typeface="Calibri" pitchFamily="34" charset="0"/>
-                <a:ea typeface="Calibri" pitchFamily="34" charset="-122"/>
-                <a:cs typeface="Calibri" pitchFamily="34" charset="-120"/>
-              </a:rPr>
-              <a:t>05</a:t>
-            </a:r>
-            <a:endParaRPr lang="en-US" sz="1100" dirty="0"/>
+              <a:t>Semana 1 · 28/09–04/10</a:t>
+            </a:r>
+            <a:endParaRPr lang="en-US" sz="1000" dirty="0"/>
           </a:p>
         </p:txBody>
       </p:sp>
@@ -4207,8 +4190,8 @@
         </p:nvSpPr>
         <p:spPr>
           <a:xfrm>
-            <a:off x="7488936" y="1417320"/>
-            <a:ext cx="585216" cy="457200"/>
+            <a:off x="9006840" y="1417320"/>
+            <a:ext cx="2176272" cy="228600"/>
           </a:xfrm>
           <a:prstGeom prst="rect">
             <a:avLst/>
@@ -4224,7 +4207,7 @@
               <a:buNone/>
             </a:pPr>
             <a:r>
-              <a:rPr lang="en-US" sz="1100" b="1" dirty="0">
+              <a:rPr lang="en-US" sz="1000" b="1" dirty="0">
                 <a:solidFill>
                   <a:schemeClr val="accent4"/>
                 </a:solidFill>
@@ -4232,26 +4215,9 @@
                 <a:ea typeface="Calibri" pitchFamily="34" charset="-122"/>
                 <a:cs typeface="Calibri" pitchFamily="34" charset="-120"/>
               </a:rPr>
-              <a:t>Mar</a:t>
-            </a:r>
-            <a:endParaRPr lang="en-US" sz="1100" dirty="0"/>
-          </a:p>
-          <a:p>
-            <a:pPr algn="ctr" indent="0" marL="0">
-              <a:buNone/>
-            </a:pPr>
-            <a:r>
-              <a:rPr lang="en-US" sz="1100" b="1" dirty="0">
-                <a:solidFill>
-                  <a:schemeClr val="accent4"/>
-                </a:solidFill>
-                <a:latin typeface="Calibri" pitchFamily="34" charset="0"/>
-                <a:ea typeface="Calibri" pitchFamily="34" charset="-122"/>
-                <a:cs typeface="Calibri" pitchFamily="34" charset="-120"/>
-              </a:rPr>
-              <a:t>06</a:t>
-            </a:r>
-            <a:endParaRPr lang="en-US" sz="1100" dirty="0"/>
+              <a:t>Semana 2 · 05/10–11/10</a:t>
+            </a:r>
+            <a:endParaRPr lang="en-US" sz="1000" dirty="0"/>
           </a:p>
         </p:txBody>
       </p:sp>
@@ -4263,8 +4229,8 @@
         </p:nvSpPr>
         <p:spPr>
           <a:xfrm>
-            <a:off x="8074152" y="1417320"/>
-            <a:ext cx="585216" cy="457200"/>
+            <a:off x="11183112" y="1417320"/>
+            <a:ext cx="310896" cy="228600"/>
           </a:xfrm>
           <a:prstGeom prst="rect">
             <a:avLst/>
@@ -4280,34 +4246,17 @@
               <a:buNone/>
             </a:pPr>
             <a:r>
-              <a:rPr lang="en-US" sz="1100" b="1" dirty="0">
-                <a:solidFill>
-                  <a:schemeClr val="accent4"/>
-                </a:solidFill>
-                <a:latin typeface="Calibri" pitchFamily="34" charset="0"/>
-                <a:ea typeface="Calibri" pitchFamily="34" charset="-122"/>
-                <a:cs typeface="Calibri" pitchFamily="34" charset="-120"/>
-              </a:rPr>
-              <a:t>Mié</a:t>
-            </a:r>
-            <a:endParaRPr lang="en-US" sz="1100" dirty="0"/>
-          </a:p>
-          <a:p>
-            <a:pPr algn="ctr" indent="0" marL="0">
-              <a:buNone/>
-            </a:pPr>
-            <a:r>
-              <a:rPr lang="en-US" sz="1100" b="1" dirty="0">
-                <a:solidFill>
-                  <a:schemeClr val="accent4"/>
-                </a:solidFill>
-                <a:latin typeface="Calibri" pitchFamily="34" charset="0"/>
-                <a:ea typeface="Calibri" pitchFamily="34" charset="-122"/>
-                <a:cs typeface="Calibri" pitchFamily="34" charset="-120"/>
-              </a:rPr>
-              <a:t>07</a:t>
-            </a:r>
-            <a:endParaRPr lang="en-US" sz="1100" dirty="0"/>
+              <a:rPr lang="en-US" sz="1000" b="1" dirty="0">
+                <a:solidFill>
+                  <a:schemeClr val="accent3"/>
+                </a:solidFill>
+                <a:latin typeface="Calibri" pitchFamily="34" charset="0"/>
+                <a:ea typeface="Calibri" pitchFamily="34" charset="-122"/>
+                <a:cs typeface="Calibri" pitchFamily="34" charset="-120"/>
+              </a:rPr>
+              <a:t>Expo</a:t>
+            </a:r>
+            <a:endParaRPr lang="en-US" sz="1000" dirty="0"/>
           </a:p>
         </p:txBody>
       </p:sp>
@@ -4319,8 +4268,8 @@
         </p:nvSpPr>
         <p:spPr>
           <a:xfrm>
-            <a:off x="8659368" y="1417320"/>
-            <a:ext cx="585216" cy="457200"/>
+            <a:off x="6830568" y="1645920"/>
+            <a:ext cx="310896" cy="182880"/>
           </a:xfrm>
           <a:prstGeom prst="rect">
             <a:avLst/>
@@ -4336,7 +4285,7 @@
               <a:buNone/>
             </a:pPr>
             <a:r>
-              <a:rPr lang="en-US" sz="1100" b="1" dirty="0">
+              <a:rPr lang="en-US" sz="800" dirty="0">
                 <a:solidFill>
                   <a:schemeClr val="accent4"/>
                 </a:solidFill>
@@ -4344,26 +4293,9 @@
                 <a:ea typeface="Calibri" pitchFamily="34" charset="-122"/>
                 <a:cs typeface="Calibri" pitchFamily="34" charset="-120"/>
               </a:rPr>
-              <a:t>Jue</a:t>
-            </a:r>
-            <a:endParaRPr lang="en-US" sz="1100" dirty="0"/>
-          </a:p>
-          <a:p>
-            <a:pPr algn="ctr" indent="0" marL="0">
-              <a:buNone/>
-            </a:pPr>
-            <a:r>
-              <a:rPr lang="en-US" sz="1100" b="1" dirty="0">
-                <a:solidFill>
-                  <a:schemeClr val="accent4"/>
-                </a:solidFill>
-                <a:latin typeface="Calibri" pitchFamily="34" charset="0"/>
-                <a:ea typeface="Calibri" pitchFamily="34" charset="-122"/>
-                <a:cs typeface="Calibri" pitchFamily="34" charset="-120"/>
-              </a:rPr>
-              <a:t>08</a:t>
-            </a:r>
-            <a:endParaRPr lang="en-US" sz="1100" dirty="0"/>
+              <a:t>L</a:t>
+            </a:r>
+            <a:endParaRPr lang="en-US" sz="800" dirty="0"/>
           </a:p>
         </p:txBody>
       </p:sp>
@@ -4375,8 +4307,8 @@
         </p:nvSpPr>
         <p:spPr>
           <a:xfrm>
-            <a:off x="9244584" y="1417320"/>
-            <a:ext cx="585216" cy="457200"/>
+            <a:off x="6830568" y="1810512"/>
+            <a:ext cx="310896" cy="201168"/>
           </a:xfrm>
           <a:prstGeom prst="rect">
             <a:avLst/>
@@ -4392,7 +4324,7 @@
               <a:buNone/>
             </a:pPr>
             <a:r>
-              <a:rPr lang="en-US" sz="1100" b="1" dirty="0">
+              <a:rPr lang="en-US" sz="1000" b="1" dirty="0">
                 <a:solidFill>
                   <a:schemeClr val="accent4"/>
                 </a:solidFill>
@@ -4400,26 +4332,9 @@
                 <a:ea typeface="Calibri" pitchFamily="34" charset="-122"/>
                 <a:cs typeface="Calibri" pitchFamily="34" charset="-120"/>
               </a:rPr>
-              <a:t>Vie</a:t>
-            </a:r>
-            <a:endParaRPr lang="en-US" sz="1100" dirty="0"/>
-          </a:p>
-          <a:p>
-            <a:pPr algn="ctr" indent="0" marL="0">
-              <a:buNone/>
-            </a:pPr>
-            <a:r>
-              <a:rPr lang="en-US" sz="1100" b="1" dirty="0">
-                <a:solidFill>
-                  <a:schemeClr val="accent4"/>
-                </a:solidFill>
-                <a:latin typeface="Calibri" pitchFamily="34" charset="0"/>
-                <a:ea typeface="Calibri" pitchFamily="34" charset="-122"/>
-                <a:cs typeface="Calibri" pitchFamily="34" charset="-120"/>
-              </a:rPr>
-              <a:t>09</a:t>
-            </a:r>
-            <a:endParaRPr lang="en-US" sz="1100" dirty="0"/>
+              <a:t>28</a:t>
+            </a:r>
+            <a:endParaRPr lang="en-US" sz="1000" dirty="0"/>
           </a:p>
         </p:txBody>
       </p:sp>
@@ -4431,8 +4346,8 @@
         </p:nvSpPr>
         <p:spPr>
           <a:xfrm>
-            <a:off x="9829800" y="1417320"/>
-            <a:ext cx="585216" cy="457200"/>
+            <a:off x="7141464" y="1645920"/>
+            <a:ext cx="310896" cy="182880"/>
           </a:xfrm>
           <a:prstGeom prst="rect">
             <a:avLst/>
@@ -4448,7 +4363,7 @@
               <a:buNone/>
             </a:pPr>
             <a:r>
-              <a:rPr lang="en-US" sz="1100" b="1" dirty="0">
+              <a:rPr lang="en-US" sz="800" dirty="0">
                 <a:solidFill>
                   <a:schemeClr val="accent4"/>
                 </a:solidFill>
@@ -4456,26 +4371,9 @@
                 <a:ea typeface="Calibri" pitchFamily="34" charset="-122"/>
                 <a:cs typeface="Calibri" pitchFamily="34" charset="-120"/>
               </a:rPr>
-              <a:t>Sáb</a:t>
-            </a:r>
-            <a:endParaRPr lang="en-US" sz="1100" dirty="0"/>
-          </a:p>
-          <a:p>
-            <a:pPr algn="ctr" indent="0" marL="0">
-              <a:buNone/>
-            </a:pPr>
-            <a:r>
-              <a:rPr lang="en-US" sz="1100" b="1" dirty="0">
-                <a:solidFill>
-                  <a:schemeClr val="accent4"/>
-                </a:solidFill>
-                <a:latin typeface="Calibri" pitchFamily="34" charset="0"/>
-                <a:ea typeface="Calibri" pitchFamily="34" charset="-122"/>
-                <a:cs typeface="Calibri" pitchFamily="34" charset="-120"/>
-              </a:rPr>
-              <a:t>10</a:t>
-            </a:r>
-            <a:endParaRPr lang="en-US" sz="1100" dirty="0"/>
+              <a:t>M</a:t>
+            </a:r>
+            <a:endParaRPr lang="en-US" sz="800" dirty="0"/>
           </a:p>
         </p:txBody>
       </p:sp>
@@ -4487,8 +4385,8 @@
         </p:nvSpPr>
         <p:spPr>
           <a:xfrm>
-            <a:off x="10415016" y="1417320"/>
-            <a:ext cx="585216" cy="457200"/>
+            <a:off x="7141464" y="1810512"/>
+            <a:ext cx="310896" cy="201168"/>
           </a:xfrm>
           <a:prstGeom prst="rect">
             <a:avLst/>
@@ -4504,7 +4402,7 @@
               <a:buNone/>
             </a:pPr>
             <a:r>
-              <a:rPr lang="en-US" sz="1100" b="1" dirty="0">
+              <a:rPr lang="en-US" sz="1000" b="1" dirty="0">
                 <a:solidFill>
                   <a:schemeClr val="accent4"/>
                 </a:solidFill>
@@ -4512,26 +4410,9 @@
                 <a:ea typeface="Calibri" pitchFamily="34" charset="-122"/>
                 <a:cs typeface="Calibri" pitchFamily="34" charset="-120"/>
               </a:rPr>
-              <a:t>Dom</a:t>
-            </a:r>
-            <a:endParaRPr lang="en-US" sz="1100" dirty="0"/>
-          </a:p>
-          <a:p>
-            <a:pPr algn="ctr" indent="0" marL="0">
-              <a:buNone/>
-            </a:pPr>
-            <a:r>
-              <a:rPr lang="en-US" sz="1100" b="1" dirty="0">
-                <a:solidFill>
-                  <a:schemeClr val="accent4"/>
-                </a:solidFill>
-                <a:latin typeface="Calibri" pitchFamily="34" charset="0"/>
-                <a:ea typeface="Calibri" pitchFamily="34" charset="-122"/>
-                <a:cs typeface="Calibri" pitchFamily="34" charset="-120"/>
-              </a:rPr>
-              <a:t>11</a:t>
-            </a:r>
-            <a:endParaRPr lang="en-US" sz="1100" dirty="0"/>
+              <a:t>29</a:t>
+            </a:r>
+            <a:endParaRPr lang="en-US" sz="1000" dirty="0"/>
           </a:p>
         </p:txBody>
       </p:sp>
@@ -4543,8 +4424,8 @@
         </p:nvSpPr>
         <p:spPr>
           <a:xfrm>
-            <a:off x="11000232" y="1417320"/>
-            <a:ext cx="585216" cy="457200"/>
+            <a:off x="7452360" y="1645920"/>
+            <a:ext cx="310896" cy="182880"/>
           </a:xfrm>
           <a:prstGeom prst="rect">
             <a:avLst/>
@@ -4560,7 +4441,943 @@
               <a:buNone/>
             </a:pPr>
             <a:r>
-              <a:rPr lang="en-US" sz="1100" b="1" dirty="0">
+              <a:rPr lang="en-US" sz="800" dirty="0">
+                <a:solidFill>
+                  <a:schemeClr val="accent4"/>
+                </a:solidFill>
+                <a:latin typeface="Calibri" pitchFamily="34" charset="0"/>
+                <a:ea typeface="Calibri" pitchFamily="34" charset="-122"/>
+                <a:cs typeface="Calibri" pitchFamily="34" charset="-120"/>
+              </a:rPr>
+              <a:t>M</a:t>
+            </a:r>
+            <a:endParaRPr lang="en-US" sz="800" dirty="0"/>
+          </a:p>
+        </p:txBody>
+      </p:sp>
+      <p:sp>
+        <p:nvSpPr>
+          <p:cNvPr id="18" name="Text 16"/>
+          <p:cNvSpPr txBox="1"/>
+          <p:nvPr/>
+        </p:nvSpPr>
+        <p:spPr>
+          <a:xfrm>
+            <a:off x="7452360" y="1810512"/>
+            <a:ext cx="310896" cy="201168"/>
+          </a:xfrm>
+          <a:prstGeom prst="rect">
+            <a:avLst/>
+          </a:prstGeom>
+          <a:noFill/>
+          <a:ln/>
+        </p:spPr>
+        <p:txBody>
+          <a:bodyPr wrap="square" lIns="0" tIns="0" rIns="0" bIns="0" rtlCol="0" anchor="ctr"/>
+          <a:lstStyle/>
+          <a:p>
+            <a:pPr algn="ctr" indent="0" marL="0">
+              <a:buNone/>
+            </a:pPr>
+            <a:r>
+              <a:rPr lang="en-US" sz="1000" b="1" dirty="0">
+                <a:solidFill>
+                  <a:schemeClr val="accent4"/>
+                </a:solidFill>
+                <a:latin typeface="Calibri" pitchFamily="34" charset="0"/>
+                <a:ea typeface="Calibri" pitchFamily="34" charset="-122"/>
+                <a:cs typeface="Calibri" pitchFamily="34" charset="-120"/>
+              </a:rPr>
+              <a:t>30</a:t>
+            </a:r>
+            <a:endParaRPr lang="en-US" sz="1000" dirty="0"/>
+          </a:p>
+        </p:txBody>
+      </p:sp>
+      <p:sp>
+        <p:nvSpPr>
+          <p:cNvPr id="19" name="Text 17"/>
+          <p:cNvSpPr txBox="1"/>
+          <p:nvPr/>
+        </p:nvSpPr>
+        <p:spPr>
+          <a:xfrm>
+            <a:off x="7763256" y="1645920"/>
+            <a:ext cx="310896" cy="182880"/>
+          </a:xfrm>
+          <a:prstGeom prst="rect">
+            <a:avLst/>
+          </a:prstGeom>
+          <a:noFill/>
+          <a:ln/>
+        </p:spPr>
+        <p:txBody>
+          <a:bodyPr wrap="square" lIns="0" tIns="0" rIns="0" bIns="0" rtlCol="0" anchor="ctr"/>
+          <a:lstStyle/>
+          <a:p>
+            <a:pPr algn="ctr" indent="0" marL="0">
+              <a:buNone/>
+            </a:pPr>
+            <a:r>
+              <a:rPr lang="en-US" sz="800" dirty="0">
+                <a:solidFill>
+                  <a:schemeClr val="accent4"/>
+                </a:solidFill>
+                <a:latin typeface="Calibri" pitchFamily="34" charset="0"/>
+                <a:ea typeface="Calibri" pitchFamily="34" charset="-122"/>
+                <a:cs typeface="Calibri" pitchFamily="34" charset="-120"/>
+              </a:rPr>
+              <a:t>J</a:t>
+            </a:r>
+            <a:endParaRPr lang="en-US" sz="800" dirty="0"/>
+          </a:p>
+        </p:txBody>
+      </p:sp>
+      <p:sp>
+        <p:nvSpPr>
+          <p:cNvPr id="20" name="Text 18"/>
+          <p:cNvSpPr txBox="1"/>
+          <p:nvPr/>
+        </p:nvSpPr>
+        <p:spPr>
+          <a:xfrm>
+            <a:off x="7763256" y="1810512"/>
+            <a:ext cx="310896" cy="201168"/>
+          </a:xfrm>
+          <a:prstGeom prst="rect">
+            <a:avLst/>
+          </a:prstGeom>
+          <a:noFill/>
+          <a:ln/>
+        </p:spPr>
+        <p:txBody>
+          <a:bodyPr wrap="square" lIns="0" tIns="0" rIns="0" bIns="0" rtlCol="0" anchor="ctr"/>
+          <a:lstStyle/>
+          <a:p>
+            <a:pPr algn="ctr" indent="0" marL="0">
+              <a:buNone/>
+            </a:pPr>
+            <a:r>
+              <a:rPr lang="en-US" sz="1000" b="1" dirty="0">
+                <a:solidFill>
+                  <a:schemeClr val="accent4"/>
+                </a:solidFill>
+                <a:latin typeface="Calibri" pitchFamily="34" charset="0"/>
+                <a:ea typeface="Calibri" pitchFamily="34" charset="-122"/>
+                <a:cs typeface="Calibri" pitchFamily="34" charset="-120"/>
+              </a:rPr>
+              <a:t>1</a:t>
+            </a:r>
+            <a:endParaRPr lang="en-US" sz="1000" dirty="0"/>
+          </a:p>
+        </p:txBody>
+      </p:sp>
+      <p:sp>
+        <p:nvSpPr>
+          <p:cNvPr id="21" name="Text 19"/>
+          <p:cNvSpPr txBox="1"/>
+          <p:nvPr/>
+        </p:nvSpPr>
+        <p:spPr>
+          <a:xfrm>
+            <a:off x="8074152" y="1645920"/>
+            <a:ext cx="310896" cy="182880"/>
+          </a:xfrm>
+          <a:prstGeom prst="rect">
+            <a:avLst/>
+          </a:prstGeom>
+          <a:noFill/>
+          <a:ln/>
+        </p:spPr>
+        <p:txBody>
+          <a:bodyPr wrap="square" lIns="0" tIns="0" rIns="0" bIns="0" rtlCol="0" anchor="ctr"/>
+          <a:lstStyle/>
+          <a:p>
+            <a:pPr algn="ctr" indent="0" marL="0">
+              <a:buNone/>
+            </a:pPr>
+            <a:r>
+              <a:rPr lang="en-US" sz="800" dirty="0">
+                <a:solidFill>
+                  <a:schemeClr val="accent4"/>
+                </a:solidFill>
+                <a:latin typeface="Calibri" pitchFamily="34" charset="0"/>
+                <a:ea typeface="Calibri" pitchFamily="34" charset="-122"/>
+                <a:cs typeface="Calibri" pitchFamily="34" charset="-120"/>
+              </a:rPr>
+              <a:t>V</a:t>
+            </a:r>
+            <a:endParaRPr lang="en-US" sz="800" dirty="0"/>
+          </a:p>
+        </p:txBody>
+      </p:sp>
+      <p:sp>
+        <p:nvSpPr>
+          <p:cNvPr id="22" name="Text 20"/>
+          <p:cNvSpPr txBox="1"/>
+          <p:nvPr/>
+        </p:nvSpPr>
+        <p:spPr>
+          <a:xfrm>
+            <a:off x="8074152" y="1810512"/>
+            <a:ext cx="310896" cy="201168"/>
+          </a:xfrm>
+          <a:prstGeom prst="rect">
+            <a:avLst/>
+          </a:prstGeom>
+          <a:noFill/>
+          <a:ln/>
+        </p:spPr>
+        <p:txBody>
+          <a:bodyPr wrap="square" lIns="0" tIns="0" rIns="0" bIns="0" rtlCol="0" anchor="ctr"/>
+          <a:lstStyle/>
+          <a:p>
+            <a:pPr algn="ctr" indent="0" marL="0">
+              <a:buNone/>
+            </a:pPr>
+            <a:r>
+              <a:rPr lang="en-US" sz="1000" b="1" dirty="0">
+                <a:solidFill>
+                  <a:schemeClr val="accent4"/>
+                </a:solidFill>
+                <a:latin typeface="Calibri" pitchFamily="34" charset="0"/>
+                <a:ea typeface="Calibri" pitchFamily="34" charset="-122"/>
+                <a:cs typeface="Calibri" pitchFamily="34" charset="-120"/>
+              </a:rPr>
+              <a:t>2</a:t>
+            </a:r>
+            <a:endParaRPr lang="en-US" sz="1000" dirty="0"/>
+          </a:p>
+        </p:txBody>
+      </p:sp>
+      <p:sp>
+        <p:nvSpPr>
+          <p:cNvPr id="23" name="Text 21"/>
+          <p:cNvSpPr txBox="1"/>
+          <p:nvPr/>
+        </p:nvSpPr>
+        <p:spPr>
+          <a:xfrm>
+            <a:off x="8385048" y="1645920"/>
+            <a:ext cx="310896" cy="182880"/>
+          </a:xfrm>
+          <a:prstGeom prst="rect">
+            <a:avLst/>
+          </a:prstGeom>
+          <a:noFill/>
+          <a:ln/>
+        </p:spPr>
+        <p:txBody>
+          <a:bodyPr wrap="square" lIns="0" tIns="0" rIns="0" bIns="0" rtlCol="0" anchor="ctr"/>
+          <a:lstStyle/>
+          <a:p>
+            <a:pPr algn="ctr" indent="0" marL="0">
+              <a:buNone/>
+            </a:pPr>
+            <a:r>
+              <a:rPr lang="en-US" sz="800" dirty="0">
+                <a:solidFill>
+                  <a:schemeClr val="accent4"/>
+                </a:solidFill>
+                <a:latin typeface="Calibri" pitchFamily="34" charset="0"/>
+                <a:ea typeface="Calibri" pitchFamily="34" charset="-122"/>
+                <a:cs typeface="Calibri" pitchFamily="34" charset="-120"/>
+              </a:rPr>
+              <a:t>S</a:t>
+            </a:r>
+            <a:endParaRPr lang="en-US" sz="800" dirty="0"/>
+          </a:p>
+        </p:txBody>
+      </p:sp>
+      <p:sp>
+        <p:nvSpPr>
+          <p:cNvPr id="24" name="Text 22"/>
+          <p:cNvSpPr txBox="1"/>
+          <p:nvPr/>
+        </p:nvSpPr>
+        <p:spPr>
+          <a:xfrm>
+            <a:off x="8385048" y="1810512"/>
+            <a:ext cx="310896" cy="201168"/>
+          </a:xfrm>
+          <a:prstGeom prst="rect">
+            <a:avLst/>
+          </a:prstGeom>
+          <a:noFill/>
+          <a:ln/>
+        </p:spPr>
+        <p:txBody>
+          <a:bodyPr wrap="square" lIns="0" tIns="0" rIns="0" bIns="0" rtlCol="0" anchor="ctr"/>
+          <a:lstStyle/>
+          <a:p>
+            <a:pPr algn="ctr" indent="0" marL="0">
+              <a:buNone/>
+            </a:pPr>
+            <a:r>
+              <a:rPr lang="en-US" sz="1000" b="1" dirty="0">
+                <a:solidFill>
+                  <a:schemeClr val="accent4"/>
+                </a:solidFill>
+                <a:latin typeface="Calibri" pitchFamily="34" charset="0"/>
+                <a:ea typeface="Calibri" pitchFamily="34" charset="-122"/>
+                <a:cs typeface="Calibri" pitchFamily="34" charset="-120"/>
+              </a:rPr>
+              <a:t>3</a:t>
+            </a:r>
+            <a:endParaRPr lang="en-US" sz="1000" dirty="0"/>
+          </a:p>
+        </p:txBody>
+      </p:sp>
+      <p:sp>
+        <p:nvSpPr>
+          <p:cNvPr id="25" name="Text 23"/>
+          <p:cNvSpPr txBox="1"/>
+          <p:nvPr/>
+        </p:nvSpPr>
+        <p:spPr>
+          <a:xfrm>
+            <a:off x="8695944" y="1645920"/>
+            <a:ext cx="310896" cy="182880"/>
+          </a:xfrm>
+          <a:prstGeom prst="rect">
+            <a:avLst/>
+          </a:prstGeom>
+          <a:noFill/>
+          <a:ln/>
+        </p:spPr>
+        <p:txBody>
+          <a:bodyPr wrap="square" lIns="0" tIns="0" rIns="0" bIns="0" rtlCol="0" anchor="ctr"/>
+          <a:lstStyle/>
+          <a:p>
+            <a:pPr algn="ctr" indent="0" marL="0">
+              <a:buNone/>
+            </a:pPr>
+            <a:r>
+              <a:rPr lang="en-US" sz="800" dirty="0">
+                <a:solidFill>
+                  <a:schemeClr val="accent4"/>
+                </a:solidFill>
+                <a:latin typeface="Calibri" pitchFamily="34" charset="0"/>
+                <a:ea typeface="Calibri" pitchFamily="34" charset="-122"/>
+                <a:cs typeface="Calibri" pitchFamily="34" charset="-120"/>
+              </a:rPr>
+              <a:t>D</a:t>
+            </a:r>
+            <a:endParaRPr lang="en-US" sz="800" dirty="0"/>
+          </a:p>
+        </p:txBody>
+      </p:sp>
+      <p:sp>
+        <p:nvSpPr>
+          <p:cNvPr id="26" name="Text 24"/>
+          <p:cNvSpPr txBox="1"/>
+          <p:nvPr/>
+        </p:nvSpPr>
+        <p:spPr>
+          <a:xfrm>
+            <a:off x="8695944" y="1810512"/>
+            <a:ext cx="310896" cy="201168"/>
+          </a:xfrm>
+          <a:prstGeom prst="rect">
+            <a:avLst/>
+          </a:prstGeom>
+          <a:noFill/>
+          <a:ln/>
+        </p:spPr>
+        <p:txBody>
+          <a:bodyPr wrap="square" lIns="0" tIns="0" rIns="0" bIns="0" rtlCol="0" anchor="ctr"/>
+          <a:lstStyle/>
+          <a:p>
+            <a:pPr algn="ctr" indent="0" marL="0">
+              <a:buNone/>
+            </a:pPr>
+            <a:r>
+              <a:rPr lang="en-US" sz="1000" b="1" dirty="0">
+                <a:solidFill>
+                  <a:schemeClr val="accent4"/>
+                </a:solidFill>
+                <a:latin typeface="Calibri" pitchFamily="34" charset="0"/>
+                <a:ea typeface="Calibri" pitchFamily="34" charset="-122"/>
+                <a:cs typeface="Calibri" pitchFamily="34" charset="-120"/>
+              </a:rPr>
+              <a:t>4</a:t>
+            </a:r>
+            <a:endParaRPr lang="en-US" sz="1000" dirty="0"/>
+          </a:p>
+        </p:txBody>
+      </p:sp>
+      <p:sp>
+        <p:nvSpPr>
+          <p:cNvPr id="27" name="Text 25"/>
+          <p:cNvSpPr txBox="1"/>
+          <p:nvPr/>
+        </p:nvSpPr>
+        <p:spPr>
+          <a:xfrm>
+            <a:off x="9006840" y="1645920"/>
+            <a:ext cx="310896" cy="182880"/>
+          </a:xfrm>
+          <a:prstGeom prst="rect">
+            <a:avLst/>
+          </a:prstGeom>
+          <a:noFill/>
+          <a:ln/>
+        </p:spPr>
+        <p:txBody>
+          <a:bodyPr wrap="square" lIns="0" tIns="0" rIns="0" bIns="0" rtlCol="0" anchor="ctr"/>
+          <a:lstStyle/>
+          <a:p>
+            <a:pPr algn="ctr" indent="0" marL="0">
+              <a:buNone/>
+            </a:pPr>
+            <a:r>
+              <a:rPr lang="en-US" sz="800" dirty="0">
+                <a:solidFill>
+                  <a:schemeClr val="accent4"/>
+                </a:solidFill>
+                <a:latin typeface="Calibri" pitchFamily="34" charset="0"/>
+                <a:ea typeface="Calibri" pitchFamily="34" charset="-122"/>
+                <a:cs typeface="Calibri" pitchFamily="34" charset="-120"/>
+              </a:rPr>
+              <a:t>L</a:t>
+            </a:r>
+            <a:endParaRPr lang="en-US" sz="800" dirty="0"/>
+          </a:p>
+        </p:txBody>
+      </p:sp>
+      <p:sp>
+        <p:nvSpPr>
+          <p:cNvPr id="28" name="Text 26"/>
+          <p:cNvSpPr txBox="1"/>
+          <p:nvPr/>
+        </p:nvSpPr>
+        <p:spPr>
+          <a:xfrm>
+            <a:off x="9006840" y="1810512"/>
+            <a:ext cx="310896" cy="201168"/>
+          </a:xfrm>
+          <a:prstGeom prst="rect">
+            <a:avLst/>
+          </a:prstGeom>
+          <a:noFill/>
+          <a:ln/>
+        </p:spPr>
+        <p:txBody>
+          <a:bodyPr wrap="square" lIns="0" tIns="0" rIns="0" bIns="0" rtlCol="0" anchor="ctr"/>
+          <a:lstStyle/>
+          <a:p>
+            <a:pPr algn="ctr" indent="0" marL="0">
+              <a:buNone/>
+            </a:pPr>
+            <a:r>
+              <a:rPr lang="en-US" sz="1000" b="1" dirty="0">
+                <a:solidFill>
+                  <a:schemeClr val="accent4"/>
+                </a:solidFill>
+                <a:latin typeface="Calibri" pitchFamily="34" charset="0"/>
+                <a:ea typeface="Calibri" pitchFamily="34" charset="-122"/>
+                <a:cs typeface="Calibri" pitchFamily="34" charset="-120"/>
+              </a:rPr>
+              <a:t>5</a:t>
+            </a:r>
+            <a:endParaRPr lang="en-US" sz="1000" dirty="0"/>
+          </a:p>
+        </p:txBody>
+      </p:sp>
+      <p:sp>
+        <p:nvSpPr>
+          <p:cNvPr id="29" name="Text 27"/>
+          <p:cNvSpPr txBox="1"/>
+          <p:nvPr/>
+        </p:nvSpPr>
+        <p:spPr>
+          <a:xfrm>
+            <a:off x="9317736" y="1645920"/>
+            <a:ext cx="310896" cy="182880"/>
+          </a:xfrm>
+          <a:prstGeom prst="rect">
+            <a:avLst/>
+          </a:prstGeom>
+          <a:noFill/>
+          <a:ln/>
+        </p:spPr>
+        <p:txBody>
+          <a:bodyPr wrap="square" lIns="0" tIns="0" rIns="0" bIns="0" rtlCol="0" anchor="ctr"/>
+          <a:lstStyle/>
+          <a:p>
+            <a:pPr algn="ctr" indent="0" marL="0">
+              <a:buNone/>
+            </a:pPr>
+            <a:r>
+              <a:rPr lang="en-US" sz="800" dirty="0">
+                <a:solidFill>
+                  <a:schemeClr val="accent4"/>
+                </a:solidFill>
+                <a:latin typeface="Calibri" pitchFamily="34" charset="0"/>
+                <a:ea typeface="Calibri" pitchFamily="34" charset="-122"/>
+                <a:cs typeface="Calibri" pitchFamily="34" charset="-120"/>
+              </a:rPr>
+              <a:t>M</a:t>
+            </a:r>
+            <a:endParaRPr lang="en-US" sz="800" dirty="0"/>
+          </a:p>
+        </p:txBody>
+      </p:sp>
+      <p:sp>
+        <p:nvSpPr>
+          <p:cNvPr id="30" name="Text 28"/>
+          <p:cNvSpPr txBox="1"/>
+          <p:nvPr/>
+        </p:nvSpPr>
+        <p:spPr>
+          <a:xfrm>
+            <a:off x="9317736" y="1810512"/>
+            <a:ext cx="310896" cy="201168"/>
+          </a:xfrm>
+          <a:prstGeom prst="rect">
+            <a:avLst/>
+          </a:prstGeom>
+          <a:noFill/>
+          <a:ln/>
+        </p:spPr>
+        <p:txBody>
+          <a:bodyPr wrap="square" lIns="0" tIns="0" rIns="0" bIns="0" rtlCol="0" anchor="ctr"/>
+          <a:lstStyle/>
+          <a:p>
+            <a:pPr algn="ctr" indent="0" marL="0">
+              <a:buNone/>
+            </a:pPr>
+            <a:r>
+              <a:rPr lang="en-US" sz="1000" b="1" dirty="0">
+                <a:solidFill>
+                  <a:schemeClr val="accent4"/>
+                </a:solidFill>
+                <a:latin typeface="Calibri" pitchFamily="34" charset="0"/>
+                <a:ea typeface="Calibri" pitchFamily="34" charset="-122"/>
+                <a:cs typeface="Calibri" pitchFamily="34" charset="-120"/>
+              </a:rPr>
+              <a:t>6</a:t>
+            </a:r>
+            <a:endParaRPr lang="en-US" sz="1000" dirty="0"/>
+          </a:p>
+        </p:txBody>
+      </p:sp>
+      <p:sp>
+        <p:nvSpPr>
+          <p:cNvPr id="31" name="Text 29"/>
+          <p:cNvSpPr txBox="1"/>
+          <p:nvPr/>
+        </p:nvSpPr>
+        <p:spPr>
+          <a:xfrm>
+            <a:off x="9628632" y="1645920"/>
+            <a:ext cx="310896" cy="182880"/>
+          </a:xfrm>
+          <a:prstGeom prst="rect">
+            <a:avLst/>
+          </a:prstGeom>
+          <a:noFill/>
+          <a:ln/>
+        </p:spPr>
+        <p:txBody>
+          <a:bodyPr wrap="square" lIns="0" tIns="0" rIns="0" bIns="0" rtlCol="0" anchor="ctr"/>
+          <a:lstStyle/>
+          <a:p>
+            <a:pPr algn="ctr" indent="0" marL="0">
+              <a:buNone/>
+            </a:pPr>
+            <a:r>
+              <a:rPr lang="en-US" sz="800" dirty="0">
+                <a:solidFill>
+                  <a:schemeClr val="accent4"/>
+                </a:solidFill>
+                <a:latin typeface="Calibri" pitchFamily="34" charset="0"/>
+                <a:ea typeface="Calibri" pitchFamily="34" charset="-122"/>
+                <a:cs typeface="Calibri" pitchFamily="34" charset="-120"/>
+              </a:rPr>
+              <a:t>M</a:t>
+            </a:r>
+            <a:endParaRPr lang="en-US" sz="800" dirty="0"/>
+          </a:p>
+        </p:txBody>
+      </p:sp>
+      <p:sp>
+        <p:nvSpPr>
+          <p:cNvPr id="32" name="Text 30"/>
+          <p:cNvSpPr txBox="1"/>
+          <p:nvPr/>
+        </p:nvSpPr>
+        <p:spPr>
+          <a:xfrm>
+            <a:off x="9628632" y="1810512"/>
+            <a:ext cx="310896" cy="201168"/>
+          </a:xfrm>
+          <a:prstGeom prst="rect">
+            <a:avLst/>
+          </a:prstGeom>
+          <a:noFill/>
+          <a:ln/>
+        </p:spPr>
+        <p:txBody>
+          <a:bodyPr wrap="square" lIns="0" tIns="0" rIns="0" bIns="0" rtlCol="0" anchor="ctr"/>
+          <a:lstStyle/>
+          <a:p>
+            <a:pPr algn="ctr" indent="0" marL="0">
+              <a:buNone/>
+            </a:pPr>
+            <a:r>
+              <a:rPr lang="en-US" sz="1000" b="1" dirty="0">
+                <a:solidFill>
+                  <a:schemeClr val="accent4"/>
+                </a:solidFill>
+                <a:latin typeface="Calibri" pitchFamily="34" charset="0"/>
+                <a:ea typeface="Calibri" pitchFamily="34" charset="-122"/>
+                <a:cs typeface="Calibri" pitchFamily="34" charset="-120"/>
+              </a:rPr>
+              <a:t>7</a:t>
+            </a:r>
+            <a:endParaRPr lang="en-US" sz="1000" dirty="0"/>
+          </a:p>
+        </p:txBody>
+      </p:sp>
+      <p:sp>
+        <p:nvSpPr>
+          <p:cNvPr id="33" name="Text 31"/>
+          <p:cNvSpPr txBox="1"/>
+          <p:nvPr/>
+        </p:nvSpPr>
+        <p:spPr>
+          <a:xfrm>
+            <a:off x="9939528" y="1645920"/>
+            <a:ext cx="310896" cy="182880"/>
+          </a:xfrm>
+          <a:prstGeom prst="rect">
+            <a:avLst/>
+          </a:prstGeom>
+          <a:noFill/>
+          <a:ln/>
+        </p:spPr>
+        <p:txBody>
+          <a:bodyPr wrap="square" lIns="0" tIns="0" rIns="0" bIns="0" rtlCol="0" anchor="ctr"/>
+          <a:lstStyle/>
+          <a:p>
+            <a:pPr algn="ctr" indent="0" marL="0">
+              <a:buNone/>
+            </a:pPr>
+            <a:r>
+              <a:rPr lang="en-US" sz="800" dirty="0">
+                <a:solidFill>
+                  <a:schemeClr val="accent4"/>
+                </a:solidFill>
+                <a:latin typeface="Calibri" pitchFamily="34" charset="0"/>
+                <a:ea typeface="Calibri" pitchFamily="34" charset="-122"/>
+                <a:cs typeface="Calibri" pitchFamily="34" charset="-120"/>
+              </a:rPr>
+              <a:t>J</a:t>
+            </a:r>
+            <a:endParaRPr lang="en-US" sz="800" dirty="0"/>
+          </a:p>
+        </p:txBody>
+      </p:sp>
+      <p:sp>
+        <p:nvSpPr>
+          <p:cNvPr id="34" name="Text 32"/>
+          <p:cNvSpPr txBox="1"/>
+          <p:nvPr/>
+        </p:nvSpPr>
+        <p:spPr>
+          <a:xfrm>
+            <a:off x="9939528" y="1810512"/>
+            <a:ext cx="310896" cy="201168"/>
+          </a:xfrm>
+          <a:prstGeom prst="rect">
+            <a:avLst/>
+          </a:prstGeom>
+          <a:noFill/>
+          <a:ln/>
+        </p:spPr>
+        <p:txBody>
+          <a:bodyPr wrap="square" lIns="0" tIns="0" rIns="0" bIns="0" rtlCol="0" anchor="ctr"/>
+          <a:lstStyle/>
+          <a:p>
+            <a:pPr algn="ctr" indent="0" marL="0">
+              <a:buNone/>
+            </a:pPr>
+            <a:r>
+              <a:rPr lang="en-US" sz="1000" b="1" dirty="0">
+                <a:solidFill>
+                  <a:schemeClr val="accent4"/>
+                </a:solidFill>
+                <a:latin typeface="Calibri" pitchFamily="34" charset="0"/>
+                <a:ea typeface="Calibri" pitchFamily="34" charset="-122"/>
+                <a:cs typeface="Calibri" pitchFamily="34" charset="-120"/>
+              </a:rPr>
+              <a:t>8</a:t>
+            </a:r>
+            <a:endParaRPr lang="en-US" sz="1000" dirty="0"/>
+          </a:p>
+        </p:txBody>
+      </p:sp>
+      <p:sp>
+        <p:nvSpPr>
+          <p:cNvPr id="35" name="Text 33"/>
+          <p:cNvSpPr txBox="1"/>
+          <p:nvPr/>
+        </p:nvSpPr>
+        <p:spPr>
+          <a:xfrm>
+            <a:off x="10250424" y="1645920"/>
+            <a:ext cx="310896" cy="182880"/>
+          </a:xfrm>
+          <a:prstGeom prst="rect">
+            <a:avLst/>
+          </a:prstGeom>
+          <a:noFill/>
+          <a:ln/>
+        </p:spPr>
+        <p:txBody>
+          <a:bodyPr wrap="square" lIns="0" tIns="0" rIns="0" bIns="0" rtlCol="0" anchor="ctr"/>
+          <a:lstStyle/>
+          <a:p>
+            <a:pPr algn="ctr" indent="0" marL="0">
+              <a:buNone/>
+            </a:pPr>
+            <a:r>
+              <a:rPr lang="en-US" sz="800" dirty="0">
+                <a:solidFill>
+                  <a:schemeClr val="accent4"/>
+                </a:solidFill>
+                <a:latin typeface="Calibri" pitchFamily="34" charset="0"/>
+                <a:ea typeface="Calibri" pitchFamily="34" charset="-122"/>
+                <a:cs typeface="Calibri" pitchFamily="34" charset="-120"/>
+              </a:rPr>
+              <a:t>V</a:t>
+            </a:r>
+            <a:endParaRPr lang="en-US" sz="800" dirty="0"/>
+          </a:p>
+        </p:txBody>
+      </p:sp>
+      <p:sp>
+        <p:nvSpPr>
+          <p:cNvPr id="36" name="Text 34"/>
+          <p:cNvSpPr txBox="1"/>
+          <p:nvPr/>
+        </p:nvSpPr>
+        <p:spPr>
+          <a:xfrm>
+            <a:off x="10250424" y="1810512"/>
+            <a:ext cx="310896" cy="201168"/>
+          </a:xfrm>
+          <a:prstGeom prst="rect">
+            <a:avLst/>
+          </a:prstGeom>
+          <a:noFill/>
+          <a:ln/>
+        </p:spPr>
+        <p:txBody>
+          <a:bodyPr wrap="square" lIns="0" tIns="0" rIns="0" bIns="0" rtlCol="0" anchor="ctr"/>
+          <a:lstStyle/>
+          <a:p>
+            <a:pPr algn="ctr" indent="0" marL="0">
+              <a:buNone/>
+            </a:pPr>
+            <a:r>
+              <a:rPr lang="en-US" sz="1000" b="1" dirty="0">
+                <a:solidFill>
+                  <a:schemeClr val="accent4"/>
+                </a:solidFill>
+                <a:latin typeface="Calibri" pitchFamily="34" charset="0"/>
+                <a:ea typeface="Calibri" pitchFamily="34" charset="-122"/>
+                <a:cs typeface="Calibri" pitchFamily="34" charset="-120"/>
+              </a:rPr>
+              <a:t>9</a:t>
+            </a:r>
+            <a:endParaRPr lang="en-US" sz="1000" dirty="0"/>
+          </a:p>
+        </p:txBody>
+      </p:sp>
+      <p:sp>
+        <p:nvSpPr>
+          <p:cNvPr id="37" name="Text 35"/>
+          <p:cNvSpPr txBox="1"/>
+          <p:nvPr/>
+        </p:nvSpPr>
+        <p:spPr>
+          <a:xfrm>
+            <a:off x="10561320" y="1645920"/>
+            <a:ext cx="310896" cy="182880"/>
+          </a:xfrm>
+          <a:prstGeom prst="rect">
+            <a:avLst/>
+          </a:prstGeom>
+          <a:noFill/>
+          <a:ln/>
+        </p:spPr>
+        <p:txBody>
+          <a:bodyPr wrap="square" lIns="0" tIns="0" rIns="0" bIns="0" rtlCol="0" anchor="ctr"/>
+          <a:lstStyle/>
+          <a:p>
+            <a:pPr algn="ctr" indent="0" marL="0">
+              <a:buNone/>
+            </a:pPr>
+            <a:r>
+              <a:rPr lang="en-US" sz="800" dirty="0">
+                <a:solidFill>
+                  <a:schemeClr val="accent4"/>
+                </a:solidFill>
+                <a:latin typeface="Calibri" pitchFamily="34" charset="0"/>
+                <a:ea typeface="Calibri" pitchFamily="34" charset="-122"/>
+                <a:cs typeface="Calibri" pitchFamily="34" charset="-120"/>
+              </a:rPr>
+              <a:t>S</a:t>
+            </a:r>
+            <a:endParaRPr lang="en-US" sz="800" dirty="0"/>
+          </a:p>
+        </p:txBody>
+      </p:sp>
+      <p:sp>
+        <p:nvSpPr>
+          <p:cNvPr id="38" name="Text 36"/>
+          <p:cNvSpPr txBox="1"/>
+          <p:nvPr/>
+        </p:nvSpPr>
+        <p:spPr>
+          <a:xfrm>
+            <a:off x="10561320" y="1810512"/>
+            <a:ext cx="310896" cy="201168"/>
+          </a:xfrm>
+          <a:prstGeom prst="rect">
+            <a:avLst/>
+          </a:prstGeom>
+          <a:noFill/>
+          <a:ln/>
+        </p:spPr>
+        <p:txBody>
+          <a:bodyPr wrap="square" lIns="0" tIns="0" rIns="0" bIns="0" rtlCol="0" anchor="ctr"/>
+          <a:lstStyle/>
+          <a:p>
+            <a:pPr algn="ctr" indent="0" marL="0">
+              <a:buNone/>
+            </a:pPr>
+            <a:r>
+              <a:rPr lang="en-US" sz="1000" b="1" dirty="0">
+                <a:solidFill>
+                  <a:schemeClr val="accent4"/>
+                </a:solidFill>
+                <a:latin typeface="Calibri" pitchFamily="34" charset="0"/>
+                <a:ea typeface="Calibri" pitchFamily="34" charset="-122"/>
+                <a:cs typeface="Calibri" pitchFamily="34" charset="-120"/>
+              </a:rPr>
+              <a:t>10</a:t>
+            </a:r>
+            <a:endParaRPr lang="en-US" sz="1000" dirty="0"/>
+          </a:p>
+        </p:txBody>
+      </p:sp>
+      <p:sp>
+        <p:nvSpPr>
+          <p:cNvPr id="39" name="Text 37"/>
+          <p:cNvSpPr txBox="1"/>
+          <p:nvPr/>
+        </p:nvSpPr>
+        <p:spPr>
+          <a:xfrm>
+            <a:off x="10872216" y="1645920"/>
+            <a:ext cx="310896" cy="182880"/>
+          </a:xfrm>
+          <a:prstGeom prst="rect">
+            <a:avLst/>
+          </a:prstGeom>
+          <a:noFill/>
+          <a:ln/>
+        </p:spPr>
+        <p:txBody>
+          <a:bodyPr wrap="square" lIns="0" tIns="0" rIns="0" bIns="0" rtlCol="0" anchor="ctr"/>
+          <a:lstStyle/>
+          <a:p>
+            <a:pPr algn="ctr" indent="0" marL="0">
+              <a:buNone/>
+            </a:pPr>
+            <a:r>
+              <a:rPr lang="en-US" sz="800" dirty="0">
+                <a:solidFill>
+                  <a:schemeClr val="accent4"/>
+                </a:solidFill>
+                <a:latin typeface="Calibri" pitchFamily="34" charset="0"/>
+                <a:ea typeface="Calibri" pitchFamily="34" charset="-122"/>
+                <a:cs typeface="Calibri" pitchFamily="34" charset="-120"/>
+              </a:rPr>
+              <a:t>D</a:t>
+            </a:r>
+            <a:endParaRPr lang="en-US" sz="800" dirty="0"/>
+          </a:p>
+        </p:txBody>
+      </p:sp>
+      <p:sp>
+        <p:nvSpPr>
+          <p:cNvPr id="40" name="Text 38"/>
+          <p:cNvSpPr txBox="1"/>
+          <p:nvPr/>
+        </p:nvSpPr>
+        <p:spPr>
+          <a:xfrm>
+            <a:off x="10872216" y="1810512"/>
+            <a:ext cx="310896" cy="201168"/>
+          </a:xfrm>
+          <a:prstGeom prst="rect">
+            <a:avLst/>
+          </a:prstGeom>
+          <a:noFill/>
+          <a:ln/>
+        </p:spPr>
+        <p:txBody>
+          <a:bodyPr wrap="square" lIns="0" tIns="0" rIns="0" bIns="0" rtlCol="0" anchor="ctr"/>
+          <a:lstStyle/>
+          <a:p>
+            <a:pPr algn="ctr" indent="0" marL="0">
+              <a:buNone/>
+            </a:pPr>
+            <a:r>
+              <a:rPr lang="en-US" sz="1000" b="1" dirty="0">
+                <a:solidFill>
+                  <a:schemeClr val="accent4"/>
+                </a:solidFill>
+                <a:latin typeface="Calibri" pitchFamily="34" charset="0"/>
+                <a:ea typeface="Calibri" pitchFamily="34" charset="-122"/>
+                <a:cs typeface="Calibri" pitchFamily="34" charset="-120"/>
+              </a:rPr>
+              <a:t>11</a:t>
+            </a:r>
+            <a:endParaRPr lang="en-US" sz="1000" dirty="0"/>
+          </a:p>
+        </p:txBody>
+      </p:sp>
+      <p:sp>
+        <p:nvSpPr>
+          <p:cNvPr id="41" name="Text 39"/>
+          <p:cNvSpPr txBox="1"/>
+          <p:nvPr/>
+        </p:nvSpPr>
+        <p:spPr>
+          <a:xfrm>
+            <a:off x="11183112" y="1645920"/>
+            <a:ext cx="310896" cy="182880"/>
+          </a:xfrm>
+          <a:prstGeom prst="rect">
+            <a:avLst/>
+          </a:prstGeom>
+          <a:noFill/>
+          <a:ln/>
+        </p:spPr>
+        <p:txBody>
+          <a:bodyPr wrap="square" lIns="0" tIns="0" rIns="0" bIns="0" rtlCol="0" anchor="ctr"/>
+          <a:lstStyle/>
+          <a:p>
+            <a:pPr algn="ctr" indent="0" marL="0">
+              <a:buNone/>
+            </a:pPr>
+            <a:r>
+              <a:rPr lang="en-US" sz="800" dirty="0">
                 <a:solidFill>
                   <a:schemeClr val="accent3"/>
                 </a:solidFill>
@@ -4568,16 +5385,38 @@
                 <a:ea typeface="Calibri" pitchFamily="34" charset="-122"/>
                 <a:cs typeface="Calibri" pitchFamily="34" charset="-120"/>
               </a:rPr>
-              <a:t>Mar</a:t>
-            </a:r>
-            <a:endParaRPr lang="en-US" sz="1100" dirty="0"/>
-          </a:p>
+              <a:t>M</a:t>
+            </a:r>
+            <a:endParaRPr lang="en-US" sz="800" dirty="0"/>
+          </a:p>
+        </p:txBody>
+      </p:sp>
+      <p:sp>
+        <p:nvSpPr>
+          <p:cNvPr id="42" name="Text 40"/>
+          <p:cNvSpPr txBox="1"/>
+          <p:nvPr/>
+        </p:nvSpPr>
+        <p:spPr>
+          <a:xfrm>
+            <a:off x="11183112" y="1810512"/>
+            <a:ext cx="310896" cy="201168"/>
+          </a:xfrm>
+          <a:prstGeom prst="rect">
+            <a:avLst/>
+          </a:prstGeom>
+          <a:noFill/>
+          <a:ln/>
+        </p:spPr>
+        <p:txBody>
+          <a:bodyPr wrap="square" lIns="0" tIns="0" rIns="0" bIns="0" rtlCol="0" anchor="ctr"/>
+          <a:lstStyle/>
           <a:p>
             <a:pPr algn="ctr" indent="0" marL="0">
               <a:buNone/>
             </a:pPr>
             <a:r>
-              <a:rPr lang="en-US" sz="1100" b="1" dirty="0">
+              <a:rPr lang="en-US" sz="1000" b="1" dirty="0">
                 <a:solidFill>
                   <a:schemeClr val="accent3"/>
                 </a:solidFill>
@@ -4587,20 +5426,59 @@
               </a:rPr>
               <a:t>13</a:t>
             </a:r>
-            <a:endParaRPr lang="en-US" sz="1100" dirty="0"/>
-          </a:p>
-        </p:txBody>
-      </p:sp>
-      <p:sp>
-        <p:nvSpPr>
-          <p:cNvPr id="18" name="fila-87"/>
+            <a:endParaRPr lang="en-US" sz="1000" dirty="0"/>
+          </a:p>
+        </p:txBody>
+      </p:sp>
+      <p:sp>
+        <p:nvSpPr>
+          <p:cNvPr id="43" name="Text 41"/>
+          <p:cNvSpPr txBox="1"/>
+          <p:nvPr/>
+        </p:nvSpPr>
+        <p:spPr>
+          <a:xfrm>
+            <a:off x="6446520" y="1810512"/>
+            <a:ext cx="384048" cy="201168"/>
+          </a:xfrm>
+          <a:prstGeom prst="rect">
+            <a:avLst/>
+          </a:prstGeom>
+          <a:noFill/>
+          <a:ln/>
+        </p:spPr>
+        <p:txBody>
+          <a:bodyPr wrap="square" lIns="0" tIns="0" rIns="0" bIns="0" rtlCol="0" anchor="ctr"/>
+          <a:lstStyle/>
+          <a:p>
+            <a:pPr algn="ctr" indent="0" marL="0">
+              <a:buNone/>
+            </a:pPr>
+            <a:r>
+              <a:rPr lang="en-US" sz="1000" b="1" dirty="0">
+                <a:solidFill>
+                  <a:schemeClr val="accent4"/>
+                </a:solidFill>
+                <a:latin typeface="Calibri" pitchFamily="34" charset="0"/>
+                <a:ea typeface="Calibri" pitchFamily="34" charset="-122"/>
+                <a:cs typeface="Calibri" pitchFamily="34" charset="-120"/>
+              </a:rPr>
+              <a:t>h</a:t>
+            </a:r>
+            <a:endParaRPr lang="en-US" sz="1000" dirty="0"/>
+          </a:p>
+        </p:txBody>
+      </p:sp>
+      <p:sp>
+        <p:nvSpPr>
+          <p:cNvPr id="44" name="fila-87"/>
           <p:cNvSpPr/>
           <p:nvPr/>
         </p:nvSpPr>
         <p:spPr>
           <a:xfrm>
-            <a:off x="4343400" y="1920240"/>
-            <a:ext cx="7242048" cy="429768"/>
+            <a:off x="4343400" y="2057400"/>
+            <a:ext cx="7150608" cy="365760"/>
           </a:xfrm>
           <a:prstGeom prst="rect">
             <a:avLst/>
@@ -4613,14 +5491,14 @@
       </p:sp>
       <p:sp>
         <p:nvSpPr>
-          <p:cNvPr id="19" name="Text 17"/>
+          <p:cNvPr id="45" name="Text 43"/>
           <p:cNvSpPr txBox="1"/>
           <p:nvPr/>
         </p:nvSpPr>
         <p:spPr>
           <a:xfrm>
-            <a:off x="4416552" y="1920240"/>
-            <a:ext cx="2514600" cy="429768"/>
+            <a:off x="4398264" y="2057400"/>
+            <a:ext cx="2048256" cy="365760"/>
           </a:xfrm>
           <a:prstGeom prst="rect">
             <a:avLst/>
@@ -4636,7 +5514,7 @@
               <a:buNone/>
             </a:pPr>
             <a:r>
-              <a:rPr lang="en-US" sz="1300" dirty="0">
+              <a:rPr lang="en-US" sz="1200" dirty="0">
                 <a:solidFill>
                   <a:schemeClr val="tx1"/>
                 </a:solidFill>
@@ -4644,26 +5522,65 @@
                 <a:ea typeface="Calibri" pitchFamily="34" charset="-122"/>
                 <a:cs typeface="Calibri" pitchFamily="34" charset="-120"/>
               </a:rPr>
-              <a:t>Análisis y requisitos</a:t>
-            </a:r>
-            <a:endParaRPr lang="en-US" sz="1300" dirty="0"/>
-          </a:p>
-        </p:txBody>
-      </p:sp>
-      <p:sp>
-        <p:nvSpPr>
-          <p:cNvPr id="20" name="barra-88"/>
+              <a:t>Beat Chart y plan de trabajo</a:t>
+            </a:r>
+            <a:endParaRPr lang="en-US" sz="1200" dirty="0"/>
+          </a:p>
+        </p:txBody>
+      </p:sp>
+      <p:sp>
+        <p:nvSpPr>
+          <p:cNvPr id="46" name="Text 44"/>
+          <p:cNvSpPr txBox="1"/>
+          <p:nvPr/>
+        </p:nvSpPr>
+        <p:spPr>
+          <a:xfrm>
+            <a:off x="6446520" y="2057400"/>
+            <a:ext cx="384048" cy="365760"/>
+          </a:xfrm>
+          <a:prstGeom prst="rect">
+            <a:avLst/>
+          </a:prstGeom>
+          <a:noFill/>
+          <a:ln/>
+        </p:spPr>
+        <p:txBody>
+          <a:bodyPr wrap="square" lIns="0" tIns="0" rIns="0" bIns="0" rtlCol="0" anchor="ctr"/>
+          <a:lstStyle/>
+          <a:p>
+            <a:pPr algn="ctr" indent="0" marL="0">
+              <a:buNone/>
+            </a:pPr>
+            <a:r>
+              <a:rPr lang="en-US" sz="1200" b="1" dirty="0">
+                <a:solidFill>
+                  <a:schemeClr val="tx1"/>
+                </a:solidFill>
+                <a:latin typeface="Calibri" pitchFamily="34" charset="0"/>
+                <a:ea typeface="Calibri" pitchFamily="34" charset="-122"/>
+                <a:cs typeface="Calibri" pitchFamily="34" charset="-120"/>
+              </a:rPr>
+              <a:t>3</a:t>
+            </a:r>
+            <a:endParaRPr lang="en-US" sz="1200" dirty="0"/>
+          </a:p>
+        </p:txBody>
+      </p:sp>
+      <p:sp>
+        <p:nvSpPr>
+          <p:cNvPr id="47" name="barra-88"/>
           <p:cNvSpPr/>
           <p:nvPr/>
         </p:nvSpPr>
         <p:spPr>
           <a:xfrm>
-            <a:off x="6940296" y="2029968"/>
-            <a:ext cx="1097280" cy="210312"/>
+            <a:off x="6858000" y="2148840"/>
+            <a:ext cx="566928" cy="182880"/>
           </a:xfrm>
           <a:prstGeom prst="roundRect">
             <a:avLst>
-              <a:gd name="adj" fmla="val 26087"/>
+              <a:gd name="adj" fmla="val 25000"/>
             </a:avLst>
           </a:prstGeom>
           <a:solidFill>
@@ -4674,14 +5591,14 @@
       </p:sp>
       <p:sp>
         <p:nvSpPr>
-          <p:cNvPr id="21" name="Text 19"/>
+          <p:cNvPr id="48" name="Text 46"/>
           <p:cNvSpPr txBox="1"/>
           <p:nvPr/>
         </p:nvSpPr>
         <p:spPr>
           <a:xfrm>
-            <a:off x="4416552" y="2350008"/>
-            <a:ext cx="2514600" cy="429768"/>
+            <a:off x="4398264" y="2423160"/>
+            <a:ext cx="2048256" cy="365760"/>
           </a:xfrm>
           <a:prstGeom prst="rect">
             <a:avLst/>
@@ -4697,7 +5614,7 @@
               <a:buNone/>
             </a:pPr>
             <a:r>
-              <a:rPr lang="en-US" sz="1300" dirty="0">
+              <a:rPr lang="en-US" sz="1200" dirty="0">
                 <a:solidFill>
                   <a:schemeClr val="tx1"/>
                 </a:solidFill>
@@ -4705,26 +5622,65 @@
                 <a:ea typeface="Calibri" pitchFamily="34" charset="-122"/>
                 <a:cs typeface="Calibri" pitchFamily="34" charset="-120"/>
               </a:rPr>
-              <a:t>Diseño y arquitectura</a:t>
-            </a:r>
-            <a:endParaRPr lang="en-US" sz="1300" dirty="0"/>
-          </a:p>
-        </p:txBody>
-      </p:sp>
-      <p:sp>
-        <p:nvSpPr>
-          <p:cNvPr id="22" name="barra-89"/>
+              <a:t>Cuestionario y relevamiento</a:t>
+            </a:r>
+            <a:endParaRPr lang="en-US" sz="1200" dirty="0"/>
+          </a:p>
+        </p:txBody>
+      </p:sp>
+      <p:sp>
+        <p:nvSpPr>
+          <p:cNvPr id="49" name="Text 47"/>
+          <p:cNvSpPr txBox="1"/>
+          <p:nvPr/>
+        </p:nvSpPr>
+        <p:spPr>
+          <a:xfrm>
+            <a:off x="6446520" y="2423160"/>
+            <a:ext cx="384048" cy="365760"/>
+          </a:xfrm>
+          <a:prstGeom prst="rect">
+            <a:avLst/>
+          </a:prstGeom>
+          <a:noFill/>
+          <a:ln/>
+        </p:spPr>
+        <p:txBody>
+          <a:bodyPr wrap="square" lIns="0" tIns="0" rIns="0" bIns="0" rtlCol="0" anchor="ctr"/>
+          <a:lstStyle/>
+          <a:p>
+            <a:pPr algn="ctr" indent="0" marL="0">
+              <a:buNone/>
+            </a:pPr>
+            <a:r>
+              <a:rPr lang="en-US" sz="1200" b="1" dirty="0">
+                <a:solidFill>
+                  <a:schemeClr val="tx1"/>
+                </a:solidFill>
+                <a:latin typeface="Calibri" pitchFamily="34" charset="0"/>
+                <a:ea typeface="Calibri" pitchFamily="34" charset="-122"/>
+                <a:cs typeface="Calibri" pitchFamily="34" charset="-120"/>
+              </a:rPr>
+              <a:t>5</a:t>
+            </a:r>
+            <a:endParaRPr lang="en-US" sz="1200" dirty="0"/>
+          </a:p>
+        </p:txBody>
+      </p:sp>
+      <p:sp>
+        <p:nvSpPr>
+          <p:cNvPr id="50" name="barra-89"/>
           <p:cNvSpPr/>
           <p:nvPr/>
         </p:nvSpPr>
         <p:spPr>
           <a:xfrm>
-            <a:off x="6940296" y="2459736"/>
-            <a:ext cx="512064" cy="210312"/>
+            <a:off x="7479792" y="2514600"/>
+            <a:ext cx="877824" cy="182880"/>
           </a:xfrm>
           <a:prstGeom prst="roundRect">
             <a:avLst>
-              <a:gd name="adj" fmla="val 26087"/>
+              <a:gd name="adj" fmla="val 25000"/>
             </a:avLst>
           </a:prstGeom>
           <a:solidFill>
@@ -4735,14 +5691,14 @@
       </p:sp>
       <p:sp>
         <p:nvSpPr>
-          <p:cNvPr id="23" name="fila-90"/>
+          <p:cNvPr id="51" name="fila-90"/>
           <p:cNvSpPr/>
           <p:nvPr/>
         </p:nvSpPr>
         <p:spPr>
           <a:xfrm>
-            <a:off x="4343400" y="2779776"/>
-            <a:ext cx="7242048" cy="429768"/>
+            <a:off x="4343400" y="2788920"/>
+            <a:ext cx="7150608" cy="365760"/>
           </a:xfrm>
           <a:prstGeom prst="rect">
             <a:avLst/>
@@ -4755,14 +5711,14 @@
       </p:sp>
       <p:sp>
         <p:nvSpPr>
-          <p:cNvPr id="24" name="Text 22"/>
+          <p:cNvPr id="52" name="Text 50"/>
           <p:cNvSpPr txBox="1"/>
           <p:nvPr/>
         </p:nvSpPr>
         <p:spPr>
           <a:xfrm>
-            <a:off x="4416552" y="2779776"/>
-            <a:ext cx="2514600" cy="429768"/>
+            <a:off x="4398264" y="2788920"/>
+            <a:ext cx="2048256" cy="365760"/>
           </a:xfrm>
           <a:prstGeom prst="rect">
             <a:avLst/>
@@ -4778,7 +5734,7 @@
               <a:buNone/>
             </a:pPr>
             <a:r>
-              <a:rPr lang="en-US" sz="1300" dirty="0">
+              <a:rPr lang="en-US" sz="1200" dirty="0">
                 <a:solidFill>
                   <a:schemeClr val="tx1"/>
                 </a:solidFill>
@@ -4786,26 +5742,165 @@
                 <a:ea typeface="Calibri" pitchFamily="34" charset="-122"/>
                 <a:cs typeface="Calibri" pitchFamily="34" charset="-120"/>
               </a:rPr>
-              <a:t>Inc. 1–2: carta y carrito</a:t>
-            </a:r>
-            <a:endParaRPr lang="en-US" sz="1300" dirty="0"/>
-          </a:p>
-        </p:txBody>
-      </p:sp>
-      <p:sp>
-        <p:nvSpPr>
-          <p:cNvPr id="25" name="barra-91"/>
+              <a:t>Diseño: interfaz y arquitectura</a:t>
+            </a:r>
+            <a:endParaRPr lang="en-US" sz="1200" dirty="0"/>
+          </a:p>
+        </p:txBody>
+      </p:sp>
+      <p:sp>
+        <p:nvSpPr>
+          <p:cNvPr id="53" name="Text 51"/>
+          <p:cNvSpPr txBox="1"/>
+          <p:nvPr/>
+        </p:nvSpPr>
+        <p:spPr>
+          <a:xfrm>
+            <a:off x="6446520" y="2788920"/>
+            <a:ext cx="384048" cy="365760"/>
+          </a:xfrm>
+          <a:prstGeom prst="rect">
+            <a:avLst/>
+          </a:prstGeom>
+          <a:noFill/>
+          <a:ln/>
+        </p:spPr>
+        <p:txBody>
+          <a:bodyPr wrap="square" lIns="0" tIns="0" rIns="0" bIns="0" rtlCol="0" anchor="ctr"/>
+          <a:lstStyle/>
+          <a:p>
+            <a:pPr algn="ctr" indent="0" marL="0">
+              <a:buNone/>
+            </a:pPr>
+            <a:r>
+              <a:rPr lang="en-US" sz="1200" b="1" dirty="0">
+                <a:solidFill>
+                  <a:schemeClr val="tx1"/>
+                </a:solidFill>
+                <a:latin typeface="Calibri" pitchFamily="34" charset="0"/>
+                <a:ea typeface="Calibri" pitchFamily="34" charset="-122"/>
+                <a:cs typeface="Calibri" pitchFamily="34" charset="-120"/>
+              </a:rPr>
+              <a:t>8</a:t>
+            </a:r>
+            <a:endParaRPr lang="en-US" sz="1200" dirty="0"/>
+          </a:p>
+        </p:txBody>
+      </p:sp>
+      <p:sp>
+        <p:nvSpPr>
+          <p:cNvPr id="54" name="barra-91"/>
           <p:cNvSpPr/>
           <p:nvPr/>
         </p:nvSpPr>
         <p:spPr>
           <a:xfrm>
-            <a:off x="6940296" y="2889504"/>
-            <a:ext cx="1097280" cy="210312"/>
+            <a:off x="7790688" y="2880360"/>
+            <a:ext cx="877824" cy="182880"/>
           </a:xfrm>
           <a:prstGeom prst="roundRect">
             <a:avLst>
-              <a:gd name="adj" fmla="val 26087"/>
+              <a:gd name="adj" fmla="val 25000"/>
+            </a:avLst>
+          </a:prstGeom>
+          <a:solidFill>
+            <a:schemeClr val="accent4"/>
+          </a:solidFill>
+          <a:ln/>
+        </p:spPr>
+      </p:sp>
+      <p:sp>
+        <p:nvSpPr>
+          <p:cNvPr id="55" name="Text 53"/>
+          <p:cNvSpPr txBox="1"/>
+          <p:nvPr/>
+        </p:nvSpPr>
+        <p:spPr>
+          <a:xfrm>
+            <a:off x="4398264" y="3154680"/>
+            <a:ext cx="2048256" cy="365760"/>
+          </a:xfrm>
+          <a:prstGeom prst="rect">
+            <a:avLst/>
+          </a:prstGeom>
+          <a:noFill/>
+          <a:ln/>
+        </p:spPr>
+        <p:txBody>
+          <a:bodyPr wrap="square" lIns="0" tIns="0" rIns="0" bIns="0" rtlCol="0" anchor="ctr"/>
+          <a:lstStyle/>
+          <a:p>
+            <a:pPr indent="0" marL="0">
+              <a:buNone/>
+            </a:pPr>
+            <a:r>
+              <a:rPr lang="en-US" sz="1200" dirty="0">
+                <a:solidFill>
+                  <a:schemeClr val="tx1"/>
+                </a:solidFill>
+                <a:latin typeface="Calibri" pitchFamily="34" charset="0"/>
+                <a:ea typeface="Calibri" pitchFamily="34" charset="-122"/>
+                <a:cs typeface="Calibri" pitchFamily="34" charset="-120"/>
+              </a:rPr>
+              <a:t>Inc. 1: carta (prototipo)</a:t>
+            </a:r>
+            <a:endParaRPr lang="en-US" sz="1200" dirty="0"/>
+          </a:p>
+        </p:txBody>
+      </p:sp>
+      <p:sp>
+        <p:nvSpPr>
+          <p:cNvPr id="56" name="Text 54"/>
+          <p:cNvSpPr txBox="1"/>
+          <p:nvPr/>
+        </p:nvSpPr>
+        <p:spPr>
+          <a:xfrm>
+            <a:off x="6446520" y="3154680"/>
+            <a:ext cx="384048" cy="365760"/>
+          </a:xfrm>
+          <a:prstGeom prst="rect">
+            <a:avLst/>
+          </a:prstGeom>
+          <a:noFill/>
+          <a:ln/>
+        </p:spPr>
+        <p:txBody>
+          <a:bodyPr wrap="square" lIns="0" tIns="0" rIns="0" bIns="0" rtlCol="0" anchor="ctr"/>
+          <a:lstStyle/>
+          <a:p>
+            <a:pPr algn="ctr" indent="0" marL="0">
+              <a:buNone/>
+            </a:pPr>
+            <a:r>
+              <a:rPr lang="en-US" sz="1200" b="1" dirty="0">
+                <a:solidFill>
+                  <a:schemeClr val="tx1"/>
+                </a:solidFill>
+                <a:latin typeface="Calibri" pitchFamily="34" charset="0"/>
+                <a:ea typeface="Calibri" pitchFamily="34" charset="-122"/>
+                <a:cs typeface="Calibri" pitchFamily="34" charset="-120"/>
+              </a:rPr>
+              <a:t>5</a:t>
+            </a:r>
+            <a:endParaRPr lang="en-US" sz="1200" dirty="0"/>
+          </a:p>
+        </p:txBody>
+      </p:sp>
+      <p:sp>
+        <p:nvSpPr>
+          <p:cNvPr id="57" name="barra-92"/>
+          <p:cNvSpPr/>
+          <p:nvPr/>
+        </p:nvSpPr>
+        <p:spPr>
+          <a:xfrm>
+            <a:off x="8412480" y="3246120"/>
+            <a:ext cx="566928" cy="182880"/>
+          </a:xfrm>
+          <a:prstGeom prst="roundRect">
+            <a:avLst>
+              <a:gd name="adj" fmla="val 25000"/>
             </a:avLst>
           </a:prstGeom>
           <a:solidFill>
@@ -4816,14 +5911,34 @@
       </p:sp>
       <p:sp>
         <p:nvSpPr>
-          <p:cNvPr id="26" name="Text 24"/>
+          <p:cNvPr id="58" name="fila-93"/>
+          <p:cNvSpPr/>
+          <p:nvPr/>
+        </p:nvSpPr>
+        <p:spPr>
+          <a:xfrm>
+            <a:off x="4343400" y="3520440"/>
+            <a:ext cx="7150608" cy="365760"/>
+          </a:xfrm>
+          <a:prstGeom prst="rect">
+            <a:avLst/>
+          </a:prstGeom>
+          <a:solidFill>
+            <a:schemeClr val="accent6"/>
+          </a:solidFill>
+          <a:ln/>
+        </p:spPr>
+      </p:sp>
+      <p:sp>
+        <p:nvSpPr>
+          <p:cNvPr id="59" name="Text 57"/>
           <p:cNvSpPr txBox="1"/>
           <p:nvPr/>
         </p:nvSpPr>
         <p:spPr>
           <a:xfrm>
-            <a:off x="4416552" y="3209544"/>
-            <a:ext cx="2514600" cy="429768"/>
+            <a:off x="4398264" y="3520440"/>
+            <a:ext cx="2048256" cy="365760"/>
           </a:xfrm>
           <a:prstGeom prst="rect">
             <a:avLst/>
@@ -4839,7 +5954,7 @@
               <a:buNone/>
             </a:pPr>
             <a:r>
-              <a:rPr lang="en-US" sz="1300" dirty="0">
+              <a:rPr lang="en-US" sz="1200" dirty="0">
                 <a:solidFill>
                   <a:schemeClr val="tx1"/>
                 </a:solidFill>
@@ -4847,26 +5962,65 @@
                 <a:ea typeface="Calibri" pitchFamily="34" charset="-122"/>
                 <a:cs typeface="Calibri" pitchFamily="34" charset="-120"/>
               </a:rPr>
-              <a:t>Inc. 3–4: recibo y backend</a:t>
-            </a:r>
-            <a:endParaRPr lang="en-US" sz="1300" dirty="0"/>
-          </a:p>
-        </p:txBody>
-      </p:sp>
-      <p:sp>
-        <p:nvSpPr>
-          <p:cNvPr id="27" name="barra-92"/>
+              <a:t>Inc. 2: carrito y mitades</a:t>
+            </a:r>
+            <a:endParaRPr lang="en-US" sz="1200" dirty="0"/>
+          </a:p>
+        </p:txBody>
+      </p:sp>
+      <p:sp>
+        <p:nvSpPr>
+          <p:cNvPr id="60" name="Text 58"/>
+          <p:cNvSpPr txBox="1"/>
+          <p:nvPr/>
+        </p:nvSpPr>
+        <p:spPr>
+          <a:xfrm>
+            <a:off x="6446520" y="3520440"/>
+            <a:ext cx="384048" cy="365760"/>
+          </a:xfrm>
+          <a:prstGeom prst="rect">
+            <a:avLst/>
+          </a:prstGeom>
+          <a:noFill/>
+          <a:ln/>
+        </p:spPr>
+        <p:txBody>
+          <a:bodyPr wrap="square" lIns="0" tIns="0" rIns="0" bIns="0" rtlCol="0" anchor="ctr"/>
+          <a:lstStyle/>
+          <a:p>
+            <a:pPr algn="ctr" indent="0" marL="0">
+              <a:buNone/>
+            </a:pPr>
+            <a:r>
+              <a:rPr lang="en-US" sz="1200" b="1" dirty="0">
+                <a:solidFill>
+                  <a:schemeClr val="tx1"/>
+                </a:solidFill>
+                <a:latin typeface="Calibri" pitchFamily="34" charset="0"/>
+                <a:ea typeface="Calibri" pitchFamily="34" charset="-122"/>
+                <a:cs typeface="Calibri" pitchFamily="34" charset="-120"/>
+              </a:rPr>
+              <a:t>5</a:t>
+            </a:r>
+            <a:endParaRPr lang="en-US" sz="1200" dirty="0"/>
+          </a:p>
+        </p:txBody>
+      </p:sp>
+      <p:sp>
+        <p:nvSpPr>
+          <p:cNvPr id="61" name="barra-94"/>
           <p:cNvSpPr/>
           <p:nvPr/>
         </p:nvSpPr>
         <p:spPr>
           <a:xfrm>
-            <a:off x="7525512" y="3319272"/>
-            <a:ext cx="512064" cy="210312"/>
+            <a:off x="9034272" y="3611880"/>
+            <a:ext cx="256032" cy="182880"/>
           </a:xfrm>
           <a:prstGeom prst="roundRect">
             <a:avLst>
-              <a:gd name="adj" fmla="val 26087"/>
+              <a:gd name="adj" fmla="val 25000"/>
             </a:avLst>
           </a:prstGeom>
           <a:solidFill>
@@ -4877,14 +6031,114 @@
       </p:sp>
       <p:sp>
         <p:nvSpPr>
-          <p:cNvPr id="28" name="fila-93"/>
+          <p:cNvPr id="62" name="Text 60"/>
+          <p:cNvSpPr txBox="1"/>
+          <p:nvPr/>
+        </p:nvSpPr>
+        <p:spPr>
+          <a:xfrm>
+            <a:off x="4398264" y="3886200"/>
+            <a:ext cx="2048256" cy="365760"/>
+          </a:xfrm>
+          <a:prstGeom prst="rect">
+            <a:avLst/>
+          </a:prstGeom>
+          <a:noFill/>
+          <a:ln/>
+        </p:spPr>
+        <p:txBody>
+          <a:bodyPr wrap="square" lIns="0" tIns="0" rIns="0" bIns="0" rtlCol="0" anchor="ctr"/>
+          <a:lstStyle/>
+          <a:p>
+            <a:pPr indent="0" marL="0">
+              <a:buNone/>
+            </a:pPr>
+            <a:r>
+              <a:rPr lang="en-US" sz="1200" dirty="0">
+                <a:solidFill>
+                  <a:schemeClr val="tx1"/>
+                </a:solidFill>
+                <a:latin typeface="Calibri" pitchFamily="34" charset="0"/>
+                <a:ea typeface="Calibri" pitchFamily="34" charset="-122"/>
+                <a:cs typeface="Calibri" pitchFamily="34" charset="-120"/>
+              </a:rPr>
+              <a:t>Inc. 3–4: recibo y backend</a:t>
+            </a:r>
+            <a:endParaRPr lang="en-US" sz="1200" dirty="0"/>
+          </a:p>
+        </p:txBody>
+      </p:sp>
+      <p:sp>
+        <p:nvSpPr>
+          <p:cNvPr id="63" name="Text 61"/>
+          <p:cNvSpPr txBox="1"/>
+          <p:nvPr/>
+        </p:nvSpPr>
+        <p:spPr>
+          <a:xfrm>
+            <a:off x="6446520" y="3886200"/>
+            <a:ext cx="384048" cy="365760"/>
+          </a:xfrm>
+          <a:prstGeom prst="rect">
+            <a:avLst/>
+          </a:prstGeom>
+          <a:noFill/>
+          <a:ln/>
+        </p:spPr>
+        <p:txBody>
+          <a:bodyPr wrap="square" lIns="0" tIns="0" rIns="0" bIns="0" rtlCol="0" anchor="ctr"/>
+          <a:lstStyle/>
+          <a:p>
+            <a:pPr algn="ctr" indent="0" marL="0">
+              <a:buNone/>
+            </a:pPr>
+            <a:r>
+              <a:rPr lang="en-US" sz="1200" b="1" dirty="0">
+                <a:solidFill>
+                  <a:schemeClr val="tx1"/>
+                </a:solidFill>
+                <a:latin typeface="Calibri" pitchFamily="34" charset="0"/>
+                <a:ea typeface="Calibri" pitchFamily="34" charset="-122"/>
+                <a:cs typeface="Calibri" pitchFamily="34" charset="-120"/>
+              </a:rPr>
+              <a:t>8</a:t>
+            </a:r>
+            <a:endParaRPr lang="en-US" sz="1200" dirty="0"/>
+          </a:p>
+        </p:txBody>
+      </p:sp>
+      <p:sp>
+        <p:nvSpPr>
+          <p:cNvPr id="64" name="barra-95"/>
           <p:cNvSpPr/>
           <p:nvPr/>
         </p:nvSpPr>
         <p:spPr>
           <a:xfrm>
-            <a:off x="4343400" y="3639312"/>
-            <a:ext cx="7242048" cy="429768"/>
+            <a:off x="9345168" y="3977640"/>
+            <a:ext cx="566928" cy="182880"/>
+          </a:xfrm>
+          <a:prstGeom prst="roundRect">
+            <a:avLst>
+              <a:gd name="adj" fmla="val 25000"/>
+            </a:avLst>
+          </a:prstGeom>
+          <a:solidFill>
+            <a:schemeClr val="accent1"/>
+          </a:solidFill>
+          <a:ln/>
+        </p:spPr>
+      </p:sp>
+      <p:sp>
+        <p:nvSpPr>
+          <p:cNvPr id="65" name="fila-96"/>
+          <p:cNvSpPr/>
+          <p:nvPr/>
+        </p:nvSpPr>
+        <p:spPr>
+          <a:xfrm>
+            <a:off x="4343400" y="4251960"/>
+            <a:ext cx="7150608" cy="365760"/>
           </a:xfrm>
           <a:prstGeom prst="rect">
             <a:avLst/>
@@ -4897,14 +6151,14 @@
       </p:sp>
       <p:sp>
         <p:nvSpPr>
-          <p:cNvPr id="29" name="Text 27"/>
+          <p:cNvPr id="66" name="Text 64"/>
           <p:cNvSpPr txBox="1"/>
           <p:nvPr/>
         </p:nvSpPr>
         <p:spPr>
           <a:xfrm>
-            <a:off x="4416552" y="3639312"/>
-            <a:ext cx="2514600" cy="429768"/>
+            <a:off x="4398264" y="4251960"/>
+            <a:ext cx="2048256" cy="365760"/>
           </a:xfrm>
           <a:prstGeom prst="rect">
             <a:avLst/>
@@ -4920,7 +6174,7 @@
               <a:buNone/>
             </a:pPr>
             <a:r>
-              <a:rPr lang="en-US" sz="1300" dirty="0">
+              <a:rPr lang="en-US" sz="1200" dirty="0">
                 <a:solidFill>
                   <a:schemeClr val="tx1"/>
                 </a:solidFill>
@@ -4928,26 +6182,65 @@
                 <a:ea typeface="Calibri" pitchFamily="34" charset="-122"/>
                 <a:cs typeface="Calibri" pitchFamily="34" charset="-120"/>
               </a:rPr>
-              <a:t>Pruebas y publicación</a:t>
-            </a:r>
-            <a:endParaRPr lang="en-US" sz="1300" dirty="0"/>
-          </a:p>
-        </p:txBody>
-      </p:sp>
-      <p:sp>
-        <p:nvSpPr>
-          <p:cNvPr id="30" name="barra-94"/>
+              <a:t>Pruebas (44 automáticas)</a:t>
+            </a:r>
+            <a:endParaRPr lang="en-US" sz="1200" dirty="0"/>
+          </a:p>
+        </p:txBody>
+      </p:sp>
+      <p:sp>
+        <p:nvSpPr>
+          <p:cNvPr id="67" name="Text 65"/>
+          <p:cNvSpPr txBox="1"/>
+          <p:nvPr/>
+        </p:nvSpPr>
+        <p:spPr>
+          <a:xfrm>
+            <a:off x="6446520" y="4251960"/>
+            <a:ext cx="384048" cy="365760"/>
+          </a:xfrm>
+          <a:prstGeom prst="rect">
+            <a:avLst/>
+          </a:prstGeom>
+          <a:noFill/>
+          <a:ln/>
+        </p:spPr>
+        <p:txBody>
+          <a:bodyPr wrap="square" lIns="0" tIns="0" rIns="0" bIns="0" rtlCol="0" anchor="ctr"/>
+          <a:lstStyle/>
+          <a:p>
+            <a:pPr algn="ctr" indent="0" marL="0">
+              <a:buNone/>
+            </a:pPr>
+            <a:r>
+              <a:rPr lang="en-US" sz="1200" b="1" dirty="0">
+                <a:solidFill>
+                  <a:schemeClr val="tx1"/>
+                </a:solidFill>
+                <a:latin typeface="Calibri" pitchFamily="34" charset="0"/>
+                <a:ea typeface="Calibri" pitchFamily="34" charset="-122"/>
+                <a:cs typeface="Calibri" pitchFamily="34" charset="-120"/>
+              </a:rPr>
+              <a:t>8</a:t>
+            </a:r>
+            <a:endParaRPr lang="en-US" sz="1200" dirty="0"/>
+          </a:p>
+        </p:txBody>
+      </p:sp>
+      <p:sp>
+        <p:nvSpPr>
+          <p:cNvPr id="68" name="barra-97"/>
           <p:cNvSpPr/>
           <p:nvPr/>
         </p:nvSpPr>
         <p:spPr>
           <a:xfrm>
-            <a:off x="7525512" y="3749040"/>
-            <a:ext cx="512064" cy="210312"/>
+            <a:off x="9034272" y="4343400"/>
+            <a:ext cx="1188720" cy="182880"/>
           </a:xfrm>
           <a:prstGeom prst="roundRect">
             <a:avLst>
-              <a:gd name="adj" fmla="val 26087"/>
+              <a:gd name="adj" fmla="val 25000"/>
             </a:avLst>
           </a:prstGeom>
           <a:solidFill>
@@ -4958,14 +6251,14 @@
       </p:sp>
       <p:sp>
         <p:nvSpPr>
-          <p:cNvPr id="31" name="Text 29"/>
+          <p:cNvPr id="69" name="Text 67"/>
           <p:cNvSpPr txBox="1"/>
           <p:nvPr/>
         </p:nvSpPr>
         <p:spPr>
           <a:xfrm>
-            <a:off x="4416552" y="4069080"/>
-            <a:ext cx="2514600" cy="429768"/>
+            <a:off x="4398264" y="4617720"/>
+            <a:ext cx="2048256" cy="365760"/>
           </a:xfrm>
           <a:prstGeom prst="rect">
             <a:avLst/>
@@ -4981,7 +6274,7 @@
               <a:buNone/>
             </a:pPr>
             <a:r>
-              <a:rPr lang="en-US" sz="1300" dirty="0">
+              <a:rPr lang="en-US" sz="1200" dirty="0">
                 <a:solidFill>
                   <a:schemeClr val="tx1"/>
                 </a:solidFill>
@@ -4989,26 +6282,185 @@
                 <a:ea typeface="Calibri" pitchFamily="34" charset="-122"/>
                 <a:cs typeface="Calibri" pitchFamily="34" charset="-120"/>
               </a:rPr>
-              <a:t>Validación con el negocio</a:t>
-            </a:r>
-            <a:endParaRPr lang="en-US" sz="1300" dirty="0"/>
-          </a:p>
-        </p:txBody>
-      </p:sp>
-      <p:sp>
-        <p:nvSpPr>
-          <p:cNvPr id="32" name="barra-95"/>
+              <a:t>Despliegue y CI</a:t>
+            </a:r>
+            <a:endParaRPr lang="en-US" sz="1200" dirty="0"/>
+          </a:p>
+        </p:txBody>
+      </p:sp>
+      <p:sp>
+        <p:nvSpPr>
+          <p:cNvPr id="70" name="Text 68"/>
+          <p:cNvSpPr txBox="1"/>
+          <p:nvPr/>
+        </p:nvSpPr>
+        <p:spPr>
+          <a:xfrm>
+            <a:off x="6446520" y="4617720"/>
+            <a:ext cx="384048" cy="365760"/>
+          </a:xfrm>
+          <a:prstGeom prst="rect">
+            <a:avLst/>
+          </a:prstGeom>
+          <a:noFill/>
+          <a:ln/>
+        </p:spPr>
+        <p:txBody>
+          <a:bodyPr wrap="square" lIns="0" tIns="0" rIns="0" bIns="0" rtlCol="0" anchor="ctr"/>
+          <a:lstStyle/>
+          <a:p>
+            <a:pPr algn="ctr" indent="0" marL="0">
+              <a:buNone/>
+            </a:pPr>
+            <a:r>
+              <a:rPr lang="en-US" sz="1200" b="1" dirty="0">
+                <a:solidFill>
+                  <a:schemeClr val="tx1"/>
+                </a:solidFill>
+                <a:latin typeface="Calibri" pitchFamily="34" charset="0"/>
+                <a:ea typeface="Calibri" pitchFamily="34" charset="-122"/>
+                <a:cs typeface="Calibri" pitchFamily="34" charset="-120"/>
+              </a:rPr>
+              <a:t>6</a:t>
+            </a:r>
+            <a:endParaRPr lang="en-US" sz="1200" dirty="0"/>
+          </a:p>
+        </p:txBody>
+      </p:sp>
+      <p:sp>
+        <p:nvSpPr>
+          <p:cNvPr id="71" name="barra-98"/>
           <p:cNvSpPr/>
           <p:nvPr/>
         </p:nvSpPr>
         <p:spPr>
           <a:xfrm>
-            <a:off x="8110728" y="4178808"/>
-            <a:ext cx="512064" cy="210312"/>
+            <a:off x="9345168" y="4709160"/>
+            <a:ext cx="566928" cy="182880"/>
           </a:xfrm>
           <a:prstGeom prst="roundRect">
             <a:avLst>
-              <a:gd name="adj" fmla="val 26087"/>
+              <a:gd name="adj" fmla="val 25000"/>
+            </a:avLst>
+          </a:prstGeom>
+          <a:solidFill>
+            <a:schemeClr val="accent2"/>
+          </a:solidFill>
+          <a:ln/>
+        </p:spPr>
+      </p:sp>
+      <p:sp>
+        <p:nvSpPr>
+          <p:cNvPr id="72" name="fila-99"/>
+          <p:cNvSpPr/>
+          <p:nvPr/>
+        </p:nvSpPr>
+        <p:spPr>
+          <a:xfrm>
+            <a:off x="4343400" y="4983480"/>
+            <a:ext cx="7150608" cy="365760"/>
+          </a:xfrm>
+          <a:prstGeom prst="rect">
+            <a:avLst/>
+          </a:prstGeom>
+          <a:solidFill>
+            <a:schemeClr val="accent6"/>
+          </a:solidFill>
+          <a:ln/>
+        </p:spPr>
+      </p:sp>
+      <p:sp>
+        <p:nvSpPr>
+          <p:cNvPr id="73" name="Text 71"/>
+          <p:cNvSpPr txBox="1"/>
+          <p:nvPr/>
+        </p:nvSpPr>
+        <p:spPr>
+          <a:xfrm>
+            <a:off x="4398264" y="4983480"/>
+            <a:ext cx="2048256" cy="365760"/>
+          </a:xfrm>
+          <a:prstGeom prst="rect">
+            <a:avLst/>
+          </a:prstGeom>
+          <a:noFill/>
+          <a:ln/>
+        </p:spPr>
+        <p:txBody>
+          <a:bodyPr wrap="square" lIns="0" tIns="0" rIns="0" bIns="0" rtlCol="0" anchor="ctr"/>
+          <a:lstStyle/>
+          <a:p>
+            <a:pPr indent="0" marL="0">
+              <a:buNone/>
+            </a:pPr>
+            <a:r>
+              <a:rPr lang="en-US" sz="1200" dirty="0">
+                <a:solidFill>
+                  <a:schemeClr val="tx1"/>
+                </a:solidFill>
+                <a:latin typeface="Calibri" pitchFamily="34" charset="0"/>
+                <a:ea typeface="Calibri" pitchFamily="34" charset="-122"/>
+                <a:cs typeface="Calibri" pitchFamily="34" charset="-120"/>
+              </a:rPr>
+              <a:t>Validación y evaluación</a:t>
+            </a:r>
+            <a:endParaRPr lang="en-US" sz="1200" dirty="0"/>
+          </a:p>
+        </p:txBody>
+      </p:sp>
+      <p:sp>
+        <p:nvSpPr>
+          <p:cNvPr id="74" name="Text 72"/>
+          <p:cNvSpPr txBox="1"/>
+          <p:nvPr/>
+        </p:nvSpPr>
+        <p:spPr>
+          <a:xfrm>
+            <a:off x="6446520" y="4983480"/>
+            <a:ext cx="384048" cy="365760"/>
+          </a:xfrm>
+          <a:prstGeom prst="rect">
+            <a:avLst/>
+          </a:prstGeom>
+          <a:noFill/>
+          <a:ln/>
+        </p:spPr>
+        <p:txBody>
+          <a:bodyPr wrap="square" lIns="0" tIns="0" rIns="0" bIns="0" rtlCol="0" anchor="ctr"/>
+          <a:lstStyle/>
+          <a:p>
+            <a:pPr algn="ctr" indent="0" marL="0">
+              <a:buNone/>
+            </a:pPr>
+            <a:r>
+              <a:rPr lang="en-US" sz="1200" b="1" dirty="0">
+                <a:solidFill>
+                  <a:schemeClr val="accent4"/>
+                </a:solidFill>
+                <a:latin typeface="Calibri" pitchFamily="34" charset="0"/>
+                <a:ea typeface="Calibri" pitchFamily="34" charset="-122"/>
+                <a:cs typeface="Calibri" pitchFamily="34" charset="-120"/>
+              </a:rPr>
+              <a:t>—</a:t>
+            </a:r>
+            <a:endParaRPr lang="en-US" sz="1200" dirty="0"/>
+          </a:p>
+        </p:txBody>
+      </p:sp>
+      <p:sp>
+        <p:nvSpPr>
+          <p:cNvPr id="75" name="barra-100"/>
+          <p:cNvSpPr/>
+          <p:nvPr/>
+        </p:nvSpPr>
+        <p:spPr>
+          <a:xfrm>
+            <a:off x="9656064" y="5074920"/>
+            <a:ext cx="566928" cy="182880"/>
+          </a:xfrm>
+          <a:prstGeom prst="roundRect">
+            <a:avLst>
+              <a:gd name="adj" fmla="val 25000"/>
             </a:avLst>
           </a:prstGeom>
           <a:solidFill>
@@ -5019,14 +6471,114 @@
       </p:sp>
       <p:sp>
         <p:nvSpPr>
-          <p:cNvPr id="33" name="fila-96"/>
+          <p:cNvPr id="76" name="Text 74"/>
+          <p:cNvSpPr txBox="1"/>
+          <p:nvPr/>
+        </p:nvSpPr>
+        <p:spPr>
+          <a:xfrm>
+            <a:off x="4398264" y="5349240"/>
+            <a:ext cx="2048256" cy="365760"/>
+          </a:xfrm>
+          <a:prstGeom prst="rect">
+            <a:avLst/>
+          </a:prstGeom>
+          <a:noFill/>
+          <a:ln/>
+        </p:spPr>
+        <p:txBody>
+          <a:bodyPr wrap="square" lIns="0" tIns="0" rIns="0" bIns="0" rtlCol="0" anchor="ctr"/>
+          <a:lstStyle/>
+          <a:p>
+            <a:pPr indent="0" marL="0">
+              <a:buNone/>
+            </a:pPr>
+            <a:r>
+              <a:rPr lang="en-US" sz="1200" dirty="0">
+                <a:solidFill>
+                  <a:schemeClr val="tx1"/>
+                </a:solidFill>
+                <a:latin typeface="Calibri" pitchFamily="34" charset="0"/>
+                <a:ea typeface="Calibri" pitchFamily="34" charset="-122"/>
+                <a:cs typeface="Calibri" pitchFamily="34" charset="-120"/>
+              </a:rPr>
+              <a:t>Pedido real y medición</a:t>
+            </a:r>
+            <a:endParaRPr lang="en-US" sz="1200" dirty="0"/>
+          </a:p>
+        </p:txBody>
+      </p:sp>
+      <p:sp>
+        <p:nvSpPr>
+          <p:cNvPr id="77" name="Text 75"/>
+          <p:cNvSpPr txBox="1"/>
+          <p:nvPr/>
+        </p:nvSpPr>
+        <p:spPr>
+          <a:xfrm>
+            <a:off x="6446520" y="5349240"/>
+            <a:ext cx="384048" cy="365760"/>
+          </a:xfrm>
+          <a:prstGeom prst="rect">
+            <a:avLst/>
+          </a:prstGeom>
+          <a:noFill/>
+          <a:ln/>
+        </p:spPr>
+        <p:txBody>
+          <a:bodyPr wrap="square" lIns="0" tIns="0" rIns="0" bIns="0" rtlCol="0" anchor="ctr"/>
+          <a:lstStyle/>
+          <a:p>
+            <a:pPr algn="ctr" indent="0" marL="0">
+              <a:buNone/>
+            </a:pPr>
+            <a:r>
+              <a:rPr lang="en-US" sz="1200" b="1" dirty="0">
+                <a:solidFill>
+                  <a:schemeClr val="accent4"/>
+                </a:solidFill>
+                <a:latin typeface="Calibri" pitchFamily="34" charset="0"/>
+                <a:ea typeface="Calibri" pitchFamily="34" charset="-122"/>
+                <a:cs typeface="Calibri" pitchFamily="34" charset="-120"/>
+              </a:rPr>
+              <a:t>—</a:t>
+            </a:r>
+            <a:endParaRPr lang="en-US" sz="1200" dirty="0"/>
+          </a:p>
+        </p:txBody>
+      </p:sp>
+      <p:sp>
+        <p:nvSpPr>
+          <p:cNvPr id="78" name="barra-101"/>
           <p:cNvSpPr/>
           <p:nvPr/>
         </p:nvSpPr>
         <p:spPr>
           <a:xfrm>
-            <a:off x="4343400" y="4498848"/>
-            <a:ext cx="7242048" cy="429768"/>
+            <a:off x="9966960" y="5440680"/>
+            <a:ext cx="1188720" cy="182880"/>
+          </a:xfrm>
+          <a:prstGeom prst="roundRect">
+            <a:avLst>
+              <a:gd name="adj" fmla="val 25000"/>
+            </a:avLst>
+          </a:prstGeom>
+          <a:solidFill>
+            <a:schemeClr val="tx2"/>
+          </a:solidFill>
+          <a:ln/>
+        </p:spPr>
+      </p:sp>
+      <p:sp>
+        <p:nvSpPr>
+          <p:cNvPr id="79" name="fila-102"/>
+          <p:cNvSpPr/>
+          <p:nvPr/>
+        </p:nvSpPr>
+        <p:spPr>
+          <a:xfrm>
+            <a:off x="4343400" y="5715000"/>
+            <a:ext cx="7150608" cy="365760"/>
           </a:xfrm>
           <a:prstGeom prst="rect">
             <a:avLst/>
@@ -5039,14 +6591,14 @@
       </p:sp>
       <p:sp>
         <p:nvSpPr>
-          <p:cNvPr id="34" name="Text 32"/>
+          <p:cNvPr id="80" name="Text 78"/>
           <p:cNvSpPr txBox="1"/>
           <p:nvPr/>
         </p:nvSpPr>
         <p:spPr>
           <a:xfrm>
-            <a:off x="4416552" y="4498848"/>
-            <a:ext cx="2514600" cy="429768"/>
+            <a:off x="4398264" y="5715000"/>
+            <a:ext cx="2048256" cy="365760"/>
           </a:xfrm>
           <a:prstGeom prst="rect">
             <a:avLst/>
@@ -5062,7 +6614,7 @@
               <a:buNone/>
             </a:pPr>
             <a:r>
-              <a:rPr lang="en-US" sz="1300" dirty="0">
+              <a:rPr lang="en-US" sz="1200" dirty="0">
                 <a:solidFill>
                   <a:schemeClr val="tx1"/>
                 </a:solidFill>
@@ -5070,168 +6622,65 @@
                 <a:ea typeface="Calibri" pitchFamily="34" charset="-122"/>
                 <a:cs typeface="Calibri" pitchFamily="34" charset="-120"/>
               </a:rPr>
-              <a:t>Evaluación y documentos</a:t>
-            </a:r>
-            <a:endParaRPr lang="en-US" sz="1300" dirty="0"/>
-          </a:p>
-        </p:txBody>
-      </p:sp>
-      <p:sp>
-        <p:nvSpPr>
-          <p:cNvPr id="35" name="barra-97"/>
+              <a:t>Presentación y ensayo</a:t>
+            </a:r>
+            <a:endParaRPr lang="en-US" sz="1200" dirty="0"/>
+          </a:p>
+        </p:txBody>
+      </p:sp>
+      <p:sp>
+        <p:nvSpPr>
+          <p:cNvPr id="81" name="Text 79"/>
+          <p:cNvSpPr txBox="1"/>
+          <p:nvPr/>
+        </p:nvSpPr>
+        <p:spPr>
+          <a:xfrm>
+            <a:off x="6446520" y="5715000"/>
+            <a:ext cx="384048" cy="365760"/>
+          </a:xfrm>
+          <a:prstGeom prst="rect">
+            <a:avLst/>
+          </a:prstGeom>
+          <a:noFill/>
+          <a:ln/>
+        </p:spPr>
+        <p:txBody>
+          <a:bodyPr wrap="square" lIns="0" tIns="0" rIns="0" bIns="0" rtlCol="0" anchor="ctr"/>
+          <a:lstStyle/>
+          <a:p>
+            <a:pPr algn="ctr" indent="0" marL="0">
+              <a:buNone/>
+            </a:pPr>
+            <a:r>
+              <a:rPr lang="en-US" sz="1200" b="1" dirty="0">
+                <a:solidFill>
+                  <a:schemeClr val="accent4"/>
+                </a:solidFill>
+                <a:latin typeface="Calibri" pitchFamily="34" charset="0"/>
+                <a:ea typeface="Calibri" pitchFamily="34" charset="-122"/>
+                <a:cs typeface="Calibri" pitchFamily="34" charset="-120"/>
+              </a:rPr>
+              <a:t>—</a:t>
+            </a:r>
+            <a:endParaRPr lang="en-US" sz="1200" dirty="0"/>
+          </a:p>
+        </p:txBody>
+      </p:sp>
+      <p:sp>
+        <p:nvSpPr>
+          <p:cNvPr id="82" name="barra-103"/>
           <p:cNvSpPr/>
           <p:nvPr/>
         </p:nvSpPr>
         <p:spPr>
           <a:xfrm>
-            <a:off x="8110728" y="4608576"/>
-            <a:ext cx="1097280" cy="210312"/>
+            <a:off x="9656064" y="5806440"/>
+            <a:ext cx="1499616" cy="182880"/>
           </a:xfrm>
           <a:prstGeom prst="roundRect">
             <a:avLst>
-              <a:gd name="adj" fmla="val 26087"/>
-            </a:avLst>
-          </a:prstGeom>
-          <a:solidFill>
-            <a:schemeClr val="tx2"/>
-          </a:solidFill>
-          <a:ln/>
-        </p:spPr>
-      </p:sp>
-      <p:sp>
-        <p:nvSpPr>
-          <p:cNvPr id="36" name="Text 34"/>
-          <p:cNvSpPr txBox="1"/>
-          <p:nvPr/>
-        </p:nvSpPr>
-        <p:spPr>
-          <a:xfrm>
-            <a:off x="4416552" y="4928616"/>
-            <a:ext cx="2514600" cy="429768"/>
-          </a:xfrm>
-          <a:prstGeom prst="rect">
-            <a:avLst/>
-          </a:prstGeom>
-          <a:noFill/>
-          <a:ln/>
-        </p:spPr>
-        <p:txBody>
-          <a:bodyPr wrap="square" lIns="0" tIns="0" rIns="0" bIns="0" rtlCol="0" anchor="ctr"/>
-          <a:lstStyle/>
-          <a:p>
-            <a:pPr indent="0" marL="0">
-              <a:buNone/>
-            </a:pPr>
-            <a:r>
-              <a:rPr lang="en-US" sz="1300" dirty="0">
-                <a:solidFill>
-                  <a:schemeClr val="tx1"/>
-                </a:solidFill>
-                <a:latin typeface="Calibri" pitchFamily="34" charset="0"/>
-                <a:ea typeface="Calibri" pitchFamily="34" charset="-122"/>
-                <a:cs typeface="Calibri" pitchFamily="34" charset="-120"/>
-              </a:rPr>
-              <a:t>Pedido real y medición</a:t>
-            </a:r>
-            <a:endParaRPr lang="en-US" sz="1300" dirty="0"/>
-          </a:p>
-        </p:txBody>
-      </p:sp>
-      <p:sp>
-        <p:nvSpPr>
-          <p:cNvPr id="37" name="barra-98"/>
-          <p:cNvSpPr/>
-          <p:nvPr/>
-        </p:nvSpPr>
-        <p:spPr>
-          <a:xfrm>
-            <a:off x="8695944" y="5038344"/>
-            <a:ext cx="2267712" cy="210312"/>
-          </a:xfrm>
-          <a:prstGeom prst="roundRect">
-            <a:avLst>
-              <a:gd name="adj" fmla="val 26087"/>
-            </a:avLst>
-          </a:prstGeom>
-          <a:solidFill>
-            <a:schemeClr val="accent2"/>
-          </a:solidFill>
-          <a:ln/>
-        </p:spPr>
-      </p:sp>
-      <p:sp>
-        <p:nvSpPr>
-          <p:cNvPr id="38" name="fila-99"/>
-          <p:cNvSpPr/>
-          <p:nvPr/>
-        </p:nvSpPr>
-        <p:spPr>
-          <a:xfrm>
-            <a:off x="4343400" y="5358384"/>
-            <a:ext cx="7242048" cy="429768"/>
-          </a:xfrm>
-          <a:prstGeom prst="rect">
-            <a:avLst/>
-          </a:prstGeom>
-          <a:solidFill>
-            <a:schemeClr val="accent6"/>
-          </a:solidFill>
-          <a:ln/>
-        </p:spPr>
-      </p:sp>
-      <p:sp>
-        <p:nvSpPr>
-          <p:cNvPr id="39" name="Text 37"/>
-          <p:cNvSpPr txBox="1"/>
-          <p:nvPr/>
-        </p:nvSpPr>
-        <p:spPr>
-          <a:xfrm>
-            <a:off x="4416552" y="5358384"/>
-            <a:ext cx="2514600" cy="429768"/>
-          </a:xfrm>
-          <a:prstGeom prst="rect">
-            <a:avLst/>
-          </a:prstGeom>
-          <a:noFill/>
-          <a:ln/>
-        </p:spPr>
-        <p:txBody>
-          <a:bodyPr wrap="square" lIns="0" tIns="0" rIns="0" bIns="0" rtlCol="0" anchor="ctr"/>
-          <a:lstStyle/>
-          <a:p>
-            <a:pPr indent="0" marL="0">
-              <a:buNone/>
-            </a:pPr>
-            <a:r>
-              <a:rPr lang="en-US" sz="1300" dirty="0">
-                <a:solidFill>
-                  <a:schemeClr val="tx1"/>
-                </a:solidFill>
-                <a:latin typeface="Calibri" pitchFamily="34" charset="0"/>
-                <a:ea typeface="Calibri" pitchFamily="34" charset="-122"/>
-                <a:cs typeface="Calibri" pitchFamily="34" charset="-120"/>
-              </a:rPr>
-              <a:t>Presentación y ensayo</a:t>
-            </a:r>
-            <a:endParaRPr lang="en-US" sz="1300" dirty="0"/>
-          </a:p>
-        </p:txBody>
-      </p:sp>
-      <p:sp>
-        <p:nvSpPr>
-          <p:cNvPr id="40" name="barra-100"/>
-          <p:cNvSpPr/>
-          <p:nvPr/>
-        </p:nvSpPr>
-        <p:spPr>
-          <a:xfrm>
-            <a:off x="8110728" y="5468112"/>
-            <a:ext cx="2852928" cy="210312"/>
-          </a:xfrm>
-          <a:prstGeom prst="roundRect">
-            <a:avLst>
-              <a:gd name="adj" fmla="val 26087"/>
+              <a:gd name="adj" fmla="val 25000"/>
             </a:avLst>
           </a:prstGeom>
           <a:solidFill>
@@ -5242,14 +6691,37 @@
       </p:sp>
       <p:sp>
         <p:nvSpPr>
-          <p:cNvPr id="41" name="hito-101"/>
+          <p:cNvPr id="83" name="semana-104"/>
           <p:cNvSpPr/>
           <p:nvPr/>
         </p:nvSpPr>
         <p:spPr>
           <a:xfrm>
-            <a:off x="8074152" y="1874520"/>
-            <a:ext cx="0" cy="3959352"/>
+            <a:off x="9006840" y="1645920"/>
+            <a:ext cx="0" cy="4434840"/>
+          </a:xfrm>
+          <a:prstGeom prst="line">
+            <a:avLst/>
+          </a:prstGeom>
+          <a:noFill/>
+          <a:ln w="12700">
+            <a:solidFill>
+              <a:srgbClr val="E4DCD2"/>
+            </a:solidFill>
+            <a:prstDash val="solid"/>
+          </a:ln>
+        </p:spPr>
+      </p:sp>
+      <p:sp>
+        <p:nvSpPr>
+          <p:cNvPr id="84" name="hito-105"/>
+          <p:cNvSpPr/>
+          <p:nvPr/>
+        </p:nvSpPr>
+        <p:spPr>
+          <a:xfrm>
+            <a:off x="9628632" y="2011680"/>
+            <a:ext cx="0" cy="4114800"/>
           </a:xfrm>
           <a:prstGeom prst="line">
             <a:avLst/>
@@ -5265,14 +6737,14 @@
       </p:sp>
       <p:sp>
         <p:nvSpPr>
-          <p:cNvPr id="42" name="hito-102"/>
+          <p:cNvPr id="85" name="hito-106"/>
           <p:cNvSpPr/>
           <p:nvPr/>
         </p:nvSpPr>
         <p:spPr>
           <a:xfrm>
-            <a:off x="11292840" y="1874520"/>
-            <a:ext cx="0" cy="3959352"/>
+            <a:off x="11338560" y="2011680"/>
+            <a:ext cx="0" cy="4114800"/>
           </a:xfrm>
           <a:prstGeom prst="line">
             <a:avLst/>
@@ -5288,14 +6760,14 @@
       </p:sp>
       <p:sp>
         <p:nvSpPr>
-          <p:cNvPr id="43" name="Text 41"/>
+          <p:cNvPr id="86" name="Text 84"/>
           <p:cNvSpPr txBox="1"/>
           <p:nvPr/>
         </p:nvSpPr>
         <p:spPr>
           <a:xfrm>
-            <a:off x="8028432" y="5897880"/>
-            <a:ext cx="1737360" cy="274320"/>
+            <a:off x="4398264" y="6126480"/>
+            <a:ext cx="2432304" cy="274320"/>
           </a:xfrm>
           <a:prstGeom prst="rect">
             <a:avLst/>
@@ -5307,89 +6779,128 @@
           <a:bodyPr wrap="square" lIns="0" tIns="0" rIns="0" bIns="0" rtlCol="0" anchor="t"/>
           <a:lstStyle/>
           <a:p>
+            <a:pPr algn="r" indent="0" marL="0">
+              <a:buNone/>
+            </a:pPr>
+            <a:r>
+              <a:rPr lang="en-US" sz="1200" b="1" dirty="0">
+                <a:solidFill>
+                  <a:schemeClr val="tx1"/>
+                </a:solidFill>
+                <a:latin typeface="Calibri" pitchFamily="34" charset="0"/>
+                <a:ea typeface="Calibri" pitchFamily="34" charset="-122"/>
+                <a:cs typeface="Calibri" pitchFamily="34" charset="-120"/>
+              </a:rPr>
+              <a:t>Total 48 h</a:t>
+            </a:r>
+            <a:endParaRPr lang="en-US" sz="1200" dirty="0"/>
+          </a:p>
+        </p:txBody>
+      </p:sp>
+      <p:sp>
+        <p:nvSpPr>
+          <p:cNvPr id="87" name="Text 85"/>
+          <p:cNvSpPr txBox="1"/>
+          <p:nvPr/>
+        </p:nvSpPr>
+        <p:spPr>
+          <a:xfrm>
+            <a:off x="7936992" y="6126480"/>
+            <a:ext cx="1645920" cy="274320"/>
+          </a:xfrm>
+          <a:prstGeom prst="rect">
+            <a:avLst/>
+          </a:prstGeom>
+          <a:noFill/>
+          <a:ln/>
+        </p:spPr>
+        <p:txBody>
+          <a:bodyPr wrap="square" lIns="0" tIns="0" rIns="0" bIns="0" rtlCol="0" anchor="t"/>
+          <a:lstStyle/>
+          <a:p>
+            <a:pPr algn="r" indent="0" marL="0">
+              <a:buNone/>
+            </a:pPr>
+            <a:r>
+              <a:rPr lang="en-US" sz="1200" b="1" dirty="0">
+                <a:solidFill>
+                  <a:schemeClr val="tx1"/>
+                </a:solidFill>
+                <a:latin typeface="Calibri" pitchFamily="34" charset="0"/>
+                <a:ea typeface="Calibri" pitchFamily="34" charset="-122"/>
+                <a:cs typeface="Calibri" pitchFamily="34" charset="-120"/>
+              </a:rPr>
+              <a:t>Publicado 06/10 ▲</a:t>
+            </a:r>
+            <a:endParaRPr lang="en-US" sz="1200" dirty="0"/>
+          </a:p>
+        </p:txBody>
+      </p:sp>
+      <p:sp>
+        <p:nvSpPr>
+          <p:cNvPr id="88" name="Text 86"/>
+          <p:cNvSpPr txBox="1"/>
+          <p:nvPr/>
+        </p:nvSpPr>
+        <p:spPr>
+          <a:xfrm>
+            <a:off x="10012680" y="6126480"/>
+            <a:ext cx="1280160" cy="274320"/>
+          </a:xfrm>
+          <a:prstGeom prst="rect">
+            <a:avLst/>
+          </a:prstGeom>
+          <a:noFill/>
+          <a:ln/>
+        </p:spPr>
+        <p:txBody>
+          <a:bodyPr wrap="square" lIns="0" tIns="0" rIns="0" bIns="0" rtlCol="0" anchor="t"/>
+          <a:lstStyle/>
+          <a:p>
+            <a:pPr algn="r" indent="0" marL="0">
+              <a:buNone/>
+            </a:pPr>
+            <a:r>
+              <a:rPr lang="en-US" sz="1200" b="1" dirty="0">
+                <a:solidFill>
+                  <a:schemeClr val="accent3"/>
+                </a:solidFill>
+                <a:latin typeface="Calibri" pitchFamily="34" charset="0"/>
+                <a:ea typeface="Calibri" pitchFamily="34" charset="-122"/>
+                <a:cs typeface="Calibri" pitchFamily="34" charset="-120"/>
+              </a:rPr>
+              <a:t>Expo 13/10 ▲</a:t>
+            </a:r>
+            <a:endParaRPr lang="en-US" sz="1200" dirty="0"/>
+          </a:p>
+        </p:txBody>
+      </p:sp>
+      <p:sp>
+        <p:nvSpPr>
+          <p:cNvPr id="89" name="Text 87"/>
+          <p:cNvSpPr txBox="1"/>
+          <p:nvPr/>
+        </p:nvSpPr>
+        <p:spPr>
+          <a:xfrm>
+            <a:off x="4343400" y="6428232"/>
+            <a:ext cx="7223760" cy="256032"/>
+          </a:xfrm>
+          <a:prstGeom prst="rect">
+            <a:avLst/>
+          </a:prstGeom>
+          <a:noFill/>
+          <a:ln/>
+        </p:spPr>
+        <p:txBody>
+          <a:bodyPr wrap="square" lIns="0" tIns="0" rIns="0" bIns="0" rtlCol="0" anchor="t"/>
+          <a:lstStyle/>
+          <a:p>
             <a:pPr indent="0" marL="0">
               <a:buNone/>
             </a:pPr>
             <a:r>
-              <a:rPr lang="en-US" sz="1200" b="1" dirty="0">
-                <a:solidFill>
-                  <a:schemeClr val="tx1"/>
-                </a:solidFill>
-                <a:latin typeface="Calibri" pitchFamily="34" charset="0"/>
-                <a:ea typeface="Calibri" pitchFamily="34" charset="-122"/>
-                <a:cs typeface="Calibri" pitchFamily="34" charset="-120"/>
-              </a:rPr>
-              <a:t>▲ Publicado 06/10</a:t>
-            </a:r>
-            <a:endParaRPr lang="en-US" sz="1200" dirty="0"/>
-          </a:p>
-        </p:txBody>
-      </p:sp>
-      <p:sp>
-        <p:nvSpPr>
-          <p:cNvPr id="44" name="Text 42"/>
-          <p:cNvSpPr txBox="1"/>
-          <p:nvPr/>
-        </p:nvSpPr>
-        <p:spPr>
-          <a:xfrm>
-            <a:off x="9966960" y="5897880"/>
-            <a:ext cx="1280160" cy="274320"/>
-          </a:xfrm>
-          <a:prstGeom prst="rect">
-            <a:avLst/>
-          </a:prstGeom>
-          <a:noFill/>
-          <a:ln/>
-        </p:spPr>
-        <p:txBody>
-          <a:bodyPr wrap="square" lIns="0" tIns="0" rIns="0" bIns="0" rtlCol="0" anchor="t"/>
-          <a:lstStyle/>
-          <a:p>
-            <a:pPr algn="r" indent="0" marL="0">
-              <a:buNone/>
-            </a:pPr>
-            <a:r>
-              <a:rPr lang="en-US" sz="1200" b="1" dirty="0">
-                <a:solidFill>
-                  <a:schemeClr val="accent3"/>
-                </a:solidFill>
-                <a:latin typeface="Calibri" pitchFamily="34" charset="0"/>
-                <a:ea typeface="Calibri" pitchFamily="34" charset="-122"/>
-                <a:cs typeface="Calibri" pitchFamily="34" charset="-120"/>
-              </a:rPr>
-              <a:t>Expo 13/10 ▲</a:t>
-            </a:r>
-            <a:endParaRPr lang="en-US" sz="1200" dirty="0"/>
-          </a:p>
-        </p:txBody>
-      </p:sp>
-      <p:sp>
-        <p:nvSpPr>
-          <p:cNvPr id="45" name="Text 43"/>
-          <p:cNvSpPr txBox="1"/>
-          <p:nvPr/>
-        </p:nvSpPr>
-        <p:spPr>
-          <a:xfrm>
-            <a:off x="4343400" y="6199632"/>
-            <a:ext cx="7223760" cy="274320"/>
-          </a:xfrm>
-          <a:prstGeom prst="rect">
-            <a:avLst/>
-          </a:prstGeom>
-          <a:noFill/>
-          <a:ln/>
-        </p:spPr>
-        <p:txBody>
-          <a:bodyPr wrap="square" lIns="0" tIns="0" rIns="0" bIns="0" rtlCol="0" anchor="t"/>
-          <a:lstStyle/>
-          <a:p>
-            <a:pPr indent="0" marL="0">
-              <a:buNone/>
-            </a:pPr>
-            <a:r>
-              <a:rPr lang="en-US" sz="1200" i="1" dirty="0">
+              <a:rPr lang="en-US" sz="1100" i="1" dirty="0">
                 <a:solidFill>
                   <a:schemeClr val="accent4"/>
                 </a:solidFill>
@@ -5399,7 +6910,7 @@
               </a:rPr>
               <a:t>Todas las tareas terminan el domingo 11/10.</a:t>
             </a:r>
-            <a:endParaRPr lang="en-US" sz="1200" dirty="0"/>
+            <a:endParaRPr lang="en-US" sz="1100" dirty="0"/>
           </a:p>
         </p:txBody>
       </p:sp>
@@ -5573,7 +7084,7 @@
       </p:graphicFrame>
       <p:sp>
         <p:nvSpPr>
-          <p:cNvPr id="5" name="card-103"/>
+          <p:cNvPr id="5" name="card-107"/>
           <p:cNvSpPr/>
           <p:nvPr/>
         </p:nvSpPr>
@@ -5712,7 +7223,7 @@
       </p:sp>
       <p:sp>
         <p:nvSpPr>
-          <p:cNvPr id="9" name="card-104"/>
+          <p:cNvPr id="9" name="card-108"/>
           <p:cNvSpPr/>
           <p:nvPr/>
         </p:nvSpPr>
@@ -6049,7 +7560,7 @@
       </p:sp>
       <p:sp>
         <p:nvSpPr>
-          <p:cNvPr id="5" name="icono-fondo-105"/>
+          <p:cNvPr id="5" name="icono-fondo-109"/>
           <p:cNvSpPr/>
           <p:nvPr/>
         </p:nvSpPr>
@@ -6069,7 +7580,7 @@
       </p:sp>
       <p:pic>
         <p:nvPicPr>
-          <p:cNvPr id="6" name="icono-106" descr="preencoded.png">    </p:cNvPr>
+          <p:cNvPr id="6" name="icono-110" descr="preencoded.png">    </p:cNvPr>
           <p:cNvPicPr>
             <a:picLocks noChangeAspect="1"/>
           </p:cNvPicPr>
@@ -6171,7 +7682,7 @@
       </p:sp>
       <p:sp>
         <p:nvSpPr>
-          <p:cNvPr id="9" name="icono-fondo-107"/>
+          <p:cNvPr id="9" name="icono-fondo-111"/>
           <p:cNvSpPr/>
           <p:nvPr/>
         </p:nvSpPr>
@@ -6191,7 +7702,7 @@
       </p:sp>
       <p:pic>
         <p:nvPicPr>
-          <p:cNvPr id="10" name="icono-108" descr="preencoded.png">    </p:cNvPr>
+          <p:cNvPr id="10" name="icono-112" descr="preencoded.png">    </p:cNvPr>
           <p:cNvPicPr>
             <a:picLocks noChangeAspect="1"/>
           </p:cNvPicPr>
@@ -6293,7 +7804,7 @@
       </p:sp>
       <p:sp>
         <p:nvSpPr>
-          <p:cNvPr id="13" name="icono-fondo-109"/>
+          <p:cNvPr id="13" name="icono-fondo-113"/>
           <p:cNvSpPr/>
           <p:nvPr/>
         </p:nvSpPr>
@@ -6313,7 +7824,7 @@
       </p:sp>
       <p:pic>
         <p:nvPicPr>
-          <p:cNvPr id="14" name="icono-110" descr="preencoded.png">    </p:cNvPr>
+          <p:cNvPr id="14" name="icono-114" descr="preencoded.png">    </p:cNvPr>
           <p:cNvPicPr>
             <a:picLocks noChangeAspect="1"/>
           </p:cNvPicPr>
@@ -6415,7 +7926,7 @@
       </p:sp>
       <p:sp>
         <p:nvSpPr>
-          <p:cNvPr id="17" name="card-111"/>
+          <p:cNvPr id="17" name="card-115"/>
           <p:cNvSpPr/>
           <p:nvPr/>
         </p:nvSpPr>
@@ -8643,7 +10154,7 @@
       </p:sp>
       <p:sp>
         <p:nvSpPr>
-          <p:cNvPr id="6" name="card-112"/>
+          <p:cNvPr id="6" name="card-116"/>
           <p:cNvSpPr/>
           <p:nvPr/>
         </p:nvSpPr>
@@ -8743,7 +10254,7 @@
       </p:sp>
       <p:sp>
         <p:nvSpPr>
-          <p:cNvPr id="9" name="card-113"/>
+          <p:cNvPr id="9" name="card-117"/>
           <p:cNvSpPr/>
           <p:nvPr/>
         </p:nvSpPr>
@@ -8843,7 +10354,7 @@
       </p:sp>
       <p:sp>
         <p:nvSpPr>
-          <p:cNvPr id="12" name="card-114"/>
+          <p:cNvPr id="12" name="card-118"/>
           <p:cNvSpPr/>
           <p:nvPr/>
         </p:nvSpPr>
@@ -9073,7 +10584,7 @@
       </p:sp>
       <p:sp>
         <p:nvSpPr>
-          <p:cNvPr id="4" name="nodo-115"/>
+          <p:cNvPr id="4" name="nodo-119"/>
           <p:cNvSpPr/>
           <p:nvPr/>
         </p:nvSpPr>
@@ -9180,7 +10691,7 @@
       </p:sp>
       <p:sp>
         <p:nvSpPr>
-          <p:cNvPr id="7" name="nodo-116"/>
+          <p:cNvPr id="7" name="nodo-120"/>
           <p:cNvSpPr/>
           <p:nvPr/>
         </p:nvSpPr>
@@ -9248,7 +10759,7 @@
       </p:sp>
       <p:sp>
         <p:nvSpPr>
-          <p:cNvPr id="9" name="capa-117"/>
+          <p:cNvPr id="9" name="capa-121"/>
           <p:cNvSpPr/>
           <p:nvPr/>
         </p:nvSpPr>
@@ -9326,7 +10837,7 @@
       </p:sp>
       <p:sp>
         <p:nvSpPr>
-          <p:cNvPr id="11" name="capa-118"/>
+          <p:cNvPr id="11" name="capa-122"/>
           <p:cNvSpPr/>
           <p:nvPr/>
         </p:nvSpPr>
@@ -9404,7 +10915,7 @@
       </p:sp>
       <p:sp>
         <p:nvSpPr>
-          <p:cNvPr id="13" name="capa-119"/>
+          <p:cNvPr id="13" name="capa-123"/>
           <p:cNvSpPr/>
           <p:nvPr/>
         </p:nvSpPr>
@@ -9482,7 +10993,7 @@
       </p:sp>
       <p:sp>
         <p:nvSpPr>
-          <p:cNvPr id="15" name="nodo-120"/>
+          <p:cNvPr id="15" name="nodo-124"/>
           <p:cNvSpPr/>
           <p:nvPr/>
         </p:nvSpPr>
@@ -9589,7 +11100,7 @@
       </p:sp>
       <p:sp>
         <p:nvSpPr>
-          <p:cNvPr id="18" name="nodo-121"/>
+          <p:cNvPr id="18" name="nodo-125"/>
           <p:cNvSpPr/>
           <p:nvPr/>
         </p:nvSpPr>
@@ -9696,7 +11207,7 @@
       </p:sp>
       <p:sp>
         <p:nvSpPr>
-          <p:cNvPr id="21" name="nodo-122"/>
+          <p:cNvPr id="21" name="nodo-126"/>
           <p:cNvSpPr/>
           <p:nvPr/>
         </p:nvSpPr>
@@ -9764,7 +11275,7 @@
       </p:sp>
       <p:sp>
         <p:nvSpPr>
-          <p:cNvPr id="23" name="nodo-123"/>
+          <p:cNvPr id="23" name="nodo-127"/>
           <p:cNvSpPr/>
           <p:nvPr/>
         </p:nvSpPr>
@@ -9832,7 +11343,7 @@
       </p:sp>
       <p:sp>
         <p:nvSpPr>
-          <p:cNvPr id="25" name="flecha-124"/>
+          <p:cNvPr id="25" name="flecha-128"/>
           <p:cNvSpPr/>
           <p:nvPr/>
         </p:nvSpPr>
@@ -9895,7 +11406,7 @@
       </p:sp>
       <p:sp>
         <p:nvSpPr>
-          <p:cNvPr id="27" name="flecha-125"/>
+          <p:cNvPr id="27" name="flecha-129"/>
           <p:cNvSpPr/>
           <p:nvPr/>
         </p:nvSpPr>
@@ -9958,7 +11469,7 @@
       </p:sp>
       <p:sp>
         <p:nvSpPr>
-          <p:cNvPr id="29" name="flecha-126"/>
+          <p:cNvPr id="29" name="flecha-130"/>
           <p:cNvSpPr/>
           <p:nvPr/>
         </p:nvSpPr>
@@ -9982,7 +11493,7 @@
       </p:sp>
       <p:sp>
         <p:nvSpPr>
-          <p:cNvPr id="30" name="flecha-127"/>
+          <p:cNvPr id="30" name="flecha-131"/>
           <p:cNvSpPr/>
           <p:nvPr/>
         </p:nvSpPr>
@@ -10045,7 +11556,7 @@
       </p:sp>
       <p:sp>
         <p:nvSpPr>
-          <p:cNvPr id="32" name="flecha-128"/>
+          <p:cNvPr id="32" name="flecha-132"/>
           <p:cNvSpPr/>
           <p:nvPr/>
         </p:nvSpPr>
@@ -10108,7 +11619,7 @@
       </p:sp>
       <p:sp>
         <p:nvSpPr>
-          <p:cNvPr id="34" name="card-129"/>
+          <p:cNvPr id="34" name="card-133"/>
           <p:cNvSpPr/>
           <p:nvPr/>
         </p:nvSpPr>
@@ -10360,7 +11871,7 @@
       </p:sp>
       <p:sp>
         <p:nvSpPr>
-          <p:cNvPr id="5" name="card-130"/>
+          <p:cNvPr id="5" name="card-134"/>
           <p:cNvSpPr/>
           <p:nvPr/>
         </p:nvSpPr>
@@ -10438,7 +11949,7 @@
       </p:sp>
       <p:sp>
         <p:nvSpPr>
-          <p:cNvPr id="7" name="card-131"/>
+          <p:cNvPr id="7" name="card-135"/>
           <p:cNvSpPr/>
           <p:nvPr/>
         </p:nvSpPr>
@@ -10516,7 +12027,7 @@
       </p:sp>
       <p:sp>
         <p:nvSpPr>
-          <p:cNvPr id="9" name="card-132"/>
+          <p:cNvPr id="9" name="card-136"/>
           <p:cNvSpPr/>
           <p:nvPr/>
         </p:nvSpPr>
@@ -10594,7 +12105,7 @@
       </p:sp>
       <p:sp>
         <p:nvSpPr>
-          <p:cNvPr id="11" name="card-133"/>
+          <p:cNvPr id="11" name="card-137"/>
           <p:cNvSpPr/>
           <p:nvPr/>
         </p:nvSpPr>
@@ -10672,7 +12183,7 @@
       </p:sp>
       <p:sp>
         <p:nvSpPr>
-          <p:cNvPr id="13" name="card-134"/>
+          <p:cNvPr id="13" name="card-138"/>
           <p:cNvSpPr/>
           <p:nvPr/>
         </p:nvSpPr>
@@ -10750,7 +12261,7 @@
       </p:sp>
       <p:sp>
         <p:nvSpPr>
-          <p:cNvPr id="15" name="card-135"/>
+          <p:cNvPr id="15" name="card-139"/>
           <p:cNvSpPr/>
           <p:nvPr/>
         </p:nvSpPr>
@@ -10906,7 +12417,7 @@
       </p:sp>
       <p:sp>
         <p:nvSpPr>
-          <p:cNvPr id="19" name="etiqueta-136"/>
+          <p:cNvPr id="19" name="etiqueta-140"/>
           <p:cNvSpPr/>
           <p:nvPr/>
         </p:nvSpPr>
@@ -10967,7 +12478,7 @@
       </p:sp>
       <p:sp>
         <p:nvSpPr>
-          <p:cNvPr id="21" name="etiqueta-137"/>
+          <p:cNvPr id="21" name="etiqueta-141"/>
           <p:cNvSpPr/>
           <p:nvPr/>
         </p:nvSpPr>
@@ -11028,7 +12539,7 @@
       </p:sp>
       <p:sp>
         <p:nvSpPr>
-          <p:cNvPr id="23" name="etiqueta-138"/>
+          <p:cNvPr id="23" name="etiqueta-142"/>
           <p:cNvSpPr/>
           <p:nvPr/>
         </p:nvSpPr>
@@ -11089,7 +12600,7 @@
       </p:sp>
       <p:sp>
         <p:nvSpPr>
-          <p:cNvPr id="25" name="etiqueta-139"/>
+          <p:cNvPr id="25" name="etiqueta-143"/>
           <p:cNvSpPr/>
           <p:nvPr/>
         </p:nvSpPr>
@@ -11150,7 +12661,7 @@
       </p:sp>
       <p:sp>
         <p:nvSpPr>
-          <p:cNvPr id="27" name="etiqueta-140"/>
+          <p:cNvPr id="27" name="etiqueta-144"/>
           <p:cNvSpPr/>
           <p:nvPr/>
         </p:nvSpPr>
@@ -11211,7 +12722,7 @@
       </p:sp>
       <p:sp>
         <p:nvSpPr>
-          <p:cNvPr id="29" name="etiqueta-141"/>
+          <p:cNvPr id="29" name="etiqueta-145"/>
           <p:cNvSpPr/>
           <p:nvPr/>
         </p:nvSpPr>
@@ -11272,7 +12783,7 @@
       </p:sp>
       <p:sp>
         <p:nvSpPr>
-          <p:cNvPr id="31" name="etiqueta-142"/>
+          <p:cNvPr id="31" name="etiqueta-146"/>
           <p:cNvSpPr/>
           <p:nvPr/>
         </p:nvSpPr>
@@ -11333,7 +12844,7 @@
       </p:sp>
       <p:sp>
         <p:nvSpPr>
-          <p:cNvPr id="33" name="etiqueta-143"/>
+          <p:cNvPr id="33" name="etiqueta-147"/>
           <p:cNvSpPr/>
           <p:nvPr/>
         </p:nvSpPr>
@@ -11394,7 +12905,7 @@
       </p:sp>
       <p:sp>
         <p:nvSpPr>
-          <p:cNvPr id="35" name="card-144"/>
+          <p:cNvPr id="35" name="card-148"/>
           <p:cNvSpPr/>
           <p:nvPr/>
         </p:nvSpPr>
@@ -11646,7 +13157,7 @@
       </p:sp>
       <p:sp>
         <p:nvSpPr>
-          <p:cNvPr id="4" name="icono-fondo-145"/>
+          <p:cNvPr id="4" name="icono-fondo-149"/>
           <p:cNvSpPr/>
           <p:nvPr/>
         </p:nvSpPr>
@@ -11666,7 +13177,7 @@
       </p:sp>
       <p:pic>
         <p:nvPicPr>
-          <p:cNvPr id="5" name="icono-146" descr="preencoded.png">    </p:cNvPr>
+          <p:cNvPr id="5" name="icono-150" descr="preencoded.png">    </p:cNvPr>
           <p:cNvPicPr>
             <a:picLocks noChangeAspect="1"/>
           </p:cNvPicPr>
@@ -11768,7 +13279,7 @@
       </p:sp>
       <p:pic>
         <p:nvPicPr>
-          <p:cNvPr id="8" name="flecha-147" descr="preencoded.png">    </p:cNvPr>
+          <p:cNvPr id="8" name="flecha-151" descr="preencoded.png">    </p:cNvPr>
           <p:cNvPicPr>
             <a:picLocks noChangeAspect="1"/>
           </p:cNvPicPr>
@@ -11792,7 +13303,7 @@
       </p:pic>
       <p:sp>
         <p:nvSpPr>
-          <p:cNvPr id="9" name="icono-fondo-148"/>
+          <p:cNvPr id="9" name="icono-fondo-152"/>
           <p:cNvSpPr/>
           <p:nvPr/>
         </p:nvSpPr>
@@ -11812,7 +13323,7 @@
       </p:sp>
       <p:pic>
         <p:nvPicPr>
-          <p:cNvPr id="10" name="icono-149" descr="preencoded.png">    </p:cNvPr>
+          <p:cNvPr id="10" name="icono-153" descr="preencoded.png">    </p:cNvPr>
           <p:cNvPicPr>
             <a:picLocks noChangeAspect="1"/>
           </p:cNvPicPr>
@@ -11914,7 +13425,7 @@
       </p:sp>
       <p:pic>
         <p:nvPicPr>
-          <p:cNvPr id="13" name="flecha-150" descr="preencoded.png">    </p:cNvPr>
+          <p:cNvPr id="13" name="flecha-154" descr="preencoded.png">    </p:cNvPr>
           <p:cNvPicPr>
             <a:picLocks noChangeAspect="1"/>
           </p:cNvPicPr>
@@ -11938,7 +13449,7 @@
       </p:pic>
       <p:sp>
         <p:nvSpPr>
-          <p:cNvPr id="14" name="icono-fondo-151"/>
+          <p:cNvPr id="14" name="icono-fondo-155"/>
           <p:cNvSpPr/>
           <p:nvPr/>
         </p:nvSpPr>
@@ -11958,7 +13469,7 @@
       </p:sp>
       <p:pic>
         <p:nvPicPr>
-          <p:cNvPr id="15" name="icono-152" descr="preencoded.png">    </p:cNvPr>
+          <p:cNvPr id="15" name="icono-156" descr="preencoded.png">    </p:cNvPr>
           <p:cNvPicPr>
             <a:picLocks noChangeAspect="1"/>
           </p:cNvPicPr>
@@ -12060,7 +13571,7 @@
       </p:sp>
       <p:pic>
         <p:nvPicPr>
-          <p:cNvPr id="18" name="flecha-153" descr="preencoded.png">    </p:cNvPr>
+          <p:cNvPr id="18" name="flecha-157" descr="preencoded.png">    </p:cNvPr>
           <p:cNvPicPr>
             <a:picLocks noChangeAspect="1"/>
           </p:cNvPicPr>
@@ -12084,7 +13595,7 @@
       </p:pic>
       <p:sp>
         <p:nvSpPr>
-          <p:cNvPr id="19" name="icono-fondo-154"/>
+          <p:cNvPr id="19" name="icono-fondo-158"/>
           <p:cNvSpPr/>
           <p:nvPr/>
         </p:nvSpPr>
@@ -12104,7 +13615,7 @@
       </p:sp>
       <p:pic>
         <p:nvPicPr>
-          <p:cNvPr id="20" name="icono-155" descr="preencoded.png">    </p:cNvPr>
+          <p:cNvPr id="20" name="icono-159" descr="preencoded.png">    </p:cNvPr>
           <p:cNvPicPr>
             <a:picLocks noChangeAspect="1"/>
           </p:cNvPicPr>
@@ -12206,7 +13717,7 @@
       </p:sp>
       <p:sp>
         <p:nvSpPr>
-          <p:cNvPr id="23" name="card-156"/>
+          <p:cNvPr id="23" name="card-160"/>
           <p:cNvSpPr/>
           <p:nvPr/>
         </p:nvSpPr>
@@ -12267,7 +13778,7 @@
       </p:sp>
       <p:sp>
         <p:nvSpPr>
-          <p:cNvPr id="25" name="card-157"/>
+          <p:cNvPr id="25" name="card-161"/>
           <p:cNvSpPr/>
           <p:nvPr/>
         </p:nvSpPr>
@@ -12367,7 +13878,7 @@
       </p:sp>
       <p:sp>
         <p:nvSpPr>
-          <p:cNvPr id="28" name="card-158"/>
+          <p:cNvPr id="28" name="card-162"/>
           <p:cNvSpPr/>
           <p:nvPr/>
         </p:nvSpPr>
@@ -12467,7 +13978,7 @@
       </p:sp>
       <p:sp>
         <p:nvSpPr>
-          <p:cNvPr id="31" name="card-159"/>
+          <p:cNvPr id="31" name="card-163"/>
           <p:cNvSpPr/>
           <p:nvPr/>
         </p:nvSpPr>
@@ -12567,7 +14078,7 @@
       </p:sp>
       <p:sp>
         <p:nvSpPr>
-          <p:cNvPr id="34" name="marco-celular-160"/>
+          <p:cNvPr id="34" name="marco-celular-164"/>
           <p:cNvSpPr/>
           <p:nvPr/>
         </p:nvSpPr>
@@ -12589,7 +14100,7 @@
       </p:sp>
       <p:pic>
         <p:nvPicPr>
-          <p:cNvPr id="35" name="captura-161" descr="/home/claude/danypizzas/docs/capturas/01-movil-inicio.png">    </p:cNvPr>
+          <p:cNvPr id="35" name="captura-165" descr="/home/claude/danypizzas/docs/capturas/01-movil-inicio.png">    </p:cNvPr>
           <p:cNvPicPr>
             <a:picLocks noChangeAspect="1"/>
           </p:cNvPicPr>
@@ -12612,7 +14123,7 @@
       </p:pic>
       <p:sp>
         <p:nvSpPr>
-          <p:cNvPr id="36" name="marco-celular-162"/>
+          <p:cNvPr id="36" name="marco-celular-166"/>
           <p:cNvSpPr/>
           <p:nvPr/>
         </p:nvSpPr>
@@ -12634,7 +14145,7 @@
       </p:sp>
       <p:pic>
         <p:nvPicPr>
-          <p:cNvPr id="37" name="captura-163" descr="/home/claude/danypizzas/docs/capturas/03-movil-confirmacion.png">    </p:cNvPr>
+          <p:cNvPr id="37" name="captura-167" descr="/home/claude/danypizzas/docs/capturas/03-movil-confirmacion.png">    </p:cNvPr>
           <p:cNvPicPr>
             <a:picLocks noChangeAspect="1"/>
           </p:cNvPicPr>
@@ -14507,7 +16018,7 @@
       </p:sp>
       <p:sp>
         <p:nvSpPr>
-          <p:cNvPr id="6" name="pendiente-164"/>
+          <p:cNvPr id="6" name="pendiente-168"/>
           <p:cNvSpPr/>
           <p:nvPr/>
         </p:nvSpPr>
@@ -14587,7 +16098,7 @@
       </p:sp>
       <p:sp>
         <p:nvSpPr>
-          <p:cNvPr id="8" name="pendiente-165"/>
+          <p:cNvPr id="8" name="pendiente-169"/>
           <p:cNvSpPr/>
           <p:nvPr/>
         </p:nvSpPr>
@@ -14667,7 +16178,7 @@
       </p:sp>
       <p:sp>
         <p:nvSpPr>
-          <p:cNvPr id="10" name="pendiente-166"/>
+          <p:cNvPr id="10" name="pendiente-170"/>
           <p:cNvSpPr/>
           <p:nvPr/>
         </p:nvSpPr>
@@ -14747,7 +16258,7 @@
       </p:sp>
       <p:sp>
         <p:nvSpPr>
-          <p:cNvPr id="12" name="pendiente-167"/>
+          <p:cNvPr id="12" name="pendiente-171"/>
           <p:cNvSpPr/>
           <p:nvPr/>
         </p:nvSpPr>
@@ -16069,7 +17580,7 @@
       </p:graphicFrame>
       <p:sp>
         <p:nvSpPr>
-          <p:cNvPr id="5" name="card-168"/>
+          <p:cNvPr id="5" name="card-172"/>
           <p:cNvSpPr/>
           <p:nvPr/>
         </p:nvSpPr>
@@ -16296,7 +17807,7 @@
       </p:sp>
       <p:sp>
         <p:nvSpPr>
-          <p:cNvPr id="4" name="card-169"/>
+          <p:cNvPr id="4" name="card-173"/>
           <p:cNvSpPr/>
           <p:nvPr/>
         </p:nvSpPr>
@@ -16318,7 +17829,7 @@
       </p:sp>
       <p:sp>
         <p:nvSpPr>
-          <p:cNvPr id="5" name="icono-fondo-170"/>
+          <p:cNvPr id="5" name="icono-fondo-174"/>
           <p:cNvSpPr/>
           <p:nvPr/>
         </p:nvSpPr>
@@ -16338,7 +17849,7 @@
       </p:sp>
       <p:pic>
         <p:nvPicPr>
-          <p:cNvPr id="6" name="icono-171" descr="preencoded.png">    </p:cNvPr>
+          <p:cNvPr id="6" name="icono-175" descr="preencoded.png">    </p:cNvPr>
           <p:cNvPicPr>
             <a:picLocks noChangeAspect="1"/>
           </p:cNvPicPr>
@@ -16486,7 +17997,7 @@
       </p:sp>
       <p:sp>
         <p:nvSpPr>
-          <p:cNvPr id="9" name="card-172"/>
+          <p:cNvPr id="9" name="card-176"/>
           <p:cNvSpPr/>
           <p:nvPr/>
         </p:nvSpPr>
@@ -16508,7 +18019,7 @@
       </p:sp>
       <p:sp>
         <p:nvSpPr>
-          <p:cNvPr id="10" name="icono-fondo-173"/>
+          <p:cNvPr id="10" name="icono-fondo-177"/>
           <p:cNvSpPr/>
           <p:nvPr/>
         </p:nvSpPr>
@@ -16528,7 +18039,7 @@
       </p:sp>
       <p:pic>
         <p:nvPicPr>
-          <p:cNvPr id="11" name="icono-174" descr="preencoded.png">    </p:cNvPr>
+          <p:cNvPr id="11" name="icono-178" descr="preencoded.png">    </p:cNvPr>
           <p:cNvPicPr>
             <a:picLocks noChangeAspect="1"/>
           </p:cNvPicPr>
@@ -16676,7 +18187,7 @@
       </p:sp>
       <p:sp>
         <p:nvSpPr>
-          <p:cNvPr id="14" name="card-175"/>
+          <p:cNvPr id="14" name="card-179"/>
           <p:cNvSpPr/>
           <p:nvPr/>
         </p:nvSpPr>
@@ -16698,7 +18209,7 @@
       </p:sp>
       <p:sp>
         <p:nvSpPr>
-          <p:cNvPr id="15" name="icono-fondo-176"/>
+          <p:cNvPr id="15" name="icono-fondo-180"/>
           <p:cNvSpPr/>
           <p:nvPr/>
         </p:nvSpPr>
@@ -16718,7 +18229,7 @@
       </p:sp>
       <p:pic>
         <p:nvPicPr>
-          <p:cNvPr id="16" name="icono-177" descr="preencoded.png">    </p:cNvPr>
+          <p:cNvPr id="16" name="icono-181" descr="preencoded.png">    </p:cNvPr>
           <p:cNvPicPr>
             <a:picLocks noChangeAspect="1"/>
           </p:cNvPicPr>

</xml_diff>

<commit_message>
Presentación: diapositiva 3 con el CV (UNdeC, intercambio en Moquegua, ICPC), sin foto
Co-Authored-By: Claude Opus 5.5 <noreply@anthropic.com>
Claude-Session: https://claude.ai/code/session_01KjW6Rcbm4CLMi8kGU9T2EW
</commit_message>
<xml_diff>
--- a/docs/presentacion/DanyPizzas_Presentacion.pptx
+++ b/docs/presentacion/DanyPizzas_Presentacion.pptx
@@ -126,25 +126,25 @@
   <p:extLst>
     <p:ext uri="{521415D9-36F7-43E2-AB2F-B90AF26B5E84}">
       <p14:sectionLst xmlns:p14="http://schemas.microsoft.com/office/powerpoint/2010/main">
-        <p14:section name="Introducción" id="{b78d934f-615c-f4c5-96c2-df7f1a88393f}">
+        <p14:section name="Introducción" id="{317671ae-d16a-740c-3e05-f399366cf62a}">
           <p14:sldIdLst>
             <p14:sldId id="256"/>
             <p14:sldId id="257"/>
           </p14:sldIdLst>
         </p14:section>
-        <p14:section name="I. Curriculum vitae" id="{e4a94dcd-0360-7152-87eb-b3bcd670174b}">
+        <p14:section name="I. Curriculum vitae" id="{1b55d632-9d95-47fe-09e2-607b29e441f5}">
           <p14:sldIdLst>
             <p14:sldId id="258"/>
           </p14:sldIdLst>
         </p14:section>
-        <p14:section name="II. Memoria descriptiva" id="{3ba987fd-7d85-6ea0-b948-9c5252e1be6a}">
+        <p14:section name="II. Memoria descriptiva" id="{8f216b5a-9520-82d2-6c2b-442bb8cc3df2}">
           <p14:sldIdLst>
             <p14:sldId id="259"/>
             <p14:sldId id="260"/>
             <p14:sldId id="261"/>
           </p14:sldIdLst>
         </p14:section>
-        <p14:section name="III. Trabajo principal" id="{e6046d1e-052e-237b-3840-e02a2737e42e}">
+        <p14:section name="III. Trabajo principal" id="{f0309800-b62e-cfbd-06ca-216d5787ad17}">
           <p14:sldIdLst>
             <p14:sldId id="262"/>
             <p14:sldId id="263"/>
@@ -1995,7 +1995,7 @@
             <a:r>
               <a:rPr lang="en-US" dirty="0"/>
               <a:t>⏱ 0:30 (acumulado 1:10)
-Breve: carrera, año y experiencia. Mencionar que este es un proyecto real, no un ejercicio. [Completar con el CV]</a:t>
+Soy Máximo Castro, estudiante de tercer año de Ingeniería en Sistemas en la Universidad Nacional de Chilecito, en Argentina, y este semestre estoy de intercambio acá en Moquegua. Antes me recibí de técnico agrónomo. Lo que más me formó en programación es la competencia ICPC: mención honorable en la final sudamericana de 2024 y primer puesto provincial dos años seguidos. También fui asistente tecnológico en las jornadas de investigación del NOA. Y este proyecto no es un ejercicio: es un sistema real, publicado y en uso para un emprendimiento de mi ciudad.</a:t>
             </a:r>
             <a:endParaRPr lang="en-US" dirty="0"/>
           </a:p>
@@ -3345,7 +3345,7 @@
       </p:sp>
       <p:pic>
         <p:nvPicPr>
-          <p:cNvPr id="3" name="logo" descr="/home/claude/danypizzas/site/assets/img/logo.png">    </p:cNvPr>
+          <p:cNvPr id="3" name="logo" descr="/tmp/claude-0/-home-claude/c096e975-9e6a-561f-aa0a-08cce324a4b6/scratchpad/repo/site/assets/img/logo.png">    </p:cNvPr>
           <p:cNvPicPr>
             <a:picLocks noChangeAspect="1"/>
           </p:cNvPicPr>
@@ -3811,7 +3811,7 @@
       </p:sp>
       <p:sp>
         <p:nvSpPr>
-          <p:cNvPr id="4" name="card-85"/>
+          <p:cNvPr id="4" name="card-95"/>
           <p:cNvSpPr/>
           <p:nvPr/>
         </p:nvSpPr>
@@ -3978,7 +3978,7 @@
       </p:sp>
       <p:sp>
         <p:nvSpPr>
-          <p:cNvPr id="7" name="card-86"/>
+          <p:cNvPr id="7" name="card-96"/>
           <p:cNvSpPr/>
           <p:nvPr/>
         </p:nvSpPr>
@@ -5471,7 +5471,7 @@
       </p:sp>
       <p:sp>
         <p:nvSpPr>
-          <p:cNvPr id="44" name="fila-87"/>
+          <p:cNvPr id="44" name="fila-97"/>
           <p:cNvSpPr/>
           <p:nvPr/>
         </p:nvSpPr>
@@ -5569,7 +5569,7 @@
       </p:sp>
       <p:sp>
         <p:nvSpPr>
-          <p:cNvPr id="47" name="barra-88"/>
+          <p:cNvPr id="47" name="barra-98"/>
           <p:cNvSpPr/>
           <p:nvPr/>
         </p:nvSpPr>
@@ -5669,7 +5669,7 @@
       </p:sp>
       <p:sp>
         <p:nvSpPr>
-          <p:cNvPr id="50" name="barra-89"/>
+          <p:cNvPr id="50" name="barra-99"/>
           <p:cNvSpPr/>
           <p:nvPr/>
         </p:nvSpPr>
@@ -5691,7 +5691,7 @@
       </p:sp>
       <p:sp>
         <p:nvSpPr>
-          <p:cNvPr id="51" name="fila-90"/>
+          <p:cNvPr id="51" name="fila-100"/>
           <p:cNvSpPr/>
           <p:nvPr/>
         </p:nvSpPr>
@@ -5789,7 +5789,7 @@
       </p:sp>
       <p:sp>
         <p:nvSpPr>
-          <p:cNvPr id="54" name="barra-91"/>
+          <p:cNvPr id="54" name="barra-101"/>
           <p:cNvSpPr/>
           <p:nvPr/>
         </p:nvSpPr>
@@ -5889,7 +5889,7 @@
       </p:sp>
       <p:sp>
         <p:nvSpPr>
-          <p:cNvPr id="57" name="barra-92"/>
+          <p:cNvPr id="57" name="barra-102"/>
           <p:cNvSpPr/>
           <p:nvPr/>
         </p:nvSpPr>
@@ -5911,7 +5911,7 @@
       </p:sp>
       <p:sp>
         <p:nvSpPr>
-          <p:cNvPr id="58" name="fila-93"/>
+          <p:cNvPr id="58" name="fila-103"/>
           <p:cNvSpPr/>
           <p:nvPr/>
         </p:nvSpPr>
@@ -6009,7 +6009,7 @@
       </p:sp>
       <p:sp>
         <p:nvSpPr>
-          <p:cNvPr id="61" name="barra-94"/>
+          <p:cNvPr id="61" name="barra-104"/>
           <p:cNvSpPr/>
           <p:nvPr/>
         </p:nvSpPr>
@@ -6109,7 +6109,7 @@
       </p:sp>
       <p:sp>
         <p:nvSpPr>
-          <p:cNvPr id="64" name="barra-95"/>
+          <p:cNvPr id="64" name="barra-105"/>
           <p:cNvSpPr/>
           <p:nvPr/>
         </p:nvSpPr>
@@ -6131,7 +6131,7 @@
       </p:sp>
       <p:sp>
         <p:nvSpPr>
-          <p:cNvPr id="65" name="fila-96"/>
+          <p:cNvPr id="65" name="fila-106"/>
           <p:cNvSpPr/>
           <p:nvPr/>
         </p:nvSpPr>
@@ -6229,7 +6229,7 @@
       </p:sp>
       <p:sp>
         <p:nvSpPr>
-          <p:cNvPr id="68" name="barra-97"/>
+          <p:cNvPr id="68" name="barra-107"/>
           <p:cNvSpPr/>
           <p:nvPr/>
         </p:nvSpPr>
@@ -6329,7 +6329,7 @@
       </p:sp>
       <p:sp>
         <p:nvSpPr>
-          <p:cNvPr id="71" name="barra-98"/>
+          <p:cNvPr id="71" name="barra-108"/>
           <p:cNvSpPr/>
           <p:nvPr/>
         </p:nvSpPr>
@@ -6351,7 +6351,7 @@
       </p:sp>
       <p:sp>
         <p:nvSpPr>
-          <p:cNvPr id="72" name="fila-99"/>
+          <p:cNvPr id="72" name="fila-109"/>
           <p:cNvSpPr/>
           <p:nvPr/>
         </p:nvSpPr>
@@ -6449,7 +6449,7 @@
       </p:sp>
       <p:sp>
         <p:nvSpPr>
-          <p:cNvPr id="75" name="barra-100"/>
+          <p:cNvPr id="75" name="barra-110"/>
           <p:cNvSpPr/>
           <p:nvPr/>
         </p:nvSpPr>
@@ -6549,7 +6549,7 @@
       </p:sp>
       <p:sp>
         <p:nvSpPr>
-          <p:cNvPr id="78" name="barra-101"/>
+          <p:cNvPr id="78" name="barra-111"/>
           <p:cNvSpPr/>
           <p:nvPr/>
         </p:nvSpPr>
@@ -6571,7 +6571,7 @@
       </p:sp>
       <p:sp>
         <p:nvSpPr>
-          <p:cNvPr id="79" name="fila-102"/>
+          <p:cNvPr id="79" name="fila-112"/>
           <p:cNvSpPr/>
           <p:nvPr/>
         </p:nvSpPr>
@@ -6669,7 +6669,7 @@
       </p:sp>
       <p:sp>
         <p:nvSpPr>
-          <p:cNvPr id="82" name="barra-103"/>
+          <p:cNvPr id="82" name="barra-113"/>
           <p:cNvSpPr/>
           <p:nvPr/>
         </p:nvSpPr>
@@ -6691,7 +6691,7 @@
       </p:sp>
       <p:sp>
         <p:nvSpPr>
-          <p:cNvPr id="83" name="semana-104"/>
+          <p:cNvPr id="83" name="semana-114"/>
           <p:cNvSpPr/>
           <p:nvPr/>
         </p:nvSpPr>
@@ -6714,7 +6714,7 @@
       </p:sp>
       <p:sp>
         <p:nvSpPr>
-          <p:cNvPr id="84" name="hito-105"/>
+          <p:cNvPr id="84" name="hito-115"/>
           <p:cNvSpPr/>
           <p:nvPr/>
         </p:nvSpPr>
@@ -6737,7 +6737,7 @@
       </p:sp>
       <p:sp>
         <p:nvSpPr>
-          <p:cNvPr id="85" name="hito-106"/>
+          <p:cNvPr id="85" name="hito-116"/>
           <p:cNvSpPr/>
           <p:nvPr/>
         </p:nvSpPr>
@@ -7084,7 +7084,7 @@
       </p:graphicFrame>
       <p:sp>
         <p:nvSpPr>
-          <p:cNvPr id="5" name="card-107"/>
+          <p:cNvPr id="5" name="card-117"/>
           <p:cNvSpPr/>
           <p:nvPr/>
         </p:nvSpPr>
@@ -7223,7 +7223,7 @@
       </p:sp>
       <p:sp>
         <p:nvSpPr>
-          <p:cNvPr id="9" name="card-108"/>
+          <p:cNvPr id="9" name="card-118"/>
           <p:cNvSpPr/>
           <p:nvPr/>
         </p:nvSpPr>
@@ -7560,7 +7560,7 @@
       </p:sp>
       <p:sp>
         <p:nvSpPr>
-          <p:cNvPr id="5" name="icono-fondo-109"/>
+          <p:cNvPr id="5" name="icono-fondo-119"/>
           <p:cNvSpPr/>
           <p:nvPr/>
         </p:nvSpPr>
@@ -7580,7 +7580,7 @@
       </p:sp>
       <p:pic>
         <p:nvPicPr>
-          <p:cNvPr id="6" name="icono-110" descr="preencoded.png">    </p:cNvPr>
+          <p:cNvPr id="6" name="icono-120" descr="preencoded.png">    </p:cNvPr>
           <p:cNvPicPr>
             <a:picLocks noChangeAspect="1"/>
           </p:cNvPicPr>
@@ -7682,7 +7682,7 @@
       </p:sp>
       <p:sp>
         <p:nvSpPr>
-          <p:cNvPr id="9" name="icono-fondo-111"/>
+          <p:cNvPr id="9" name="icono-fondo-121"/>
           <p:cNvSpPr/>
           <p:nvPr/>
         </p:nvSpPr>
@@ -7702,7 +7702,7 @@
       </p:sp>
       <p:pic>
         <p:nvPicPr>
-          <p:cNvPr id="10" name="icono-112" descr="preencoded.png">    </p:cNvPr>
+          <p:cNvPr id="10" name="icono-122" descr="preencoded.png">    </p:cNvPr>
           <p:cNvPicPr>
             <a:picLocks noChangeAspect="1"/>
           </p:cNvPicPr>
@@ -7804,7 +7804,7 @@
       </p:sp>
       <p:sp>
         <p:nvSpPr>
-          <p:cNvPr id="13" name="icono-fondo-113"/>
+          <p:cNvPr id="13" name="icono-fondo-123"/>
           <p:cNvSpPr/>
           <p:nvPr/>
         </p:nvSpPr>
@@ -7824,7 +7824,7 @@
       </p:sp>
       <p:pic>
         <p:nvPicPr>
-          <p:cNvPr id="14" name="icono-114" descr="preencoded.png">    </p:cNvPr>
+          <p:cNvPr id="14" name="icono-124" descr="preencoded.png">    </p:cNvPr>
           <p:cNvPicPr>
             <a:picLocks noChangeAspect="1"/>
           </p:cNvPicPr>
@@ -7926,7 +7926,7 @@
       </p:sp>
       <p:sp>
         <p:nvSpPr>
-          <p:cNvPr id="17" name="card-115"/>
+          <p:cNvPr id="17" name="card-125"/>
           <p:cNvSpPr/>
           <p:nvPr/>
         </p:nvSpPr>
@@ -10091,7 +10091,7 @@
       </p:sp>
       <p:pic>
         <p:nvPicPr>
-          <p:cNvPr id="4" name="grafico-montecarlo" descr="/home/claude/danypizzas/docs/analisis/economia/montecarlo_van.png">    </p:cNvPr>
+          <p:cNvPr id="4" name="grafico-montecarlo" descr="/tmp/claude-0/-home-claude/c096e975-9e6a-561f-aa0a-08cce324a4b6/scratchpad/repo/docs/analisis/economia/montecarlo_van.png">    </p:cNvPr>
           <p:cNvPicPr>
             <a:picLocks noChangeAspect="1"/>
           </p:cNvPicPr>
@@ -10154,7 +10154,7 @@
       </p:sp>
       <p:sp>
         <p:nvSpPr>
-          <p:cNvPr id="6" name="card-116"/>
+          <p:cNvPr id="6" name="card-126"/>
           <p:cNvSpPr/>
           <p:nvPr/>
         </p:nvSpPr>
@@ -10254,7 +10254,7 @@
       </p:sp>
       <p:sp>
         <p:nvSpPr>
-          <p:cNvPr id="9" name="card-117"/>
+          <p:cNvPr id="9" name="card-127"/>
           <p:cNvSpPr/>
           <p:nvPr/>
         </p:nvSpPr>
@@ -10354,7 +10354,7 @@
       </p:sp>
       <p:sp>
         <p:nvSpPr>
-          <p:cNvPr id="12" name="card-118"/>
+          <p:cNvPr id="12" name="card-128"/>
           <p:cNvSpPr/>
           <p:nvPr/>
         </p:nvSpPr>
@@ -10584,7 +10584,7 @@
       </p:sp>
       <p:sp>
         <p:nvSpPr>
-          <p:cNvPr id="4" name="nodo-119"/>
+          <p:cNvPr id="4" name="nodo-129"/>
           <p:cNvSpPr/>
           <p:nvPr/>
         </p:nvSpPr>
@@ -10691,7 +10691,7 @@
       </p:sp>
       <p:sp>
         <p:nvSpPr>
-          <p:cNvPr id="7" name="nodo-120"/>
+          <p:cNvPr id="7" name="nodo-130"/>
           <p:cNvSpPr/>
           <p:nvPr/>
         </p:nvSpPr>
@@ -10759,7 +10759,7 @@
       </p:sp>
       <p:sp>
         <p:nvSpPr>
-          <p:cNvPr id="9" name="capa-121"/>
+          <p:cNvPr id="9" name="capa-131"/>
           <p:cNvSpPr/>
           <p:nvPr/>
         </p:nvSpPr>
@@ -10837,7 +10837,7 @@
       </p:sp>
       <p:sp>
         <p:nvSpPr>
-          <p:cNvPr id="11" name="capa-122"/>
+          <p:cNvPr id="11" name="capa-132"/>
           <p:cNvSpPr/>
           <p:nvPr/>
         </p:nvSpPr>
@@ -10915,7 +10915,7 @@
       </p:sp>
       <p:sp>
         <p:nvSpPr>
-          <p:cNvPr id="13" name="capa-123"/>
+          <p:cNvPr id="13" name="capa-133"/>
           <p:cNvSpPr/>
           <p:nvPr/>
         </p:nvSpPr>
@@ -10993,7 +10993,7 @@
       </p:sp>
       <p:sp>
         <p:nvSpPr>
-          <p:cNvPr id="15" name="nodo-124"/>
+          <p:cNvPr id="15" name="nodo-134"/>
           <p:cNvSpPr/>
           <p:nvPr/>
         </p:nvSpPr>
@@ -11100,7 +11100,7 @@
       </p:sp>
       <p:sp>
         <p:nvSpPr>
-          <p:cNvPr id="18" name="nodo-125"/>
+          <p:cNvPr id="18" name="nodo-135"/>
           <p:cNvSpPr/>
           <p:nvPr/>
         </p:nvSpPr>
@@ -11207,7 +11207,7 @@
       </p:sp>
       <p:sp>
         <p:nvSpPr>
-          <p:cNvPr id="21" name="nodo-126"/>
+          <p:cNvPr id="21" name="nodo-136"/>
           <p:cNvSpPr/>
           <p:nvPr/>
         </p:nvSpPr>
@@ -11275,7 +11275,7 @@
       </p:sp>
       <p:sp>
         <p:nvSpPr>
-          <p:cNvPr id="23" name="nodo-127"/>
+          <p:cNvPr id="23" name="nodo-137"/>
           <p:cNvSpPr/>
           <p:nvPr/>
         </p:nvSpPr>
@@ -11343,7 +11343,7 @@
       </p:sp>
       <p:sp>
         <p:nvSpPr>
-          <p:cNvPr id="25" name="flecha-128"/>
+          <p:cNvPr id="25" name="flecha-138"/>
           <p:cNvSpPr/>
           <p:nvPr/>
         </p:nvSpPr>
@@ -11406,7 +11406,7 @@
       </p:sp>
       <p:sp>
         <p:nvSpPr>
-          <p:cNvPr id="27" name="flecha-129"/>
+          <p:cNvPr id="27" name="flecha-139"/>
           <p:cNvSpPr/>
           <p:nvPr/>
         </p:nvSpPr>
@@ -11469,7 +11469,7 @@
       </p:sp>
       <p:sp>
         <p:nvSpPr>
-          <p:cNvPr id="29" name="flecha-130"/>
+          <p:cNvPr id="29" name="flecha-140"/>
           <p:cNvSpPr/>
           <p:nvPr/>
         </p:nvSpPr>
@@ -11493,7 +11493,7 @@
       </p:sp>
       <p:sp>
         <p:nvSpPr>
-          <p:cNvPr id="30" name="flecha-131"/>
+          <p:cNvPr id="30" name="flecha-141"/>
           <p:cNvSpPr/>
           <p:nvPr/>
         </p:nvSpPr>
@@ -11556,7 +11556,7 @@
       </p:sp>
       <p:sp>
         <p:nvSpPr>
-          <p:cNvPr id="32" name="flecha-132"/>
+          <p:cNvPr id="32" name="flecha-142"/>
           <p:cNvSpPr/>
           <p:nvPr/>
         </p:nvSpPr>
@@ -11619,7 +11619,7 @@
       </p:sp>
       <p:sp>
         <p:nvSpPr>
-          <p:cNvPr id="34" name="card-133"/>
+          <p:cNvPr id="34" name="card-143"/>
           <p:cNvSpPr/>
           <p:nvPr/>
         </p:nvSpPr>
@@ -11871,7 +11871,7 @@
       </p:sp>
       <p:sp>
         <p:nvSpPr>
-          <p:cNvPr id="5" name="card-134"/>
+          <p:cNvPr id="5" name="card-144"/>
           <p:cNvSpPr/>
           <p:nvPr/>
         </p:nvSpPr>
@@ -11949,7 +11949,7 @@
       </p:sp>
       <p:sp>
         <p:nvSpPr>
-          <p:cNvPr id="7" name="card-135"/>
+          <p:cNvPr id="7" name="card-145"/>
           <p:cNvSpPr/>
           <p:nvPr/>
         </p:nvSpPr>
@@ -12027,7 +12027,7 @@
       </p:sp>
       <p:sp>
         <p:nvSpPr>
-          <p:cNvPr id="9" name="card-136"/>
+          <p:cNvPr id="9" name="card-146"/>
           <p:cNvSpPr/>
           <p:nvPr/>
         </p:nvSpPr>
@@ -12105,7 +12105,7 @@
       </p:sp>
       <p:sp>
         <p:nvSpPr>
-          <p:cNvPr id="11" name="card-137"/>
+          <p:cNvPr id="11" name="card-147"/>
           <p:cNvSpPr/>
           <p:nvPr/>
         </p:nvSpPr>
@@ -12183,7 +12183,7 @@
       </p:sp>
       <p:sp>
         <p:nvSpPr>
-          <p:cNvPr id="13" name="card-138"/>
+          <p:cNvPr id="13" name="card-148"/>
           <p:cNvSpPr/>
           <p:nvPr/>
         </p:nvSpPr>
@@ -12261,7 +12261,7 @@
       </p:sp>
       <p:sp>
         <p:nvSpPr>
-          <p:cNvPr id="15" name="card-139"/>
+          <p:cNvPr id="15" name="card-149"/>
           <p:cNvSpPr/>
           <p:nvPr/>
         </p:nvSpPr>
@@ -12417,7 +12417,7 @@
       </p:sp>
       <p:sp>
         <p:nvSpPr>
-          <p:cNvPr id="19" name="etiqueta-140"/>
+          <p:cNvPr id="19" name="etiqueta-150"/>
           <p:cNvSpPr/>
           <p:nvPr/>
         </p:nvSpPr>
@@ -12478,7 +12478,7 @@
       </p:sp>
       <p:sp>
         <p:nvSpPr>
-          <p:cNvPr id="21" name="etiqueta-141"/>
+          <p:cNvPr id="21" name="etiqueta-151"/>
           <p:cNvSpPr/>
           <p:nvPr/>
         </p:nvSpPr>
@@ -12539,7 +12539,7 @@
       </p:sp>
       <p:sp>
         <p:nvSpPr>
-          <p:cNvPr id="23" name="etiqueta-142"/>
+          <p:cNvPr id="23" name="etiqueta-152"/>
           <p:cNvSpPr/>
           <p:nvPr/>
         </p:nvSpPr>
@@ -12600,7 +12600,7 @@
       </p:sp>
       <p:sp>
         <p:nvSpPr>
-          <p:cNvPr id="25" name="etiqueta-143"/>
+          <p:cNvPr id="25" name="etiqueta-153"/>
           <p:cNvSpPr/>
           <p:nvPr/>
         </p:nvSpPr>
@@ -12661,7 +12661,7 @@
       </p:sp>
       <p:sp>
         <p:nvSpPr>
-          <p:cNvPr id="27" name="etiqueta-144"/>
+          <p:cNvPr id="27" name="etiqueta-154"/>
           <p:cNvSpPr/>
           <p:nvPr/>
         </p:nvSpPr>
@@ -12722,7 +12722,7 @@
       </p:sp>
       <p:sp>
         <p:nvSpPr>
-          <p:cNvPr id="29" name="etiqueta-145"/>
+          <p:cNvPr id="29" name="etiqueta-155"/>
           <p:cNvSpPr/>
           <p:nvPr/>
         </p:nvSpPr>
@@ -12783,7 +12783,7 @@
       </p:sp>
       <p:sp>
         <p:nvSpPr>
-          <p:cNvPr id="31" name="etiqueta-146"/>
+          <p:cNvPr id="31" name="etiqueta-156"/>
           <p:cNvSpPr/>
           <p:nvPr/>
         </p:nvSpPr>
@@ -12844,7 +12844,7 @@
       </p:sp>
       <p:sp>
         <p:nvSpPr>
-          <p:cNvPr id="33" name="etiqueta-147"/>
+          <p:cNvPr id="33" name="etiqueta-157"/>
           <p:cNvSpPr/>
           <p:nvPr/>
         </p:nvSpPr>
@@ -12905,7 +12905,7 @@
       </p:sp>
       <p:sp>
         <p:nvSpPr>
-          <p:cNvPr id="35" name="card-148"/>
+          <p:cNvPr id="35" name="card-158"/>
           <p:cNvSpPr/>
           <p:nvPr/>
         </p:nvSpPr>
@@ -13157,7 +13157,7 @@
       </p:sp>
       <p:sp>
         <p:nvSpPr>
-          <p:cNvPr id="4" name="icono-fondo-149"/>
+          <p:cNvPr id="4" name="icono-fondo-159"/>
           <p:cNvSpPr/>
           <p:nvPr/>
         </p:nvSpPr>
@@ -13177,7 +13177,7 @@
       </p:sp>
       <p:pic>
         <p:nvPicPr>
-          <p:cNvPr id="5" name="icono-150" descr="preencoded.png">    </p:cNvPr>
+          <p:cNvPr id="5" name="icono-160" descr="preencoded.png">    </p:cNvPr>
           <p:cNvPicPr>
             <a:picLocks noChangeAspect="1"/>
           </p:cNvPicPr>
@@ -13279,7 +13279,7 @@
       </p:sp>
       <p:pic>
         <p:nvPicPr>
-          <p:cNvPr id="8" name="flecha-151" descr="preencoded.png">    </p:cNvPr>
+          <p:cNvPr id="8" name="flecha-161" descr="preencoded.png">    </p:cNvPr>
           <p:cNvPicPr>
             <a:picLocks noChangeAspect="1"/>
           </p:cNvPicPr>
@@ -13303,7 +13303,7 @@
       </p:pic>
       <p:sp>
         <p:nvSpPr>
-          <p:cNvPr id="9" name="icono-fondo-152"/>
+          <p:cNvPr id="9" name="icono-fondo-162"/>
           <p:cNvSpPr/>
           <p:nvPr/>
         </p:nvSpPr>
@@ -13323,7 +13323,7 @@
       </p:sp>
       <p:pic>
         <p:nvPicPr>
-          <p:cNvPr id="10" name="icono-153" descr="preencoded.png">    </p:cNvPr>
+          <p:cNvPr id="10" name="icono-163" descr="preencoded.png">    </p:cNvPr>
           <p:cNvPicPr>
             <a:picLocks noChangeAspect="1"/>
           </p:cNvPicPr>
@@ -13425,7 +13425,7 @@
       </p:sp>
       <p:pic>
         <p:nvPicPr>
-          <p:cNvPr id="13" name="flecha-154" descr="preencoded.png">    </p:cNvPr>
+          <p:cNvPr id="13" name="flecha-164" descr="preencoded.png">    </p:cNvPr>
           <p:cNvPicPr>
             <a:picLocks noChangeAspect="1"/>
           </p:cNvPicPr>
@@ -13449,7 +13449,7 @@
       </p:pic>
       <p:sp>
         <p:nvSpPr>
-          <p:cNvPr id="14" name="icono-fondo-155"/>
+          <p:cNvPr id="14" name="icono-fondo-165"/>
           <p:cNvSpPr/>
           <p:nvPr/>
         </p:nvSpPr>
@@ -13469,7 +13469,7 @@
       </p:sp>
       <p:pic>
         <p:nvPicPr>
-          <p:cNvPr id="15" name="icono-156" descr="preencoded.png">    </p:cNvPr>
+          <p:cNvPr id="15" name="icono-166" descr="preencoded.png">    </p:cNvPr>
           <p:cNvPicPr>
             <a:picLocks noChangeAspect="1"/>
           </p:cNvPicPr>
@@ -13571,7 +13571,7 @@
       </p:sp>
       <p:pic>
         <p:nvPicPr>
-          <p:cNvPr id="18" name="flecha-157" descr="preencoded.png">    </p:cNvPr>
+          <p:cNvPr id="18" name="flecha-167" descr="preencoded.png">    </p:cNvPr>
           <p:cNvPicPr>
             <a:picLocks noChangeAspect="1"/>
           </p:cNvPicPr>
@@ -13595,7 +13595,7 @@
       </p:pic>
       <p:sp>
         <p:nvSpPr>
-          <p:cNvPr id="19" name="icono-fondo-158"/>
+          <p:cNvPr id="19" name="icono-fondo-168"/>
           <p:cNvSpPr/>
           <p:nvPr/>
         </p:nvSpPr>
@@ -13615,7 +13615,7 @@
       </p:sp>
       <p:pic>
         <p:nvPicPr>
-          <p:cNvPr id="20" name="icono-159" descr="preencoded.png">    </p:cNvPr>
+          <p:cNvPr id="20" name="icono-169" descr="preencoded.png">    </p:cNvPr>
           <p:cNvPicPr>
             <a:picLocks noChangeAspect="1"/>
           </p:cNvPicPr>
@@ -13717,7 +13717,7 @@
       </p:sp>
       <p:sp>
         <p:nvSpPr>
-          <p:cNvPr id="23" name="card-160"/>
+          <p:cNvPr id="23" name="card-170"/>
           <p:cNvSpPr/>
           <p:nvPr/>
         </p:nvSpPr>
@@ -13778,7 +13778,7 @@
       </p:sp>
       <p:sp>
         <p:nvSpPr>
-          <p:cNvPr id="25" name="card-161"/>
+          <p:cNvPr id="25" name="card-171"/>
           <p:cNvSpPr/>
           <p:nvPr/>
         </p:nvSpPr>
@@ -13878,7 +13878,7 @@
       </p:sp>
       <p:sp>
         <p:nvSpPr>
-          <p:cNvPr id="28" name="card-162"/>
+          <p:cNvPr id="28" name="card-172"/>
           <p:cNvSpPr/>
           <p:nvPr/>
         </p:nvSpPr>
@@ -13978,7 +13978,7 @@
       </p:sp>
       <p:sp>
         <p:nvSpPr>
-          <p:cNvPr id="31" name="card-163"/>
+          <p:cNvPr id="31" name="card-173"/>
           <p:cNvSpPr/>
           <p:nvPr/>
         </p:nvSpPr>
@@ -14078,7 +14078,7 @@
       </p:sp>
       <p:sp>
         <p:nvSpPr>
-          <p:cNvPr id="34" name="marco-celular-164"/>
+          <p:cNvPr id="34" name="marco-celular-174"/>
           <p:cNvSpPr/>
           <p:nvPr/>
         </p:nvSpPr>
@@ -14100,7 +14100,7 @@
       </p:sp>
       <p:pic>
         <p:nvPicPr>
-          <p:cNvPr id="35" name="captura-165" descr="/home/claude/danypizzas/docs/capturas/01-movil-inicio.png">    </p:cNvPr>
+          <p:cNvPr id="35" name="captura-175" descr="/tmp/claude-0/-home-claude/c096e975-9e6a-561f-aa0a-08cce324a4b6/scratchpad/repo/docs/capturas/01-movil-inicio.png">    </p:cNvPr>
           <p:cNvPicPr>
             <a:picLocks noChangeAspect="1"/>
           </p:cNvPicPr>
@@ -14123,7 +14123,7 @@
       </p:pic>
       <p:sp>
         <p:nvSpPr>
-          <p:cNvPr id="36" name="marco-celular-166"/>
+          <p:cNvPr id="36" name="marco-celular-176"/>
           <p:cNvSpPr/>
           <p:nvPr/>
         </p:nvSpPr>
@@ -14145,7 +14145,7 @@
       </p:sp>
       <p:pic>
         <p:nvPicPr>
-          <p:cNvPr id="37" name="captura-167" descr="/home/claude/danypizzas/docs/capturas/03-movil-confirmacion.png">    </p:cNvPr>
+          <p:cNvPr id="37" name="captura-177" descr="/tmp/claude-0/-home-claude/c096e975-9e6a-561f-aa0a-08cce324a4b6/scratchpad/repo/docs/capturas/03-movil-confirmacion.png">    </p:cNvPr>
           <p:cNvPicPr>
             <a:picLocks noChangeAspect="1"/>
           </p:cNvPicPr>
@@ -16018,7 +16018,7 @@
       </p:sp>
       <p:sp>
         <p:nvSpPr>
-          <p:cNvPr id="6" name="pendiente-168"/>
+          <p:cNvPr id="6" name="pendiente-178"/>
           <p:cNvSpPr/>
           <p:nvPr/>
         </p:nvSpPr>
@@ -16098,7 +16098,7 @@
       </p:sp>
       <p:sp>
         <p:nvSpPr>
-          <p:cNvPr id="8" name="pendiente-169"/>
+          <p:cNvPr id="8" name="pendiente-179"/>
           <p:cNvSpPr/>
           <p:nvPr/>
         </p:nvSpPr>
@@ -16178,7 +16178,7 @@
       </p:sp>
       <p:sp>
         <p:nvSpPr>
-          <p:cNvPr id="10" name="pendiente-170"/>
+          <p:cNvPr id="10" name="pendiente-180"/>
           <p:cNvSpPr/>
           <p:nvPr/>
         </p:nvSpPr>
@@ -16258,7 +16258,7 @@
       </p:sp>
       <p:sp>
         <p:nvSpPr>
-          <p:cNvPr id="12" name="pendiente-171"/>
+          <p:cNvPr id="12" name="pendiente-181"/>
           <p:cNvSpPr/>
           <p:nvPr/>
         </p:nvSpPr>
@@ -17580,7 +17580,7 @@
       </p:graphicFrame>
       <p:sp>
         <p:nvSpPr>
-          <p:cNvPr id="5" name="card-172"/>
+          <p:cNvPr id="5" name="card-182"/>
           <p:cNvSpPr/>
           <p:nvPr/>
         </p:nvSpPr>
@@ -17807,7 +17807,7 @@
       </p:sp>
       <p:sp>
         <p:nvSpPr>
-          <p:cNvPr id="4" name="card-173"/>
+          <p:cNvPr id="4" name="card-183"/>
           <p:cNvSpPr/>
           <p:nvPr/>
         </p:nvSpPr>
@@ -17829,7 +17829,7 @@
       </p:sp>
       <p:sp>
         <p:nvSpPr>
-          <p:cNvPr id="5" name="icono-fondo-174"/>
+          <p:cNvPr id="5" name="icono-fondo-184"/>
           <p:cNvSpPr/>
           <p:nvPr/>
         </p:nvSpPr>
@@ -17849,7 +17849,7 @@
       </p:sp>
       <p:pic>
         <p:nvPicPr>
-          <p:cNvPr id="6" name="icono-175" descr="preencoded.png">    </p:cNvPr>
+          <p:cNvPr id="6" name="icono-185" descr="preencoded.png">    </p:cNvPr>
           <p:cNvPicPr>
             <a:picLocks noChangeAspect="1"/>
           </p:cNvPicPr>
@@ -17997,7 +17997,7 @@
       </p:sp>
       <p:sp>
         <p:nvSpPr>
-          <p:cNvPr id="9" name="card-176"/>
+          <p:cNvPr id="9" name="card-186"/>
           <p:cNvSpPr/>
           <p:nvPr/>
         </p:nvSpPr>
@@ -18019,7 +18019,7 @@
       </p:sp>
       <p:sp>
         <p:nvSpPr>
-          <p:cNvPr id="10" name="icono-fondo-177"/>
+          <p:cNvPr id="10" name="icono-fondo-187"/>
           <p:cNvSpPr/>
           <p:nvPr/>
         </p:nvSpPr>
@@ -18039,7 +18039,7 @@
       </p:sp>
       <p:pic>
         <p:nvPicPr>
-          <p:cNvPr id="11" name="icono-178" descr="preencoded.png">    </p:cNvPr>
+          <p:cNvPr id="11" name="icono-188" descr="preencoded.png">    </p:cNvPr>
           <p:cNvPicPr>
             <a:picLocks noChangeAspect="1"/>
           </p:cNvPicPr>
@@ -18187,7 +18187,7 @@
       </p:sp>
       <p:sp>
         <p:nvSpPr>
-          <p:cNvPr id="14" name="card-179"/>
+          <p:cNvPr id="14" name="card-189"/>
           <p:cNvSpPr/>
           <p:nvPr/>
         </p:nvSpPr>
@@ -18209,7 +18209,7 @@
       </p:sp>
       <p:sp>
         <p:nvSpPr>
-          <p:cNvPr id="15" name="icono-fondo-180"/>
+          <p:cNvPr id="15" name="icono-fondo-190"/>
           <p:cNvSpPr/>
           <p:nvPr/>
         </p:nvSpPr>
@@ -18229,7 +18229,7 @@
       </p:sp>
       <p:pic>
         <p:nvPicPr>
-          <p:cNvPr id="16" name="icono-181" descr="preencoded.png">    </p:cNvPr>
+          <p:cNvPr id="16" name="icono-191" descr="preencoded.png">    </p:cNvPr>
           <p:cNvPicPr>
             <a:picLocks noChangeAspect="1"/>
           </p:cNvPicPr>
@@ -19381,7 +19381,7 @@
       </p:sp>
       <p:pic>
         <p:nvPicPr>
-          <p:cNvPr id="6" name="qr-cierre" descr="/home/claude/danypizzas/docs/qr-sitio.png">    </p:cNvPr>
+          <p:cNvPr id="6" name="qr-cierre" descr="/tmp/claude-0/-home-claude/c096e975-9e6a-561f-aa0a-08cce324a4b6/scratchpad/repo/docs/qr-sitio.png">    </p:cNvPr>
           <p:cNvPicPr>
             <a:picLocks noChangeAspect="1"/>
           </p:cNvPicPr>
@@ -19551,155 +19551,74 @@
       </p:sp>
       <p:sp>
         <p:nvSpPr>
-          <p:cNvPr id="4" name="foto-cv"/>
+          <p:cNvPr id="4" name="Text 2"/>
+          <p:cNvSpPr txBox="1"/>
+          <p:nvPr/>
+        </p:nvSpPr>
+        <p:spPr>
+          <a:xfrm>
+            <a:off x="548640" y="1463040"/>
+            <a:ext cx="11064240" cy="868680"/>
+          </a:xfrm>
+          <a:prstGeom prst="rect">
+            <a:avLst/>
+          </a:prstGeom>
+          <a:noFill/>
+          <a:ln/>
+        </p:spPr>
+        <p:txBody>
+          <a:bodyPr wrap="square" lIns="0" tIns="0" rIns="0" bIns="0" rtlCol="0" anchor="t"/>
+          <a:lstStyle/>
+          <a:p>
+            <a:pPr indent="0" marL="0">
+              <a:buNone/>
+            </a:pPr>
+            <a:r>
+              <a:rPr lang="en-US" sz="2000" b="1" dirty="0">
+                <a:solidFill>
+                  <a:schemeClr val="tx1"/>
+                </a:solidFill>
+                <a:latin typeface="Calibri" pitchFamily="34" charset="0"/>
+                <a:ea typeface="Calibri" pitchFamily="34" charset="-122"/>
+                <a:cs typeface="Calibri" pitchFamily="34" charset="-120"/>
+              </a:rPr>
+              <a:t>Estudiante de Ingeniería en Sistemas · 3.er año</a:t>
+            </a:r>
+            <a:endParaRPr lang="en-US" sz="1400" dirty="0"/>
+          </a:p>
+          <a:p>
+            <a:pPr indent="0" marL="0">
+              <a:buNone/>
+            </a:pPr>
+            <a:r>
+              <a:rPr lang="en-US" sz="1500" dirty="0">
+                <a:solidFill>
+                  <a:schemeClr val="accent4"/>
+                </a:solidFill>
+                <a:latin typeface="Calibri" pitchFamily="34" charset="0"/>
+                <a:ea typeface="Calibri" pitchFamily="34" charset="-122"/>
+                <a:cs typeface="Calibri" pitchFamily="34" charset="-120"/>
+              </a:rPr>
+              <a:t>Universidad Nacional de Chilecito (UNdeC), Argentina  ·  De intercambio en la Universidad Nacional de Moquegua, Perú</a:t>
+            </a:r>
+            <a:endParaRPr lang="en-US" sz="1400" dirty="0"/>
+          </a:p>
+        </p:txBody>
+      </p:sp>
+      <p:sp>
+        <p:nvSpPr>
+          <p:cNvPr id="5" name="card-10"/>
           <p:cNvSpPr/>
           <p:nvPr/>
         </p:nvSpPr>
         <p:spPr>
           <a:xfrm>
-            <a:off x="731520" y="1645920"/>
-            <a:ext cx="2377440" cy="2377440"/>
-          </a:xfrm>
-          <a:prstGeom prst="ellipse">
-            <a:avLst/>
-          </a:prstGeom>
-          <a:solidFill>
-            <a:schemeClr val="bg2"/>
-          </a:solidFill>
-          <a:ln w="19050">
-            <a:solidFill>
-              <a:srgbClr val="E83030"/>
-            </a:solidFill>
-            <a:prstDash val="dash"/>
-          </a:ln>
-        </p:spPr>
-      </p:sp>
-      <p:sp>
-        <p:nvSpPr>
-          <p:cNvPr id="5" name="Text 3"/>
-          <p:cNvSpPr txBox="1"/>
-          <p:nvPr/>
-        </p:nvSpPr>
-        <p:spPr>
-          <a:xfrm>
-            <a:off x="731520" y="2514600"/>
-            <a:ext cx="2377440" cy="731520"/>
-          </a:xfrm>
-          <a:prstGeom prst="rect">
-            <a:avLst/>
-          </a:prstGeom>
-          <a:noFill/>
-          <a:ln/>
-        </p:spPr>
-        <p:txBody>
-          <a:bodyPr wrap="square" lIns="0" tIns="0" rIns="0" bIns="0" rtlCol="0" anchor="t"/>
-          <a:lstStyle/>
-          <a:p>
-            <a:pPr algn="ctr" indent="0" marL="0">
-              <a:buNone/>
-            </a:pPr>
-            <a:r>
-              <a:rPr lang="en-US" sz="1400" dirty="0">
-                <a:solidFill>
-                  <a:schemeClr val="accent4"/>
-                </a:solidFill>
-                <a:latin typeface="Calibri" pitchFamily="34" charset="0"/>
-                <a:ea typeface="Calibri" pitchFamily="34" charset="-122"/>
-                <a:cs typeface="Calibri" pitchFamily="34" charset="-120"/>
-              </a:rPr>
-              <a:t>Foto</a:t>
-            </a:r>
-            <a:endParaRPr lang="en-US" sz="1400" dirty="0"/>
-          </a:p>
-          <a:p>
-            <a:pPr algn="ctr" indent="0" marL="0">
-              <a:buNone/>
-            </a:pPr>
-            <a:r>
-              <a:rPr lang="en-US" sz="1400" dirty="0">
-                <a:solidFill>
-                  <a:schemeClr val="accent4"/>
-                </a:solidFill>
-                <a:latin typeface="Calibri" pitchFamily="34" charset="0"/>
-                <a:ea typeface="Calibri" pitchFamily="34" charset="-122"/>
-                <a:cs typeface="Calibri" pitchFamily="34" charset="-120"/>
-              </a:rPr>
-              <a:t>(opcional)</a:t>
-            </a:r>
-            <a:endParaRPr lang="en-US" sz="1400" dirty="0"/>
-          </a:p>
-        </p:txBody>
-      </p:sp>
-      <p:sp>
-        <p:nvSpPr>
-          <p:cNvPr id="6" name="Text 4"/>
-          <p:cNvSpPr txBox="1"/>
-          <p:nvPr/>
-        </p:nvSpPr>
-        <p:spPr>
-          <a:xfrm>
-            <a:off x="3566160" y="1645920"/>
-            <a:ext cx="7863840" cy="822960"/>
-          </a:xfrm>
-          <a:prstGeom prst="rect">
-            <a:avLst/>
-          </a:prstGeom>
-          <a:noFill/>
-          <a:ln/>
-        </p:spPr>
-        <p:txBody>
-          <a:bodyPr wrap="square" lIns="0" tIns="0" rIns="0" bIns="0" rtlCol="0" anchor="t"/>
-          <a:lstStyle/>
-          <a:p>
-            <a:pPr indent="0" marL="0">
-              <a:buNone/>
-            </a:pPr>
-            <a:r>
-              <a:rPr lang="en-US" sz="1800" b="1" dirty="0">
-                <a:solidFill>
-                  <a:schemeClr val="tx1"/>
-                </a:solidFill>
-                <a:latin typeface="Calibri" pitchFamily="34" charset="0"/>
-                <a:ea typeface="Calibri" pitchFamily="34" charset="-122"/>
-                <a:cs typeface="Calibri" pitchFamily="34" charset="-120"/>
-              </a:rPr>
-              <a:t>Estudiante de Ingeniería de Sistemas</a:t>
-            </a:r>
-            <a:endParaRPr lang="en-US" sz="1500" dirty="0"/>
-          </a:p>
-          <a:p>
-            <a:pPr indent="0" marL="0">
-              <a:buNone/>
-            </a:pPr>
-            <a:r>
-              <a:rPr lang="en-US" sz="1500" dirty="0">
-                <a:solidFill>
-                  <a:schemeClr val="accent4"/>
-                </a:solidFill>
-                <a:latin typeface="Calibri" pitchFamily="34" charset="0"/>
-                <a:ea typeface="Calibri" pitchFamily="34" charset="-122"/>
-                <a:cs typeface="Calibri" pitchFamily="34" charset="-120"/>
-              </a:rPr>
-              <a:t>Universidad Nacional de Moquegua · Escuela Profesional de Ingeniería de Sistemas e Informática</a:t>
-            </a:r>
-            <a:endParaRPr lang="en-US" sz="1500" dirty="0"/>
-          </a:p>
-        </p:txBody>
-      </p:sp>
-      <p:sp>
-        <p:nvSpPr>
-          <p:cNvPr id="7" name="card-10"/>
-          <p:cNvSpPr/>
-          <p:nvPr/>
-        </p:nvSpPr>
-        <p:spPr>
-          <a:xfrm>
-            <a:off x="3566160" y="2606040"/>
-            <a:ext cx="3749040" cy="2148840"/>
+            <a:off x="548640" y="2560320"/>
+            <a:ext cx="4480560" cy="2697480"/>
           </a:xfrm>
           <a:prstGeom prst="roundRect">
             <a:avLst>
-              <a:gd name="adj" fmla="val 5106"/>
+              <a:gd name="adj" fmla="val 4068"/>
             </a:avLst>
           </a:prstGeom>
           <a:solidFill>
@@ -19710,14 +19629,58 @@
       </p:sp>
       <p:sp>
         <p:nvSpPr>
-          <p:cNvPr id="8" name="Text 6"/>
+          <p:cNvPr id="6" name="icono-fondo-11"/>
+          <p:cNvSpPr/>
+          <p:nvPr/>
+        </p:nvSpPr>
+        <p:spPr>
+          <a:xfrm>
+            <a:off x="777240" y="2788920"/>
+            <a:ext cx="502920" cy="502920"/>
+          </a:xfrm>
+          <a:prstGeom prst="ellipse">
+            <a:avLst/>
+          </a:prstGeom>
+          <a:solidFill>
+            <a:schemeClr val="accent1"/>
+          </a:solidFill>
+          <a:ln/>
+        </p:spPr>
+      </p:sp>
+      <p:pic>
+        <p:nvPicPr>
+          <p:cNvPr id="7" name="icono-12" descr="preencoded.png">    </p:cNvPr>
+          <p:cNvPicPr>
+            <a:picLocks noChangeAspect="1"/>
+          </p:cNvPicPr>
+          <p:nvPr/>
+        </p:nvPicPr>
+        <p:blipFill>
+          <a:blip r:embed="rId1"/>
+          <a:stretch>
+            <a:fillRect/>
+          </a:stretch>
+        </p:blipFill>
+        <p:spPr>
+          <a:xfrm>
+            <a:off x="897941" y="2909621"/>
+            <a:ext cx="261518" cy="261518"/>
+          </a:xfrm>
+          <a:prstGeom prst="rect">
+            <a:avLst/>
+          </a:prstGeom>
+        </p:spPr>
+      </p:pic>
+      <p:sp>
+        <p:nvSpPr>
+          <p:cNvPr id="8" name="Text 5"/>
           <p:cNvSpPr txBox="1"/>
           <p:nvPr/>
         </p:nvSpPr>
         <p:spPr>
           <a:xfrm>
-            <a:off x="3794760" y="2743200"/>
-            <a:ext cx="3291840" cy="320040"/>
+            <a:off x="1417320" y="2862072"/>
+            <a:ext cx="3474720" cy="365760"/>
           </a:xfrm>
           <a:prstGeom prst="rect">
             <a:avLst/>
@@ -19733,7 +19696,7 @@
               <a:buNone/>
             </a:pPr>
             <a:r>
-              <a:rPr lang="en-US" sz="1400" b="1" dirty="0">
+              <a:rPr lang="en-US" sz="1500" b="1" dirty="0">
                 <a:solidFill>
                   <a:schemeClr val="accent1"/>
                 </a:solidFill>
@@ -19741,38 +19704,63 @@
                 <a:ea typeface="Calibri" pitchFamily="34" charset="-122"/>
                 <a:cs typeface="Calibri" pitchFamily="34" charset="-120"/>
               </a:rPr>
-              <a:t>Proyecto destacado</a:t>
+              <a:t>Programación competitiva (ICPC)</a:t>
+            </a:r>
+            <a:endParaRPr lang="en-US" sz="1500" dirty="0"/>
+          </a:p>
+        </p:txBody>
+      </p:sp>
+      <p:sp>
+        <p:nvSpPr>
+          <p:cNvPr id="9" name="Text 6"/>
+          <p:cNvSpPr txBox="1"/>
+          <p:nvPr/>
+        </p:nvSpPr>
+        <p:spPr>
+          <a:xfrm>
+            <a:off x="777240" y="3474720"/>
+            <a:ext cx="4069080" cy="1645920"/>
+          </a:xfrm>
+          <a:prstGeom prst="rect">
+            <a:avLst/>
+          </a:prstGeom>
+          <a:noFill/>
+          <a:ln/>
+        </p:spPr>
+        <p:txBody>
+          <a:bodyPr wrap="square" lIns="0" tIns="0" rIns="0" bIns="0" rtlCol="0" anchor="t"/>
+          <a:lstStyle/>
+          <a:p>
+            <a:pPr marL="342900" indent="-342900">
+              <a:spcAft>
+                <a:spcPts val="600"/>
+              </a:spcAft>
+              <a:buSzPct val="100000"/>
+              <a:buChar char="•"/>
+            </a:pPr>
+            <a:r>
+              <a:rPr lang="en-US" sz="1400" dirty="0">
+                <a:solidFill>
+                  <a:schemeClr val="tx1"/>
+                </a:solidFill>
+                <a:latin typeface="Calibri" pitchFamily="34" charset="0"/>
+                <a:ea typeface="Calibri" pitchFamily="34" charset="-122"/>
+                <a:cs typeface="Calibri" pitchFamily="34" charset="-120"/>
+              </a:rPr>
+              <a:t>Mención Honorable · Final Sudamérica Sur 2024 (Buenos Aires)</a:t>
             </a:r>
             <a:endParaRPr lang="en-US" sz="1400" dirty="0"/>
           </a:p>
-        </p:txBody>
-      </p:sp>
-      <p:sp>
-        <p:nvSpPr>
-          <p:cNvPr id="9" name="Text 7"/>
-          <p:cNvSpPr txBox="1"/>
-          <p:nvPr/>
-        </p:nvSpPr>
-        <p:spPr>
-          <a:xfrm>
-            <a:off x="3794760" y="3090672"/>
-            <a:ext cx="3291840" cy="1600200"/>
-          </a:xfrm>
-          <a:prstGeom prst="rect">
-            <a:avLst/>
-          </a:prstGeom>
-          <a:noFill/>
-          <a:ln/>
-        </p:spPr>
-        <p:txBody>
-          <a:bodyPr wrap="square" lIns="0" tIns="0" rIns="0" bIns="0" rtlCol="0" anchor="t"/>
-          <a:lstStyle/>
-          <a:p>
-            <a:pPr indent="0" marL="0">
-              <a:buNone/>
-            </a:pPr>
-            <a:r>
-              <a:rPr lang="en-US" sz="1500" dirty="0">
+          <a:p>
+            <a:pPr marL="342900" indent="-342900">
+              <a:spcAft>
+                <a:spcPts val="600"/>
+              </a:spcAft>
+              <a:buSzPct val="100000"/>
+              <a:buChar char="•"/>
+            </a:pPr>
+            <a:r>
+              <a:rPr lang="en-US" sz="1400" dirty="0">
                 <a:solidFill>
                   <a:schemeClr val="tx1"/>
                 </a:solidFill>
@@ -19780,26 +19768,47 @@
                 <a:ea typeface="Calibri" pitchFamily="34" charset="-122"/>
                 <a:cs typeface="Calibri" pitchFamily="34" charset="-120"/>
               </a:rPr>
-              <a:t>Dany Pizzas Web (2026): sistema de pedidos publicado y en uso para un emprendimiento real.</a:t>
-            </a:r>
-            <a:endParaRPr lang="en-US" sz="1500" dirty="0"/>
-          </a:p>
-        </p:txBody>
-      </p:sp>
-      <p:sp>
-        <p:nvSpPr>
-          <p:cNvPr id="10" name="card-11"/>
+              <a:t>1.er puesto provincial · Torneo Argentino de Programación 2024 y 2025</a:t>
+            </a:r>
+            <a:endParaRPr lang="en-US" sz="1400" dirty="0"/>
+          </a:p>
+          <a:p>
+            <a:pPr marL="342900" indent="-342900">
+              <a:spcAft>
+                <a:spcPts val="600"/>
+              </a:spcAft>
+              <a:buSzPct val="100000"/>
+              <a:buChar char="•"/>
+            </a:pPr>
+            <a:r>
+              <a:rPr lang="en-US" sz="1400" dirty="0">
+                <a:solidFill>
+                  <a:schemeClr val="tx1"/>
+                </a:solidFill>
+                <a:latin typeface="Calibri" pitchFamily="34" charset="0"/>
+                <a:ea typeface="Calibri" pitchFamily="34" charset="-122"/>
+                <a:cs typeface="Calibri" pitchFamily="34" charset="-120"/>
+              </a:rPr>
+              <a:t>Final Sudamérica Sur 2025 (Santa Fe), representando a la UNdeC</a:t>
+            </a:r>
+            <a:endParaRPr lang="en-US" sz="1400" dirty="0"/>
+          </a:p>
+        </p:txBody>
+      </p:sp>
+      <p:sp>
+        <p:nvSpPr>
+          <p:cNvPr id="10" name="card-13"/>
           <p:cNvSpPr/>
           <p:nvPr/>
         </p:nvSpPr>
         <p:spPr>
           <a:xfrm>
-            <a:off x="7589520" y="2606040"/>
-            <a:ext cx="3840480" cy="2148840"/>
+            <a:off x="5212080" y="2560320"/>
+            <a:ext cx="3108960" cy="2697480"/>
           </a:xfrm>
           <a:prstGeom prst="roundRect">
             <a:avLst>
-              <a:gd name="adj" fmla="val 5106"/>
+              <a:gd name="adj" fmla="val 4068"/>
             </a:avLst>
           </a:prstGeom>
           <a:solidFill>
@@ -19810,14 +19819,58 @@
       </p:sp>
       <p:sp>
         <p:nvSpPr>
-          <p:cNvPr id="11" name="Text 9"/>
+          <p:cNvPr id="11" name="icono-fondo-14"/>
+          <p:cNvSpPr/>
+          <p:nvPr/>
+        </p:nvSpPr>
+        <p:spPr>
+          <a:xfrm>
+            <a:off x="5440680" y="2788920"/>
+            <a:ext cx="502920" cy="502920"/>
+          </a:xfrm>
+          <a:prstGeom prst="ellipse">
+            <a:avLst/>
+          </a:prstGeom>
+          <a:solidFill>
+            <a:schemeClr val="accent2"/>
+          </a:solidFill>
+          <a:ln/>
+        </p:spPr>
+      </p:sp>
+      <p:pic>
+        <p:nvPicPr>
+          <p:cNvPr id="12" name="icono-15" descr="preencoded.png">    </p:cNvPr>
+          <p:cNvPicPr>
+            <a:picLocks noChangeAspect="1"/>
+          </p:cNvPicPr>
+          <p:nvPr/>
+        </p:nvPicPr>
+        <p:blipFill>
+          <a:blip r:embed="rId2"/>
+          <a:stretch>
+            <a:fillRect/>
+          </a:stretch>
+        </p:blipFill>
+        <p:spPr>
+          <a:xfrm>
+            <a:off x="5561381" y="2909621"/>
+            <a:ext cx="261518" cy="261518"/>
+          </a:xfrm>
+          <a:prstGeom prst="rect">
+            <a:avLst/>
+          </a:prstGeom>
+        </p:spPr>
+      </p:pic>
+      <p:sp>
+        <p:nvSpPr>
+          <p:cNvPr id="13" name="Text 9"/>
           <p:cNvSpPr txBox="1"/>
           <p:nvPr/>
         </p:nvSpPr>
         <p:spPr>
           <a:xfrm>
-            <a:off x="7818120" y="2743200"/>
-            <a:ext cx="3474720" cy="320040"/>
+            <a:off x="6080760" y="2862072"/>
+            <a:ext cx="2148840" cy="365760"/>
           </a:xfrm>
           <a:prstGeom prst="rect">
             <a:avLst/>
@@ -19833,9 +19886,153 @@
               <a:buNone/>
             </a:pPr>
             <a:r>
-              <a:rPr lang="en-US" sz="1400" b="1" dirty="0">
-                <a:solidFill>
-                  <a:schemeClr val="accent1"/>
+              <a:rPr lang="en-US" sz="1500" b="1" dirty="0">
+                <a:solidFill>
+                  <a:schemeClr val="tx2"/>
+                </a:solidFill>
+                <a:latin typeface="Calibri" pitchFamily="34" charset="0"/>
+                <a:ea typeface="Calibri" pitchFamily="34" charset="-122"/>
+                <a:cs typeface="Calibri" pitchFamily="34" charset="-120"/>
+              </a:rPr>
+              <a:t>Proyecto destacado</a:t>
+            </a:r>
+            <a:endParaRPr lang="en-US" sz="1500" dirty="0"/>
+          </a:p>
+        </p:txBody>
+      </p:sp>
+      <p:sp>
+        <p:nvSpPr>
+          <p:cNvPr id="14" name="Text 10"/>
+          <p:cNvSpPr txBox="1"/>
+          <p:nvPr/>
+        </p:nvSpPr>
+        <p:spPr>
+          <a:xfrm>
+            <a:off x="5440680" y="3474720"/>
+            <a:ext cx="2697480" cy="1645920"/>
+          </a:xfrm>
+          <a:prstGeom prst="rect">
+            <a:avLst/>
+          </a:prstGeom>
+          <a:noFill/>
+          <a:ln/>
+        </p:spPr>
+        <p:txBody>
+          <a:bodyPr wrap="square" lIns="0" tIns="0" rIns="0" bIns="0" rtlCol="0" anchor="t"/>
+          <a:lstStyle/>
+          <a:p>
+            <a:pPr indent="0" marL="0">
+              <a:buNone/>
+            </a:pPr>
+            <a:r>
+              <a:rPr lang="en-US" sz="1400" dirty="0">
+                <a:solidFill>
+                  <a:schemeClr val="tx1"/>
+                </a:solidFill>
+                <a:latin typeface="Calibri" pitchFamily="34" charset="0"/>
+                <a:ea typeface="Calibri" pitchFamily="34" charset="-122"/>
+                <a:cs typeface="Calibri" pitchFamily="34" charset="-120"/>
+              </a:rPr>
+              <a:t>Dany Pizzas Web (2026): sistema de pedidos publicado y en uso para un emprendimiento real de Chilecito.</a:t>
+            </a:r>
+            <a:endParaRPr lang="en-US" sz="1400" dirty="0"/>
+          </a:p>
+        </p:txBody>
+      </p:sp>
+      <p:sp>
+        <p:nvSpPr>
+          <p:cNvPr id="15" name="card-16"/>
+          <p:cNvSpPr/>
+          <p:nvPr/>
+        </p:nvSpPr>
+        <p:spPr>
+          <a:xfrm>
+            <a:off x="8503920" y="2560320"/>
+            <a:ext cx="3108960" cy="2697480"/>
+          </a:xfrm>
+          <a:prstGeom prst="roundRect">
+            <a:avLst>
+              <a:gd name="adj" fmla="val 4068"/>
+            </a:avLst>
+          </a:prstGeom>
+          <a:solidFill>
+            <a:schemeClr val="accent6"/>
+          </a:solidFill>
+          <a:ln/>
+        </p:spPr>
+      </p:sp>
+      <p:sp>
+        <p:nvSpPr>
+          <p:cNvPr id="16" name="icono-fondo-17"/>
+          <p:cNvSpPr/>
+          <p:nvPr/>
+        </p:nvSpPr>
+        <p:spPr>
+          <a:xfrm>
+            <a:off x="8732520" y="2788920"/>
+            <a:ext cx="502920" cy="502920"/>
+          </a:xfrm>
+          <a:prstGeom prst="ellipse">
+            <a:avLst/>
+          </a:prstGeom>
+          <a:solidFill>
+            <a:schemeClr val="accent2"/>
+          </a:solidFill>
+          <a:ln/>
+        </p:spPr>
+      </p:sp>
+      <p:pic>
+        <p:nvPicPr>
+          <p:cNvPr id="17" name="icono-18" descr="preencoded.png">    </p:cNvPr>
+          <p:cNvPicPr>
+            <a:picLocks noChangeAspect="1"/>
+          </p:cNvPicPr>
+          <p:nvPr/>
+        </p:nvPicPr>
+        <p:blipFill>
+          <a:blip r:embed="rId3"/>
+          <a:stretch>
+            <a:fillRect/>
+          </a:stretch>
+        </p:blipFill>
+        <p:spPr>
+          <a:xfrm>
+            <a:off x="8853221" y="2909621"/>
+            <a:ext cx="261518" cy="261518"/>
+          </a:xfrm>
+          <a:prstGeom prst="rect">
+            <a:avLst/>
+          </a:prstGeom>
+        </p:spPr>
+      </p:pic>
+      <p:sp>
+        <p:nvSpPr>
+          <p:cNvPr id="18" name="Text 13"/>
+          <p:cNvSpPr txBox="1"/>
+          <p:nvPr/>
+        </p:nvSpPr>
+        <p:spPr>
+          <a:xfrm>
+            <a:off x="9372600" y="2862072"/>
+            <a:ext cx="2148840" cy="365760"/>
+          </a:xfrm>
+          <a:prstGeom prst="rect">
+            <a:avLst/>
+          </a:prstGeom>
+          <a:noFill/>
+          <a:ln/>
+        </p:spPr>
+        <p:txBody>
+          <a:bodyPr wrap="square" lIns="0" tIns="0" rIns="0" bIns="0" rtlCol="0" anchor="t"/>
+          <a:lstStyle/>
+          <a:p>
+            <a:pPr indent="0" marL="0">
+              <a:buNone/>
+            </a:pPr>
+            <a:r>
+              <a:rPr lang="en-US" sz="1500" b="1" dirty="0">
+                <a:solidFill>
+                  <a:schemeClr val="tx2"/>
                 </a:solidFill>
                 <a:latin typeface="Calibri" pitchFamily="34" charset="0"/>
                 <a:ea typeface="Calibri" pitchFamily="34" charset="-122"/>
@@ -19843,20 +20040,20 @@
               </a:rPr>
               <a:t>Herramientas</a:t>
             </a:r>
-            <a:endParaRPr lang="en-US" sz="1400" dirty="0"/>
-          </a:p>
-        </p:txBody>
-      </p:sp>
-      <p:sp>
-        <p:nvSpPr>
-          <p:cNvPr id="12" name="Text 10"/>
+            <a:endParaRPr lang="en-US" sz="1500" dirty="0"/>
+          </a:p>
+        </p:txBody>
+      </p:sp>
+      <p:sp>
+        <p:nvSpPr>
+          <p:cNvPr id="19" name="Text 14"/>
           <p:cNvSpPr txBox="1"/>
           <p:nvPr/>
         </p:nvSpPr>
         <p:spPr>
           <a:xfrm>
-            <a:off x="7818120" y="3090672"/>
-            <a:ext cx="3474720" cy="1600200"/>
+            <a:off x="8732520" y="3474720"/>
+            <a:ext cx="2743200" cy="1645920"/>
           </a:xfrm>
           <a:prstGeom prst="rect">
             <a:avLst/>
@@ -19905,7 +20102,7 @@
                 <a:ea typeface="Calibri" pitchFamily="34" charset="-122"/>
                 <a:cs typeface="Calibri" pitchFamily="34" charset="-120"/>
               </a:rPr>
-              <a:t>Git, GitHub y GitHub Actions</a:t>
+              <a:t>Git, GitHub y Actions</a:t>
             </a:r>
             <a:endParaRPr lang="en-US" sz="1400" dirty="0"/>
           </a:p>
@@ -19926,7 +20123,7 @@
                 <a:ea typeface="Calibri" pitchFamily="34" charset="-122"/>
                 <a:cs typeface="Calibri" pitchFamily="34" charset="-120"/>
               </a:rPr>
-              <a:t>Google Apps Script y Sheets</a:t>
+              <a:t>Apps Script y Sheets</a:t>
             </a:r>
             <a:endParaRPr lang="en-US" sz="1400" dirty="0"/>
           </a:p>
@@ -19955,41 +20152,58 @@
       </p:sp>
       <p:sp>
         <p:nvSpPr>
-          <p:cNvPr id="13" name="pendiente-12"/>
+          <p:cNvPr id="20" name="icono-fondo-19"/>
           <p:cNvSpPr/>
           <p:nvPr/>
         </p:nvSpPr>
         <p:spPr>
           <a:xfrm>
-            <a:off x="731520" y="5029200"/>
-            <a:ext cx="10698480" cy="1051560"/>
-          </a:xfrm>
-          <a:prstGeom prst="roundRect">
-            <a:avLst>
-              <a:gd name="adj" fmla="val 8696"/>
-            </a:avLst>
+            <a:off x="548640" y="5596128"/>
+            <a:ext cx="384048" cy="384048"/>
+          </a:xfrm>
+          <a:prstGeom prst="ellipse">
+            <a:avLst/>
           </a:prstGeom>
           <a:solidFill>
-            <a:srgbClr val="FFF4F2"/>
+            <a:schemeClr val="accent4"/>
           </a:solidFill>
-          <a:ln w="19050">
-            <a:solidFill>
-              <a:srgbClr val="E83030"/>
-            </a:solidFill>
-            <a:prstDash val="dash"/>
-          </a:ln>
-        </p:spPr>
-      </p:sp>
-      <p:sp>
-        <p:nvSpPr>
-          <p:cNvPr id="14" name="Text 12"/>
+          <a:ln/>
+        </p:spPr>
+      </p:sp>
+      <p:pic>
+        <p:nvPicPr>
+          <p:cNvPr id="21" name="icono-20" descr="preencoded.png">    </p:cNvPr>
+          <p:cNvPicPr>
+            <a:picLocks noChangeAspect="1"/>
+          </p:cNvPicPr>
+          <p:nvPr/>
+        </p:nvPicPr>
+        <p:blipFill>
+          <a:blip r:embed="rId4"/>
+          <a:stretch>
+            <a:fillRect/>
+          </a:stretch>
+        </p:blipFill>
+        <p:spPr>
+          <a:xfrm>
+            <a:off x="640812" y="5688300"/>
+            <a:ext cx="199705" cy="199705"/>
+          </a:xfrm>
+          <a:prstGeom prst="rect">
+            <a:avLst/>
+          </a:prstGeom>
+        </p:spPr>
+      </p:pic>
+      <p:sp>
+        <p:nvSpPr>
+          <p:cNvPr id="22" name="Text 16"/>
           <p:cNvSpPr txBox="1"/>
           <p:nvPr/>
         </p:nvSpPr>
         <p:spPr>
           <a:xfrm>
-            <a:off x="914400" y="5138928"/>
-            <a:ext cx="10332720" cy="832104"/>
+            <a:off x="1051560" y="5596128"/>
+            <a:ext cx="4754880" cy="384048"/>
           </a:xfrm>
           <a:prstGeom prst="rect">
             <a:avLst/>
@@ -20005,15 +20219,15 @@
               <a:buNone/>
             </a:pPr>
             <a:r>
-              <a:rPr lang="en-US" sz="1200" b="1" dirty="0">
-                <a:solidFill>
-                  <a:schemeClr val="accent3"/>
-                </a:solidFill>
-                <a:latin typeface="Calibri" pitchFamily="34" charset="0"/>
-                <a:ea typeface="Calibri" pitchFamily="34" charset="-122"/>
-                <a:cs typeface="Calibri" pitchFamily="34" charset="-120"/>
-              </a:rPr>
-              <a:t>PENDIENTE  </a:t>
+              <a:rPr lang="en-US" sz="1400" b="1" dirty="0">
+                <a:solidFill>
+                  <a:schemeClr val="tx1"/>
+                </a:solidFill>
+                <a:latin typeface="Calibri" pitchFamily="34" charset="0"/>
+                <a:ea typeface="Calibri" pitchFamily="34" charset="-122"/>
+                <a:cs typeface="Calibri" pitchFamily="34" charset="-120"/>
+              </a:rPr>
+              <a:t>Formación previa: </a:t>
             </a:r>
             <a:pPr indent="0" marL="0">
               <a:buNone/>
@@ -20021,13 +20235,96 @@
             <a:r>
               <a:rPr lang="en-US" sz="1400" dirty="0">
                 <a:solidFill>
-                  <a:schemeClr val="accent3"/>
-                </a:solidFill>
-                <a:latin typeface="Calibri" pitchFamily="34" charset="0"/>
-                <a:ea typeface="Calibri" pitchFamily="34" charset="-122"/>
-                <a:cs typeface="Calibri" pitchFamily="34" charset="-120"/>
-              </a:rPr>
-              <a:t>Completar con tu CV: año que cursás, formación previa, experiencia laboral, cursos o certificaciones, idiomas y datos de contacto.</a:t>
+                  <a:schemeClr val="tx1"/>
+                </a:solidFill>
+                <a:latin typeface="Calibri" pitchFamily="34" charset="0"/>
+                <a:ea typeface="Calibri" pitchFamily="34" charset="-122"/>
+                <a:cs typeface="Calibri" pitchFamily="34" charset="-120"/>
+              </a:rPr>
+              <a:t>Técnico Agrónomo (2023)</a:t>
+            </a:r>
+            <a:endParaRPr lang="en-US" sz="1400" dirty="0"/>
+          </a:p>
+        </p:txBody>
+      </p:sp>
+      <p:sp>
+        <p:nvSpPr>
+          <p:cNvPr id="23" name="icono-fondo-21"/>
+          <p:cNvSpPr/>
+          <p:nvPr/>
+        </p:nvSpPr>
+        <p:spPr>
+          <a:xfrm>
+            <a:off x="6035040" y="5596128"/>
+            <a:ext cx="384048" cy="384048"/>
+          </a:xfrm>
+          <a:prstGeom prst="ellipse">
+            <a:avLst/>
+          </a:prstGeom>
+          <a:solidFill>
+            <a:schemeClr val="accent4"/>
+          </a:solidFill>
+          <a:ln/>
+        </p:spPr>
+      </p:sp>
+      <p:pic>
+        <p:nvPicPr>
+          <p:cNvPr id="24" name="icono-22" descr="preencoded.png">    </p:cNvPr>
+          <p:cNvPicPr>
+            <a:picLocks noChangeAspect="1"/>
+          </p:cNvPicPr>
+          <p:nvPr/>
+        </p:nvPicPr>
+        <p:blipFill>
+          <a:blip r:embed="rId5"/>
+          <a:stretch>
+            <a:fillRect/>
+          </a:stretch>
+        </p:blipFill>
+        <p:spPr>
+          <a:xfrm>
+            <a:off x="6127212" y="5688300"/>
+            <a:ext cx="199705" cy="199705"/>
+          </a:xfrm>
+          <a:prstGeom prst="rect">
+            <a:avLst/>
+          </a:prstGeom>
+        </p:spPr>
+      </p:pic>
+      <p:sp>
+        <p:nvSpPr>
+          <p:cNvPr id="25" name="Text 18"/>
+          <p:cNvSpPr txBox="1"/>
+          <p:nvPr/>
+        </p:nvSpPr>
+        <p:spPr>
+          <a:xfrm>
+            <a:off x="6537960" y="5596128"/>
+            <a:ext cx="5029200" cy="384048"/>
+          </a:xfrm>
+          <a:prstGeom prst="rect">
+            <a:avLst/>
+          </a:prstGeom>
+          <a:noFill/>
+          <a:ln/>
+        </p:spPr>
+        <p:txBody>
+          <a:bodyPr wrap="square" lIns="0" tIns="0" rIns="0" bIns="0" rtlCol="0" anchor="ctr"/>
+          <a:lstStyle/>
+          <a:p>
+            <a:pPr indent="0" marL="0">
+              <a:buNone/>
+            </a:pPr>
+            <a:r>
+              <a:rPr lang="en-US" sz="1400" dirty="0">
+                <a:solidFill>
+                  <a:schemeClr val="tx1"/>
+                </a:solidFill>
+                <a:latin typeface="Calibri" pitchFamily="34" charset="0"/>
+                <a:ea typeface="Calibri" pitchFamily="34" charset="-122"/>
+                <a:cs typeface="Calibri" pitchFamily="34" charset="-120"/>
+              </a:rPr>
+              <a:t>maximodanielcastro2004@gmail.com</a:t>
             </a:r>
             <a:endParaRPr lang="en-US" sz="1400" dirty="0"/>
           </a:p>
@@ -20187,7 +20484,7 @@
       </p:sp>
       <p:pic>
         <p:nvPicPr>
-          <p:cNvPr id="4" name="foto-pizza" descr="/home/claude/danypizzas/site/assets/img/napolitana.jpg">    </p:cNvPr>
+          <p:cNvPr id="4" name="foto-pizza" descr="/tmp/claude-0/-home-claude/c096e975-9e6a-561f-aa0a-08cce324a4b6/scratchpad/repo/site/assets/img/napolitana.jpg">    </p:cNvPr>
           <p:cNvPicPr>
             <a:picLocks noChangeAspect="1"/>
           </p:cNvPicPr>
@@ -20211,7 +20508,7 @@
       </p:pic>
       <p:sp>
         <p:nvSpPr>
-          <p:cNvPr id="5" name="card-13"/>
+          <p:cNvPr id="5" name="card-23"/>
           <p:cNvSpPr/>
           <p:nvPr/>
         </p:nvSpPr>
@@ -20311,7 +20608,7 @@
       </p:sp>
       <p:sp>
         <p:nvSpPr>
-          <p:cNvPr id="8" name="card-14"/>
+          <p:cNvPr id="8" name="card-24"/>
           <p:cNvSpPr/>
           <p:nvPr/>
         </p:nvSpPr>
@@ -20411,7 +20708,7 @@
       </p:sp>
       <p:sp>
         <p:nvSpPr>
-          <p:cNvPr id="11" name="card-15"/>
+          <p:cNvPr id="11" name="card-25"/>
           <p:cNvSpPr/>
           <p:nvPr/>
         </p:nvSpPr>
@@ -20511,7 +20808,7 @@
       </p:sp>
       <p:sp>
         <p:nvSpPr>
-          <p:cNvPr id="14" name="icono-fondo-16"/>
+          <p:cNvPr id="14" name="icono-fondo-26"/>
           <p:cNvSpPr/>
           <p:nvPr/>
         </p:nvSpPr>
@@ -20531,7 +20828,7 @@
       </p:sp>
       <p:pic>
         <p:nvPicPr>
-          <p:cNvPr id="15" name="icono-17" descr="preencoded.png">    </p:cNvPr>
+          <p:cNvPr id="15" name="icono-27" descr="preencoded.png">    </p:cNvPr>
           <p:cNvPicPr>
             <a:picLocks noChangeAspect="1"/>
           </p:cNvPicPr>
@@ -20633,7 +20930,7 @@
       </p:sp>
       <p:sp>
         <p:nvSpPr>
-          <p:cNvPr id="18" name="icono-fondo-18"/>
+          <p:cNvPr id="18" name="icono-fondo-28"/>
           <p:cNvSpPr/>
           <p:nvPr/>
         </p:nvSpPr>
@@ -20653,7 +20950,7 @@
       </p:sp>
       <p:pic>
         <p:nvPicPr>
-          <p:cNvPr id="19" name="icono-19" descr="preencoded.png">    </p:cNvPr>
+          <p:cNvPr id="19" name="icono-29" descr="preencoded.png">    </p:cNvPr>
           <p:cNvPicPr>
             <a:picLocks noChangeAspect="1"/>
           </p:cNvPicPr>
@@ -20755,7 +21052,7 @@
       </p:sp>
       <p:sp>
         <p:nvSpPr>
-          <p:cNvPr id="22" name="icono-fondo-20"/>
+          <p:cNvPr id="22" name="icono-fondo-30"/>
           <p:cNvSpPr/>
           <p:nvPr/>
         </p:nvSpPr>
@@ -20775,7 +21072,7 @@
       </p:sp>
       <p:pic>
         <p:nvPicPr>
-          <p:cNvPr id="23" name="icono-21" descr="preencoded.png">    </p:cNvPr>
+          <p:cNvPr id="23" name="icono-31" descr="preencoded.png">    </p:cNvPr>
           <p:cNvPicPr>
             <a:picLocks noChangeAspect="1"/>
           </p:cNvPicPr>
@@ -20877,7 +21174,7 @@
       </p:sp>
       <p:sp>
         <p:nvSpPr>
-          <p:cNvPr id="26" name="icono-fondo-22"/>
+          <p:cNvPr id="26" name="icono-fondo-32"/>
           <p:cNvSpPr/>
           <p:nvPr/>
         </p:nvSpPr>
@@ -20897,7 +21194,7 @@
       </p:sp>
       <p:pic>
         <p:nvPicPr>
-          <p:cNvPr id="27" name="icono-23" descr="preencoded.png">    </p:cNvPr>
+          <p:cNvPr id="27" name="icono-33" descr="preencoded.png">    </p:cNvPr>
           <p:cNvPicPr>
             <a:picLocks noChangeAspect="1"/>
           </p:cNvPicPr>
@@ -20999,7 +21296,7 @@
       </p:sp>
       <p:sp>
         <p:nvSpPr>
-          <p:cNvPr id="30" name="card-24"/>
+          <p:cNvPr id="30" name="card-34"/>
           <p:cNvSpPr/>
           <p:nvPr/>
         </p:nvSpPr>
@@ -21021,7 +21318,7 @@
       </p:sp>
       <p:sp>
         <p:nvSpPr>
-          <p:cNvPr id="31" name="etiqueta-25"/>
+          <p:cNvPr id="31" name="etiqueta-35"/>
           <p:cNvSpPr/>
           <p:nvPr/>
         </p:nvSpPr>
@@ -21383,7 +21680,7 @@
       </p:sp>
       <p:sp>
         <p:nvSpPr>
-          <p:cNvPr id="4" name="linea-26"/>
+          <p:cNvPr id="4" name="linea-36"/>
           <p:cNvSpPr/>
           <p:nvPr/>
         </p:nvSpPr>
@@ -21406,7 +21703,7 @@
       </p:sp>
       <p:sp>
         <p:nvSpPr>
-          <p:cNvPr id="5" name="linea-27"/>
+          <p:cNvPr id="5" name="linea-37"/>
           <p:cNvSpPr/>
           <p:nvPr/>
         </p:nvSpPr>
@@ -21429,7 +21726,7 @@
       </p:sp>
       <p:sp>
         <p:nvSpPr>
-          <p:cNvPr id="6" name="linea-28"/>
+          <p:cNvPr id="6" name="linea-38"/>
           <p:cNvSpPr/>
           <p:nvPr/>
         </p:nvSpPr>
@@ -21452,7 +21749,7 @@
       </p:sp>
       <p:sp>
         <p:nvSpPr>
-          <p:cNvPr id="7" name="linea-29"/>
+          <p:cNvPr id="7" name="linea-39"/>
           <p:cNvSpPr/>
           <p:nvPr/>
         </p:nvSpPr>
@@ -21475,7 +21772,7 @@
       </p:sp>
       <p:sp>
         <p:nvSpPr>
-          <p:cNvPr id="8" name="linea-30"/>
+          <p:cNvPr id="8" name="linea-40"/>
           <p:cNvSpPr/>
           <p:nvPr/>
         </p:nvSpPr>
@@ -21498,7 +21795,7 @@
       </p:sp>
       <p:sp>
         <p:nvSpPr>
-          <p:cNvPr id="9" name="org-31"/>
+          <p:cNvPr id="9" name="org-41"/>
           <p:cNvSpPr/>
           <p:nvPr/>
         </p:nvSpPr>
@@ -21598,7 +21895,7 @@
       </p:sp>
       <p:sp>
         <p:nvSpPr>
-          <p:cNvPr id="12" name="org-32"/>
+          <p:cNvPr id="12" name="org-42"/>
           <p:cNvSpPr/>
           <p:nvPr/>
         </p:nvSpPr>
@@ -21698,7 +21995,7 @@
       </p:sp>
       <p:sp>
         <p:nvSpPr>
-          <p:cNvPr id="15" name="org-33"/>
+          <p:cNvPr id="15" name="org-43"/>
           <p:cNvSpPr/>
           <p:nvPr/>
         </p:nvSpPr>
@@ -21798,7 +22095,7 @@
       </p:sp>
       <p:sp>
         <p:nvSpPr>
-          <p:cNvPr id="18" name="org-34"/>
+          <p:cNvPr id="18" name="org-44"/>
           <p:cNvSpPr/>
           <p:nvPr/>
         </p:nvSpPr>
@@ -21903,7 +22200,7 @@
       </p:sp>
       <p:sp>
         <p:nvSpPr>
-          <p:cNvPr id="21" name="card-35"/>
+          <p:cNvPr id="21" name="card-45"/>
           <p:cNvSpPr/>
           <p:nvPr/>
         </p:nvSpPr>
@@ -21964,7 +22261,7 @@
       </p:sp>
       <p:sp>
         <p:nvSpPr>
-          <p:cNvPr id="23" name="icono-fondo-36"/>
+          <p:cNvPr id="23" name="icono-fondo-46"/>
           <p:cNvSpPr/>
           <p:nvPr/>
         </p:nvSpPr>
@@ -21984,7 +22281,7 @@
       </p:sp>
       <p:pic>
         <p:nvPicPr>
-          <p:cNvPr id="24" name="icono-37" descr="preencoded.png">    </p:cNvPr>
+          <p:cNvPr id="24" name="icono-47" descr="preencoded.png">    </p:cNvPr>
           <p:cNvPicPr>
             <a:picLocks noChangeAspect="1"/>
           </p:cNvPicPr>
@@ -22047,7 +22344,7 @@
       </p:sp>
       <p:sp>
         <p:nvSpPr>
-          <p:cNvPr id="26" name="icono-fondo-38"/>
+          <p:cNvPr id="26" name="icono-fondo-48"/>
           <p:cNvSpPr/>
           <p:nvPr/>
         </p:nvSpPr>
@@ -22067,7 +22364,7 @@
       </p:sp>
       <p:pic>
         <p:nvPicPr>
-          <p:cNvPr id="27" name="icono-39" descr="preencoded.png">    </p:cNvPr>
+          <p:cNvPr id="27" name="icono-49" descr="preencoded.png">    </p:cNvPr>
           <p:cNvPicPr>
             <a:picLocks noChangeAspect="1"/>
           </p:cNvPicPr>
@@ -22130,7 +22427,7 @@
       </p:sp>
       <p:sp>
         <p:nvSpPr>
-          <p:cNvPr id="29" name="icono-fondo-40"/>
+          <p:cNvPr id="29" name="icono-fondo-50"/>
           <p:cNvSpPr/>
           <p:nvPr/>
         </p:nvSpPr>
@@ -22150,7 +22447,7 @@
       </p:sp>
       <p:pic>
         <p:nvPicPr>
-          <p:cNvPr id="30" name="icono-41" descr="preencoded.png">    </p:cNvPr>
+          <p:cNvPr id="30" name="icono-51" descr="preencoded.png">    </p:cNvPr>
           <p:cNvPicPr>
             <a:picLocks noChangeAspect="1"/>
           </p:cNvPicPr>
@@ -22213,7 +22510,7 @@
       </p:sp>
       <p:sp>
         <p:nvSpPr>
-          <p:cNvPr id="32" name="icono-fondo-42"/>
+          <p:cNvPr id="32" name="icono-fondo-52"/>
           <p:cNvSpPr/>
           <p:nvPr/>
         </p:nvSpPr>
@@ -22233,7 +22530,7 @@
       </p:sp>
       <p:pic>
         <p:nvPicPr>
-          <p:cNvPr id="33" name="icono-43" descr="preencoded.png">    </p:cNvPr>
+          <p:cNvPr id="33" name="icono-53" descr="preencoded.png">    </p:cNvPr>
           <p:cNvPicPr>
             <a:picLocks noChangeAspect="1"/>
           </p:cNvPicPr>
@@ -22448,7 +22745,7 @@
       </p:sp>
       <p:sp>
         <p:nvSpPr>
-          <p:cNvPr id="4" name="card-44"/>
+          <p:cNvPr id="4" name="card-54"/>
           <p:cNvSpPr/>
           <p:nvPr/>
         </p:nvSpPr>
@@ -22470,7 +22767,7 @@
       </p:sp>
       <p:sp>
         <p:nvSpPr>
-          <p:cNvPr id="5" name="letra-45"/>
+          <p:cNvPr id="5" name="letra-55"/>
           <p:cNvSpPr/>
           <p:nvPr/>
         </p:nvSpPr>
@@ -22653,7 +22950,7 @@
       </p:sp>
       <p:sp>
         <p:nvSpPr>
-          <p:cNvPr id="9" name="card-46"/>
+          <p:cNvPr id="9" name="card-56"/>
           <p:cNvSpPr/>
           <p:nvPr/>
         </p:nvSpPr>
@@ -22675,7 +22972,7 @@
       </p:sp>
       <p:sp>
         <p:nvSpPr>
-          <p:cNvPr id="10" name="letra-47"/>
+          <p:cNvPr id="10" name="letra-57"/>
           <p:cNvSpPr/>
           <p:nvPr/>
         </p:nvSpPr>
@@ -22858,7 +23155,7 @@
       </p:sp>
       <p:sp>
         <p:nvSpPr>
-          <p:cNvPr id="14" name="card-48"/>
+          <p:cNvPr id="14" name="card-58"/>
           <p:cNvSpPr/>
           <p:nvPr/>
         </p:nvSpPr>
@@ -22880,7 +23177,7 @@
       </p:sp>
       <p:sp>
         <p:nvSpPr>
-          <p:cNvPr id="15" name="letra-49"/>
+          <p:cNvPr id="15" name="letra-59"/>
           <p:cNvSpPr/>
           <p:nvPr/>
         </p:nvSpPr>
@@ -23063,7 +23360,7 @@
       </p:sp>
       <p:sp>
         <p:nvSpPr>
-          <p:cNvPr id="19" name="card-50"/>
+          <p:cNvPr id="19" name="card-60"/>
           <p:cNvSpPr/>
           <p:nvPr/>
         </p:nvSpPr>
@@ -23085,7 +23382,7 @@
       </p:sp>
       <p:sp>
         <p:nvSpPr>
-          <p:cNvPr id="20" name="letra-51"/>
+          <p:cNvPr id="20" name="letra-61"/>
           <p:cNvSpPr/>
           <p:nvPr/>
         </p:nvSpPr>
@@ -23268,7 +23565,7 @@
       </p:sp>
       <p:sp>
         <p:nvSpPr>
-          <p:cNvPr id="24" name="card-52"/>
+          <p:cNvPr id="24" name="card-62"/>
           <p:cNvSpPr/>
           <p:nvPr/>
         </p:nvSpPr>
@@ -23731,7 +24028,7 @@
       </p:sp>
       <p:sp>
         <p:nvSpPr>
-          <p:cNvPr id="6" name="mensaje-53"/>
+          <p:cNvPr id="6" name="mensaje-63"/>
           <p:cNvSpPr/>
           <p:nvPr/>
         </p:nvSpPr>
@@ -23792,7 +24089,7 @@
       </p:sp>
       <p:sp>
         <p:nvSpPr>
-          <p:cNvPr id="8" name="mensaje-54"/>
+          <p:cNvPr id="8" name="mensaje-64"/>
           <p:cNvSpPr/>
           <p:nvPr/>
         </p:nvSpPr>
@@ -23853,7 +24150,7 @@
       </p:sp>
       <p:sp>
         <p:nvSpPr>
-          <p:cNvPr id="10" name="mensaje-55"/>
+          <p:cNvPr id="10" name="mensaje-65"/>
           <p:cNvSpPr/>
           <p:nvPr/>
         </p:nvSpPr>
@@ -23914,7 +24211,7 @@
       </p:sp>
       <p:sp>
         <p:nvSpPr>
-          <p:cNvPr id="12" name="mensaje-56"/>
+          <p:cNvPr id="12" name="mensaje-66"/>
           <p:cNvSpPr/>
           <p:nvPr/>
         </p:nvSpPr>
@@ -23975,7 +24272,7 @@
       </p:sp>
       <p:sp>
         <p:nvSpPr>
-          <p:cNvPr id="14" name="mensaje-57"/>
+          <p:cNvPr id="14" name="mensaje-67"/>
           <p:cNvSpPr/>
           <p:nvPr/>
         </p:nvSpPr>
@@ -24036,7 +24333,7 @@
       </p:sp>
       <p:sp>
         <p:nvSpPr>
-          <p:cNvPr id="16" name="mensaje-58"/>
+          <p:cNvPr id="16" name="mensaje-68"/>
           <p:cNvSpPr/>
           <p:nvPr/>
         </p:nvSpPr>
@@ -24097,7 +24394,7 @@
       </p:sp>
       <p:sp>
         <p:nvSpPr>
-          <p:cNvPr id="18" name="mensaje-59"/>
+          <p:cNvPr id="18" name="mensaje-69"/>
           <p:cNvSpPr/>
           <p:nvPr/>
         </p:nvSpPr>
@@ -24197,7 +24494,7 @@
       </p:sp>
       <p:sp>
         <p:nvSpPr>
-          <p:cNvPr id="21" name="card-60"/>
+          <p:cNvPr id="21" name="card-70"/>
           <p:cNvSpPr/>
           <p:nvPr/>
         </p:nvSpPr>
@@ -24314,7 +24611,7 @@
       </p:sp>
       <p:sp>
         <p:nvSpPr>
-          <p:cNvPr id="24" name="card-61"/>
+          <p:cNvPr id="24" name="card-71"/>
           <p:cNvSpPr/>
           <p:nvPr/>
         </p:nvSpPr>
@@ -24431,7 +24728,7 @@
       </p:sp>
       <p:sp>
         <p:nvSpPr>
-          <p:cNvPr id="27" name="card-62"/>
+          <p:cNvPr id="27" name="card-72"/>
           <p:cNvSpPr/>
           <p:nvPr/>
         </p:nvSpPr>
@@ -24824,7 +25121,7 @@
       </p:sp>
       <p:sp>
         <p:nvSpPr>
-          <p:cNvPr id="7" name="hueso-63"/>
+          <p:cNvPr id="7" name="hueso-73"/>
           <p:cNvSpPr/>
           <p:nvPr/>
         </p:nvSpPr>
@@ -24847,7 +25144,7 @@
       </p:sp>
       <p:sp>
         <p:nvSpPr>
-          <p:cNvPr id="8" name="categoria-64"/>
+          <p:cNvPr id="8" name="categoria-74"/>
           <p:cNvSpPr/>
           <p:nvPr/>
         </p:nvSpPr>
@@ -25025,7 +25322,7 @@
       </p:sp>
       <p:sp>
         <p:nvSpPr>
-          <p:cNvPr id="13" name="hueso-65"/>
+          <p:cNvPr id="13" name="hueso-75"/>
           <p:cNvSpPr/>
           <p:nvPr/>
         </p:nvSpPr>
@@ -25048,7 +25345,7 @@
       </p:sp>
       <p:sp>
         <p:nvSpPr>
-          <p:cNvPr id="14" name="categoria-66"/>
+          <p:cNvPr id="14" name="categoria-76"/>
           <p:cNvSpPr/>
           <p:nvPr/>
         </p:nvSpPr>
@@ -25226,7 +25523,7 @@
       </p:sp>
       <p:sp>
         <p:nvSpPr>
-          <p:cNvPr id="19" name="hueso-67"/>
+          <p:cNvPr id="19" name="hueso-77"/>
           <p:cNvSpPr/>
           <p:nvPr/>
         </p:nvSpPr>
@@ -25249,7 +25546,7 @@
       </p:sp>
       <p:sp>
         <p:nvSpPr>
-          <p:cNvPr id="20" name="categoria-68"/>
+          <p:cNvPr id="20" name="categoria-78"/>
           <p:cNvSpPr/>
           <p:nvPr/>
         </p:nvSpPr>
@@ -25427,7 +25724,7 @@
       </p:sp>
       <p:sp>
         <p:nvSpPr>
-          <p:cNvPr id="25" name="hueso-69"/>
+          <p:cNvPr id="25" name="hueso-79"/>
           <p:cNvSpPr/>
           <p:nvPr/>
         </p:nvSpPr>
@@ -25450,7 +25747,7 @@
       </p:sp>
       <p:sp>
         <p:nvSpPr>
-          <p:cNvPr id="26" name="categoria-70"/>
+          <p:cNvPr id="26" name="categoria-80"/>
           <p:cNvSpPr/>
           <p:nvPr/>
         </p:nvSpPr>
@@ -25628,7 +25925,7 @@
       </p:sp>
       <p:sp>
         <p:nvSpPr>
-          <p:cNvPr id="31" name="hueso-71"/>
+          <p:cNvPr id="31" name="hueso-81"/>
           <p:cNvSpPr/>
           <p:nvPr/>
         </p:nvSpPr>
@@ -25651,7 +25948,7 @@
       </p:sp>
       <p:sp>
         <p:nvSpPr>
-          <p:cNvPr id="32" name="categoria-72"/>
+          <p:cNvPr id="32" name="categoria-82"/>
           <p:cNvSpPr/>
           <p:nvPr/>
         </p:nvSpPr>
@@ -25829,7 +26126,7 @@
       </p:sp>
       <p:sp>
         <p:nvSpPr>
-          <p:cNvPr id="37" name="hueso-73"/>
+          <p:cNvPr id="37" name="hueso-83"/>
           <p:cNvSpPr/>
           <p:nvPr/>
         </p:nvSpPr>
@@ -25852,7 +26149,7 @@
       </p:sp>
       <p:sp>
         <p:nvSpPr>
-          <p:cNvPr id="38" name="categoria-74"/>
+          <p:cNvPr id="38" name="categoria-84"/>
           <p:cNvSpPr/>
           <p:nvPr/>
         </p:nvSpPr>
@@ -26182,7 +26479,7 @@
       </p:sp>
       <p:sp>
         <p:nvSpPr>
-          <p:cNvPr id="4" name="card-75"/>
+          <p:cNvPr id="4" name="card-85"/>
           <p:cNvSpPr/>
           <p:nvPr/>
         </p:nvSpPr>
@@ -26257,7 +26554,7 @@
       </p:sp>
       <p:sp>
         <p:nvSpPr>
-          <p:cNvPr id="6" name="card-76"/>
+          <p:cNvPr id="6" name="card-86"/>
           <p:cNvSpPr/>
           <p:nvPr/>
         </p:nvSpPr>
@@ -26279,7 +26576,7 @@
       </p:sp>
       <p:sp>
         <p:nvSpPr>
-          <p:cNvPr id="7" name="icono-fondo-77"/>
+          <p:cNvPr id="7" name="icono-fondo-87"/>
           <p:cNvSpPr/>
           <p:nvPr/>
         </p:nvSpPr>
@@ -26299,7 +26596,7 @@
       </p:sp>
       <p:pic>
         <p:nvPicPr>
-          <p:cNvPr id="8" name="icono-78" descr="preencoded.png">    </p:cNvPr>
+          <p:cNvPr id="8" name="icono-88" descr="preencoded.png">    </p:cNvPr>
           <p:cNvPicPr>
             <a:picLocks noChangeAspect="1"/>
           </p:cNvPicPr>
@@ -26440,7 +26737,7 @@
       </p:sp>
       <p:sp>
         <p:nvSpPr>
-          <p:cNvPr id="12" name="card-79"/>
+          <p:cNvPr id="12" name="card-89"/>
           <p:cNvSpPr/>
           <p:nvPr/>
         </p:nvSpPr>
@@ -26462,7 +26759,7 @@
       </p:sp>
       <p:sp>
         <p:nvSpPr>
-          <p:cNvPr id="13" name="icono-fondo-80"/>
+          <p:cNvPr id="13" name="icono-fondo-90"/>
           <p:cNvSpPr/>
           <p:nvPr/>
         </p:nvSpPr>
@@ -26482,7 +26779,7 @@
       </p:sp>
       <p:pic>
         <p:nvPicPr>
-          <p:cNvPr id="14" name="icono-81" descr="preencoded.png">    </p:cNvPr>
+          <p:cNvPr id="14" name="icono-91" descr="preencoded.png">    </p:cNvPr>
           <p:cNvPicPr>
             <a:picLocks noChangeAspect="1"/>
           </p:cNvPicPr>
@@ -26623,7 +26920,7 @@
       </p:sp>
       <p:sp>
         <p:nvSpPr>
-          <p:cNvPr id="18" name="card-82"/>
+          <p:cNvPr id="18" name="card-92"/>
           <p:cNvSpPr/>
           <p:nvPr/>
         </p:nvSpPr>
@@ -26645,7 +26942,7 @@
       </p:sp>
       <p:sp>
         <p:nvSpPr>
-          <p:cNvPr id="19" name="icono-fondo-83"/>
+          <p:cNvPr id="19" name="icono-fondo-93"/>
           <p:cNvSpPr/>
           <p:nvPr/>
         </p:nvSpPr>
@@ -26665,7 +26962,7 @@
       </p:sp>
       <p:pic>
         <p:nvPicPr>
-          <p:cNvPr id="20" name="icono-84" descr="preencoded.png">    </p:cNvPr>
+          <p:cNvPr id="20" name="icono-94" descr="preencoded.png">    </p:cNvPr>
           <p:cNvPicPr>
             <a:picLocks noChangeAspect="1"/>
           </p:cNvPicPr>

</xml_diff>

<commit_message>
Presentación: diapositiva 17 con la evidencia del pedido real DP-261010-001 (sitio, WhatsApp, fila de la planilla)
Co-Authored-By: Claude Opus 5.5 <noreply@anthropic.com>
Claude-Session: https://claude.ai/code/session_01KjW6Rcbm4CLMi8kGU9T2EW
</commit_message>
<xml_diff>
--- a/docs/presentacion/DanyPizzas_Presentacion.pptx
+++ b/docs/presentacion/DanyPizzas_Presentacion.pptx
@@ -126,25 +126,25 @@
   <p:extLst>
     <p:ext uri="{521415D9-36F7-43E2-AB2F-B90AF26B5E84}">
       <p14:sectionLst xmlns:p14="http://schemas.microsoft.com/office/powerpoint/2010/main">
-        <p14:section name="Introducción" id="{317671ae-d16a-740c-3e05-f399366cf62a}">
+        <p14:section name="Introducción" id="{b01fb826-ebff-7cb8-e4f9-eb9d1e9e1c41}">
           <p14:sldIdLst>
             <p14:sldId id="256"/>
             <p14:sldId id="257"/>
           </p14:sldIdLst>
         </p14:section>
-        <p14:section name="I. Curriculum vitae" id="{1b55d632-9d95-47fe-09e2-607b29e441f5}">
+        <p14:section name="I. Curriculum vitae" id="{ad394339-cbf4-0518-7bce-e1d2594ae99f}">
           <p14:sldIdLst>
             <p14:sldId id="258"/>
           </p14:sldIdLst>
         </p14:section>
-        <p14:section name="II. Memoria descriptiva" id="{8f216b5a-9520-82d2-6c2b-442bb8cc3df2}">
+        <p14:section name="II. Memoria descriptiva" id="{8917fc81-7ae6-00fa-2099-96fd16e4baae}">
           <p14:sldIdLst>
             <p14:sldId id="259"/>
             <p14:sldId id="260"/>
             <p14:sldId id="261"/>
           </p14:sldIdLst>
         </p14:section>
-        <p14:section name="III. Trabajo principal" id="{f0309800-b62e-cfbd-06ca-216d5787ad17}">
+        <p14:section name="III. Trabajo principal" id="{f935fdf5-51f7-bce1-a112-1dc281a05bea}">
           <p14:sldIdLst>
             <p14:sldId id="262"/>
             <p14:sldId id="263"/>
@@ -1550,7 +1550,8 @@
             <a:r>
               <a:rPr lang="en-US" dirty="0"/>
               <a:t>⏱ 0:50 (acumulado 11:50)
-Los resultados, objetivo por objetivo, comparando antes y ahora. OE1: la carta dejó de ser una imagen reenviada y el pedido llega siempre completo. OE2: antes no había ningún registro, hoy hay una planilla mensual y los precios se cambian editando una celda. OE3: cuesta cero por mes y pasa 44 pruebas. Y acá tienen la evidencia de un pedido real: [mostrar capturas].</a:t>
+Los resultados, objetivo por objetivo, comparando antes y ahora. OE1: la carta dejó de ser una imagen reenviada y el pedido llega siempre completo. OE2: antes no había ningún registro, hoy hay una planilla mensual y los precios se cambian editando una celda. OE3: cuesta cero por mes y pasa 44 pruebas. Y acá está la evidencia de un pedido real, el DP-261010-001, de punta a punta: (1) el cliente confirma en el sitio y recibe su número; (2) el recibo llega armado al WhatsApp del negocio; (3) queda registrado solo en la planilla del mes, con el total recalculado por el servidor. El mismo número aparece en los tres lugares.
+Si preguntan: la hora del recibo (13:16) es la de Argentina, la del negocio; WhatsApp muestra la hora de mi celular en Perú. El aviso de 'fuera de horario' aparece porque lo hice de día: el sitio deja pedir igual y avisa al negocio. En la planilla muestro solo esta fila porque las demás tienen datos de clientes.</a:t>
             </a:r>
             <a:endParaRPr lang="en-US" dirty="0"/>
           </a:p>
@@ -14372,7 +14373,7 @@
           </p:nvPr>
         </p:nvGraphicFramePr>
         <p:xfrm>
-          <a:off x="548640" y="1463040"/>
+          <a:off x="548640" y="1371600"/>
           <a:ext cx="11064240" cy="914400"/>
         </p:xfrm>
         <a:graphic>
@@ -14385,7 +14386,7 @@
                 <a:gridCol w="3657600"/>
                 <a:gridCol w="4114800"/>
               </a:tblGrid>
-              <a:tr h="475488">
+              <a:tr h="393192">
                 <a:tc>
                   <a:txBody>
                     <a:bodyPr/>
@@ -14394,7 +14395,7 @@
                       <a:pPr indent="0" marL="0">
                         <a:buNone/>
                       </a:pPr>
-                      <a:endParaRPr lang="en-US" sz="1500" dirty="0">
+                      <a:endParaRPr lang="en-US" sz="1400" dirty="0">
                         <a:latin typeface="Calibri" charset="0"/>
                         <a:ea typeface="Calibri" charset="0"/>
                         <a:cs typeface="Calibri" charset="0"/>
@@ -14452,7 +14453,7 @@
                         <a:buNone/>
                       </a:pPr>
                       <a:r>
-                        <a:rPr lang="en-US" sz="1500" b="1" dirty="0">
+                        <a:rPr lang="en-US" sz="1400" b="1" dirty="0">
                           <a:solidFill>
                             <a:schemeClr val="bg1"/>
                           </a:solidFill>
@@ -14462,7 +14463,7 @@
                         </a:rPr>
                         <a:t>Indicador</a:t>
                       </a:r>
-                      <a:endParaRPr lang="en-US" sz="1500" dirty="0">
+                      <a:endParaRPr lang="en-US" sz="1400" dirty="0">
                         <a:latin typeface="Calibri" charset="0"/>
                         <a:ea typeface="Calibri" charset="0"/>
                         <a:cs typeface="Calibri" charset="0"/>
@@ -14520,7 +14521,7 @@
                         <a:buNone/>
                       </a:pPr>
                       <a:r>
-                        <a:rPr lang="en-US" sz="1500" b="1" dirty="0">
+                        <a:rPr lang="en-US" sz="1400" b="1" dirty="0">
                           <a:solidFill>
                             <a:schemeClr val="bg1"/>
                           </a:solidFill>
@@ -14530,7 +14531,7 @@
                         </a:rPr>
                         <a:t>Antes</a:t>
                       </a:r>
-                      <a:endParaRPr lang="en-US" sz="1500" dirty="0">
+                      <a:endParaRPr lang="en-US" sz="1400" dirty="0">
                         <a:latin typeface="Calibri" charset="0"/>
                         <a:ea typeface="Calibri" charset="0"/>
                         <a:cs typeface="Calibri" charset="0"/>
@@ -14588,7 +14589,7 @@
                         <a:buNone/>
                       </a:pPr>
                       <a:r>
-                        <a:rPr lang="en-US" sz="1500" b="1" dirty="0">
+                        <a:rPr lang="en-US" sz="1400" b="1" dirty="0">
                           <a:solidFill>
                             <a:schemeClr val="bg1"/>
                           </a:solidFill>
@@ -14596,9 +14597,9 @@
                           <a:ea typeface="Calibri" pitchFamily="34" charset="-122"/>
                           <a:cs typeface="Calibri" pitchFamily="34" charset="-120"/>
                         </a:rPr>
-                        <a:t>Ahora (07/10/2026)</a:t>
+                        <a:t>Ahora (10/10/2026)</a:t>
                       </a:r>
-                      <a:endParaRPr lang="en-US" sz="1500" dirty="0">
+                      <a:endParaRPr lang="en-US" sz="1400" dirty="0">
                         <a:latin typeface="Calibri" charset="0"/>
                         <a:ea typeface="Calibri" charset="0"/>
                         <a:cs typeface="Calibri" charset="0"/>
@@ -14648,7 +14649,7 @@
                   </a:tcPr>
                 </a:tc>
               </a:tr>
-              <a:tr h="475488">
+              <a:tr h="393192">
                 <a:tc>
                   <a:txBody>
                     <a:bodyPr/>
@@ -14658,7 +14659,7 @@
                         <a:buNone/>
                       </a:pPr>
                       <a:r>
-                        <a:rPr lang="en-US" sz="1500" b="1" dirty="0">
+                        <a:rPr lang="en-US" sz="1400" b="1" dirty="0">
                           <a:solidFill>
                             <a:schemeClr val="bg1"/>
                           </a:solidFill>
@@ -14668,7 +14669,7 @@
                         </a:rPr>
                         <a:t>OE1</a:t>
                       </a:r>
-                      <a:endParaRPr lang="en-US" sz="1500" dirty="0">
+                      <a:endParaRPr lang="en-US" sz="1400" dirty="0">
                         <a:latin typeface="Calibri" charset="0"/>
                         <a:ea typeface="Calibri" charset="0"/>
                         <a:cs typeface="Calibri" charset="0"/>
@@ -14726,7 +14727,7 @@
                         <a:buNone/>
                       </a:pPr>
                       <a:r>
-                        <a:rPr lang="en-US" sz="1500" b="1" dirty="0">
+                        <a:rPr lang="en-US" sz="1400" b="1" dirty="0">
                           <a:solidFill>
                             <a:srgbClr val="2B2420"/>
                           </a:solidFill>
@@ -14736,7 +14737,7 @@
                         </a:rPr>
                         <a:t>Carta</a:t>
                       </a:r>
-                      <a:endParaRPr lang="en-US" sz="1500" dirty="0">
+                      <a:endParaRPr lang="en-US" sz="1400" dirty="0">
                         <a:latin typeface="Calibri" charset="0"/>
                         <a:ea typeface="Calibri" charset="0"/>
                         <a:cs typeface="Calibri" charset="0"/>
@@ -14791,7 +14792,7 @@
                         <a:buNone/>
                       </a:pPr>
                       <a:r>
-                        <a:rPr lang="en-US" sz="1500" dirty="0">
+                        <a:rPr lang="en-US" sz="1400" dirty="0">
                           <a:solidFill>
                             <a:srgbClr val="8A7F76"/>
                           </a:solidFill>
@@ -14801,7 +14802,7 @@
                         </a:rPr>
                         <a:t>Imagen reenviada por chat</a:t>
                       </a:r>
-                      <a:endParaRPr lang="en-US" sz="1500" dirty="0">
+                      <a:endParaRPr lang="en-US" sz="1400" dirty="0">
                         <a:latin typeface="Calibri" charset="0"/>
                         <a:ea typeface="Calibri" charset="0"/>
                         <a:cs typeface="Calibri" charset="0"/>
@@ -14856,7 +14857,7 @@
                         <a:buNone/>
                       </a:pPr>
                       <a:r>
-                        <a:rPr lang="en-US" sz="1500" b="1" dirty="0">
+                        <a:rPr lang="en-US" sz="1400" b="1" dirty="0">
                           <a:solidFill>
                             <a:srgbClr val="1F6E5C"/>
                           </a:solidFill>
@@ -14866,7 +14867,7 @@
                         </a:rPr>
                         <a:t>Sitio publicado con fotos y precios</a:t>
                       </a:r>
-                      <a:endParaRPr lang="en-US" sz="1500" dirty="0">
+                      <a:endParaRPr lang="en-US" sz="1400" dirty="0">
                         <a:latin typeface="Calibri" charset="0"/>
                         <a:ea typeface="Calibri" charset="0"/>
                         <a:cs typeface="Calibri" charset="0"/>
@@ -14913,7 +14914,7 @@
                   </a:tcPr>
                 </a:tc>
               </a:tr>
-              <a:tr h="475488">
+              <a:tr h="393192">
                 <a:tc>
                   <a:txBody>
                     <a:bodyPr/>
@@ -14923,7 +14924,7 @@
                         <a:buNone/>
                       </a:pPr>
                       <a:r>
-                        <a:rPr lang="en-US" sz="1500" b="1" dirty="0">
+                        <a:rPr lang="en-US" sz="1400" b="1" dirty="0">
                           <a:solidFill>
                             <a:schemeClr val="bg1"/>
                           </a:solidFill>
@@ -14933,7 +14934,7 @@
                         </a:rPr>
                         <a:t>OE1</a:t>
                       </a:r>
-                      <a:endParaRPr lang="en-US" sz="1500" dirty="0">
+                      <a:endParaRPr lang="en-US" sz="1400" dirty="0">
                         <a:latin typeface="Calibri" charset="0"/>
                         <a:ea typeface="Calibri" charset="0"/>
                         <a:cs typeface="Calibri" charset="0"/>
@@ -14991,7 +14992,7 @@
                         <a:buNone/>
                       </a:pPr>
                       <a:r>
-                        <a:rPr lang="en-US" sz="1500" b="1" dirty="0">
+                        <a:rPr lang="en-US" sz="1400" b="1" dirty="0">
                           <a:solidFill>
                             <a:srgbClr val="2B2420"/>
                           </a:solidFill>
@@ -15001,7 +15002,7 @@
                         </a:rPr>
                         <a:t>Datos del pedido</a:t>
                       </a:r>
-                      <a:endParaRPr lang="en-US" sz="1500" dirty="0">
+                      <a:endParaRPr lang="en-US" sz="1400" dirty="0">
                         <a:latin typeface="Calibri" charset="0"/>
                         <a:ea typeface="Calibri" charset="0"/>
                         <a:cs typeface="Calibri" charset="0"/>
@@ -15056,7 +15057,7 @@
                         <a:buNone/>
                       </a:pPr>
                       <a:r>
-                        <a:rPr lang="en-US" sz="1500" dirty="0">
+                        <a:rPr lang="en-US" sz="1400" dirty="0">
                           <a:solidFill>
                             <a:srgbClr val="8A7F76"/>
                           </a:solidFill>
@@ -15066,7 +15067,7 @@
                         </a:rPr>
                         <a:t>Incompletos (1 de cada 10 con error)</a:t>
                       </a:r>
-                      <a:endParaRPr lang="en-US" sz="1500" dirty="0">
+                      <a:endParaRPr lang="en-US" sz="1400" dirty="0">
                         <a:latin typeface="Calibri" charset="0"/>
                         <a:ea typeface="Calibri" charset="0"/>
                         <a:cs typeface="Calibri" charset="0"/>
@@ -15121,7 +15122,7 @@
                         <a:buNone/>
                       </a:pPr>
                       <a:r>
-                        <a:rPr lang="en-US" sz="1500" b="1" dirty="0">
+                        <a:rPr lang="en-US" sz="1400" b="1" dirty="0">
                           <a:solidFill>
                             <a:srgbClr val="1F6E5C"/>
                           </a:solidFill>
@@ -15131,7 +15132,7 @@
                         </a:rPr>
                         <a:t>100 % completos: no se envía sin ellos</a:t>
                       </a:r>
-                      <a:endParaRPr lang="en-US" sz="1500" dirty="0">
+                      <a:endParaRPr lang="en-US" sz="1400" dirty="0">
                         <a:latin typeface="Calibri" charset="0"/>
                         <a:ea typeface="Calibri" charset="0"/>
                         <a:cs typeface="Calibri" charset="0"/>
@@ -15178,7 +15179,7 @@
                   </a:tcPr>
                 </a:tc>
               </a:tr>
-              <a:tr h="475488">
+              <a:tr h="393192">
                 <a:tc>
                   <a:txBody>
                     <a:bodyPr/>
@@ -15188,7 +15189,7 @@
                         <a:buNone/>
                       </a:pPr>
                       <a:r>
-                        <a:rPr lang="en-US" sz="1500" b="1" dirty="0">
+                        <a:rPr lang="en-US" sz="1400" b="1" dirty="0">
                           <a:solidFill>
                             <a:schemeClr val="bg1"/>
                           </a:solidFill>
@@ -15198,7 +15199,7 @@
                         </a:rPr>
                         <a:t>OE2</a:t>
                       </a:r>
-                      <a:endParaRPr lang="en-US" sz="1500" dirty="0">
+                      <a:endParaRPr lang="en-US" sz="1400" dirty="0">
                         <a:latin typeface="Calibri" charset="0"/>
                         <a:ea typeface="Calibri" charset="0"/>
                         <a:cs typeface="Calibri" charset="0"/>
@@ -15256,7 +15257,7 @@
                         <a:buNone/>
                       </a:pPr>
                       <a:r>
-                        <a:rPr lang="en-US" sz="1500" b="1" dirty="0">
+                        <a:rPr lang="en-US" sz="1400" b="1" dirty="0">
                           <a:solidFill>
                             <a:srgbClr val="2B2420"/>
                           </a:solidFill>
@@ -15266,7 +15267,7 @@
                         </a:rPr>
                         <a:t>Registro de pedidos</a:t>
                       </a:r>
-                      <a:endParaRPr lang="en-US" sz="1500" dirty="0">
+                      <a:endParaRPr lang="en-US" sz="1400" dirty="0">
                         <a:latin typeface="Calibri" charset="0"/>
                         <a:ea typeface="Calibri" charset="0"/>
                         <a:cs typeface="Calibri" charset="0"/>
@@ -15321,7 +15322,7 @@
                         <a:buNone/>
                       </a:pPr>
                       <a:r>
-                        <a:rPr lang="en-US" sz="1500" dirty="0">
+                        <a:rPr lang="en-US" sz="1400" dirty="0">
                           <a:solidFill>
                             <a:srgbClr val="8A7F76"/>
                           </a:solidFill>
@@ -15331,7 +15332,7 @@
                         </a:rPr>
                         <a:t>No existía</a:t>
                       </a:r>
-                      <a:endParaRPr lang="en-US" sz="1500" dirty="0">
+                      <a:endParaRPr lang="en-US" sz="1400" dirty="0">
                         <a:latin typeface="Calibri" charset="0"/>
                         <a:ea typeface="Calibri" charset="0"/>
                         <a:cs typeface="Calibri" charset="0"/>
@@ -15386,7 +15387,7 @@
                         <a:buNone/>
                       </a:pPr>
                       <a:r>
-                        <a:rPr lang="en-US" sz="1500" b="1" dirty="0">
+                        <a:rPr lang="en-US" sz="1400" b="1" dirty="0">
                           <a:solidFill>
                             <a:srgbClr val="1F6E5C"/>
                           </a:solidFill>
@@ -15396,7 +15397,7 @@
                         </a:rPr>
                         <a:t>Planilla mensual activa desde 06/10</a:t>
                       </a:r>
-                      <a:endParaRPr lang="en-US" sz="1500" dirty="0">
+                      <a:endParaRPr lang="en-US" sz="1400" dirty="0">
                         <a:latin typeface="Calibri" charset="0"/>
                         <a:ea typeface="Calibri" charset="0"/>
                         <a:cs typeface="Calibri" charset="0"/>
@@ -15443,7 +15444,7 @@
                   </a:tcPr>
                 </a:tc>
               </a:tr>
-              <a:tr h="475488">
+              <a:tr h="393192">
                 <a:tc>
                   <a:txBody>
                     <a:bodyPr/>
@@ -15453,7 +15454,7 @@
                         <a:buNone/>
                       </a:pPr>
                       <a:r>
-                        <a:rPr lang="en-US" sz="1500" b="1" dirty="0">
+                        <a:rPr lang="en-US" sz="1400" b="1" dirty="0">
                           <a:solidFill>
                             <a:schemeClr val="bg1"/>
                           </a:solidFill>
@@ -15463,7 +15464,7 @@
                         </a:rPr>
                         <a:t>OE2</a:t>
                       </a:r>
-                      <a:endParaRPr lang="en-US" sz="1500" dirty="0">
+                      <a:endParaRPr lang="en-US" sz="1400" dirty="0">
                         <a:latin typeface="Calibri" charset="0"/>
                         <a:ea typeface="Calibri" charset="0"/>
                         <a:cs typeface="Calibri" charset="0"/>
@@ -15521,7 +15522,7 @@
                         <a:buNone/>
                       </a:pPr>
                       <a:r>
-                        <a:rPr lang="en-US" sz="1500" b="1" dirty="0">
+                        <a:rPr lang="en-US" sz="1400" b="1" dirty="0">
                           <a:solidFill>
                             <a:srgbClr val="2B2420"/>
                           </a:solidFill>
@@ -15531,7 +15532,7 @@
                         </a:rPr>
                         <a:t>Cambio de precios</a:t>
                       </a:r>
-                      <a:endParaRPr lang="en-US" sz="1500" dirty="0">
+                      <a:endParaRPr lang="en-US" sz="1400" dirty="0">
                         <a:latin typeface="Calibri" charset="0"/>
                         <a:ea typeface="Calibri" charset="0"/>
                         <a:cs typeface="Calibri" charset="0"/>
@@ -15586,7 +15587,7 @@
                         <a:buNone/>
                       </a:pPr>
                       <a:r>
-                        <a:rPr lang="en-US" sz="1500" dirty="0">
+                        <a:rPr lang="en-US" sz="1400" dirty="0">
                           <a:solidFill>
                             <a:srgbClr val="8A7F76"/>
                           </a:solidFill>
@@ -15596,7 +15597,7 @@
                         </a:rPr>
                         <a:t>Reenviar la carta</a:t>
                       </a:r>
-                      <a:endParaRPr lang="en-US" sz="1500" dirty="0">
+                      <a:endParaRPr lang="en-US" sz="1400" dirty="0">
                         <a:latin typeface="Calibri" charset="0"/>
                         <a:ea typeface="Calibri" charset="0"/>
                         <a:cs typeface="Calibri" charset="0"/>
@@ -15651,7 +15652,7 @@
                         <a:buNone/>
                       </a:pPr>
                       <a:r>
-                        <a:rPr lang="en-US" sz="1500" b="1" dirty="0">
+                        <a:rPr lang="en-US" sz="1400" b="1" dirty="0">
                           <a:solidFill>
                             <a:srgbClr val="1F6E5C"/>
                           </a:solidFill>
@@ -15661,7 +15662,7 @@
                         </a:rPr>
                         <a:t>Editar una celda</a:t>
                       </a:r>
-                      <a:endParaRPr lang="en-US" sz="1500" dirty="0">
+                      <a:endParaRPr lang="en-US" sz="1400" dirty="0">
                         <a:latin typeface="Calibri" charset="0"/>
                         <a:ea typeface="Calibri" charset="0"/>
                         <a:cs typeface="Calibri" charset="0"/>
@@ -15708,7 +15709,7 @@
                   </a:tcPr>
                 </a:tc>
               </a:tr>
-              <a:tr h="475488">
+              <a:tr h="393192">
                 <a:tc>
                   <a:txBody>
                     <a:bodyPr/>
@@ -15718,7 +15719,7 @@
                         <a:buNone/>
                       </a:pPr>
                       <a:r>
-                        <a:rPr lang="en-US" sz="1500" b="1" dirty="0">
+                        <a:rPr lang="en-US" sz="1400" b="1" dirty="0">
                           <a:solidFill>
                             <a:schemeClr val="bg1"/>
                           </a:solidFill>
@@ -15728,7 +15729,7 @@
                         </a:rPr>
                         <a:t>OE3</a:t>
                       </a:r>
-                      <a:endParaRPr lang="en-US" sz="1500" dirty="0">
+                      <a:endParaRPr lang="en-US" sz="1400" dirty="0">
                         <a:latin typeface="Calibri" charset="0"/>
                         <a:ea typeface="Calibri" charset="0"/>
                         <a:cs typeface="Calibri" charset="0"/>
@@ -15786,7 +15787,7 @@
                         <a:buNone/>
                       </a:pPr>
                       <a:r>
-                        <a:rPr lang="en-US" sz="1500" b="1" dirty="0">
+                        <a:rPr lang="en-US" sz="1400" b="1" dirty="0">
                           <a:solidFill>
                             <a:srgbClr val="2B2420"/>
                           </a:solidFill>
@@ -15796,7 +15797,7 @@
                         </a:rPr>
                         <a:t>Costo y calidad</a:t>
                       </a:r>
-                      <a:endParaRPr lang="en-US" sz="1500" dirty="0">
+                      <a:endParaRPr lang="en-US" sz="1400" dirty="0">
                         <a:latin typeface="Calibri" charset="0"/>
                         <a:ea typeface="Calibri" charset="0"/>
                         <a:cs typeface="Calibri" charset="0"/>
@@ -15851,7 +15852,7 @@
                         <a:buNone/>
                       </a:pPr>
                       <a:r>
-                        <a:rPr lang="en-US" sz="1500" dirty="0">
+                        <a:rPr lang="en-US" sz="1400" dirty="0">
                           <a:solidFill>
                             <a:srgbClr val="8A7F76"/>
                           </a:solidFill>
@@ -15861,7 +15862,7 @@
                         </a:rPr>
                         <a:t>—</a:t>
                       </a:r>
-                      <a:endParaRPr lang="en-US" sz="1500" dirty="0">
+                      <a:endParaRPr lang="en-US" sz="1400" dirty="0">
                         <a:latin typeface="Calibri" charset="0"/>
                         <a:ea typeface="Calibri" charset="0"/>
                         <a:cs typeface="Calibri" charset="0"/>
@@ -15916,7 +15917,7 @@
                         <a:buNone/>
                       </a:pPr>
                       <a:r>
-                        <a:rPr lang="en-US" sz="1500" b="1" dirty="0">
+                        <a:rPr lang="en-US" sz="1400" b="1" dirty="0">
                           <a:solidFill>
                             <a:srgbClr val="1F6E5C"/>
                           </a:solidFill>
@@ -15926,7 +15927,7 @@
                         </a:rPr>
                         <a:t>$0 por mes · 44 pruebas en verde</a:t>
                       </a:r>
-                      <a:endParaRPr lang="en-US" sz="1500" dirty="0">
+                      <a:endParaRPr lang="en-US" sz="1400" dirty="0">
                         <a:latin typeface="Calibri" charset="0"/>
                         <a:ea typeface="Calibri" charset="0"/>
                         <a:cs typeface="Calibri" charset="0"/>
@@ -15985,8 +15986,8 @@
         </p:nvSpPr>
         <p:spPr>
           <a:xfrm>
-            <a:off x="548640" y="4526280"/>
-            <a:ext cx="5486400" cy="365760"/>
+            <a:off x="548640" y="3913632"/>
+            <a:ext cx="11064240" cy="365760"/>
           </a:xfrm>
           <a:prstGeom prst="rect">
             <a:avLst/>
@@ -16010,49 +16011,196 @@
                 <a:ea typeface="Cambria" pitchFamily="34" charset="-122"/>
                 <a:cs typeface="Cambria" pitchFamily="34" charset="-120"/>
               </a:rPr>
-              <a:t>Evidencia del uso real</a:t>
+              <a:t>Evidencia: pedido real DP‑261010‑001</a:t>
+            </a:r>
+            <a:pPr indent="0" marL="0">
+              <a:buNone/>
+            </a:pPr>
+            <a:r>
+              <a:rPr lang="en-US" sz="1400" dirty="0">
+                <a:solidFill>
+                  <a:schemeClr val="accent4"/>
+                </a:solidFill>
+                <a:latin typeface="Cambria" pitchFamily="34" charset="0"/>
+                <a:ea typeface="Cambria" pitchFamily="34" charset="-122"/>
+                <a:cs typeface="Cambria" pitchFamily="34" charset="-120"/>
+              </a:rPr>
+              <a:t>  ·  10/10/2026, de punta a punta</a:t>
             </a:r>
             <a:endParaRPr lang="en-US" sz="1700" dirty="0"/>
           </a:p>
         </p:txBody>
       </p:sp>
-      <p:sp>
-        <p:nvSpPr>
-          <p:cNvPr id="6" name="pendiente-178"/>
+      <p:pic>
+        <p:nvPicPr>
+          <p:cNvPr id="6" name="evidencia-sitio" descr="/tmp/claude-0/-home-claude/c096e975-9e6a-561f-aa0a-08cce324a4b6/scratchpad/repo/docs/presentacion/assets/evidencia_confirmacion.png">    </p:cNvPr>
+          <p:cNvPicPr>
+            <a:picLocks noChangeAspect="1"/>
+          </p:cNvPicPr>
+          <p:nvPr/>
+        </p:nvPicPr>
+        <p:blipFill>
+          <a:blip r:embed="rId1"/>
+          <a:stretch>
+            <a:fillRect/>
+          </a:stretch>
+        </p:blipFill>
+        <p:spPr>
+          <a:xfrm>
+            <a:off x="548640" y="4343400"/>
+            <a:ext cx="1617119" cy="1901952"/>
+          </a:xfrm>
+          <a:prstGeom prst="rect">
+            <a:avLst/>
+          </a:prstGeom>
+        </p:spPr>
+      </p:pic>
+      <p:sp>
+        <p:nvSpPr>
+          <p:cNvPr id="7" name="marco-178"/>
           <p:cNvSpPr/>
           <p:nvPr/>
         </p:nvSpPr>
         <p:spPr>
           <a:xfrm>
-            <a:off x="548640" y="4937760"/>
-            <a:ext cx="2606040" cy="1234440"/>
+            <a:off x="548640" y="4343400"/>
+            <a:ext cx="1617119" cy="1901952"/>
+          </a:xfrm>
+          <a:prstGeom prst="rect">
+            <a:avLst/>
+          </a:prstGeom>
+          <a:ln w="12700">
+            <a:solidFill>
+              <a:srgbClr val="E4DCD2"/>
+            </a:solidFill>
+            <a:prstDash val="solid"/>
+          </a:ln>
+        </p:spPr>
+      </p:sp>
+      <p:pic>
+        <p:nvPicPr>
+          <p:cNvPr id="8" name="evidencia-whatsapp" descr="/tmp/claude-0/-home-claude/c096e975-9e6a-561f-aa0a-08cce324a4b6/scratchpad/repo/docs/presentacion/assets/evidencia_whatsapp.png">    </p:cNvPr>
+          <p:cNvPicPr>
+            <a:picLocks noChangeAspect="1"/>
+          </p:cNvPicPr>
+          <p:nvPr/>
+        </p:nvPicPr>
+        <p:blipFill>
+          <a:blip r:embed="rId2"/>
+          <a:stretch>
+            <a:fillRect/>
+          </a:stretch>
+        </p:blipFill>
+        <p:spPr>
+          <a:xfrm>
+            <a:off x="2348639" y="4343400"/>
+            <a:ext cx="2215742" cy="1901952"/>
+          </a:xfrm>
+          <a:prstGeom prst="rect">
+            <a:avLst/>
+          </a:prstGeom>
+        </p:spPr>
+      </p:pic>
+      <p:sp>
+        <p:nvSpPr>
+          <p:cNvPr id="9" name="marco-179"/>
+          <p:cNvSpPr/>
+          <p:nvPr/>
+        </p:nvSpPr>
+        <p:spPr>
+          <a:xfrm>
+            <a:off x="2348639" y="4343400"/>
+            <a:ext cx="2215742" cy="1901952"/>
+          </a:xfrm>
+          <a:prstGeom prst="rect">
+            <a:avLst/>
+          </a:prstGeom>
+          <a:ln w="12700">
+            <a:solidFill>
+              <a:srgbClr val="E4DCD2"/>
+            </a:solidFill>
+            <a:prstDash val="solid"/>
+          </a:ln>
+        </p:spPr>
+      </p:sp>
+      <p:pic>
+        <p:nvPicPr>
+          <p:cNvPr id="10" name="evidencia-planilla" descr="/tmp/claude-0/-home-claude/c096e975-9e6a-561f-aa0a-08cce324a4b6/scratchpad/repo/docs/presentacion/assets/evidencia_planilla.png">    </p:cNvPr>
+          <p:cNvPicPr>
+            <a:picLocks noChangeAspect="1"/>
+          </p:cNvPicPr>
+          <p:nvPr/>
+        </p:nvPicPr>
+        <p:blipFill>
+          <a:blip r:embed="rId3"/>
+          <a:stretch>
+            <a:fillRect/>
+          </a:stretch>
+        </p:blipFill>
+        <p:spPr>
+          <a:xfrm>
+            <a:off x="4792981" y="4727448"/>
+            <a:ext cx="6819899" cy="556435"/>
+          </a:xfrm>
+          <a:prstGeom prst="rect">
+            <a:avLst/>
+          </a:prstGeom>
+        </p:spPr>
+      </p:pic>
+      <p:sp>
+        <p:nvSpPr>
+          <p:cNvPr id="11" name="marco-180"/>
+          <p:cNvSpPr/>
+          <p:nvPr/>
+        </p:nvSpPr>
+        <p:spPr>
+          <a:xfrm>
+            <a:off x="4792981" y="4727448"/>
+            <a:ext cx="6819899" cy="556435"/>
+          </a:xfrm>
+          <a:prstGeom prst="rect">
+            <a:avLst/>
+          </a:prstGeom>
+          <a:ln w="12700">
+            <a:solidFill>
+              <a:srgbClr val="E4DCD2"/>
+            </a:solidFill>
+            <a:prstDash val="solid"/>
+          </a:ln>
+        </p:spPr>
+      </p:sp>
+      <p:sp>
+        <p:nvSpPr>
+          <p:cNvPr id="12" name="etiqueta-181"/>
+          <p:cNvSpPr/>
+          <p:nvPr/>
+        </p:nvSpPr>
+        <p:spPr>
+          <a:xfrm>
+            <a:off x="621792" y="5861304"/>
+            <a:ext cx="1005840" cy="310896"/>
           </a:xfrm>
           <a:prstGeom prst="roundRect">
             <a:avLst>
-              <a:gd name="adj" fmla="val 7407"/>
+              <a:gd name="adj" fmla="val 50000"/>
             </a:avLst>
           </a:prstGeom>
           <a:solidFill>
-            <a:srgbClr val="FFF4F2"/>
+            <a:schemeClr val="accent1"/>
           </a:solidFill>
-          <a:ln w="19050">
-            <a:solidFill>
-              <a:srgbClr val="E83030"/>
-            </a:solidFill>
-            <a:prstDash val="dash"/>
-          </a:ln>
-        </p:spPr>
-      </p:sp>
-      <p:sp>
-        <p:nvSpPr>
-          <p:cNvPr id="7" name="Text 4"/>
+          <a:ln/>
+        </p:spPr>
+      </p:sp>
+      <p:sp>
+        <p:nvSpPr>
+          <p:cNvPr id="13" name="Text 7"/>
           <p:cNvSpPr txBox="1"/>
           <p:nvPr/>
         </p:nvSpPr>
         <p:spPr>
           <a:xfrm>
-            <a:off x="731520" y="5047488"/>
-            <a:ext cx="2240280" cy="1014984"/>
+            <a:off x="621792" y="5861304"/>
+            <a:ext cx="1005840" cy="310896"/>
           </a:xfrm>
           <a:prstGeom prst="rect">
             <a:avLst/>
@@ -16064,75 +16212,56 @@
           <a:bodyPr wrap="square" lIns="0" tIns="0" rIns="0" bIns="0" rtlCol="0" anchor="ctr"/>
           <a:lstStyle/>
           <a:p>
-            <a:pPr indent="0" marL="0">
-              <a:buNone/>
-            </a:pPr>
-            <a:r>
-              <a:rPr lang="en-US" sz="1000" b="1" dirty="0">
-                <a:solidFill>
-                  <a:schemeClr val="accent3"/>
-                </a:solidFill>
-                <a:latin typeface="Calibri" pitchFamily="34" charset="0"/>
-                <a:ea typeface="Calibri" pitchFamily="34" charset="-122"/>
-                <a:cs typeface="Calibri" pitchFamily="34" charset="-120"/>
-              </a:rPr>
-              <a:t>PENDIENTE  </a:t>
-            </a:r>
-            <a:pPr indent="0" marL="0">
-              <a:buNone/>
-            </a:pPr>
-            <a:r>
-              <a:rPr lang="en-US" sz="1200" dirty="0">
-                <a:solidFill>
-                  <a:schemeClr val="accent3"/>
-                </a:solidFill>
-                <a:latin typeface="Calibri" pitchFamily="34" charset="0"/>
-                <a:ea typeface="Calibri" pitchFamily="34" charset="-122"/>
-                <a:cs typeface="Calibri" pitchFamily="34" charset="-120"/>
-              </a:rPr>
-              <a:t>Captura: confirmación en el sitio</a:t>
-            </a:r>
-            <a:endParaRPr lang="en-US" sz="1400" dirty="0"/>
-          </a:p>
-        </p:txBody>
-      </p:sp>
-      <p:sp>
-        <p:nvSpPr>
-          <p:cNvPr id="8" name="pendiente-179"/>
+            <a:pPr algn="ctr" indent="0" marL="0">
+              <a:buNone/>
+            </a:pPr>
+            <a:r>
+              <a:rPr lang="en-US" sz="1100" b="1" dirty="0">
+                <a:solidFill>
+                  <a:schemeClr val="bg1"/>
+                </a:solidFill>
+                <a:latin typeface="Calibri" pitchFamily="34" charset="0"/>
+                <a:ea typeface="Calibri" pitchFamily="34" charset="-122"/>
+                <a:cs typeface="Calibri" pitchFamily="34" charset="-120"/>
+              </a:rPr>
+              <a:t>1 · Sitio</a:t>
+            </a:r>
+            <a:endParaRPr lang="en-US" sz="1100" dirty="0"/>
+          </a:p>
+        </p:txBody>
+      </p:sp>
+      <p:sp>
+        <p:nvSpPr>
+          <p:cNvPr id="14" name="etiqueta-182"/>
           <p:cNvSpPr/>
           <p:nvPr/>
         </p:nvSpPr>
         <p:spPr>
           <a:xfrm>
-            <a:off x="3360420" y="4937760"/>
-            <a:ext cx="2606040" cy="1234440"/>
+            <a:off x="2421791" y="5861304"/>
+            <a:ext cx="1234440" cy="310896"/>
           </a:xfrm>
           <a:prstGeom prst="roundRect">
             <a:avLst>
-              <a:gd name="adj" fmla="val 7407"/>
+              <a:gd name="adj" fmla="val 50000"/>
             </a:avLst>
           </a:prstGeom>
           <a:solidFill>
-            <a:srgbClr val="FFF4F2"/>
+            <a:schemeClr val="accent2"/>
           </a:solidFill>
-          <a:ln w="19050">
-            <a:solidFill>
-              <a:srgbClr val="E83030"/>
-            </a:solidFill>
-            <a:prstDash val="dash"/>
-          </a:ln>
-        </p:spPr>
-      </p:sp>
-      <p:sp>
-        <p:nvSpPr>
-          <p:cNvPr id="9" name="Text 6"/>
+          <a:ln/>
+        </p:spPr>
+      </p:sp>
+      <p:sp>
+        <p:nvSpPr>
+          <p:cNvPr id="15" name="Text 9"/>
           <p:cNvSpPr txBox="1"/>
           <p:nvPr/>
         </p:nvSpPr>
         <p:spPr>
           <a:xfrm>
-            <a:off x="3543300" y="5047488"/>
-            <a:ext cx="2240280" cy="1014984"/>
+            <a:off x="2421791" y="5861304"/>
+            <a:ext cx="1234440" cy="310896"/>
           </a:xfrm>
           <a:prstGeom prst="rect">
             <a:avLst/>
@@ -16144,75 +16273,56 @@
           <a:bodyPr wrap="square" lIns="0" tIns="0" rIns="0" bIns="0" rtlCol="0" anchor="ctr"/>
           <a:lstStyle/>
           <a:p>
-            <a:pPr indent="0" marL="0">
-              <a:buNone/>
-            </a:pPr>
-            <a:r>
-              <a:rPr lang="en-US" sz="1000" b="1" dirty="0">
-                <a:solidFill>
-                  <a:schemeClr val="accent3"/>
-                </a:solidFill>
-                <a:latin typeface="Calibri" pitchFamily="34" charset="0"/>
-                <a:ea typeface="Calibri" pitchFamily="34" charset="-122"/>
-                <a:cs typeface="Calibri" pitchFamily="34" charset="-120"/>
-              </a:rPr>
-              <a:t>PENDIENTE  </a:t>
-            </a:r>
-            <a:pPr indent="0" marL="0">
-              <a:buNone/>
-            </a:pPr>
-            <a:r>
-              <a:rPr lang="en-US" sz="1200" dirty="0">
-                <a:solidFill>
-                  <a:schemeClr val="accent3"/>
-                </a:solidFill>
-                <a:latin typeface="Calibri" pitchFamily="34" charset="0"/>
-                <a:ea typeface="Calibri" pitchFamily="34" charset="-122"/>
-                <a:cs typeface="Calibri" pitchFamily="34" charset="-120"/>
-              </a:rPr>
-              <a:t>Captura: mensaje en WhatsApp</a:t>
-            </a:r>
-            <a:endParaRPr lang="en-US" sz="1400" dirty="0"/>
-          </a:p>
-        </p:txBody>
-      </p:sp>
-      <p:sp>
-        <p:nvSpPr>
-          <p:cNvPr id="10" name="pendiente-180"/>
+            <a:pPr algn="ctr" indent="0" marL="0">
+              <a:buNone/>
+            </a:pPr>
+            <a:r>
+              <a:rPr lang="en-US" sz="1100" b="1" dirty="0">
+                <a:solidFill>
+                  <a:schemeClr val="bg1"/>
+                </a:solidFill>
+                <a:latin typeface="Calibri" pitchFamily="34" charset="0"/>
+                <a:ea typeface="Calibri" pitchFamily="34" charset="-122"/>
+                <a:cs typeface="Calibri" pitchFamily="34" charset="-120"/>
+              </a:rPr>
+              <a:t>2 · WhatsApp</a:t>
+            </a:r>
+            <a:endParaRPr lang="en-US" sz="1100" dirty="0"/>
+          </a:p>
+        </p:txBody>
+      </p:sp>
+      <p:sp>
+        <p:nvSpPr>
+          <p:cNvPr id="16" name="etiqueta-183"/>
           <p:cNvSpPr/>
           <p:nvPr/>
         </p:nvSpPr>
         <p:spPr>
           <a:xfrm>
-            <a:off x="6172200" y="4937760"/>
-            <a:ext cx="2606040" cy="1234440"/>
+            <a:off x="4792981" y="4343400"/>
+            <a:ext cx="1234440" cy="310896"/>
           </a:xfrm>
           <a:prstGeom prst="roundRect">
             <a:avLst>
-              <a:gd name="adj" fmla="val 7407"/>
+              <a:gd name="adj" fmla="val 50000"/>
             </a:avLst>
           </a:prstGeom>
           <a:solidFill>
-            <a:srgbClr val="FFF4F2"/>
+            <a:schemeClr val="tx2"/>
           </a:solidFill>
-          <a:ln w="19050">
-            <a:solidFill>
-              <a:srgbClr val="E83030"/>
-            </a:solidFill>
-            <a:prstDash val="dash"/>
-          </a:ln>
-        </p:spPr>
-      </p:sp>
-      <p:sp>
-        <p:nvSpPr>
-          <p:cNvPr id="11" name="Text 8"/>
+          <a:ln/>
+        </p:spPr>
+      </p:sp>
+      <p:sp>
+        <p:nvSpPr>
+          <p:cNvPr id="17" name="Text 11"/>
           <p:cNvSpPr txBox="1"/>
           <p:nvPr/>
         </p:nvSpPr>
         <p:spPr>
           <a:xfrm>
-            <a:off x="6355080" y="5047488"/>
-            <a:ext cx="2240280" cy="1014984"/>
+            <a:off x="4792981" y="4343400"/>
+            <a:ext cx="1234440" cy="310896"/>
           </a:xfrm>
           <a:prstGeom prst="rect">
             <a:avLst/>
@@ -16224,115 +16334,106 @@
           <a:bodyPr wrap="square" lIns="0" tIns="0" rIns="0" bIns="0" rtlCol="0" anchor="ctr"/>
           <a:lstStyle/>
           <a:p>
-            <a:pPr indent="0" marL="0">
-              <a:buNone/>
-            </a:pPr>
-            <a:r>
-              <a:rPr lang="en-US" sz="1000" b="1" dirty="0">
-                <a:solidFill>
-                  <a:schemeClr val="accent3"/>
-                </a:solidFill>
-                <a:latin typeface="Calibri" pitchFamily="34" charset="0"/>
-                <a:ea typeface="Calibri" pitchFamily="34" charset="-122"/>
-                <a:cs typeface="Calibri" pitchFamily="34" charset="-120"/>
-              </a:rPr>
-              <a:t>PENDIENTE  </a:t>
-            </a:r>
-            <a:pPr indent="0" marL="0">
-              <a:buNone/>
-            </a:pPr>
-            <a:r>
-              <a:rPr lang="en-US" sz="1200" dirty="0">
-                <a:solidFill>
-                  <a:schemeClr val="accent3"/>
-                </a:solidFill>
-                <a:latin typeface="Calibri" pitchFamily="34" charset="0"/>
-                <a:ea typeface="Calibri" pitchFamily="34" charset="-122"/>
-                <a:cs typeface="Calibri" pitchFamily="34" charset="-120"/>
-              </a:rPr>
-              <a:t>Captura: fila en la planilla</a:t>
-            </a:r>
-            <a:endParaRPr lang="en-US" sz="1400" dirty="0"/>
-          </a:p>
-        </p:txBody>
-      </p:sp>
-      <p:sp>
-        <p:nvSpPr>
-          <p:cNvPr id="12" name="pendiente-181"/>
-          <p:cNvSpPr/>
-          <p:nvPr/>
-        </p:nvSpPr>
-        <p:spPr>
-          <a:xfrm>
-            <a:off x="8983980" y="4937760"/>
-            <a:ext cx="2606040" cy="1234440"/>
-          </a:xfrm>
-          <a:prstGeom prst="roundRect">
-            <a:avLst>
-              <a:gd name="adj" fmla="val 7407"/>
-            </a:avLst>
-          </a:prstGeom>
-          <a:solidFill>
-            <a:srgbClr val="FFF4F2"/>
-          </a:solidFill>
-          <a:ln w="19050">
-            <a:solidFill>
-              <a:srgbClr val="E83030"/>
-            </a:solidFill>
-            <a:prstDash val="dash"/>
-          </a:ln>
-        </p:spPr>
-      </p:sp>
-      <p:sp>
-        <p:nvSpPr>
-          <p:cNvPr id="13" name="Text 10"/>
+            <a:pPr algn="ctr" indent="0" marL="0">
+              <a:buNone/>
+            </a:pPr>
+            <a:r>
+              <a:rPr lang="en-US" sz="1100" b="1" dirty="0">
+                <a:solidFill>
+                  <a:schemeClr val="bg1"/>
+                </a:solidFill>
+                <a:latin typeface="Calibri" pitchFamily="34" charset="0"/>
+                <a:ea typeface="Calibri" pitchFamily="34" charset="-122"/>
+                <a:cs typeface="Calibri" pitchFamily="34" charset="-120"/>
+              </a:rPr>
+              <a:t>3 · Planilla</a:t>
+            </a:r>
+            <a:endParaRPr lang="en-US" sz="1100" dirty="0"/>
+          </a:p>
+        </p:txBody>
+      </p:sp>
+      <p:sp>
+        <p:nvSpPr>
+          <p:cNvPr id="18" name="Text 12"/>
           <p:cNvSpPr txBox="1"/>
           <p:nvPr/>
         </p:nvSpPr>
         <p:spPr>
           <a:xfrm>
-            <a:off x="9166860" y="5047488"/>
-            <a:ext cx="2240280" cy="1014984"/>
-          </a:xfrm>
-          <a:prstGeom prst="rect">
-            <a:avLst/>
-          </a:prstGeom>
-          <a:noFill/>
-          <a:ln/>
-        </p:spPr>
-        <p:txBody>
-          <a:bodyPr wrap="square" lIns="0" tIns="0" rIns="0" bIns="0" rtlCol="0" anchor="ctr"/>
-          <a:lstStyle/>
-          <a:p>
-            <a:pPr indent="0" marL="0">
-              <a:buNone/>
-            </a:pPr>
-            <a:r>
-              <a:rPr lang="en-US" sz="1000" b="1" dirty="0">
-                <a:solidFill>
-                  <a:schemeClr val="accent3"/>
-                </a:solidFill>
-                <a:latin typeface="Calibri" pitchFamily="34" charset="0"/>
-                <a:ea typeface="Calibri" pitchFamily="34" charset="-122"/>
-                <a:cs typeface="Calibri" pitchFamily="34" charset="-120"/>
-              </a:rPr>
-              <a:t>PENDIENTE  </a:t>
-            </a:r>
-            <a:pPr indent="0" marL="0">
-              <a:buNone/>
-            </a:pPr>
-            <a:r>
-              <a:rPr lang="en-US" sz="1200" dirty="0">
-                <a:solidFill>
-                  <a:schemeClr val="accent3"/>
-                </a:solidFill>
-                <a:latin typeface="Calibri" pitchFamily="34" charset="0"/>
-                <a:ea typeface="Calibri" pitchFamily="34" charset="-122"/>
-                <a:cs typeface="Calibri" pitchFamily="34" charset="-120"/>
-              </a:rPr>
-              <a:t>Pedidos web hasta el 13/10</a:t>
-            </a:r>
-            <a:endParaRPr lang="en-US" sz="1400" dirty="0"/>
+            <a:off x="4792981" y="5448475"/>
+            <a:ext cx="6819899" cy="796877"/>
+          </a:xfrm>
+          <a:prstGeom prst="rect">
+            <a:avLst/>
+          </a:prstGeom>
+          <a:noFill/>
+          <a:ln/>
+        </p:spPr>
+        <p:txBody>
+          <a:bodyPr wrap="square" lIns="0" tIns="0" rIns="0" bIns="0" rtlCol="0" anchor="t"/>
+          <a:lstStyle/>
+          <a:p>
+            <a:pPr marL="342900" indent="-342900">
+              <a:spcAft>
+                <a:spcPts val="300"/>
+              </a:spcAft>
+              <a:buSzPct val="100000"/>
+              <a:buChar char="•"/>
+            </a:pPr>
+            <a:r>
+              <a:rPr lang="en-US" sz="1300" dirty="0">
+                <a:solidFill>
+                  <a:schemeClr val="tx1"/>
+                </a:solidFill>
+                <a:latin typeface="Calibri" pitchFamily="34" charset="0"/>
+                <a:ea typeface="Calibri" pitchFamily="34" charset="-122"/>
+                <a:cs typeface="Calibri" pitchFamily="34" charset="-120"/>
+              </a:rPr>
+              <a:t>Total calculado solo: $32.500 (con mitad incluida)</a:t>
+            </a:r>
+            <a:endParaRPr lang="en-US" sz="1300" dirty="0"/>
+          </a:p>
+          <a:p>
+            <a:pPr marL="342900" indent="-342900">
+              <a:spcAft>
+                <a:spcPts val="300"/>
+              </a:spcAft>
+              <a:buSzPct val="100000"/>
+              <a:buChar char="•"/>
+            </a:pPr>
+            <a:r>
+              <a:rPr lang="en-US" sz="1300" dirty="0">
+                <a:solidFill>
+                  <a:schemeClr val="tx1"/>
+                </a:solidFill>
+                <a:latin typeface="Calibri" pitchFamily="34" charset="0"/>
+                <a:ea typeface="Calibri" pitchFamily="34" charset="-122"/>
+                <a:cs typeface="Calibri" pitchFamily="34" charset="-120"/>
+              </a:rPr>
+              <a:t>Mismo número de pedido en el sitio, WhatsApp y planilla</a:t>
+            </a:r>
+            <a:endParaRPr lang="en-US" sz="1300" dirty="0"/>
+          </a:p>
+          <a:p>
+            <a:pPr marL="342900" indent="-342900">
+              <a:spcAft>
+                <a:spcPts val="300"/>
+              </a:spcAft>
+              <a:buSzPct val="100000"/>
+              <a:buChar char="•"/>
+            </a:pPr>
+            <a:r>
+              <a:rPr lang="en-US" sz="1300" dirty="0">
+                <a:solidFill>
+                  <a:schemeClr val="tx1"/>
+                </a:solidFill>
+                <a:latin typeface="Calibri" pitchFamily="34" charset="0"/>
+                <a:ea typeface="Calibri" pitchFamily="34" charset="-122"/>
+                <a:cs typeface="Calibri" pitchFamily="34" charset="-120"/>
+              </a:rPr>
+              <a:t>Registrado sin intervención del negocio</a:t>
+            </a:r>
+            <a:endParaRPr lang="en-US" sz="1300" dirty="0"/>
           </a:p>
         </p:txBody>
       </p:sp>
@@ -17580,7 +17681,7 @@
       </p:graphicFrame>
       <p:sp>
         <p:nvSpPr>
-          <p:cNvPr id="5" name="card-182"/>
+          <p:cNvPr id="5" name="card-184"/>
           <p:cNvSpPr/>
           <p:nvPr/>
         </p:nvSpPr>
@@ -17807,7 +17908,7 @@
       </p:sp>
       <p:sp>
         <p:nvSpPr>
-          <p:cNvPr id="4" name="card-183"/>
+          <p:cNvPr id="4" name="card-185"/>
           <p:cNvSpPr/>
           <p:nvPr/>
         </p:nvSpPr>
@@ -17829,7 +17930,7 @@
       </p:sp>
       <p:sp>
         <p:nvSpPr>
-          <p:cNvPr id="5" name="icono-fondo-184"/>
+          <p:cNvPr id="5" name="icono-fondo-186"/>
           <p:cNvSpPr/>
           <p:nvPr/>
         </p:nvSpPr>
@@ -17849,7 +17950,7 @@
       </p:sp>
       <p:pic>
         <p:nvPicPr>
-          <p:cNvPr id="6" name="icono-185" descr="preencoded.png">    </p:cNvPr>
+          <p:cNvPr id="6" name="icono-187" descr="preencoded.png">    </p:cNvPr>
           <p:cNvPicPr>
             <a:picLocks noChangeAspect="1"/>
           </p:cNvPicPr>
@@ -17997,7 +18098,7 @@
       </p:sp>
       <p:sp>
         <p:nvSpPr>
-          <p:cNvPr id="9" name="card-186"/>
+          <p:cNvPr id="9" name="card-188"/>
           <p:cNvSpPr/>
           <p:nvPr/>
         </p:nvSpPr>
@@ -18019,7 +18120,7 @@
       </p:sp>
       <p:sp>
         <p:nvSpPr>
-          <p:cNvPr id="10" name="icono-fondo-187"/>
+          <p:cNvPr id="10" name="icono-fondo-189"/>
           <p:cNvSpPr/>
           <p:nvPr/>
         </p:nvSpPr>
@@ -18039,7 +18140,7 @@
       </p:sp>
       <p:pic>
         <p:nvPicPr>
-          <p:cNvPr id="11" name="icono-188" descr="preencoded.png">    </p:cNvPr>
+          <p:cNvPr id="11" name="icono-190" descr="preencoded.png">    </p:cNvPr>
           <p:cNvPicPr>
             <a:picLocks noChangeAspect="1"/>
           </p:cNvPicPr>
@@ -18187,7 +18288,7 @@
       </p:sp>
       <p:sp>
         <p:nvSpPr>
-          <p:cNvPr id="14" name="card-189"/>
+          <p:cNvPr id="14" name="card-191"/>
           <p:cNvSpPr/>
           <p:nvPr/>
         </p:nvSpPr>
@@ -18209,7 +18310,7 @@
       </p:sp>
       <p:sp>
         <p:nvSpPr>
-          <p:cNvPr id="15" name="icono-fondo-190"/>
+          <p:cNvPr id="15" name="icono-fondo-192"/>
           <p:cNvSpPr/>
           <p:nvPr/>
         </p:nvSpPr>
@@ -18229,7 +18330,7 @@
       </p:sp>
       <p:pic>
         <p:nvPicPr>
-          <p:cNvPr id="16" name="icono-191" descr="preencoded.png">    </p:cNvPr>
+          <p:cNvPr id="16" name="icono-193" descr="preencoded.png">    </p:cNvPr>
           <p:cNvPicPr>
             <a:picLocks noChangeAspect="1"/>
           </p:cNvPicPr>

</xml_diff>

<commit_message>
Presentación: pedidos de prueba (no uso real) en diap. 3, 10 y 17; pregunta probable sobre adopción; Gantt sin cambios de fechas
Co-Authored-By: Claude Opus 5.5 <noreply@anthropic.com>
Claude-Session: https://claude.ai/code/session_01KjW6Rcbm4CLMi8kGU9T2EW
</commit_message>
<xml_diff>
--- a/docs/presentacion/DanyPizzas_Presentacion.pptx
+++ b/docs/presentacion/DanyPizzas_Presentacion.pptx
@@ -126,25 +126,25 @@
   <p:extLst>
     <p:ext uri="{521415D9-36F7-43E2-AB2F-B90AF26B5E84}">
       <p14:sectionLst xmlns:p14="http://schemas.microsoft.com/office/powerpoint/2010/main">
-        <p14:section name="Introducción" id="{b01fb826-ebff-7cb8-e4f9-eb9d1e9e1c41}">
+        <p14:section name="Introducción" id="{9b2c2ec7-0fde-d133-a032-fc3c8f72a032}">
           <p14:sldIdLst>
             <p14:sldId id="256"/>
             <p14:sldId id="257"/>
           </p14:sldIdLst>
         </p14:section>
-        <p14:section name="I. Curriculum vitae" id="{ad394339-cbf4-0518-7bce-e1d2594ae99f}">
+        <p14:section name="I. Curriculum vitae" id="{890050e9-3db7-0327-e777-e8d95e2b0225}">
           <p14:sldIdLst>
             <p14:sldId id="258"/>
           </p14:sldIdLst>
         </p14:section>
-        <p14:section name="II. Memoria descriptiva" id="{8917fc81-7ae6-00fa-2099-96fd16e4baae}">
+        <p14:section name="II. Memoria descriptiva" id="{196b26b5-9947-5989-49ca-c774c57edcaa}">
           <p14:sldIdLst>
             <p14:sldId id="259"/>
             <p14:sldId id="260"/>
             <p14:sldId id="261"/>
           </p14:sldIdLst>
         </p14:section>
-        <p14:section name="III. Trabajo principal" id="{f935fdf5-51f7-bce1-a112-1dc281a05bea}">
+        <p14:section name="III. Trabajo principal" id="{e65b5eef-630c-cfe2-f7a4-8a491478d85a}">
           <p14:sldIdLst>
             <p14:sldId id="262"/>
             <p14:sldId id="263"/>
@@ -927,7 +927,7 @@
             <a:r>
               <a:rPr lang="en-US" dirty="0"/>
               <a:t>⏱ 0:40 (acumulado 6:40)
-El alcance es deliberadamente chico: lo mínimo que resuelve el problema. El pago en línea o una app quedan para una versión 2. El proyecto llevó dos semanas y 48 horas de trabajo. La primera semana fue de planificación: el Beat Chart con el enfoque y el método, el cuestionario al negocio, el diseño y un prototipo de la carta. La segunda fue de construcción, en incrementos cortos con un tablero Kanban y mostrando cada avance a la familia: el sitio se publicó el martes 6, el 7 validé el análisis con el negocio, y hasta el domingo 11 quedan el pedido real con la medición de uso y el ensayo. Todo termina antes de la exposición del 13.</a:t>
+El alcance es deliberadamente chico: lo mínimo que resuelve el problema. El pago en línea o una app quedan para una versión 2. El proyecto llevó dos semanas y 48 horas de trabajo. La primera semana fue de planificación: el Beat Chart con el enfoque y el método, el cuestionario al negocio, el diseño y un prototipo de la carta. La segunda fue de construcción, en incrementos cortos con un tablero Kanban y mostrando cada avance a la familia: el sitio se publicó el martes 6, el 7 validé el análisis con el negocio, y hasta el domingo 11 quedan el pedido de prueba en producción y el ensayo. Todo termina antes de la exposición del 13.</a:t>
             </a:r>
             <a:endParaRPr lang="en-US" dirty="0"/>
           </a:p>
@@ -1550,8 +1550,8 @@
             <a:r>
               <a:rPr lang="en-US" dirty="0"/>
               <a:t>⏱ 0:50 (acumulado 11:50)
-Los resultados, objetivo por objetivo, comparando antes y ahora. OE1: la carta dejó de ser una imagen reenviada y el pedido llega siempre completo. OE2: antes no había ningún registro, hoy hay una planilla mensual y los precios se cambian editando una celda. OE3: cuesta cero por mes y pasa 44 pruebas. Y acá está la evidencia de un pedido real, el DP-261010-001, de punta a punta: (1) el cliente confirma en el sitio y recibe su número; (2) el recibo llega armado al WhatsApp del negocio; (3) queda registrado solo en la planilla del mes, con el total recalculado por el servidor. El mismo número aparece en los tres lugares.
-Si preguntan: la hora del recibo (13:16) es la de Argentina, la del negocio; WhatsApp muestra la hora de mi celular en Perú. El aviso de 'fuera de horario' aparece porque lo hice de día: el sitio deja pedir igual y avisa al negocio. En la planilla muestro solo esta fila porque las demás tienen datos de clientes.</a:t>
+Los resultados, objetivo por objetivo, comparando antes y ahora. OE1: la carta dejó de ser una imagen reenviada y el pedido llega siempre completo. OE2: antes no había ningún registro, hoy hay una planilla mensual y los precios se cambian editando una celda. OE3: cuesta cero por mes y pasa 44 pruebas. Y acá está la evidencia: un pedido de prueba hecho en el sistema publicado, el DP-261010-001, de punta a punta: (1) el cliente confirma en el sitio y recibe su número; (2) el recibo llega armado al WhatsApp del negocio; (3) queda registrado solo en la planilla del mes, con el total recalculado por el servidor. El mismo número aparece en los tres lugares.
+Si preguntan: la hora del recibo (13:16) es la de Argentina, la del negocio; WhatsApp muestra la hora de mi celular en Perú. El aviso de 'fuera de horario' aparece porque lo hice de día: el sitio deja pedir igual y avisa al negocio. En la planilla muestro solo esta fila. Si preguntan cuántos clientes lo usaron: se publicó el 06/10 y hasta ahora los pedidos fueron de prueba; medir la adopción real durante el primer mes es justamente la recomendación al negocio.</a:t>
             </a:r>
             <a:endParaRPr lang="en-US" dirty="0"/>
           </a:p>
@@ -1996,7 +1996,7 @@
             <a:r>
               <a:rPr lang="en-US" dirty="0"/>
               <a:t>⏱ 0:30 (acumulado 1:10)
-Soy Máximo Castro, estudiante de tercer año de Ingeniería en Sistemas en la Universidad Nacional de Chilecito, en Argentina, y este semestre estoy de intercambio acá en Moquegua. Antes me recibí de técnico agrónomo. Lo que más me formó en programación es la competencia ICPC: mención honorable en la final sudamericana de 2024 y primer puesto provincial dos años seguidos. También fui asistente tecnológico en las jornadas de investigación del NOA. Y este proyecto no es un ejercicio: es un sistema real, publicado y en uso para un emprendimiento de mi ciudad.</a:t>
+Soy Máximo Castro, estudiante de tercer año de Ingeniería en Sistemas en la Universidad Nacional de Chilecito, en Argentina, y este semestre estoy de intercambio acá en Moquegua. Antes me recibí de técnico agrónomo. Lo que más me formó en programación es la competencia ICPC: mención honorable en la final sudamericana de 2024 y primer puesto provincial dos años seguidos. También fui asistente tecnológico en las jornadas de investigación del NOA. Y este proyecto no es un ejercicio: es un sistema real, publicado y funcionando para un emprendimiento de mi ciudad.</a:t>
             </a:r>
             <a:endParaRPr lang="en-US" dirty="0"/>
           </a:p>
@@ -6503,7 +6503,7 @@
                 <a:ea typeface="Calibri" pitchFamily="34" charset="-122"/>
                 <a:cs typeface="Calibri" pitchFamily="34" charset="-120"/>
               </a:rPr>
-              <a:t>Pedido real y medición</a:t>
+              <a:t>Pedido de prueba en producción</a:t>
             </a:r>
             <a:endParaRPr lang="en-US" sz="1200" dirty="0"/>
           </a:p>
@@ -16011,7 +16011,7 @@
                 <a:ea typeface="Cambria" pitchFamily="34" charset="-122"/>
                 <a:cs typeface="Cambria" pitchFamily="34" charset="-120"/>
               </a:rPr>
-              <a:t>Evidencia: pedido real DP‑261010‑001</a:t>
+              <a:t>Evidencia: pedido de prueba en producción DP‑261010‑001</a:t>
             </a:r>
             <a:pPr indent="0" marL="0">
               <a:buNone/>
@@ -20034,7 +20034,7 @@
                 <a:ea typeface="Calibri" pitchFamily="34" charset="-122"/>
                 <a:cs typeface="Calibri" pitchFamily="34" charset="-120"/>
               </a:rPr>
-              <a:t>Dany Pizzas Web (2026): sistema de pedidos publicado y en uso para un emprendimiento real de Chilecito.</a:t>
+              <a:t>Dany Pizzas Web (2026): sistema de pedidos publicado y funcionando para un emprendimiento real de Chilecito.</a:t>
             </a:r>
             <a:endParaRPr lang="en-US" sz="1400" dirty="0"/>
           </a:p>

</xml_diff>